<commit_message>
Emphasize delivered IT projects in company slide
</commit_message>
<xml_diff>
--- a/static/audit_presentation_btg.pptx
+++ b/static/audit_presentation_btg.pptx
@@ -2,21 +2,21 @@
 <file path=ppt/presentation.xml><?xml version="1.0" encoding="utf-8"?>
 <p:presentation xmlns:p="http://schemas.openxmlformats.org/presentationml/2006/main">
   <p:sldMasterIdLst>
-    <p:sldMasterId xmlns:r="http://schemas.openxmlformats.org/officeDocument/2006/relationships" id="2147483648" r:id="Rbb13f0e079ec46d6"/>
+    <p:sldMasterId xmlns:r="http://schemas.openxmlformats.org/officeDocument/2006/relationships" id="2147483648" r:id="Ra677fb96f4d84eec"/>
   </p:sldMasterIdLst>
   <p:notesMasterIdLst>
-    <p:notesMasterId xmlns:r="http://schemas.openxmlformats.org/officeDocument/2006/relationships" r:id="R414c5b04370a48d0"/>
+    <p:notesMasterId xmlns:r="http://schemas.openxmlformats.org/officeDocument/2006/relationships" r:id="Rff7124723e2f4799"/>
   </p:notesMasterIdLst>
   <p:sldIdLst>
-    <p:sldId xmlns:r="http://schemas.openxmlformats.org/officeDocument/2006/relationships" id="256" r:id="R05dcc123d95b45a4"/>
-    <p:sldId xmlns:r="http://schemas.openxmlformats.org/officeDocument/2006/relationships" id="257" r:id="R3b1f9e15dafb4c7d"/>
-    <p:sldId xmlns:r="http://schemas.openxmlformats.org/officeDocument/2006/relationships" id="258" r:id="R764a525c8d884473"/>
-    <p:sldId xmlns:r="http://schemas.openxmlformats.org/officeDocument/2006/relationships" id="259" r:id="Rbe03c4a83a62435b"/>
-    <p:sldId xmlns:r="http://schemas.openxmlformats.org/officeDocument/2006/relationships" id="260" r:id="Rb9a2449e5709425d"/>
-    <p:sldId xmlns:r="http://schemas.openxmlformats.org/officeDocument/2006/relationships" id="261" r:id="R5a913a7bc4aa45bb"/>
-    <p:sldId xmlns:r="http://schemas.openxmlformats.org/officeDocument/2006/relationships" id="262" r:id="Rb61447adc3404b42"/>
-    <p:sldId xmlns:r="http://schemas.openxmlformats.org/officeDocument/2006/relationships" id="263" r:id="Rf1271a99de7b407f"/>
-    <p:sldId xmlns:r="http://schemas.openxmlformats.org/officeDocument/2006/relationships" id="264" r:id="R9ae511bcaeed408d"/>
+    <p:sldId xmlns:r="http://schemas.openxmlformats.org/officeDocument/2006/relationships" id="256" r:id="R68bd021c9c074a0a"/>
+    <p:sldId xmlns:r="http://schemas.openxmlformats.org/officeDocument/2006/relationships" id="257" r:id="R77ae97ec054c4097"/>
+    <p:sldId xmlns:r="http://schemas.openxmlformats.org/officeDocument/2006/relationships" id="258" r:id="Rd4f0fcab170f4a78"/>
+    <p:sldId xmlns:r="http://schemas.openxmlformats.org/officeDocument/2006/relationships" id="259" r:id="Rdc939f6f97174e8c"/>
+    <p:sldId xmlns:r="http://schemas.openxmlformats.org/officeDocument/2006/relationships" id="260" r:id="Rd5be1132e9144d8c"/>
+    <p:sldId xmlns:r="http://schemas.openxmlformats.org/officeDocument/2006/relationships" id="261" r:id="R821dcab061a44fb4"/>
+    <p:sldId xmlns:r="http://schemas.openxmlformats.org/officeDocument/2006/relationships" id="262" r:id="Re8df43ba1b4e4a8f"/>
+    <p:sldId xmlns:r="http://schemas.openxmlformats.org/officeDocument/2006/relationships" id="263" r:id="R91f4723ae5f548ff"/>
+    <p:sldId xmlns:r="http://schemas.openxmlformats.org/officeDocument/2006/relationships" id="264" r:id="R1ef48469a1134a7d"/>
   </p:sldIdLst>
   <p:sldSz cx="12192000" cy="6858000"/>
   <p:notesSz cx="6858000" cy="9144000"/>
@@ -1137,7 +1137,7 @@
   </p:cSld>
   <p:clrMap bg1="lt1" tx1="dk1" bg2="lt2" tx2="dk2" accent1="accent1" accent2="accent2" accent3="accent3" accent4="accent4" accent5="accent5" accent6="accent6" hlink="hlink" folHlink="folHlink"/>
   <p:sldLayoutIdLst>
-    <p:sldLayoutId xmlns:r="http://schemas.openxmlformats.org/officeDocument/2006/relationships" id="2147483649" r:id="R1cad63d4e3bf4176"/>
+    <p:sldLayoutId xmlns:r="http://schemas.openxmlformats.org/officeDocument/2006/relationships" id="2147483649" r:id="R805ff24632c94b2b"/>
   </p:sldLayoutIdLst>
   <p:txStyles>
     <p:titleStyle>
@@ -1688,7 +1688,7 @@
           <p:cNvPr id="1" name="">
             <a:extLst xmlns:a="http://schemas.openxmlformats.org/drawingml/2006/main">
               <a:ext uri="{FF2B5EF4-FFF2-40B4-BE49-F238E27FC236}">
-                <a16:creationId xmlns:a16="http://schemas.microsoft.com/office/drawing/2014/main" id="{A10F74A0-9DA7-4B99-A638-8877BE3D0D77}"/>
+                <a16:creationId xmlns:a16="http://schemas.microsoft.com/office/drawing/2014/main" id="{DD7E633E-FECD-493A-B990-79DA7BC2EA3F}"/>
               </a:ext>
             </a:extLst>
           </p:cNvPr>
@@ -1719,7 +1719,7 @@
           <p:cNvPr id="2" name="">
             <a:extLst xmlns:a="http://schemas.openxmlformats.org/drawingml/2006/main">
               <a:ext uri="{FF2B5EF4-FFF2-40B4-BE49-F238E27FC236}">
-                <a16:creationId xmlns:a16="http://schemas.microsoft.com/office/drawing/2014/main" id="{68E05753-7947-4ABE-B9B8-29E9BE270630}"/>
+                <a16:creationId xmlns:a16="http://schemas.microsoft.com/office/drawing/2014/main" id="{E82E1AD0-57C4-42F2-8AAB-C276BD01D1F0}"/>
               </a:ext>
             </a:extLst>
           </p:cNvPr>
@@ -1754,7 +1754,7 @@
           <p:nvPr/>
         </p:nvPicPr>
         <p:blipFill>
-          <a:blip xmlns:r="http://schemas.openxmlformats.org/officeDocument/2006/relationships" xmlns:a="http://schemas.openxmlformats.org/drawingml/2006/main" r:embed="R9de237d03c8242ff"/>
+          <a:blip xmlns:r="http://schemas.openxmlformats.org/officeDocument/2006/relationships" xmlns:a="http://schemas.openxmlformats.org/drawingml/2006/main" r:embed="R5cf247ef377545ca"/>
           <a:stretch xmlns:a="http://schemas.openxmlformats.org/drawingml/2006/main"/>
         </p:blipFill>
         <p:spPr>
@@ -1772,7 +1772,7 @@
           <p:cNvPr id="4" name="">
             <a:extLst xmlns:a="http://schemas.openxmlformats.org/drawingml/2006/main">
               <a:ext uri="{FF2B5EF4-FFF2-40B4-BE49-F238E27FC236}">
-                <a16:creationId xmlns:a16="http://schemas.microsoft.com/office/drawing/2014/main" id="{5B6B2E43-F886-4E96-84C1-810836B6E320}"/>
+                <a16:creationId xmlns:a16="http://schemas.microsoft.com/office/drawing/2014/main" id="{957798CA-A8E0-405E-A7C0-9A902A28409C}"/>
               </a:ext>
             </a:extLst>
           </p:cNvPr>
@@ -1822,7 +1822,7 @@
           <p:cNvPr id="5" name="">
             <a:extLst xmlns:a="http://schemas.openxmlformats.org/drawingml/2006/main">
               <a:ext uri="{FF2B5EF4-FFF2-40B4-BE49-F238E27FC236}">
-                <a16:creationId xmlns:a16="http://schemas.microsoft.com/office/drawing/2014/main" id="{8BCC874B-E787-4FEF-B79D-E2FDB53696AB}"/>
+                <a16:creationId xmlns:a16="http://schemas.microsoft.com/office/drawing/2014/main" id="{377EC194-7FEA-4969-B5AA-82CCEF5758E1}"/>
               </a:ext>
             </a:extLst>
           </p:cNvPr>
@@ -1872,7 +1872,7 @@
           <p:cNvPr id="6" name="">
             <a:extLst xmlns:a="http://schemas.openxmlformats.org/drawingml/2006/main">
               <a:ext uri="{FF2B5EF4-FFF2-40B4-BE49-F238E27FC236}">
-                <a16:creationId xmlns:a16="http://schemas.microsoft.com/office/drawing/2014/main" id="{37033E20-10EF-485F-BC04-AFAFBE93957A}"/>
+                <a16:creationId xmlns:a16="http://schemas.microsoft.com/office/drawing/2014/main" id="{3A7BDD4E-FE07-4611-A647-5D5D59342444}"/>
               </a:ext>
             </a:extLst>
           </p:cNvPr>
@@ -1922,7 +1922,7 @@
           <p:cNvPr id="7" name="">
             <a:extLst xmlns:a="http://schemas.openxmlformats.org/drawingml/2006/main">
               <a:ext uri="{FF2B5EF4-FFF2-40B4-BE49-F238E27FC236}">
-                <a16:creationId xmlns:a16="http://schemas.microsoft.com/office/drawing/2014/main" id="{35AB0862-6388-4236-953D-FBA94117BD2E}"/>
+                <a16:creationId xmlns:a16="http://schemas.microsoft.com/office/drawing/2014/main" id="{ACEFD9AB-F08A-4506-9D20-8BECB95795D7}"/>
               </a:ext>
             </a:extLst>
           </p:cNvPr>
@@ -1955,7 +1955,7 @@
           <p:cNvPr id="8" name="">
             <a:extLst xmlns:a="http://schemas.openxmlformats.org/drawingml/2006/main">
               <a:ext uri="{FF2B5EF4-FFF2-40B4-BE49-F238E27FC236}">
-                <a16:creationId xmlns:a16="http://schemas.microsoft.com/office/drawing/2014/main" id="{F5D84BFB-795F-465E-AC15-F86B5A7816AD}"/>
+                <a16:creationId xmlns:a16="http://schemas.microsoft.com/office/drawing/2014/main" id="{9E6706B3-29B0-4FF1-AADA-005FD954B802}"/>
               </a:ext>
             </a:extLst>
           </p:cNvPr>
@@ -2005,7 +2005,7 @@
           <p:cNvPr id="9" name="">
             <a:extLst xmlns:a="http://schemas.openxmlformats.org/drawingml/2006/main">
               <a:ext uri="{FF2B5EF4-FFF2-40B4-BE49-F238E27FC236}">
-                <a16:creationId xmlns:a16="http://schemas.microsoft.com/office/drawing/2014/main" id="{4B9757C3-262D-4649-A496-50BED84830BA}"/>
+                <a16:creationId xmlns:a16="http://schemas.microsoft.com/office/drawing/2014/main" id="{98B749E6-A2FB-4C38-898E-A11D418904F8}"/>
               </a:ext>
             </a:extLst>
           </p:cNvPr>
@@ -2055,7 +2055,7 @@
           <p:cNvPr id="10" name="">
             <a:extLst xmlns:a="http://schemas.openxmlformats.org/drawingml/2006/main">
               <a:ext uri="{FF2B5EF4-FFF2-40B4-BE49-F238E27FC236}">
-                <a16:creationId xmlns:a16="http://schemas.microsoft.com/office/drawing/2014/main" id="{E31F48D4-0ED5-4F13-8CC7-F1DFA64F20B0}"/>
+                <a16:creationId xmlns:a16="http://schemas.microsoft.com/office/drawing/2014/main" id="{9B4E3B77-806F-437F-8D29-DFED77D77CEE}"/>
               </a:ext>
             </a:extLst>
           </p:cNvPr>
@@ -2088,7 +2088,7 @@
           <p:cNvPr id="11" name="">
             <a:extLst xmlns:a="http://schemas.openxmlformats.org/drawingml/2006/main">
               <a:ext uri="{FF2B5EF4-FFF2-40B4-BE49-F238E27FC236}">
-                <a16:creationId xmlns:a16="http://schemas.microsoft.com/office/drawing/2014/main" id="{4D87645B-1807-4371-AEFD-C9B0DCC23005}"/>
+                <a16:creationId xmlns:a16="http://schemas.microsoft.com/office/drawing/2014/main" id="{B04D1C58-8F37-43AF-AB60-1262F13FF218}"/>
               </a:ext>
             </a:extLst>
           </p:cNvPr>
@@ -2138,7 +2138,7 @@
           <p:cNvPr id="12" name="">
             <a:extLst xmlns:a="http://schemas.openxmlformats.org/drawingml/2006/main">
               <a:ext uri="{FF2B5EF4-FFF2-40B4-BE49-F238E27FC236}">
-                <a16:creationId xmlns:a16="http://schemas.microsoft.com/office/drawing/2014/main" id="{D0C518A6-DC88-4CA9-A9FB-7FDC257828B1}"/>
+                <a16:creationId xmlns:a16="http://schemas.microsoft.com/office/drawing/2014/main" id="{20E15085-2508-41A5-ABE5-53CB18F82453}"/>
               </a:ext>
             </a:extLst>
           </p:cNvPr>
@@ -2188,7 +2188,7 @@
           <p:cNvPr id="13" name="">
             <a:extLst xmlns:a="http://schemas.openxmlformats.org/drawingml/2006/main">
               <a:ext uri="{FF2B5EF4-FFF2-40B4-BE49-F238E27FC236}">
-                <a16:creationId xmlns:a16="http://schemas.microsoft.com/office/drawing/2014/main" id="{6C06B3BA-2A23-49EF-946B-4E1F90561F01}"/>
+                <a16:creationId xmlns:a16="http://schemas.microsoft.com/office/drawing/2014/main" id="{150932CA-0997-4A34-90E8-941DB4A10FD7}"/>
               </a:ext>
             </a:extLst>
           </p:cNvPr>
@@ -2242,7 +2242,7 @@
           <p:nvPr/>
         </p:nvPicPr>
         <p:blipFill>
-          <a:blip xmlns:r="http://schemas.openxmlformats.org/officeDocument/2006/relationships" xmlns:a="http://schemas.openxmlformats.org/drawingml/2006/main" r:embed="R23e124e26dca4476"/>
+          <a:blip xmlns:r="http://schemas.openxmlformats.org/officeDocument/2006/relationships" xmlns:a="http://schemas.openxmlformats.org/drawingml/2006/main" r:embed="R302f0661e77c4e12"/>
           <a:srcRect xmlns:a="http://schemas.openxmlformats.org/drawingml/2006/main" l="0" t="132" r="0" b="132"/>
           <a:stretch xmlns:a="http://schemas.openxmlformats.org/drawingml/2006/main">
             <a:fillRect l="0" t="0" r="0" b="0"/>
@@ -2263,7 +2263,7 @@
           <p:cNvPr id="15" name="">
             <a:extLst xmlns:a="http://schemas.openxmlformats.org/drawingml/2006/main">
               <a:ext uri="{FF2B5EF4-FFF2-40B4-BE49-F238E27FC236}">
-                <a16:creationId xmlns:a16="http://schemas.microsoft.com/office/drawing/2014/main" id="{B7AA9F3D-7607-47DB-91F8-E1BE5EC5C02C}"/>
+                <a16:creationId xmlns:a16="http://schemas.microsoft.com/office/drawing/2014/main" id="{E73F608D-44B3-44BB-B535-C4D35F444C96}"/>
               </a:ext>
             </a:extLst>
           </p:cNvPr>
@@ -2294,7 +2294,7 @@
           <p:cNvPr id="16" name="">
             <a:extLst xmlns:a="http://schemas.openxmlformats.org/drawingml/2006/main">
               <a:ext uri="{FF2B5EF4-FFF2-40B4-BE49-F238E27FC236}">
-                <a16:creationId xmlns:a16="http://schemas.microsoft.com/office/drawing/2014/main" id="{DB4FB524-D12C-46B9-9282-EE3DC3C25AF2}"/>
+                <a16:creationId xmlns:a16="http://schemas.microsoft.com/office/drawing/2014/main" id="{6816E206-6981-4C96-9EE7-B9FB8612DD46}"/>
               </a:ext>
             </a:extLst>
           </p:cNvPr>
@@ -2342,7 +2342,7 @@
     </p:spTree>
     <p:extLst>
       <p:ext uri="{BB962C8B-B14F-4D97-AF65-F5344CB8AC3E}">
-        <p14:creationId xmlns:p14="http://schemas.microsoft.com/office/powerpoint/2010/main" val="2082446498"/>
+        <p14:creationId xmlns:p14="http://schemas.microsoft.com/office/powerpoint/2010/main" val="719718069"/>
       </p:ext>
     </p:extLst>
   </p:cSld>
@@ -2373,7 +2373,7 @@
           <p:cNvPr id="1" name="">
             <a:extLst xmlns:a="http://schemas.openxmlformats.org/drawingml/2006/main">
               <a:ext uri="{FF2B5EF4-FFF2-40B4-BE49-F238E27FC236}">
-                <a16:creationId xmlns:a16="http://schemas.microsoft.com/office/drawing/2014/main" id="{EE550082-C059-4AEB-A683-76BA0316619F}"/>
+                <a16:creationId xmlns:a16="http://schemas.microsoft.com/office/drawing/2014/main" id="{D8DE08D0-525C-420E-8871-CB41416C88BF}"/>
               </a:ext>
             </a:extLst>
           </p:cNvPr>
@@ -2408,7 +2408,7 @@
           <p:nvPr/>
         </p:nvPicPr>
         <p:blipFill>
-          <a:blip xmlns:r="http://schemas.openxmlformats.org/officeDocument/2006/relationships" xmlns:a="http://schemas.openxmlformats.org/drawingml/2006/main" r:embed="R7a46749a712144fc"/>
+          <a:blip xmlns:r="http://schemas.openxmlformats.org/officeDocument/2006/relationships" xmlns:a="http://schemas.openxmlformats.org/drawingml/2006/main" r:embed="R3b7f639393fc425a"/>
           <a:stretch xmlns:a="http://schemas.openxmlformats.org/drawingml/2006/main"/>
         </p:blipFill>
         <p:spPr>
@@ -2426,7 +2426,7 @@
           <p:cNvPr id="3" name="">
             <a:extLst xmlns:a="http://schemas.openxmlformats.org/drawingml/2006/main">
               <a:ext uri="{FF2B5EF4-FFF2-40B4-BE49-F238E27FC236}">
-                <a16:creationId xmlns:a16="http://schemas.microsoft.com/office/drawing/2014/main" id="{FC8E8C1F-FF19-487A-947E-C731D4E0359F}"/>
+                <a16:creationId xmlns:a16="http://schemas.microsoft.com/office/drawing/2014/main" id="{A8DA76FE-02D7-4819-960C-E6CFCBEA16C1}"/>
               </a:ext>
             </a:extLst>
           </p:cNvPr>
@@ -2476,7 +2476,7 @@
           <p:cNvPr id="4" name="">
             <a:extLst xmlns:a="http://schemas.openxmlformats.org/drawingml/2006/main">
               <a:ext uri="{FF2B5EF4-FFF2-40B4-BE49-F238E27FC236}">
-                <a16:creationId xmlns:a16="http://schemas.microsoft.com/office/drawing/2014/main" id="{06AC1A2B-9C2B-4566-B78E-CCA387FD80A2}"/>
+                <a16:creationId xmlns:a16="http://schemas.microsoft.com/office/drawing/2014/main" id="{C03682D9-3ECE-4B35-9983-822B317DF4B2}"/>
               </a:ext>
             </a:extLst>
           </p:cNvPr>
@@ -2509,7 +2509,7 @@
           <p:cNvPr id="5" name="">
             <a:extLst xmlns:a="http://schemas.openxmlformats.org/drawingml/2006/main">
               <a:ext uri="{FF2B5EF4-FFF2-40B4-BE49-F238E27FC236}">
-                <a16:creationId xmlns:a16="http://schemas.microsoft.com/office/drawing/2014/main" id="{5686DDC2-2A23-4218-B4F0-D284A471E116}"/>
+                <a16:creationId xmlns:a16="http://schemas.microsoft.com/office/drawing/2014/main" id="{FDB9F145-7D64-4458-B57D-5670F10239CA}"/>
               </a:ext>
             </a:extLst>
           </p:cNvPr>
@@ -2540,7 +2540,7 @@
           <p:cNvPr id="6" name="">
             <a:extLst xmlns:a="http://schemas.openxmlformats.org/drawingml/2006/main">
               <a:ext uri="{FF2B5EF4-FFF2-40B4-BE49-F238E27FC236}">
-                <a16:creationId xmlns:a16="http://schemas.microsoft.com/office/drawing/2014/main" id="{19F4FD0B-9081-4A58-A3A6-AA04C438CE9C}"/>
+                <a16:creationId xmlns:a16="http://schemas.microsoft.com/office/drawing/2014/main" id="{BA65396C-357D-4FC0-ADF7-6AADEEF14320}"/>
               </a:ext>
             </a:extLst>
           </p:cNvPr>
@@ -2590,7 +2590,7 @@
           <p:cNvPr id="7" name="">
             <a:extLst xmlns:a="http://schemas.openxmlformats.org/drawingml/2006/main">
               <a:ext uri="{FF2B5EF4-FFF2-40B4-BE49-F238E27FC236}">
-                <a16:creationId xmlns:a16="http://schemas.microsoft.com/office/drawing/2014/main" id="{F6F20A37-DCFD-4651-B718-CE4892BC6ECE}"/>
+                <a16:creationId xmlns:a16="http://schemas.microsoft.com/office/drawing/2014/main" id="{A87FC36A-D01D-48D9-9089-66ECBA4550F0}"/>
               </a:ext>
             </a:extLst>
           </p:cNvPr>
@@ -2640,7 +2640,7 @@
           <p:cNvPr id="8" name="">
             <a:extLst xmlns:a="http://schemas.openxmlformats.org/drawingml/2006/main">
               <a:ext uri="{FF2B5EF4-FFF2-40B4-BE49-F238E27FC236}">
-                <a16:creationId xmlns:a16="http://schemas.microsoft.com/office/drawing/2014/main" id="{9E9C87C8-ACFB-42F2-9E5B-162BCFBE0082}"/>
+                <a16:creationId xmlns:a16="http://schemas.microsoft.com/office/drawing/2014/main" id="{5EFB76D6-1808-4E29-915E-9FE35AC42AE5}"/>
               </a:ext>
             </a:extLst>
           </p:cNvPr>
@@ -2690,7 +2690,7 @@
           <p:cNvPr id="9" name="">
             <a:extLst xmlns:a="http://schemas.openxmlformats.org/drawingml/2006/main">
               <a:ext uri="{FF2B5EF4-FFF2-40B4-BE49-F238E27FC236}">
-                <a16:creationId xmlns:a16="http://schemas.microsoft.com/office/drawing/2014/main" id="{A63B2B4B-F4EB-434F-A5D6-36B388AB62A3}"/>
+                <a16:creationId xmlns:a16="http://schemas.microsoft.com/office/drawing/2014/main" id="{B16EDA58-3A30-4AC1-95DC-E5BF6459F31F}"/>
               </a:ext>
             </a:extLst>
           </p:cNvPr>
@@ -2740,7 +2740,7 @@
           <p:cNvPr id="10" name="">
             <a:extLst xmlns:a="http://schemas.openxmlformats.org/drawingml/2006/main">
               <a:ext uri="{FF2B5EF4-FFF2-40B4-BE49-F238E27FC236}">
-                <a16:creationId xmlns:a16="http://schemas.microsoft.com/office/drawing/2014/main" id="{60C91E4A-E197-418B-BEFC-69936BE5010A}"/>
+                <a16:creationId xmlns:a16="http://schemas.microsoft.com/office/drawing/2014/main" id="{F9EB31A5-6B3B-4C2B-9E84-69A44BC8D658}"/>
               </a:ext>
             </a:extLst>
           </p:cNvPr>
@@ -2790,7 +2790,7 @@
           <p:cNvPr id="11" name="">
             <a:extLst xmlns:a="http://schemas.openxmlformats.org/drawingml/2006/main">
               <a:ext uri="{FF2B5EF4-FFF2-40B4-BE49-F238E27FC236}">
-                <a16:creationId xmlns:a16="http://schemas.microsoft.com/office/drawing/2014/main" id="{500CEFBA-8AB5-4A32-8024-819EE5EB896C}"/>
+                <a16:creationId xmlns:a16="http://schemas.microsoft.com/office/drawing/2014/main" id="{679BD25A-6720-42A8-88B8-AEF18621F65A}"/>
               </a:ext>
             </a:extLst>
           </p:cNvPr>
@@ -2820,14 +2820,14 @@
             <a:pPr>
               <a:defRPr sz="2325" b="1">
                 <a:solidFill>
-                  <a:srgbClr val="2048A8"/>
+                  <a:srgbClr val="102A63"/>
                 </a:solidFill>
               </a:defRPr>
             </a:pPr>
             <a:r>
               <a:rPr sz="2325" b="1">
                 <a:solidFill>
-                  <a:srgbClr val="2048A8"/>
+                  <a:srgbClr val="102A63"/>
                 </a:solidFill>
               </a:rPr>
               <a:t>2019</a:t>
@@ -2840,7 +2840,7 @@
           <p:cNvPr id="12" name="">
             <a:extLst xmlns:a="http://schemas.openxmlformats.org/drawingml/2006/main">
               <a:ext uri="{FF2B5EF4-FFF2-40B4-BE49-F238E27FC236}">
-                <a16:creationId xmlns:a16="http://schemas.microsoft.com/office/drawing/2014/main" id="{8C124A9F-EFD5-43E3-871B-FD343345FF82}"/>
+                <a16:creationId xmlns:a16="http://schemas.microsoft.com/office/drawing/2014/main" id="{D0FA38F2-ED4D-4586-BC9C-69484CDB7C3D}"/>
               </a:ext>
             </a:extLst>
           </p:cNvPr>
@@ -2852,7 +2852,7 @@
         <p:spPr>
           <a:xfrm xmlns:a="http://schemas.openxmlformats.org/drawingml/2006/main">
             <a:off x="552450" y="4581525"/>
-            <a:ext cx="1409700" cy="457200"/>
+            <a:ext cx="1409700" cy="590550"/>
           </a:xfrm>
           <a:prstGeom xmlns:a="http://schemas.openxmlformats.org/drawingml/2006/main" prst="rect">
             <a:avLst/>
@@ -2890,7 +2890,7 @@
           <p:cNvPr id="13" name="">
             <a:extLst xmlns:a="http://schemas.openxmlformats.org/drawingml/2006/main">
               <a:ext uri="{FF2B5EF4-FFF2-40B4-BE49-F238E27FC236}">
-                <a16:creationId xmlns:a16="http://schemas.microsoft.com/office/drawing/2014/main" id="{FF463A62-1B46-42B2-AF2F-710027638D01}"/>
+                <a16:creationId xmlns:a16="http://schemas.microsoft.com/office/drawing/2014/main" id="{C289E1AE-9132-4131-AD0C-81DF3D1E161A}"/>
               </a:ext>
             </a:extLst>
           </p:cNvPr>
@@ -2918,16 +2918,16 @@
           <a:lstStyle xmlns:a="http://schemas.openxmlformats.org/drawingml/2006/main"/>
           <a:p xmlns:a="http://schemas.openxmlformats.org/drawingml/2006/main">
             <a:pPr>
-              <a:defRPr sz="2325" b="1">
-                <a:solidFill>
-                  <a:srgbClr val="102A63"/>
-                </a:solidFill>
-              </a:defRPr>
-            </a:pPr>
-            <a:r>
-              <a:rPr sz="2325" b="1">
-                <a:solidFill>
-                  <a:srgbClr val="102A63"/>
+              <a:defRPr sz="2700" b="1">
+                <a:solidFill>
+                  <a:srgbClr val="2048A8"/>
+                </a:solidFill>
+              </a:defRPr>
+            </a:pPr>
+            <a:r>
+              <a:rPr sz="2700" b="1">
+                <a:solidFill>
+                  <a:srgbClr val="2048A8"/>
                 </a:solidFill>
               </a:rPr>
               <a:t>70+</a:t>
@@ -2940,7 +2940,7 @@
           <p:cNvPr id="14" name="">
             <a:extLst xmlns:a="http://schemas.openxmlformats.org/drawingml/2006/main">
               <a:ext uri="{FF2B5EF4-FFF2-40B4-BE49-F238E27FC236}">
-                <a16:creationId xmlns:a16="http://schemas.microsoft.com/office/drawing/2014/main" id="{6977FDE8-0C5E-47DD-83C5-5758A735B7AA}"/>
+                <a16:creationId xmlns:a16="http://schemas.microsoft.com/office/drawing/2014/main" id="{AB49A8BC-23A3-48FF-B228-B780C3ECB3EF}"/>
               </a:ext>
             </a:extLst>
           </p:cNvPr>
@@ -2952,7 +2952,7 @@
         <p:spPr>
           <a:xfrm xmlns:a="http://schemas.openxmlformats.org/drawingml/2006/main">
             <a:off x="2247900" y="4581525"/>
-            <a:ext cx="1409700" cy="457200"/>
+            <a:ext cx="1409700" cy="590550"/>
           </a:xfrm>
           <a:prstGeom xmlns:a="http://schemas.openxmlformats.org/drawingml/2006/main" prst="rect">
             <a:avLst/>
@@ -2980,7 +2980,7 @@
                   <a:srgbClr val="596780"/>
                 </a:solidFill>
               </a:rPr>
-              <a:t>реализованных проектов</a:t>
+              <a:t>крупных ИТ-проектов</a:t>
             </a:r>
           </a:p>
         </p:txBody>
@@ -2990,7 +2990,7 @@
           <p:cNvPr id="15" name="">
             <a:extLst xmlns:a="http://schemas.openxmlformats.org/drawingml/2006/main">
               <a:ext uri="{FF2B5EF4-FFF2-40B4-BE49-F238E27FC236}">
-                <a16:creationId xmlns:a16="http://schemas.microsoft.com/office/drawing/2014/main" id="{6C9D2FB5-A07F-4DEE-8355-24959A88E1B5}"/>
+                <a16:creationId xmlns:a16="http://schemas.microsoft.com/office/drawing/2014/main" id="{5D6ADA22-4DCA-4798-96A3-2AE5494767CD}"/>
               </a:ext>
             </a:extLst>
           </p:cNvPr>
@@ -3040,7 +3040,7 @@
           <p:cNvPr id="16" name="">
             <a:extLst xmlns:a="http://schemas.openxmlformats.org/drawingml/2006/main">
               <a:ext uri="{FF2B5EF4-FFF2-40B4-BE49-F238E27FC236}">
-                <a16:creationId xmlns:a16="http://schemas.microsoft.com/office/drawing/2014/main" id="{56EC5F72-BB2C-4442-9CA3-C2FB735D29A1}"/>
+                <a16:creationId xmlns:a16="http://schemas.microsoft.com/office/drawing/2014/main" id="{7C2BFAE1-3138-4826-9BE2-00214F94AF1A}"/>
               </a:ext>
             </a:extLst>
           </p:cNvPr>
@@ -3052,7 +3052,7 @@
         <p:spPr>
           <a:xfrm xmlns:a="http://schemas.openxmlformats.org/drawingml/2006/main">
             <a:off x="3943350" y="4581525"/>
-            <a:ext cx="1409700" cy="457200"/>
+            <a:ext cx="1409700" cy="590550"/>
           </a:xfrm>
           <a:prstGeom xmlns:a="http://schemas.openxmlformats.org/drawingml/2006/main" prst="rect">
             <a:avLst/>
@@ -3090,7 +3090,7 @@
           <p:cNvPr id="17" name="">
             <a:extLst xmlns:a="http://schemas.openxmlformats.org/drawingml/2006/main">
               <a:ext uri="{FF2B5EF4-FFF2-40B4-BE49-F238E27FC236}">
-                <a16:creationId xmlns:a16="http://schemas.microsoft.com/office/drawing/2014/main" id="{24546426-ECD2-4029-8CF8-03583F1392AB}"/>
+                <a16:creationId xmlns:a16="http://schemas.microsoft.com/office/drawing/2014/main" id="{7DE1ED08-30D1-4C19-B353-33EA015F7F1B}"/>
               </a:ext>
             </a:extLst>
           </p:cNvPr>
@@ -3125,7 +3125,7 @@
           <p:cNvPr id="18" name="">
             <a:extLst xmlns:a="http://schemas.openxmlformats.org/drawingml/2006/main">
               <a:ext uri="{FF2B5EF4-FFF2-40B4-BE49-F238E27FC236}">
-                <a16:creationId xmlns:a16="http://schemas.microsoft.com/office/drawing/2014/main" id="{2B1BD577-D9EE-43BE-93E6-52691A5E3D03}"/>
+                <a16:creationId xmlns:a16="http://schemas.microsoft.com/office/drawing/2014/main" id="{28F68918-5884-4A7C-B5D2-69DAFCC9F56C}"/>
               </a:ext>
             </a:extLst>
           </p:cNvPr>
@@ -3175,7 +3175,7 @@
           <p:cNvPr id="19" name="">
             <a:extLst xmlns:a="http://schemas.openxmlformats.org/drawingml/2006/main">
               <a:ext uri="{FF2B5EF4-FFF2-40B4-BE49-F238E27FC236}">
-                <a16:creationId xmlns:a16="http://schemas.microsoft.com/office/drawing/2014/main" id="{F959B3D6-009A-4593-938A-E6A6EE0F369D}"/>
+                <a16:creationId xmlns:a16="http://schemas.microsoft.com/office/drawing/2014/main" id="{F3D5F5B2-B08C-443D-A148-E5EE6632B45E}"/>
               </a:ext>
             </a:extLst>
           </p:cNvPr>
@@ -3225,7 +3225,7 @@
           <p:cNvPr id="20" name="">
             <a:extLst xmlns:a="http://schemas.openxmlformats.org/drawingml/2006/main">
               <a:ext uri="{FF2B5EF4-FFF2-40B4-BE49-F238E27FC236}">
-                <a16:creationId xmlns:a16="http://schemas.microsoft.com/office/drawing/2014/main" id="{319A9822-B87E-4F1C-AB84-41DAB48C97FE}"/>
+                <a16:creationId xmlns:a16="http://schemas.microsoft.com/office/drawing/2014/main" id="{0BF2753C-3BAE-4E7A-AF2D-CEF3AFF02B0F}"/>
               </a:ext>
             </a:extLst>
           </p:cNvPr>
@@ -3275,7 +3275,7 @@
           <p:cNvPr id="21" name="">
             <a:extLst xmlns:a="http://schemas.openxmlformats.org/drawingml/2006/main">
               <a:ext uri="{FF2B5EF4-FFF2-40B4-BE49-F238E27FC236}">
-                <a16:creationId xmlns:a16="http://schemas.microsoft.com/office/drawing/2014/main" id="{A70B6DC7-C59A-44D7-B0EF-8F68E26287F2}"/>
+                <a16:creationId xmlns:a16="http://schemas.microsoft.com/office/drawing/2014/main" id="{8026175F-250F-4A94-84E9-75A3360A8BD7}"/>
               </a:ext>
             </a:extLst>
           </p:cNvPr>
@@ -3325,7 +3325,7 @@
           <p:cNvPr id="22" name="">
             <a:extLst xmlns:a="http://schemas.openxmlformats.org/drawingml/2006/main">
               <a:ext uri="{FF2B5EF4-FFF2-40B4-BE49-F238E27FC236}">
-                <a16:creationId xmlns:a16="http://schemas.microsoft.com/office/drawing/2014/main" id="{DC165ED1-0CA9-406B-8587-394ADA6253EC}"/>
+                <a16:creationId xmlns:a16="http://schemas.microsoft.com/office/drawing/2014/main" id="{6C468EAA-7034-490C-989E-22D480E32BC2}"/>
               </a:ext>
             </a:extLst>
           </p:cNvPr>
@@ -3356,7 +3356,7 @@
           <p:cNvPr id="23" name="">
             <a:extLst xmlns:a="http://schemas.openxmlformats.org/drawingml/2006/main">
               <a:ext uri="{FF2B5EF4-FFF2-40B4-BE49-F238E27FC236}">
-                <a16:creationId xmlns:a16="http://schemas.microsoft.com/office/drawing/2014/main" id="{E9257AB2-4C2C-47AF-A6E2-81EC169D9C43}"/>
+                <a16:creationId xmlns:a16="http://schemas.microsoft.com/office/drawing/2014/main" id="{233C6EF7-09CE-415E-9E93-C6C757640B8E}"/>
               </a:ext>
             </a:extLst>
           </p:cNvPr>
@@ -3406,7 +3406,7 @@
           <p:cNvPr id="24" name="">
             <a:extLst xmlns:a="http://schemas.openxmlformats.org/drawingml/2006/main">
               <a:ext uri="{FF2B5EF4-FFF2-40B4-BE49-F238E27FC236}">
-                <a16:creationId xmlns:a16="http://schemas.microsoft.com/office/drawing/2014/main" id="{94A4A9A0-0446-4191-B5ED-FA2E8FA45FB0}"/>
+                <a16:creationId xmlns:a16="http://schemas.microsoft.com/office/drawing/2014/main" id="{5EAA35B5-F9F8-4AC0-A895-ED301E8A4AF9}"/>
               </a:ext>
             </a:extLst>
           </p:cNvPr>
@@ -3456,7 +3456,7 @@
           <p:cNvPr id="25" name="">
             <a:extLst xmlns:a="http://schemas.openxmlformats.org/drawingml/2006/main">
               <a:ext uri="{FF2B5EF4-FFF2-40B4-BE49-F238E27FC236}">
-                <a16:creationId xmlns:a16="http://schemas.microsoft.com/office/drawing/2014/main" id="{0DE26834-12EF-4024-A0F7-00DAE44FD33D}"/>
+                <a16:creationId xmlns:a16="http://schemas.microsoft.com/office/drawing/2014/main" id="{73AE7810-06A9-42EA-A700-96C239A01740}"/>
               </a:ext>
             </a:extLst>
           </p:cNvPr>
@@ -3506,7 +3506,7 @@
           <p:cNvPr id="26" name="">
             <a:extLst xmlns:a="http://schemas.openxmlformats.org/drawingml/2006/main">
               <a:ext uri="{FF2B5EF4-FFF2-40B4-BE49-F238E27FC236}">
-                <a16:creationId xmlns:a16="http://schemas.microsoft.com/office/drawing/2014/main" id="{BEC024EB-4EDC-4ADD-99A9-A2BD2F79C5E2}"/>
+                <a16:creationId xmlns:a16="http://schemas.microsoft.com/office/drawing/2014/main" id="{D22B4C97-7239-448F-8983-045C9A9B1636}"/>
               </a:ext>
             </a:extLst>
           </p:cNvPr>
@@ -3537,7 +3537,7 @@
           <p:cNvPr id="27" name="">
             <a:extLst xmlns:a="http://schemas.openxmlformats.org/drawingml/2006/main">
               <a:ext uri="{FF2B5EF4-FFF2-40B4-BE49-F238E27FC236}">
-                <a16:creationId xmlns:a16="http://schemas.microsoft.com/office/drawing/2014/main" id="{26BDC3D0-69DD-42CF-9006-018FCECD82CD}"/>
+                <a16:creationId xmlns:a16="http://schemas.microsoft.com/office/drawing/2014/main" id="{911EDDD5-CFBA-4FA9-A197-67D942FCEE11}"/>
               </a:ext>
             </a:extLst>
           </p:cNvPr>
@@ -3587,7 +3587,7 @@
           <p:cNvPr id="28" name="">
             <a:extLst xmlns:a="http://schemas.openxmlformats.org/drawingml/2006/main">
               <a:ext uri="{FF2B5EF4-FFF2-40B4-BE49-F238E27FC236}">
-                <a16:creationId xmlns:a16="http://schemas.microsoft.com/office/drawing/2014/main" id="{10CD3E01-C051-4AEE-95CB-7793E2A1F881}"/>
+                <a16:creationId xmlns:a16="http://schemas.microsoft.com/office/drawing/2014/main" id="{6C697E01-B51C-45DD-8C50-502275E859A7}"/>
               </a:ext>
             </a:extLst>
           </p:cNvPr>
@@ -3637,7 +3637,7 @@
           <p:cNvPr id="29" name="">
             <a:extLst xmlns:a="http://schemas.openxmlformats.org/drawingml/2006/main">
               <a:ext uri="{FF2B5EF4-FFF2-40B4-BE49-F238E27FC236}">
-                <a16:creationId xmlns:a16="http://schemas.microsoft.com/office/drawing/2014/main" id="{F610E6FD-6258-4443-AF38-9B79A789AF53}"/>
+                <a16:creationId xmlns:a16="http://schemas.microsoft.com/office/drawing/2014/main" id="{F8B4D951-5B94-45E7-9BC5-9F8FCC12235B}"/>
               </a:ext>
             </a:extLst>
           </p:cNvPr>
@@ -3687,7 +3687,7 @@
           <p:cNvPr id="30" name="">
             <a:extLst xmlns:a="http://schemas.openxmlformats.org/drawingml/2006/main">
               <a:ext uri="{FF2B5EF4-FFF2-40B4-BE49-F238E27FC236}">
-                <a16:creationId xmlns:a16="http://schemas.microsoft.com/office/drawing/2014/main" id="{E46A2E93-2CFA-4173-AF77-C49AFDEA09D5}"/>
+                <a16:creationId xmlns:a16="http://schemas.microsoft.com/office/drawing/2014/main" id="{0A162806-3C25-4C29-A11B-62212FD6D1E0}"/>
               </a:ext>
             </a:extLst>
           </p:cNvPr>
@@ -3718,7 +3718,7 @@
           <p:cNvPr id="31" name="">
             <a:extLst xmlns:a="http://schemas.openxmlformats.org/drawingml/2006/main">
               <a:ext uri="{FF2B5EF4-FFF2-40B4-BE49-F238E27FC236}">
-                <a16:creationId xmlns:a16="http://schemas.microsoft.com/office/drawing/2014/main" id="{93990E01-68CF-4C95-8D5F-C04D7C77EEE8}"/>
+                <a16:creationId xmlns:a16="http://schemas.microsoft.com/office/drawing/2014/main" id="{2D303E68-9379-437C-89CD-624C18E43280}"/>
               </a:ext>
             </a:extLst>
           </p:cNvPr>
@@ -3768,7 +3768,7 @@
           <p:cNvPr id="32" name="">
             <a:extLst xmlns:a="http://schemas.openxmlformats.org/drawingml/2006/main">
               <a:ext uri="{FF2B5EF4-FFF2-40B4-BE49-F238E27FC236}">
-                <a16:creationId xmlns:a16="http://schemas.microsoft.com/office/drawing/2014/main" id="{237CB0BA-9EB9-4AC8-8992-AFF346118397}"/>
+                <a16:creationId xmlns:a16="http://schemas.microsoft.com/office/drawing/2014/main" id="{B35A2B8F-D73C-4F78-A73C-041B531C153F}"/>
               </a:ext>
             </a:extLst>
           </p:cNvPr>
@@ -3818,7 +3818,7 @@
           <p:cNvPr id="33" name="">
             <a:extLst xmlns:a="http://schemas.openxmlformats.org/drawingml/2006/main">
               <a:ext uri="{FF2B5EF4-FFF2-40B4-BE49-F238E27FC236}">
-                <a16:creationId xmlns:a16="http://schemas.microsoft.com/office/drawing/2014/main" id="{DB29E605-FD56-4E80-8DE9-B4136A9C45A1}"/>
+                <a16:creationId xmlns:a16="http://schemas.microsoft.com/office/drawing/2014/main" id="{3AB26118-4D14-467B-8094-645569EB54C7}"/>
               </a:ext>
             </a:extLst>
           </p:cNvPr>
@@ -3866,7 +3866,7 @@
     </p:spTree>
     <p:extLst>
       <p:ext uri="{BB962C8B-B14F-4D97-AF65-F5344CB8AC3E}">
-        <p14:creationId xmlns:p14="http://schemas.microsoft.com/office/powerpoint/2010/main" val="196811501"/>
+        <p14:creationId xmlns:p14="http://schemas.microsoft.com/office/powerpoint/2010/main" val="813448134"/>
       </p:ext>
     </p:extLst>
   </p:cSld>
@@ -3897,7 +3897,7 @@
           <p:cNvPr id="1" name="">
             <a:extLst xmlns:a="http://schemas.openxmlformats.org/drawingml/2006/main">
               <a:ext uri="{FF2B5EF4-FFF2-40B4-BE49-F238E27FC236}">
-                <a16:creationId xmlns:a16="http://schemas.microsoft.com/office/drawing/2014/main" id="{19A562A5-76AC-4246-9C99-330B4E9AE35F}"/>
+                <a16:creationId xmlns:a16="http://schemas.microsoft.com/office/drawing/2014/main" id="{7E1D6E64-608E-4AFE-A247-5F75C72A995F}"/>
               </a:ext>
             </a:extLst>
           </p:cNvPr>
@@ -3932,7 +3932,7 @@
           <p:nvPr/>
         </p:nvPicPr>
         <p:blipFill>
-          <a:blip xmlns:r="http://schemas.openxmlformats.org/officeDocument/2006/relationships" xmlns:a="http://schemas.openxmlformats.org/drawingml/2006/main" r:embed="R72fba05296b84ecf"/>
+          <a:blip xmlns:r="http://schemas.openxmlformats.org/officeDocument/2006/relationships" xmlns:a="http://schemas.openxmlformats.org/drawingml/2006/main" r:embed="Rd69feda7fd6943ec"/>
           <a:stretch xmlns:a="http://schemas.openxmlformats.org/drawingml/2006/main"/>
         </p:blipFill>
         <p:spPr>
@@ -3950,7 +3950,7 @@
           <p:cNvPr id="3" name="">
             <a:extLst xmlns:a="http://schemas.openxmlformats.org/drawingml/2006/main">
               <a:ext uri="{FF2B5EF4-FFF2-40B4-BE49-F238E27FC236}">
-                <a16:creationId xmlns:a16="http://schemas.microsoft.com/office/drawing/2014/main" id="{9B200513-1008-42CA-A253-F1AF7B6BD8CC}"/>
+                <a16:creationId xmlns:a16="http://schemas.microsoft.com/office/drawing/2014/main" id="{B147EF62-ED3D-4623-9377-625342315484}"/>
               </a:ext>
             </a:extLst>
           </p:cNvPr>
@@ -4000,7 +4000,7 @@
           <p:cNvPr id="4" name="">
             <a:extLst xmlns:a="http://schemas.openxmlformats.org/drawingml/2006/main">
               <a:ext uri="{FF2B5EF4-FFF2-40B4-BE49-F238E27FC236}">
-                <a16:creationId xmlns:a16="http://schemas.microsoft.com/office/drawing/2014/main" id="{438D1F86-C449-4EB9-B81A-9AEBFD913582}"/>
+                <a16:creationId xmlns:a16="http://schemas.microsoft.com/office/drawing/2014/main" id="{5665F893-252F-4A5F-A005-56C3A47A973D}"/>
               </a:ext>
             </a:extLst>
           </p:cNvPr>
@@ -4033,7 +4033,7 @@
           <p:cNvPr id="5" name="">
             <a:extLst xmlns:a="http://schemas.openxmlformats.org/drawingml/2006/main">
               <a:ext uri="{FF2B5EF4-FFF2-40B4-BE49-F238E27FC236}">
-                <a16:creationId xmlns:a16="http://schemas.microsoft.com/office/drawing/2014/main" id="{5BB73C3B-11BA-4B52-9FBB-3E5CC01EC7DC}"/>
+                <a16:creationId xmlns:a16="http://schemas.microsoft.com/office/drawing/2014/main" id="{3A7853B1-DDB0-493F-81A4-16B860C972AF}"/>
               </a:ext>
             </a:extLst>
           </p:cNvPr>
@@ -4064,7 +4064,7 @@
           <p:cNvPr id="6" name="">
             <a:extLst xmlns:a="http://schemas.openxmlformats.org/drawingml/2006/main">
               <a:ext uri="{FF2B5EF4-FFF2-40B4-BE49-F238E27FC236}">
-                <a16:creationId xmlns:a16="http://schemas.microsoft.com/office/drawing/2014/main" id="{FE3EA4C1-EB60-4F81-BF8D-79FDA5B1FCC7}"/>
+                <a16:creationId xmlns:a16="http://schemas.microsoft.com/office/drawing/2014/main" id="{BB9878FC-CCBE-4C2B-B2AD-D3640DD02352}"/>
               </a:ext>
             </a:extLst>
           </p:cNvPr>
@@ -4114,7 +4114,7 @@
           <p:cNvPr id="7" name="">
             <a:extLst xmlns:a="http://schemas.openxmlformats.org/drawingml/2006/main">
               <a:ext uri="{FF2B5EF4-FFF2-40B4-BE49-F238E27FC236}">
-                <a16:creationId xmlns:a16="http://schemas.microsoft.com/office/drawing/2014/main" id="{CBE148B4-286C-4288-9EDE-93AAB92F7893}"/>
+                <a16:creationId xmlns:a16="http://schemas.microsoft.com/office/drawing/2014/main" id="{B30A6BA6-E05C-4925-88BC-7734AD2F85FF}"/>
               </a:ext>
             </a:extLst>
           </p:cNvPr>
@@ -4164,7 +4164,7 @@
           <p:cNvPr id="8" name="">
             <a:extLst xmlns:a="http://schemas.openxmlformats.org/drawingml/2006/main">
               <a:ext uri="{FF2B5EF4-FFF2-40B4-BE49-F238E27FC236}">
-                <a16:creationId xmlns:a16="http://schemas.microsoft.com/office/drawing/2014/main" id="{707D2972-4C8D-47C3-9E1E-F35204D32197}"/>
+                <a16:creationId xmlns:a16="http://schemas.microsoft.com/office/drawing/2014/main" id="{6669804A-ED5F-443E-950D-63998CEF43BC}"/>
               </a:ext>
             </a:extLst>
           </p:cNvPr>
@@ -4214,7 +4214,7 @@
           <p:cNvPr id="9" name="">
             <a:extLst xmlns:a="http://schemas.openxmlformats.org/drawingml/2006/main">
               <a:ext uri="{FF2B5EF4-FFF2-40B4-BE49-F238E27FC236}">
-                <a16:creationId xmlns:a16="http://schemas.microsoft.com/office/drawing/2014/main" id="{B5301629-490E-4491-874C-DE46AAD1801F}"/>
+                <a16:creationId xmlns:a16="http://schemas.microsoft.com/office/drawing/2014/main" id="{9DC4F9E1-FAC3-453C-AF65-A3156B1A0F4A}"/>
               </a:ext>
             </a:extLst>
           </p:cNvPr>
@@ -4264,7 +4264,7 @@
           <p:cNvPr id="10" name="">
             <a:extLst xmlns:a="http://schemas.openxmlformats.org/drawingml/2006/main">
               <a:ext uri="{FF2B5EF4-FFF2-40B4-BE49-F238E27FC236}">
-                <a16:creationId xmlns:a16="http://schemas.microsoft.com/office/drawing/2014/main" id="{787E667C-20E8-4F3B-B9B7-F391493C8219}"/>
+                <a16:creationId xmlns:a16="http://schemas.microsoft.com/office/drawing/2014/main" id="{AD83A6F7-818B-469B-907D-A9A9FCD61B0D}"/>
               </a:ext>
             </a:extLst>
           </p:cNvPr>
@@ -4314,7 +4314,7 @@
           <p:cNvPr id="11" name="">
             <a:extLst xmlns:a="http://schemas.openxmlformats.org/drawingml/2006/main">
               <a:ext uri="{FF2B5EF4-FFF2-40B4-BE49-F238E27FC236}">
-                <a16:creationId xmlns:a16="http://schemas.microsoft.com/office/drawing/2014/main" id="{7DFB03C3-ACAB-4538-9A98-0019D5FC139F}"/>
+                <a16:creationId xmlns:a16="http://schemas.microsoft.com/office/drawing/2014/main" id="{10AB61FB-B52B-4F6F-9945-6679B2F2108A}"/>
               </a:ext>
             </a:extLst>
           </p:cNvPr>
@@ -4345,7 +4345,7 @@
           <p:cNvPr id="12" name="">
             <a:extLst xmlns:a="http://schemas.openxmlformats.org/drawingml/2006/main">
               <a:ext uri="{FF2B5EF4-FFF2-40B4-BE49-F238E27FC236}">
-                <a16:creationId xmlns:a16="http://schemas.microsoft.com/office/drawing/2014/main" id="{4ADE68DA-1303-4FEB-9990-5E6E9A205672}"/>
+                <a16:creationId xmlns:a16="http://schemas.microsoft.com/office/drawing/2014/main" id="{D0E48DDB-4657-4AA8-B123-1DD3E0CD4855}"/>
               </a:ext>
             </a:extLst>
           </p:cNvPr>
@@ -4395,7 +4395,7 @@
           <p:cNvPr id="13" name="">
             <a:extLst xmlns:a="http://schemas.openxmlformats.org/drawingml/2006/main">
               <a:ext uri="{FF2B5EF4-FFF2-40B4-BE49-F238E27FC236}">
-                <a16:creationId xmlns:a16="http://schemas.microsoft.com/office/drawing/2014/main" id="{A552E58C-6BC8-49DA-AEC5-D4709C606671}"/>
+                <a16:creationId xmlns:a16="http://schemas.microsoft.com/office/drawing/2014/main" id="{66139BD5-0DA7-48E4-A6AB-90D59403F6AD}"/>
               </a:ext>
             </a:extLst>
           </p:cNvPr>
@@ -4445,7 +4445,7 @@
           <p:cNvPr id="14" name="">
             <a:extLst xmlns:a="http://schemas.openxmlformats.org/drawingml/2006/main">
               <a:ext uri="{FF2B5EF4-FFF2-40B4-BE49-F238E27FC236}">
-                <a16:creationId xmlns:a16="http://schemas.microsoft.com/office/drawing/2014/main" id="{99F91F5E-DB8D-415C-B94E-27696FA2CB65}"/>
+                <a16:creationId xmlns:a16="http://schemas.microsoft.com/office/drawing/2014/main" id="{2BC63F8A-FE3A-43EF-BDC1-F97F168EB9EA}"/>
               </a:ext>
             </a:extLst>
           </p:cNvPr>
@@ -4476,7 +4476,7 @@
           <p:cNvPr id="15" name="">
             <a:extLst xmlns:a="http://schemas.openxmlformats.org/drawingml/2006/main">
               <a:ext uri="{FF2B5EF4-FFF2-40B4-BE49-F238E27FC236}">
-                <a16:creationId xmlns:a16="http://schemas.microsoft.com/office/drawing/2014/main" id="{30CE35FA-37C8-495A-8F68-0DC630698985}"/>
+                <a16:creationId xmlns:a16="http://schemas.microsoft.com/office/drawing/2014/main" id="{241A7983-BE2C-4D78-8BF6-DE80EED9DAA4}"/>
               </a:ext>
             </a:extLst>
           </p:cNvPr>
@@ -4526,7 +4526,7 @@
           <p:cNvPr id="16" name="">
             <a:extLst xmlns:a="http://schemas.openxmlformats.org/drawingml/2006/main">
               <a:ext uri="{FF2B5EF4-FFF2-40B4-BE49-F238E27FC236}">
-                <a16:creationId xmlns:a16="http://schemas.microsoft.com/office/drawing/2014/main" id="{717F2828-C54A-4C49-8674-C3BA507EB717}"/>
+                <a16:creationId xmlns:a16="http://schemas.microsoft.com/office/drawing/2014/main" id="{CC2AFF33-EF11-439E-B4B3-475D8CF841DE}"/>
               </a:ext>
             </a:extLst>
           </p:cNvPr>
@@ -4576,7 +4576,7 @@
           <p:cNvPr id="17" name="">
             <a:extLst xmlns:a="http://schemas.openxmlformats.org/drawingml/2006/main">
               <a:ext uri="{FF2B5EF4-FFF2-40B4-BE49-F238E27FC236}">
-                <a16:creationId xmlns:a16="http://schemas.microsoft.com/office/drawing/2014/main" id="{4E6CF8BF-BE19-434B-88BB-C01886D2099C}"/>
+                <a16:creationId xmlns:a16="http://schemas.microsoft.com/office/drawing/2014/main" id="{988C559B-0890-4D5C-9D2E-772B1BB88ABF}"/>
               </a:ext>
             </a:extLst>
           </p:cNvPr>
@@ -4607,7 +4607,7 @@
           <p:cNvPr id="18" name="">
             <a:extLst xmlns:a="http://schemas.openxmlformats.org/drawingml/2006/main">
               <a:ext uri="{FF2B5EF4-FFF2-40B4-BE49-F238E27FC236}">
-                <a16:creationId xmlns:a16="http://schemas.microsoft.com/office/drawing/2014/main" id="{A8F280A4-D807-40C2-B6A4-390BC5AAC94A}"/>
+                <a16:creationId xmlns:a16="http://schemas.microsoft.com/office/drawing/2014/main" id="{B29BCFE9-16D9-4DA3-89F0-BF77CB8FAF3F}"/>
               </a:ext>
             </a:extLst>
           </p:cNvPr>
@@ -4657,7 +4657,7 @@
           <p:cNvPr id="19" name="">
             <a:extLst xmlns:a="http://schemas.openxmlformats.org/drawingml/2006/main">
               <a:ext uri="{FF2B5EF4-FFF2-40B4-BE49-F238E27FC236}">
-                <a16:creationId xmlns:a16="http://schemas.microsoft.com/office/drawing/2014/main" id="{66B5B0B7-FA7B-4F59-89E3-AC2FC4135891}"/>
+                <a16:creationId xmlns:a16="http://schemas.microsoft.com/office/drawing/2014/main" id="{DDB33183-991E-48EB-BA51-DF3714D0E4F8}"/>
               </a:ext>
             </a:extLst>
           </p:cNvPr>
@@ -4705,7 +4705,7 @@
     </p:spTree>
     <p:extLst>
       <p:ext uri="{BB962C8B-B14F-4D97-AF65-F5344CB8AC3E}">
-        <p14:creationId xmlns:p14="http://schemas.microsoft.com/office/powerpoint/2010/main" val="2126475281"/>
+        <p14:creationId xmlns:p14="http://schemas.microsoft.com/office/powerpoint/2010/main" val="1619790579"/>
       </p:ext>
     </p:extLst>
   </p:cSld>
@@ -4736,7 +4736,7 @@
           <p:cNvPr id="1" name="">
             <a:extLst xmlns:a="http://schemas.openxmlformats.org/drawingml/2006/main">
               <a:ext uri="{FF2B5EF4-FFF2-40B4-BE49-F238E27FC236}">
-                <a16:creationId xmlns:a16="http://schemas.microsoft.com/office/drawing/2014/main" id="{E9335260-11A3-475C-8EC0-F1E4FC4C7CE5}"/>
+                <a16:creationId xmlns:a16="http://schemas.microsoft.com/office/drawing/2014/main" id="{B781270B-2F8B-4360-8272-8E6569538146}"/>
               </a:ext>
             </a:extLst>
           </p:cNvPr>
@@ -4771,7 +4771,7 @@
           <p:nvPr/>
         </p:nvPicPr>
         <p:blipFill>
-          <a:blip xmlns:r="http://schemas.openxmlformats.org/officeDocument/2006/relationships" xmlns:a="http://schemas.openxmlformats.org/drawingml/2006/main" r:embed="R855aab4df3404303"/>
+          <a:blip xmlns:r="http://schemas.openxmlformats.org/officeDocument/2006/relationships" xmlns:a="http://schemas.openxmlformats.org/drawingml/2006/main" r:embed="R86c6408cb75e4985"/>
           <a:stretch xmlns:a="http://schemas.openxmlformats.org/drawingml/2006/main"/>
         </p:blipFill>
         <p:spPr>
@@ -4789,7 +4789,7 @@
           <p:cNvPr id="3" name="">
             <a:extLst xmlns:a="http://schemas.openxmlformats.org/drawingml/2006/main">
               <a:ext uri="{FF2B5EF4-FFF2-40B4-BE49-F238E27FC236}">
-                <a16:creationId xmlns:a16="http://schemas.microsoft.com/office/drawing/2014/main" id="{69EF18F7-41AF-442B-A97B-18563ACA983A}"/>
+                <a16:creationId xmlns:a16="http://schemas.microsoft.com/office/drawing/2014/main" id="{99E6BB26-0D9A-43D1-AA44-D51E315D0BE5}"/>
               </a:ext>
             </a:extLst>
           </p:cNvPr>
@@ -4839,7 +4839,7 @@
           <p:cNvPr id="4" name="">
             <a:extLst xmlns:a="http://schemas.openxmlformats.org/drawingml/2006/main">
               <a:ext uri="{FF2B5EF4-FFF2-40B4-BE49-F238E27FC236}">
-                <a16:creationId xmlns:a16="http://schemas.microsoft.com/office/drawing/2014/main" id="{D1321E1E-3DB9-462D-9C43-3C192F377B0B}"/>
+                <a16:creationId xmlns:a16="http://schemas.microsoft.com/office/drawing/2014/main" id="{2C9FD7CC-A67C-4979-BE84-E41C18FB6BD9}"/>
               </a:ext>
             </a:extLst>
           </p:cNvPr>
@@ -4872,7 +4872,7 @@
           <p:cNvPr id="5" name="">
             <a:extLst xmlns:a="http://schemas.openxmlformats.org/drawingml/2006/main">
               <a:ext uri="{FF2B5EF4-FFF2-40B4-BE49-F238E27FC236}">
-                <a16:creationId xmlns:a16="http://schemas.microsoft.com/office/drawing/2014/main" id="{B8EF3F11-ADD8-4A6B-9514-BF405788268F}"/>
+                <a16:creationId xmlns:a16="http://schemas.microsoft.com/office/drawing/2014/main" id="{72E69065-8836-4BA2-B975-5147CE9184A2}"/>
               </a:ext>
             </a:extLst>
           </p:cNvPr>
@@ -4903,7 +4903,7 @@
           <p:cNvPr id="6" name="">
             <a:extLst xmlns:a="http://schemas.openxmlformats.org/drawingml/2006/main">
               <a:ext uri="{FF2B5EF4-FFF2-40B4-BE49-F238E27FC236}">
-                <a16:creationId xmlns:a16="http://schemas.microsoft.com/office/drawing/2014/main" id="{8262C9D0-92C2-454E-A20D-4643D70D87AE}"/>
+                <a16:creationId xmlns:a16="http://schemas.microsoft.com/office/drawing/2014/main" id="{AED69761-CF64-412B-9D81-1A7CC912FA4A}"/>
               </a:ext>
             </a:extLst>
           </p:cNvPr>
@@ -4953,7 +4953,7 @@
           <p:cNvPr id="7" name="">
             <a:extLst xmlns:a="http://schemas.openxmlformats.org/drawingml/2006/main">
               <a:ext uri="{FF2B5EF4-FFF2-40B4-BE49-F238E27FC236}">
-                <a16:creationId xmlns:a16="http://schemas.microsoft.com/office/drawing/2014/main" id="{D51715F2-7826-455E-950B-6842B0B7D212}"/>
+                <a16:creationId xmlns:a16="http://schemas.microsoft.com/office/drawing/2014/main" id="{87D6965A-9BA4-47B6-AD8C-D9F30D2F7AEC}"/>
               </a:ext>
             </a:extLst>
           </p:cNvPr>
@@ -5003,7 +5003,7 @@
           <p:cNvPr id="8" name="">
             <a:extLst xmlns:a="http://schemas.openxmlformats.org/drawingml/2006/main">
               <a:ext uri="{FF2B5EF4-FFF2-40B4-BE49-F238E27FC236}">
-                <a16:creationId xmlns:a16="http://schemas.microsoft.com/office/drawing/2014/main" id="{B93F575F-1905-4815-ABD4-57E47BA96A7E}"/>
+                <a16:creationId xmlns:a16="http://schemas.microsoft.com/office/drawing/2014/main" id="{4221C610-9E71-48B9-A384-67E29DCCD516}"/>
               </a:ext>
             </a:extLst>
           </p:cNvPr>
@@ -5038,7 +5038,7 @@
           <p:cNvPr id="9" name="">
             <a:extLst xmlns:a="http://schemas.openxmlformats.org/drawingml/2006/main">
               <a:ext uri="{FF2B5EF4-FFF2-40B4-BE49-F238E27FC236}">
-                <a16:creationId xmlns:a16="http://schemas.microsoft.com/office/drawing/2014/main" id="{5C561594-3777-48DA-A0EE-F8D7359A3F42}"/>
+                <a16:creationId xmlns:a16="http://schemas.microsoft.com/office/drawing/2014/main" id="{000E7E47-D393-45C9-9B1E-C5AA88BFBDA8}"/>
               </a:ext>
             </a:extLst>
           </p:cNvPr>
@@ -5088,7 +5088,7 @@
           <p:cNvPr id="10" name="">
             <a:extLst xmlns:a="http://schemas.openxmlformats.org/drawingml/2006/main">
               <a:ext uri="{FF2B5EF4-FFF2-40B4-BE49-F238E27FC236}">
-                <a16:creationId xmlns:a16="http://schemas.microsoft.com/office/drawing/2014/main" id="{1040EDE1-2932-48BB-A8F3-0B29189F5EAF}"/>
+                <a16:creationId xmlns:a16="http://schemas.microsoft.com/office/drawing/2014/main" id="{67EE0111-B702-42CE-86DF-5DE638263970}"/>
               </a:ext>
             </a:extLst>
           </p:cNvPr>
@@ -5138,7 +5138,7 @@
           <p:cNvPr id="11" name="">
             <a:extLst xmlns:a="http://schemas.openxmlformats.org/drawingml/2006/main">
               <a:ext uri="{FF2B5EF4-FFF2-40B4-BE49-F238E27FC236}">
-                <a16:creationId xmlns:a16="http://schemas.microsoft.com/office/drawing/2014/main" id="{A557A13A-BCFC-448B-B1DE-216CD2152E5E}"/>
+                <a16:creationId xmlns:a16="http://schemas.microsoft.com/office/drawing/2014/main" id="{DE59876C-46F3-4C04-A68B-45ED3550B50F}"/>
               </a:ext>
             </a:extLst>
           </p:cNvPr>
@@ -5173,7 +5173,7 @@
           <p:cNvPr id="12" name="">
             <a:extLst xmlns:a="http://schemas.openxmlformats.org/drawingml/2006/main">
               <a:ext uri="{FF2B5EF4-FFF2-40B4-BE49-F238E27FC236}">
-                <a16:creationId xmlns:a16="http://schemas.microsoft.com/office/drawing/2014/main" id="{226EABA4-B230-4903-8BFD-69E18662202A}"/>
+                <a16:creationId xmlns:a16="http://schemas.microsoft.com/office/drawing/2014/main" id="{50313A14-9D02-4C60-840F-AC0F59A76602}"/>
               </a:ext>
             </a:extLst>
           </p:cNvPr>
@@ -5223,7 +5223,7 @@
           <p:cNvPr id="13" name="">
             <a:extLst xmlns:a="http://schemas.openxmlformats.org/drawingml/2006/main">
               <a:ext uri="{FF2B5EF4-FFF2-40B4-BE49-F238E27FC236}">
-                <a16:creationId xmlns:a16="http://schemas.microsoft.com/office/drawing/2014/main" id="{06056447-84C6-4F31-9585-478AA6B20D3C}"/>
+                <a16:creationId xmlns:a16="http://schemas.microsoft.com/office/drawing/2014/main" id="{E3101F3F-C3A4-4C96-8935-D1FC025F04AF}"/>
               </a:ext>
             </a:extLst>
           </p:cNvPr>
@@ -5273,7 +5273,7 @@
           <p:cNvPr id="14" name="">
             <a:extLst xmlns:a="http://schemas.openxmlformats.org/drawingml/2006/main">
               <a:ext uri="{FF2B5EF4-FFF2-40B4-BE49-F238E27FC236}">
-                <a16:creationId xmlns:a16="http://schemas.microsoft.com/office/drawing/2014/main" id="{192B5532-3DBA-4E3F-BF6B-A447430A0998}"/>
+                <a16:creationId xmlns:a16="http://schemas.microsoft.com/office/drawing/2014/main" id="{08C199D8-E5E1-4703-9AC2-1890A87B0669}"/>
               </a:ext>
             </a:extLst>
           </p:cNvPr>
@@ -5308,7 +5308,7 @@
           <p:cNvPr id="15" name="">
             <a:extLst xmlns:a="http://schemas.openxmlformats.org/drawingml/2006/main">
               <a:ext uri="{FF2B5EF4-FFF2-40B4-BE49-F238E27FC236}">
-                <a16:creationId xmlns:a16="http://schemas.microsoft.com/office/drawing/2014/main" id="{50A50B21-4C1D-4C55-AF20-FBE282E787A7}"/>
+                <a16:creationId xmlns:a16="http://schemas.microsoft.com/office/drawing/2014/main" id="{7450AB77-F8F9-447B-AE62-0B4B89D9C1F7}"/>
               </a:ext>
             </a:extLst>
           </p:cNvPr>
@@ -5358,7 +5358,7 @@
           <p:cNvPr id="16" name="">
             <a:extLst xmlns:a="http://schemas.openxmlformats.org/drawingml/2006/main">
               <a:ext uri="{FF2B5EF4-FFF2-40B4-BE49-F238E27FC236}">
-                <a16:creationId xmlns:a16="http://schemas.microsoft.com/office/drawing/2014/main" id="{DEF8E04D-75E3-4C00-BA94-3E5C864003CF}"/>
+                <a16:creationId xmlns:a16="http://schemas.microsoft.com/office/drawing/2014/main" id="{148E5812-35FE-4DF8-A779-4F8C3FF53092}"/>
               </a:ext>
             </a:extLst>
           </p:cNvPr>
@@ -5408,7 +5408,7 @@
           <p:cNvPr id="17" name="">
             <a:extLst xmlns:a="http://schemas.openxmlformats.org/drawingml/2006/main">
               <a:ext uri="{FF2B5EF4-FFF2-40B4-BE49-F238E27FC236}">
-                <a16:creationId xmlns:a16="http://schemas.microsoft.com/office/drawing/2014/main" id="{2B2568FB-1057-449C-ADB1-D445E283DFF9}"/>
+                <a16:creationId xmlns:a16="http://schemas.microsoft.com/office/drawing/2014/main" id="{98D54E86-CBB4-41B3-A3CC-05A280288067}"/>
               </a:ext>
             </a:extLst>
           </p:cNvPr>
@@ -5443,7 +5443,7 @@
           <p:cNvPr id="18" name="">
             <a:extLst xmlns:a="http://schemas.openxmlformats.org/drawingml/2006/main">
               <a:ext uri="{FF2B5EF4-FFF2-40B4-BE49-F238E27FC236}">
-                <a16:creationId xmlns:a16="http://schemas.microsoft.com/office/drawing/2014/main" id="{8EAE35B9-6210-4747-9D1C-6F459B46796A}"/>
+                <a16:creationId xmlns:a16="http://schemas.microsoft.com/office/drawing/2014/main" id="{D28DA4D9-E368-44C2-AD43-F8895BEC4D42}"/>
               </a:ext>
             </a:extLst>
           </p:cNvPr>
@@ -5493,7 +5493,7 @@
           <p:cNvPr id="19" name="">
             <a:extLst xmlns:a="http://schemas.openxmlformats.org/drawingml/2006/main">
               <a:ext uri="{FF2B5EF4-FFF2-40B4-BE49-F238E27FC236}">
-                <a16:creationId xmlns:a16="http://schemas.microsoft.com/office/drawing/2014/main" id="{9BBE6399-4846-4930-9B17-7D2473C110DE}"/>
+                <a16:creationId xmlns:a16="http://schemas.microsoft.com/office/drawing/2014/main" id="{21CBAB27-837E-43F8-9FDF-FA04EC1FD9F6}"/>
               </a:ext>
             </a:extLst>
           </p:cNvPr>
@@ -5543,7 +5543,7 @@
           <p:cNvPr id="20" name="">
             <a:extLst xmlns:a="http://schemas.openxmlformats.org/drawingml/2006/main">
               <a:ext uri="{FF2B5EF4-FFF2-40B4-BE49-F238E27FC236}">
-                <a16:creationId xmlns:a16="http://schemas.microsoft.com/office/drawing/2014/main" id="{15D362A3-52A9-4C50-ABE9-C359F20723C8}"/>
+                <a16:creationId xmlns:a16="http://schemas.microsoft.com/office/drawing/2014/main" id="{7151DD97-AF39-4FD3-A673-427AED88EA6C}"/>
               </a:ext>
             </a:extLst>
           </p:cNvPr>
@@ -5593,7 +5593,7 @@
           <p:cNvPr id="21" name="">
             <a:extLst xmlns:a="http://schemas.openxmlformats.org/drawingml/2006/main">
               <a:ext uri="{FF2B5EF4-FFF2-40B4-BE49-F238E27FC236}">
-                <a16:creationId xmlns:a16="http://schemas.microsoft.com/office/drawing/2014/main" id="{023FB0B4-1596-4422-930E-5014B96DC695}"/>
+                <a16:creationId xmlns:a16="http://schemas.microsoft.com/office/drawing/2014/main" id="{175721AA-0AED-4F0D-A665-B7546897B9E3}"/>
               </a:ext>
             </a:extLst>
           </p:cNvPr>
@@ -5643,7 +5643,7 @@
           <p:cNvPr id="22" name="">
             <a:extLst xmlns:a="http://schemas.openxmlformats.org/drawingml/2006/main">
               <a:ext uri="{FF2B5EF4-FFF2-40B4-BE49-F238E27FC236}">
-                <a16:creationId xmlns:a16="http://schemas.microsoft.com/office/drawing/2014/main" id="{C5739F65-C103-448F-93DA-467D5DD60130}"/>
+                <a16:creationId xmlns:a16="http://schemas.microsoft.com/office/drawing/2014/main" id="{23F7E3C9-34CC-4096-92DF-EE2D8CB627F8}"/>
               </a:ext>
             </a:extLst>
           </p:cNvPr>
@@ -5693,7 +5693,7 @@
           <p:cNvPr id="23" name="">
             <a:extLst xmlns:a="http://schemas.openxmlformats.org/drawingml/2006/main">
               <a:ext uri="{FF2B5EF4-FFF2-40B4-BE49-F238E27FC236}">
-                <a16:creationId xmlns:a16="http://schemas.microsoft.com/office/drawing/2014/main" id="{CE693665-A95F-4736-AF1E-CECCA3ED230D}"/>
+                <a16:creationId xmlns:a16="http://schemas.microsoft.com/office/drawing/2014/main" id="{87AC026C-244B-4187-9B90-519CA882D2B0}"/>
               </a:ext>
             </a:extLst>
           </p:cNvPr>
@@ -5726,7 +5726,7 @@
           <p:cNvPr id="24" name="">
             <a:extLst xmlns:a="http://schemas.openxmlformats.org/drawingml/2006/main">
               <a:ext uri="{FF2B5EF4-FFF2-40B4-BE49-F238E27FC236}">
-                <a16:creationId xmlns:a16="http://schemas.microsoft.com/office/drawing/2014/main" id="{B44CD6B7-0C5F-4905-9958-F1B4B0E03382}"/>
+                <a16:creationId xmlns:a16="http://schemas.microsoft.com/office/drawing/2014/main" id="{60DA643A-DEE3-41D6-98E6-1DB69A36D059}"/>
               </a:ext>
             </a:extLst>
           </p:cNvPr>
@@ -5776,7 +5776,7 @@
           <p:cNvPr id="25" name="">
             <a:extLst xmlns:a="http://schemas.openxmlformats.org/drawingml/2006/main">
               <a:ext uri="{FF2B5EF4-FFF2-40B4-BE49-F238E27FC236}">
-                <a16:creationId xmlns:a16="http://schemas.microsoft.com/office/drawing/2014/main" id="{C378CB72-4E61-4150-A58B-F344A05CB460}"/>
+                <a16:creationId xmlns:a16="http://schemas.microsoft.com/office/drawing/2014/main" id="{5B98BAA0-B8E3-4174-9834-90B04BF67D43}"/>
               </a:ext>
             </a:extLst>
           </p:cNvPr>
@@ -5826,7 +5826,7 @@
           <p:cNvPr id="26" name="">
             <a:extLst xmlns:a="http://schemas.openxmlformats.org/drawingml/2006/main">
               <a:ext uri="{FF2B5EF4-FFF2-40B4-BE49-F238E27FC236}">
-                <a16:creationId xmlns:a16="http://schemas.microsoft.com/office/drawing/2014/main" id="{5C124D62-A724-4920-8B14-1B0939686496}"/>
+                <a16:creationId xmlns:a16="http://schemas.microsoft.com/office/drawing/2014/main" id="{5DF525C7-D957-4E87-B5E2-0CB63ED89245}"/>
               </a:ext>
             </a:extLst>
           </p:cNvPr>
@@ -5859,7 +5859,7 @@
           <p:cNvPr id="27" name="">
             <a:extLst xmlns:a="http://schemas.openxmlformats.org/drawingml/2006/main">
               <a:ext uri="{FF2B5EF4-FFF2-40B4-BE49-F238E27FC236}">
-                <a16:creationId xmlns:a16="http://schemas.microsoft.com/office/drawing/2014/main" id="{F84EBA5D-EBAC-4A62-BAE2-F10A6281A95C}"/>
+                <a16:creationId xmlns:a16="http://schemas.microsoft.com/office/drawing/2014/main" id="{F477756F-4734-4A96-B040-3961CDD6CBAD}"/>
               </a:ext>
             </a:extLst>
           </p:cNvPr>
@@ -5909,7 +5909,7 @@
           <p:cNvPr id="28" name="">
             <a:extLst xmlns:a="http://schemas.openxmlformats.org/drawingml/2006/main">
               <a:ext uri="{FF2B5EF4-FFF2-40B4-BE49-F238E27FC236}">
-                <a16:creationId xmlns:a16="http://schemas.microsoft.com/office/drawing/2014/main" id="{DDD389E6-310C-4804-94DD-5A819AB92E4C}"/>
+                <a16:creationId xmlns:a16="http://schemas.microsoft.com/office/drawing/2014/main" id="{B050CC48-FCF2-43A9-8821-449DAEE0F45A}"/>
               </a:ext>
             </a:extLst>
           </p:cNvPr>
@@ -5959,7 +5959,7 @@
           <p:cNvPr id="29" name="">
             <a:extLst xmlns:a="http://schemas.openxmlformats.org/drawingml/2006/main">
               <a:ext uri="{FF2B5EF4-FFF2-40B4-BE49-F238E27FC236}">
-                <a16:creationId xmlns:a16="http://schemas.microsoft.com/office/drawing/2014/main" id="{9F9A6414-C36E-46C7-957D-ED34E634DB86}"/>
+                <a16:creationId xmlns:a16="http://schemas.microsoft.com/office/drawing/2014/main" id="{0AAEF66A-C1F2-4A36-AD51-D59B17CB25FE}"/>
               </a:ext>
             </a:extLst>
           </p:cNvPr>
@@ -5992,7 +5992,7 @@
           <p:cNvPr id="30" name="">
             <a:extLst xmlns:a="http://schemas.openxmlformats.org/drawingml/2006/main">
               <a:ext uri="{FF2B5EF4-FFF2-40B4-BE49-F238E27FC236}">
-                <a16:creationId xmlns:a16="http://schemas.microsoft.com/office/drawing/2014/main" id="{CB8EAFAA-13D3-48DF-8B08-F2FE4B28CAA3}"/>
+                <a16:creationId xmlns:a16="http://schemas.microsoft.com/office/drawing/2014/main" id="{EAFDC7F5-F6EB-414E-98A6-81FB6C695151}"/>
               </a:ext>
             </a:extLst>
           </p:cNvPr>
@@ -6042,7 +6042,7 @@
           <p:cNvPr id="31" name="">
             <a:extLst xmlns:a="http://schemas.openxmlformats.org/drawingml/2006/main">
               <a:ext uri="{FF2B5EF4-FFF2-40B4-BE49-F238E27FC236}">
-                <a16:creationId xmlns:a16="http://schemas.microsoft.com/office/drawing/2014/main" id="{0F0F9FAF-2183-46AE-88F6-FE0BF1270960}"/>
+                <a16:creationId xmlns:a16="http://schemas.microsoft.com/office/drawing/2014/main" id="{6FF05BEE-2321-42C1-8150-749374628CC4}"/>
               </a:ext>
             </a:extLst>
           </p:cNvPr>
@@ -6090,7 +6090,7 @@
     </p:spTree>
     <p:extLst>
       <p:ext uri="{BB962C8B-B14F-4D97-AF65-F5344CB8AC3E}">
-        <p14:creationId xmlns:p14="http://schemas.microsoft.com/office/powerpoint/2010/main" val="1207453285"/>
+        <p14:creationId xmlns:p14="http://schemas.microsoft.com/office/powerpoint/2010/main" val="1532343062"/>
       </p:ext>
     </p:extLst>
   </p:cSld>
@@ -6121,7 +6121,7 @@
           <p:cNvPr id="1" name="">
             <a:extLst xmlns:a="http://schemas.openxmlformats.org/drawingml/2006/main">
               <a:ext uri="{FF2B5EF4-FFF2-40B4-BE49-F238E27FC236}">
-                <a16:creationId xmlns:a16="http://schemas.microsoft.com/office/drawing/2014/main" id="{123F362E-8608-4F8A-800A-47F947502972}"/>
+                <a16:creationId xmlns:a16="http://schemas.microsoft.com/office/drawing/2014/main" id="{BFAC9A0E-2682-426D-B560-A520DD5D2F74}"/>
               </a:ext>
             </a:extLst>
           </p:cNvPr>
@@ -6156,7 +6156,7 @@
           <p:nvPr/>
         </p:nvPicPr>
         <p:blipFill>
-          <a:blip xmlns:r="http://schemas.openxmlformats.org/officeDocument/2006/relationships" xmlns:a="http://schemas.openxmlformats.org/drawingml/2006/main" r:embed="R36fe295be6aa436c"/>
+          <a:blip xmlns:r="http://schemas.openxmlformats.org/officeDocument/2006/relationships" xmlns:a="http://schemas.openxmlformats.org/drawingml/2006/main" r:embed="R9ff71eef40114adf"/>
           <a:stretch xmlns:a="http://schemas.openxmlformats.org/drawingml/2006/main"/>
         </p:blipFill>
         <p:spPr>
@@ -6174,7 +6174,7 @@
           <p:cNvPr id="3" name="">
             <a:extLst xmlns:a="http://schemas.openxmlformats.org/drawingml/2006/main">
               <a:ext uri="{FF2B5EF4-FFF2-40B4-BE49-F238E27FC236}">
-                <a16:creationId xmlns:a16="http://schemas.microsoft.com/office/drawing/2014/main" id="{7104BBDB-D688-4850-90F6-10D5C3267420}"/>
+                <a16:creationId xmlns:a16="http://schemas.microsoft.com/office/drawing/2014/main" id="{C7FDF7EC-D8ED-4286-B4EE-5CE34F82A9A1}"/>
               </a:ext>
             </a:extLst>
           </p:cNvPr>
@@ -6224,7 +6224,7 @@
           <p:cNvPr id="4" name="">
             <a:extLst xmlns:a="http://schemas.openxmlformats.org/drawingml/2006/main">
               <a:ext uri="{FF2B5EF4-FFF2-40B4-BE49-F238E27FC236}">
-                <a16:creationId xmlns:a16="http://schemas.microsoft.com/office/drawing/2014/main" id="{D4E91C68-36D1-4881-9759-745DD17F2CC0}"/>
+                <a16:creationId xmlns:a16="http://schemas.microsoft.com/office/drawing/2014/main" id="{6105637F-83BA-4247-A7E7-D4DAE8B54F3E}"/>
               </a:ext>
             </a:extLst>
           </p:cNvPr>
@@ -6257,7 +6257,7 @@
           <p:cNvPr id="5" name="">
             <a:extLst xmlns:a="http://schemas.openxmlformats.org/drawingml/2006/main">
               <a:ext uri="{FF2B5EF4-FFF2-40B4-BE49-F238E27FC236}">
-                <a16:creationId xmlns:a16="http://schemas.microsoft.com/office/drawing/2014/main" id="{9A090A20-25B0-42D6-9CFD-22268BA92831}"/>
+                <a16:creationId xmlns:a16="http://schemas.microsoft.com/office/drawing/2014/main" id="{D34B97AF-68CB-470C-B61D-49EC1576F548}"/>
               </a:ext>
             </a:extLst>
           </p:cNvPr>
@@ -6288,7 +6288,7 @@
           <p:cNvPr id="6" name="">
             <a:extLst xmlns:a="http://schemas.openxmlformats.org/drawingml/2006/main">
               <a:ext uri="{FF2B5EF4-FFF2-40B4-BE49-F238E27FC236}">
-                <a16:creationId xmlns:a16="http://schemas.microsoft.com/office/drawing/2014/main" id="{05F975A5-608D-40DF-8548-DBE26B255006}"/>
+                <a16:creationId xmlns:a16="http://schemas.microsoft.com/office/drawing/2014/main" id="{142352EA-DC8E-4250-86E7-BED2380D69D0}"/>
               </a:ext>
             </a:extLst>
           </p:cNvPr>
@@ -6338,7 +6338,7 @@
           <p:cNvPr id="7" name="">
             <a:extLst xmlns:a="http://schemas.openxmlformats.org/drawingml/2006/main">
               <a:ext uri="{FF2B5EF4-FFF2-40B4-BE49-F238E27FC236}">
-                <a16:creationId xmlns:a16="http://schemas.microsoft.com/office/drawing/2014/main" id="{B3BDD7DD-6A81-4AAD-8870-26FD309AA944}"/>
+                <a16:creationId xmlns:a16="http://schemas.microsoft.com/office/drawing/2014/main" id="{A7B87033-C9C4-4B31-A2AD-C8D98C027F21}"/>
               </a:ext>
             </a:extLst>
           </p:cNvPr>
@@ -6388,7 +6388,7 @@
           <p:cNvPr id="8" name="">
             <a:extLst xmlns:a="http://schemas.openxmlformats.org/drawingml/2006/main">
               <a:ext uri="{FF2B5EF4-FFF2-40B4-BE49-F238E27FC236}">
-                <a16:creationId xmlns:a16="http://schemas.microsoft.com/office/drawing/2014/main" id="{0E77383A-C895-465F-985F-5771D191E224}"/>
+                <a16:creationId xmlns:a16="http://schemas.microsoft.com/office/drawing/2014/main" id="{2DD6D595-313C-4F67-8EDA-9DBB2C3E5142}"/>
               </a:ext>
             </a:extLst>
           </p:cNvPr>
@@ -6421,7 +6421,7 @@
           <p:cNvPr id="9" name="">
             <a:extLst xmlns:a="http://schemas.openxmlformats.org/drawingml/2006/main">
               <a:ext uri="{FF2B5EF4-FFF2-40B4-BE49-F238E27FC236}">
-                <a16:creationId xmlns:a16="http://schemas.microsoft.com/office/drawing/2014/main" id="{2166EA18-9145-4FCB-ABAD-A3B62C3B68BC}"/>
+                <a16:creationId xmlns:a16="http://schemas.microsoft.com/office/drawing/2014/main" id="{C0A6383E-8684-4684-BBFE-0CF86CA3878D}"/>
               </a:ext>
             </a:extLst>
           </p:cNvPr>
@@ -6471,7 +6471,7 @@
           <p:cNvPr id="10" name="">
             <a:extLst xmlns:a="http://schemas.openxmlformats.org/drawingml/2006/main">
               <a:ext uri="{FF2B5EF4-FFF2-40B4-BE49-F238E27FC236}">
-                <a16:creationId xmlns:a16="http://schemas.microsoft.com/office/drawing/2014/main" id="{6C3AEB8A-D491-433F-9755-E3956AC0F415}"/>
+                <a16:creationId xmlns:a16="http://schemas.microsoft.com/office/drawing/2014/main" id="{9003DD58-D29E-4403-A07F-6BA10CF98935}"/>
               </a:ext>
             </a:extLst>
           </p:cNvPr>
@@ -6521,7 +6521,7 @@
           <p:cNvPr id="11" name="">
             <a:extLst xmlns:a="http://schemas.openxmlformats.org/drawingml/2006/main">
               <a:ext uri="{FF2B5EF4-FFF2-40B4-BE49-F238E27FC236}">
-                <a16:creationId xmlns:a16="http://schemas.microsoft.com/office/drawing/2014/main" id="{AD445B7A-EBAC-446A-B3D2-0CE32791B2CF}"/>
+                <a16:creationId xmlns:a16="http://schemas.microsoft.com/office/drawing/2014/main" id="{300048E2-C240-4CF7-94AD-54535BF22A55}"/>
               </a:ext>
             </a:extLst>
           </p:cNvPr>
@@ -6571,7 +6571,7 @@
           <p:cNvPr id="12" name="">
             <a:extLst xmlns:a="http://schemas.openxmlformats.org/drawingml/2006/main">
               <a:ext uri="{FF2B5EF4-FFF2-40B4-BE49-F238E27FC236}">
-                <a16:creationId xmlns:a16="http://schemas.microsoft.com/office/drawing/2014/main" id="{64A52643-3B8C-40E3-A2AD-112566ECAE18}"/>
+                <a16:creationId xmlns:a16="http://schemas.microsoft.com/office/drawing/2014/main" id="{9BB8583F-E814-4E91-A0F3-03F521639520}"/>
               </a:ext>
             </a:extLst>
           </p:cNvPr>
@@ -6621,7 +6621,7 @@
           <p:cNvPr id="13" name="">
             <a:extLst xmlns:a="http://schemas.openxmlformats.org/drawingml/2006/main">
               <a:ext uri="{FF2B5EF4-FFF2-40B4-BE49-F238E27FC236}">
-                <a16:creationId xmlns:a16="http://schemas.microsoft.com/office/drawing/2014/main" id="{B1851367-B7E0-4D31-9316-54DCA92952CB}"/>
+                <a16:creationId xmlns:a16="http://schemas.microsoft.com/office/drawing/2014/main" id="{0AA13C5D-3871-43D5-8292-240F857704C5}"/>
               </a:ext>
             </a:extLst>
           </p:cNvPr>
@@ -6671,7 +6671,7 @@
           <p:cNvPr id="14" name="">
             <a:extLst xmlns:a="http://schemas.openxmlformats.org/drawingml/2006/main">
               <a:ext uri="{FF2B5EF4-FFF2-40B4-BE49-F238E27FC236}">
-                <a16:creationId xmlns:a16="http://schemas.microsoft.com/office/drawing/2014/main" id="{7FA5C182-3F57-44A5-8D48-15396DD17542}"/>
+                <a16:creationId xmlns:a16="http://schemas.microsoft.com/office/drawing/2014/main" id="{44919460-861F-4DB9-A2B2-C5C51F7923E4}"/>
               </a:ext>
             </a:extLst>
           </p:cNvPr>
@@ -6702,7 +6702,7 @@
           <p:cNvPr id="15" name="">
             <a:extLst xmlns:a="http://schemas.openxmlformats.org/drawingml/2006/main">
               <a:ext uri="{FF2B5EF4-FFF2-40B4-BE49-F238E27FC236}">
-                <a16:creationId xmlns:a16="http://schemas.microsoft.com/office/drawing/2014/main" id="{4AAC2F93-1BBC-43F1-8C12-6FF7E3793960}"/>
+                <a16:creationId xmlns:a16="http://schemas.microsoft.com/office/drawing/2014/main" id="{9F5DCB6B-E69F-48CC-9F97-D9A0292D2EC6}"/>
               </a:ext>
             </a:extLst>
           </p:cNvPr>
@@ -6735,7 +6735,7 @@
           <p:cNvPr id="16" name="">
             <a:extLst xmlns:a="http://schemas.openxmlformats.org/drawingml/2006/main">
               <a:ext uri="{FF2B5EF4-FFF2-40B4-BE49-F238E27FC236}">
-                <a16:creationId xmlns:a16="http://schemas.microsoft.com/office/drawing/2014/main" id="{D5D903BA-6493-42DC-A3E8-A55FF2D76638}"/>
+                <a16:creationId xmlns:a16="http://schemas.microsoft.com/office/drawing/2014/main" id="{81E3BFCD-518C-4DEF-ADEE-CD7A07656098}"/>
               </a:ext>
             </a:extLst>
           </p:cNvPr>
@@ -6785,7 +6785,7 @@
           <p:cNvPr id="17" name="">
             <a:extLst xmlns:a="http://schemas.openxmlformats.org/drawingml/2006/main">
               <a:ext uri="{FF2B5EF4-FFF2-40B4-BE49-F238E27FC236}">
-                <a16:creationId xmlns:a16="http://schemas.microsoft.com/office/drawing/2014/main" id="{74637499-F642-49BC-907D-51C8748AE954}"/>
+                <a16:creationId xmlns:a16="http://schemas.microsoft.com/office/drawing/2014/main" id="{F7C33FA8-7DF5-4735-8370-EA96A4E98B84}"/>
               </a:ext>
             </a:extLst>
           </p:cNvPr>
@@ -6835,7 +6835,7 @@
           <p:cNvPr id="18" name="">
             <a:extLst xmlns:a="http://schemas.openxmlformats.org/drawingml/2006/main">
               <a:ext uri="{FF2B5EF4-FFF2-40B4-BE49-F238E27FC236}">
-                <a16:creationId xmlns:a16="http://schemas.microsoft.com/office/drawing/2014/main" id="{D9BF340E-3189-45F9-A2BE-137D1FE8AA87}"/>
+                <a16:creationId xmlns:a16="http://schemas.microsoft.com/office/drawing/2014/main" id="{5BF8EF3B-EAB6-4435-BB40-BF57A64AAA17}"/>
               </a:ext>
             </a:extLst>
           </p:cNvPr>
@@ -6885,7 +6885,7 @@
           <p:cNvPr id="19" name="">
             <a:extLst xmlns:a="http://schemas.openxmlformats.org/drawingml/2006/main">
               <a:ext uri="{FF2B5EF4-FFF2-40B4-BE49-F238E27FC236}">
-                <a16:creationId xmlns:a16="http://schemas.microsoft.com/office/drawing/2014/main" id="{0395D36E-8027-435F-92FA-0404ED703FE1}"/>
+                <a16:creationId xmlns:a16="http://schemas.microsoft.com/office/drawing/2014/main" id="{F87C1598-7F03-45F7-81A9-8112976F0396}"/>
               </a:ext>
             </a:extLst>
           </p:cNvPr>
@@ -6935,7 +6935,7 @@
           <p:cNvPr id="20" name="">
             <a:extLst xmlns:a="http://schemas.openxmlformats.org/drawingml/2006/main">
               <a:ext uri="{FF2B5EF4-FFF2-40B4-BE49-F238E27FC236}">
-                <a16:creationId xmlns:a16="http://schemas.microsoft.com/office/drawing/2014/main" id="{C344BA87-1AC5-4A81-9B87-C51EBD10EE8B}"/>
+                <a16:creationId xmlns:a16="http://schemas.microsoft.com/office/drawing/2014/main" id="{F5518C4B-3741-4694-A201-AF5D7FC84852}"/>
               </a:ext>
             </a:extLst>
           </p:cNvPr>
@@ -6985,7 +6985,7 @@
           <p:cNvPr id="21" name="">
             <a:extLst xmlns:a="http://schemas.openxmlformats.org/drawingml/2006/main">
               <a:ext uri="{FF2B5EF4-FFF2-40B4-BE49-F238E27FC236}">
-                <a16:creationId xmlns:a16="http://schemas.microsoft.com/office/drawing/2014/main" id="{093E6380-3F70-4EF0-A63D-B68C08C1E70E}"/>
+                <a16:creationId xmlns:a16="http://schemas.microsoft.com/office/drawing/2014/main" id="{2C722705-AB80-49F0-A2A2-2899901E185C}"/>
               </a:ext>
             </a:extLst>
           </p:cNvPr>
@@ -7016,7 +7016,7 @@
           <p:cNvPr id="22" name="">
             <a:extLst xmlns:a="http://schemas.openxmlformats.org/drawingml/2006/main">
               <a:ext uri="{FF2B5EF4-FFF2-40B4-BE49-F238E27FC236}">
-                <a16:creationId xmlns:a16="http://schemas.microsoft.com/office/drawing/2014/main" id="{FBD1CF47-52CF-4A13-BB68-DE112E4505AA}"/>
+                <a16:creationId xmlns:a16="http://schemas.microsoft.com/office/drawing/2014/main" id="{6F14C373-7D1A-4324-8636-51402C9F7259}"/>
               </a:ext>
             </a:extLst>
           </p:cNvPr>
@@ -7049,7 +7049,7 @@
           <p:cNvPr id="23" name="">
             <a:extLst xmlns:a="http://schemas.openxmlformats.org/drawingml/2006/main">
               <a:ext uri="{FF2B5EF4-FFF2-40B4-BE49-F238E27FC236}">
-                <a16:creationId xmlns:a16="http://schemas.microsoft.com/office/drawing/2014/main" id="{97A05FBC-31FF-42E0-B2DC-3495176B99F5}"/>
+                <a16:creationId xmlns:a16="http://schemas.microsoft.com/office/drawing/2014/main" id="{2D9195EF-BBDF-45E4-A563-67321F56C64C}"/>
               </a:ext>
             </a:extLst>
           </p:cNvPr>
@@ -7099,7 +7099,7 @@
           <p:cNvPr id="24" name="">
             <a:extLst xmlns:a="http://schemas.openxmlformats.org/drawingml/2006/main">
               <a:ext uri="{FF2B5EF4-FFF2-40B4-BE49-F238E27FC236}">
-                <a16:creationId xmlns:a16="http://schemas.microsoft.com/office/drawing/2014/main" id="{AD4AFF18-9D2C-4FD0-BA26-99FF4C27E7DD}"/>
+                <a16:creationId xmlns:a16="http://schemas.microsoft.com/office/drawing/2014/main" id="{CB350DAD-D5A4-4C2C-9896-63B8773A688B}"/>
               </a:ext>
             </a:extLst>
           </p:cNvPr>
@@ -7149,7 +7149,7 @@
           <p:cNvPr id="25" name="">
             <a:extLst xmlns:a="http://schemas.openxmlformats.org/drawingml/2006/main">
               <a:ext uri="{FF2B5EF4-FFF2-40B4-BE49-F238E27FC236}">
-                <a16:creationId xmlns:a16="http://schemas.microsoft.com/office/drawing/2014/main" id="{82B4CFE1-CD21-4D63-8AC6-B298C9E9FA3A}"/>
+                <a16:creationId xmlns:a16="http://schemas.microsoft.com/office/drawing/2014/main" id="{6B008DBE-CBC9-45FE-A2D3-BDA450624006}"/>
               </a:ext>
             </a:extLst>
           </p:cNvPr>
@@ -7199,7 +7199,7 @@
           <p:cNvPr id="26" name="">
             <a:extLst xmlns:a="http://schemas.openxmlformats.org/drawingml/2006/main">
               <a:ext uri="{FF2B5EF4-FFF2-40B4-BE49-F238E27FC236}">
-                <a16:creationId xmlns:a16="http://schemas.microsoft.com/office/drawing/2014/main" id="{EAA229A0-DC44-4BAB-AFE7-42777D3D3751}"/>
+                <a16:creationId xmlns:a16="http://schemas.microsoft.com/office/drawing/2014/main" id="{ADEE6DD2-85AC-4A4C-BA91-CE00022F03E7}"/>
               </a:ext>
             </a:extLst>
           </p:cNvPr>
@@ -7249,7 +7249,7 @@
           <p:cNvPr id="27" name="">
             <a:extLst xmlns:a="http://schemas.openxmlformats.org/drawingml/2006/main">
               <a:ext uri="{FF2B5EF4-FFF2-40B4-BE49-F238E27FC236}">
-                <a16:creationId xmlns:a16="http://schemas.microsoft.com/office/drawing/2014/main" id="{9F19C6FD-65B9-4D7D-A48B-33EEF8C301E7}"/>
+                <a16:creationId xmlns:a16="http://schemas.microsoft.com/office/drawing/2014/main" id="{22D56DA4-2934-43E1-B073-E937C09B4A25}"/>
               </a:ext>
             </a:extLst>
           </p:cNvPr>
@@ -7299,7 +7299,7 @@
           <p:cNvPr id="28" name="">
             <a:extLst xmlns:a="http://schemas.openxmlformats.org/drawingml/2006/main">
               <a:ext uri="{FF2B5EF4-FFF2-40B4-BE49-F238E27FC236}">
-                <a16:creationId xmlns:a16="http://schemas.microsoft.com/office/drawing/2014/main" id="{EE9F351A-14EC-4FC9-9F9C-F295BC274B9B}"/>
+                <a16:creationId xmlns:a16="http://schemas.microsoft.com/office/drawing/2014/main" id="{66BFDBB5-85B5-4121-AB22-0FC49D929B78}"/>
               </a:ext>
             </a:extLst>
           </p:cNvPr>
@@ -7330,7 +7330,7 @@
           <p:cNvPr id="29" name="">
             <a:extLst xmlns:a="http://schemas.openxmlformats.org/drawingml/2006/main">
               <a:ext uri="{FF2B5EF4-FFF2-40B4-BE49-F238E27FC236}">
-                <a16:creationId xmlns:a16="http://schemas.microsoft.com/office/drawing/2014/main" id="{9F7623B3-2F9F-460F-8CDF-AD4A0C03EB9E}"/>
+                <a16:creationId xmlns:a16="http://schemas.microsoft.com/office/drawing/2014/main" id="{DC078230-6AFA-494D-A549-042EB9BF4DDD}"/>
               </a:ext>
             </a:extLst>
           </p:cNvPr>
@@ -7363,7 +7363,7 @@
           <p:cNvPr id="30" name="">
             <a:extLst xmlns:a="http://schemas.openxmlformats.org/drawingml/2006/main">
               <a:ext uri="{FF2B5EF4-FFF2-40B4-BE49-F238E27FC236}">
-                <a16:creationId xmlns:a16="http://schemas.microsoft.com/office/drawing/2014/main" id="{67D83E81-F13A-42A2-9AC8-8C9962B4E094}"/>
+                <a16:creationId xmlns:a16="http://schemas.microsoft.com/office/drawing/2014/main" id="{8B4AF1A3-BF64-45F5-8222-C4F49243D4AA}"/>
               </a:ext>
             </a:extLst>
           </p:cNvPr>
@@ -7413,7 +7413,7 @@
           <p:cNvPr id="31" name="">
             <a:extLst xmlns:a="http://schemas.openxmlformats.org/drawingml/2006/main">
               <a:ext uri="{FF2B5EF4-FFF2-40B4-BE49-F238E27FC236}">
-                <a16:creationId xmlns:a16="http://schemas.microsoft.com/office/drawing/2014/main" id="{921CC70F-799C-43F9-BC59-05EA4C1229A2}"/>
+                <a16:creationId xmlns:a16="http://schemas.microsoft.com/office/drawing/2014/main" id="{2BE8AF71-2981-4771-95CF-42B5FBD489CC}"/>
               </a:ext>
             </a:extLst>
           </p:cNvPr>
@@ -7463,7 +7463,7 @@
           <p:cNvPr id="32" name="">
             <a:extLst xmlns:a="http://schemas.openxmlformats.org/drawingml/2006/main">
               <a:ext uri="{FF2B5EF4-FFF2-40B4-BE49-F238E27FC236}">
-                <a16:creationId xmlns:a16="http://schemas.microsoft.com/office/drawing/2014/main" id="{97430D30-944E-4A8A-87CC-78502B4B6634}"/>
+                <a16:creationId xmlns:a16="http://schemas.microsoft.com/office/drawing/2014/main" id="{AFCCB569-C7EE-473D-A117-59712923D163}"/>
               </a:ext>
             </a:extLst>
           </p:cNvPr>
@@ -7513,7 +7513,7 @@
           <p:cNvPr id="33" name="">
             <a:extLst xmlns:a="http://schemas.openxmlformats.org/drawingml/2006/main">
               <a:ext uri="{FF2B5EF4-FFF2-40B4-BE49-F238E27FC236}">
-                <a16:creationId xmlns:a16="http://schemas.microsoft.com/office/drawing/2014/main" id="{E49D9875-1B4C-47B9-8DD8-1E6E98D88064}"/>
+                <a16:creationId xmlns:a16="http://schemas.microsoft.com/office/drawing/2014/main" id="{CFB2BEE3-50BD-4F1C-A0E0-AA06AE461A59}"/>
               </a:ext>
             </a:extLst>
           </p:cNvPr>
@@ -7563,7 +7563,7 @@
           <p:cNvPr id="34" name="">
             <a:extLst xmlns:a="http://schemas.openxmlformats.org/drawingml/2006/main">
               <a:ext uri="{FF2B5EF4-FFF2-40B4-BE49-F238E27FC236}">
-                <a16:creationId xmlns:a16="http://schemas.microsoft.com/office/drawing/2014/main" id="{6A121E7A-A5CF-4BEE-A3DD-379B1295BFA5}"/>
+                <a16:creationId xmlns:a16="http://schemas.microsoft.com/office/drawing/2014/main" id="{D1859288-F2A6-45D1-9288-B53BA4827E63}"/>
               </a:ext>
             </a:extLst>
           </p:cNvPr>
@@ -7611,7 +7611,7 @@
     </p:spTree>
     <p:extLst>
       <p:ext uri="{BB962C8B-B14F-4D97-AF65-F5344CB8AC3E}">
-        <p14:creationId xmlns:p14="http://schemas.microsoft.com/office/powerpoint/2010/main" val="1283516650"/>
+        <p14:creationId xmlns:p14="http://schemas.microsoft.com/office/powerpoint/2010/main" val="1781785763"/>
       </p:ext>
     </p:extLst>
   </p:cSld>
@@ -7642,7 +7642,7 @@
           <p:cNvPr id="1" name="">
             <a:extLst xmlns:a="http://schemas.openxmlformats.org/drawingml/2006/main">
               <a:ext uri="{FF2B5EF4-FFF2-40B4-BE49-F238E27FC236}">
-                <a16:creationId xmlns:a16="http://schemas.microsoft.com/office/drawing/2014/main" id="{53C33880-2579-4A76-BDD4-67F19783AB35}"/>
+                <a16:creationId xmlns:a16="http://schemas.microsoft.com/office/drawing/2014/main" id="{612807D8-546F-4D65-AB08-655F15213C58}"/>
               </a:ext>
             </a:extLst>
           </p:cNvPr>
@@ -7677,7 +7677,7 @@
           <p:nvPr/>
         </p:nvPicPr>
         <p:blipFill>
-          <a:blip xmlns:r="http://schemas.openxmlformats.org/officeDocument/2006/relationships" xmlns:a="http://schemas.openxmlformats.org/drawingml/2006/main" r:embed="R6e681fbc9e164bc3"/>
+          <a:blip xmlns:r="http://schemas.openxmlformats.org/officeDocument/2006/relationships" xmlns:a="http://schemas.openxmlformats.org/drawingml/2006/main" r:embed="R814df443ed7a43c0"/>
           <a:stretch xmlns:a="http://schemas.openxmlformats.org/drawingml/2006/main"/>
         </p:blipFill>
         <p:spPr>
@@ -7695,7 +7695,7 @@
           <p:cNvPr id="3" name="">
             <a:extLst xmlns:a="http://schemas.openxmlformats.org/drawingml/2006/main">
               <a:ext uri="{FF2B5EF4-FFF2-40B4-BE49-F238E27FC236}">
-                <a16:creationId xmlns:a16="http://schemas.microsoft.com/office/drawing/2014/main" id="{C523FBC0-5B78-4DEA-B60D-063CC9F06A69}"/>
+                <a16:creationId xmlns:a16="http://schemas.microsoft.com/office/drawing/2014/main" id="{C585F69D-B4BE-4265-B618-DB0DD524759C}"/>
               </a:ext>
             </a:extLst>
           </p:cNvPr>
@@ -7745,7 +7745,7 @@
           <p:cNvPr id="4" name="">
             <a:extLst xmlns:a="http://schemas.openxmlformats.org/drawingml/2006/main">
               <a:ext uri="{FF2B5EF4-FFF2-40B4-BE49-F238E27FC236}">
-                <a16:creationId xmlns:a16="http://schemas.microsoft.com/office/drawing/2014/main" id="{505259C6-AC96-4BAD-B65E-FA4F9F316B0B}"/>
+                <a16:creationId xmlns:a16="http://schemas.microsoft.com/office/drawing/2014/main" id="{3120442A-E2C6-4DD3-9FD4-D44DE706445C}"/>
               </a:ext>
             </a:extLst>
           </p:cNvPr>
@@ -7778,7 +7778,7 @@
           <p:cNvPr id="5" name="">
             <a:extLst xmlns:a="http://schemas.openxmlformats.org/drawingml/2006/main">
               <a:ext uri="{FF2B5EF4-FFF2-40B4-BE49-F238E27FC236}">
-                <a16:creationId xmlns:a16="http://schemas.microsoft.com/office/drawing/2014/main" id="{736CA475-CFAC-4D35-A199-0E74BCEBF11D}"/>
+                <a16:creationId xmlns:a16="http://schemas.microsoft.com/office/drawing/2014/main" id="{62E4C730-83A3-41B3-A84E-C17C60C210DA}"/>
               </a:ext>
             </a:extLst>
           </p:cNvPr>
@@ -7809,7 +7809,7 @@
           <p:cNvPr id="6" name="">
             <a:extLst xmlns:a="http://schemas.openxmlformats.org/drawingml/2006/main">
               <a:ext uri="{FF2B5EF4-FFF2-40B4-BE49-F238E27FC236}">
-                <a16:creationId xmlns:a16="http://schemas.microsoft.com/office/drawing/2014/main" id="{1AB0604D-F243-42B3-8A75-B1B2F48B5E7D}"/>
+                <a16:creationId xmlns:a16="http://schemas.microsoft.com/office/drawing/2014/main" id="{B9BC8E47-4832-4893-A9B5-D88A2FC024AE}"/>
               </a:ext>
             </a:extLst>
           </p:cNvPr>
@@ -7859,7 +7859,7 @@
           <p:cNvPr id="7" name="">
             <a:extLst xmlns:a="http://schemas.openxmlformats.org/drawingml/2006/main">
               <a:ext uri="{FF2B5EF4-FFF2-40B4-BE49-F238E27FC236}">
-                <a16:creationId xmlns:a16="http://schemas.microsoft.com/office/drawing/2014/main" id="{DDB3D77C-A0B5-4EA3-94D0-A788DAE2FCE4}"/>
+                <a16:creationId xmlns:a16="http://schemas.microsoft.com/office/drawing/2014/main" id="{D6FF3005-E3D0-44E1-AF9B-3E76A046F181}"/>
               </a:ext>
             </a:extLst>
           </p:cNvPr>
@@ -7909,7 +7909,7 @@
           <p:cNvPr id="8" name="">
             <a:extLst xmlns:a="http://schemas.openxmlformats.org/drawingml/2006/main">
               <a:ext uri="{FF2B5EF4-FFF2-40B4-BE49-F238E27FC236}">
-                <a16:creationId xmlns:a16="http://schemas.microsoft.com/office/drawing/2014/main" id="{9A669DC8-48CC-44A5-A762-92F0A2DE28E3}"/>
+                <a16:creationId xmlns:a16="http://schemas.microsoft.com/office/drawing/2014/main" id="{E0F50E79-0672-4110-B64A-590F78219565}"/>
               </a:ext>
             </a:extLst>
           </p:cNvPr>
@@ -7944,7 +7944,7 @@
           <p:cNvPr id="9" name="">
             <a:extLst xmlns:a="http://schemas.openxmlformats.org/drawingml/2006/main">
               <a:ext uri="{FF2B5EF4-FFF2-40B4-BE49-F238E27FC236}">
-                <a16:creationId xmlns:a16="http://schemas.microsoft.com/office/drawing/2014/main" id="{F6C007F6-EABB-45AA-AD64-BFE48A476414}"/>
+                <a16:creationId xmlns:a16="http://schemas.microsoft.com/office/drawing/2014/main" id="{6306B3B1-B374-46D5-8DF6-36432F170DDF}"/>
               </a:ext>
             </a:extLst>
           </p:cNvPr>
@@ -7994,7 +7994,7 @@
           <p:cNvPr id="10" name="">
             <a:extLst xmlns:a="http://schemas.openxmlformats.org/drawingml/2006/main">
               <a:ext uri="{FF2B5EF4-FFF2-40B4-BE49-F238E27FC236}">
-                <a16:creationId xmlns:a16="http://schemas.microsoft.com/office/drawing/2014/main" id="{866061CA-87FE-46C0-9B02-695802255901}"/>
+                <a16:creationId xmlns:a16="http://schemas.microsoft.com/office/drawing/2014/main" id="{FBA64B0F-966D-48A9-BAC6-375B38E829E7}"/>
               </a:ext>
             </a:extLst>
           </p:cNvPr>
@@ -8044,7 +8044,7 @@
           <p:cNvPr id="11" name="">
             <a:extLst xmlns:a="http://schemas.openxmlformats.org/drawingml/2006/main">
               <a:ext uri="{FF2B5EF4-FFF2-40B4-BE49-F238E27FC236}">
-                <a16:creationId xmlns:a16="http://schemas.microsoft.com/office/drawing/2014/main" id="{536BFEA5-48BD-437B-8E02-8CB9C1C80432}"/>
+                <a16:creationId xmlns:a16="http://schemas.microsoft.com/office/drawing/2014/main" id="{D5215E32-5BEC-4A1F-A8DB-13DC5E298378}"/>
               </a:ext>
             </a:extLst>
           </p:cNvPr>
@@ -8094,7 +8094,7 @@
           <p:cNvPr id="12" name="">
             <a:extLst xmlns:a="http://schemas.openxmlformats.org/drawingml/2006/main">
               <a:ext uri="{FF2B5EF4-FFF2-40B4-BE49-F238E27FC236}">
-                <a16:creationId xmlns:a16="http://schemas.microsoft.com/office/drawing/2014/main" id="{C5AEDC15-BA24-4147-A703-6EBF84509A40}"/>
+                <a16:creationId xmlns:a16="http://schemas.microsoft.com/office/drawing/2014/main" id="{24A615D5-3282-431C-B76B-30812A1DCDE7}"/>
               </a:ext>
             </a:extLst>
           </p:cNvPr>
@@ -8125,7 +8125,7 @@
           <p:cNvPr id="13" name="">
             <a:extLst xmlns:a="http://schemas.openxmlformats.org/drawingml/2006/main">
               <a:ext uri="{FF2B5EF4-FFF2-40B4-BE49-F238E27FC236}">
-                <a16:creationId xmlns:a16="http://schemas.microsoft.com/office/drawing/2014/main" id="{61DF2EC1-0AD0-4408-833E-DA704D9BE1F9}"/>
+                <a16:creationId xmlns:a16="http://schemas.microsoft.com/office/drawing/2014/main" id="{A3565492-A95D-4BA1-ADF0-EBEA45E85674}"/>
               </a:ext>
             </a:extLst>
           </p:cNvPr>
@@ -8175,7 +8175,7 @@
           <p:cNvPr id="14" name="">
             <a:extLst xmlns:a="http://schemas.openxmlformats.org/drawingml/2006/main">
               <a:ext uri="{FF2B5EF4-FFF2-40B4-BE49-F238E27FC236}">
-                <a16:creationId xmlns:a16="http://schemas.microsoft.com/office/drawing/2014/main" id="{64094330-5648-4DB5-92D9-170CF503DDC1}"/>
+                <a16:creationId xmlns:a16="http://schemas.microsoft.com/office/drawing/2014/main" id="{AD8A958C-1E2E-443F-A5C7-E650707D2ABA}"/>
               </a:ext>
             </a:extLst>
           </p:cNvPr>
@@ -8225,7 +8225,7 @@
           <p:cNvPr id="15" name="">
             <a:extLst xmlns:a="http://schemas.openxmlformats.org/drawingml/2006/main">
               <a:ext uri="{FF2B5EF4-FFF2-40B4-BE49-F238E27FC236}">
-                <a16:creationId xmlns:a16="http://schemas.microsoft.com/office/drawing/2014/main" id="{941BC8EE-D7DD-493A-B377-82C75189C816}"/>
+                <a16:creationId xmlns:a16="http://schemas.microsoft.com/office/drawing/2014/main" id="{39228D5F-B728-478C-B879-464E7F2818EC}"/>
               </a:ext>
             </a:extLst>
           </p:cNvPr>
@@ -8275,7 +8275,7 @@
           <p:cNvPr id="16" name="">
             <a:extLst xmlns:a="http://schemas.openxmlformats.org/drawingml/2006/main">
               <a:ext uri="{FF2B5EF4-FFF2-40B4-BE49-F238E27FC236}">
-                <a16:creationId xmlns:a16="http://schemas.microsoft.com/office/drawing/2014/main" id="{51BC1971-0AED-48C3-8653-6D90C2F412B9}"/>
+                <a16:creationId xmlns:a16="http://schemas.microsoft.com/office/drawing/2014/main" id="{243A1FA2-95B4-415D-9EB3-E5C6EFE8559D}"/>
               </a:ext>
             </a:extLst>
           </p:cNvPr>
@@ -8325,7 +8325,7 @@
           <p:cNvPr id="17" name="">
             <a:extLst xmlns:a="http://schemas.openxmlformats.org/drawingml/2006/main">
               <a:ext uri="{FF2B5EF4-FFF2-40B4-BE49-F238E27FC236}">
-                <a16:creationId xmlns:a16="http://schemas.microsoft.com/office/drawing/2014/main" id="{7489387E-C7D7-42CF-B7CD-76EA4C3130F4}"/>
+                <a16:creationId xmlns:a16="http://schemas.microsoft.com/office/drawing/2014/main" id="{50040F34-9BA9-4195-A844-1543FA5EA1A8}"/>
               </a:ext>
             </a:extLst>
           </p:cNvPr>
@@ -8360,7 +8360,7 @@
           <p:cNvPr id="18" name="">
             <a:extLst xmlns:a="http://schemas.openxmlformats.org/drawingml/2006/main">
               <a:ext uri="{FF2B5EF4-FFF2-40B4-BE49-F238E27FC236}">
-                <a16:creationId xmlns:a16="http://schemas.microsoft.com/office/drawing/2014/main" id="{38B8FD0F-BEC8-42F8-A62A-47FBBCB07C43}"/>
+                <a16:creationId xmlns:a16="http://schemas.microsoft.com/office/drawing/2014/main" id="{4472998A-0729-40E5-95DC-5F54688CB852}"/>
               </a:ext>
             </a:extLst>
           </p:cNvPr>
@@ -8410,7 +8410,7 @@
           <p:cNvPr id="19" name="">
             <a:extLst xmlns:a="http://schemas.openxmlformats.org/drawingml/2006/main">
               <a:ext uri="{FF2B5EF4-FFF2-40B4-BE49-F238E27FC236}">
-                <a16:creationId xmlns:a16="http://schemas.microsoft.com/office/drawing/2014/main" id="{0440E5BB-4303-456D-808E-B3C27FEE84F0}"/>
+                <a16:creationId xmlns:a16="http://schemas.microsoft.com/office/drawing/2014/main" id="{C9EAB7FF-AC5D-4236-A5C0-0CCD8BD1BC4E}"/>
               </a:ext>
             </a:extLst>
           </p:cNvPr>
@@ -8460,7 +8460,7 @@
           <p:cNvPr id="20" name="">
             <a:extLst xmlns:a="http://schemas.openxmlformats.org/drawingml/2006/main">
               <a:ext uri="{FF2B5EF4-FFF2-40B4-BE49-F238E27FC236}">
-                <a16:creationId xmlns:a16="http://schemas.microsoft.com/office/drawing/2014/main" id="{48E37FB6-1705-4835-9F4D-048FE4A86BCA}"/>
+                <a16:creationId xmlns:a16="http://schemas.microsoft.com/office/drawing/2014/main" id="{A0916907-C5DD-471D-8AFC-BE0AEB173FC8}"/>
               </a:ext>
             </a:extLst>
           </p:cNvPr>
@@ -8510,7 +8510,7 @@
           <p:cNvPr id="21" name="">
             <a:extLst xmlns:a="http://schemas.openxmlformats.org/drawingml/2006/main">
               <a:ext uri="{FF2B5EF4-FFF2-40B4-BE49-F238E27FC236}">
-                <a16:creationId xmlns:a16="http://schemas.microsoft.com/office/drawing/2014/main" id="{8D88ED43-5213-439A-AC6D-2EAAD2CE7AF7}"/>
+                <a16:creationId xmlns:a16="http://schemas.microsoft.com/office/drawing/2014/main" id="{BE55749F-AF9E-4604-9C78-A875A3B88B50}"/>
               </a:ext>
             </a:extLst>
           </p:cNvPr>
@@ -8541,7 +8541,7 @@
           <p:cNvPr id="22" name="">
             <a:extLst xmlns:a="http://schemas.openxmlformats.org/drawingml/2006/main">
               <a:ext uri="{FF2B5EF4-FFF2-40B4-BE49-F238E27FC236}">
-                <a16:creationId xmlns:a16="http://schemas.microsoft.com/office/drawing/2014/main" id="{94BF7D09-9859-4877-8E8F-06F2BFAA05E0}"/>
+                <a16:creationId xmlns:a16="http://schemas.microsoft.com/office/drawing/2014/main" id="{EDF30C8E-78A6-4CD7-8DA4-7445D0E7D066}"/>
               </a:ext>
             </a:extLst>
           </p:cNvPr>
@@ -8591,7 +8591,7 @@
           <p:cNvPr id="23" name="">
             <a:extLst xmlns:a="http://schemas.openxmlformats.org/drawingml/2006/main">
               <a:ext uri="{FF2B5EF4-FFF2-40B4-BE49-F238E27FC236}">
-                <a16:creationId xmlns:a16="http://schemas.microsoft.com/office/drawing/2014/main" id="{3C795183-5F45-4C1D-8066-DAAEE0185D64}"/>
+                <a16:creationId xmlns:a16="http://schemas.microsoft.com/office/drawing/2014/main" id="{8955096B-B4DF-4D1F-965B-6AA67312EBCF}"/>
               </a:ext>
             </a:extLst>
           </p:cNvPr>
@@ -8641,7 +8641,7 @@
           <p:cNvPr id="24" name="">
             <a:extLst xmlns:a="http://schemas.openxmlformats.org/drawingml/2006/main">
               <a:ext uri="{FF2B5EF4-FFF2-40B4-BE49-F238E27FC236}">
-                <a16:creationId xmlns:a16="http://schemas.microsoft.com/office/drawing/2014/main" id="{85A7E5BA-52EE-4222-8CDC-2551CC6502BD}"/>
+                <a16:creationId xmlns:a16="http://schemas.microsoft.com/office/drawing/2014/main" id="{2AB341EA-452C-4162-BBDE-E29F727FB680}"/>
               </a:ext>
             </a:extLst>
           </p:cNvPr>
@@ -8691,7 +8691,7 @@
           <p:cNvPr id="25" name="">
             <a:extLst xmlns:a="http://schemas.openxmlformats.org/drawingml/2006/main">
               <a:ext uri="{FF2B5EF4-FFF2-40B4-BE49-F238E27FC236}">
-                <a16:creationId xmlns:a16="http://schemas.microsoft.com/office/drawing/2014/main" id="{7B5DA666-006A-4153-8F39-A3340E472327}"/>
+                <a16:creationId xmlns:a16="http://schemas.microsoft.com/office/drawing/2014/main" id="{7A1866DF-E07D-4BF4-B028-C407FAC4DE26}"/>
               </a:ext>
             </a:extLst>
           </p:cNvPr>
@@ -8741,7 +8741,7 @@
           <p:cNvPr id="26" name="">
             <a:extLst xmlns:a="http://schemas.openxmlformats.org/drawingml/2006/main">
               <a:ext uri="{FF2B5EF4-FFF2-40B4-BE49-F238E27FC236}">
-                <a16:creationId xmlns:a16="http://schemas.microsoft.com/office/drawing/2014/main" id="{679A8028-5802-4243-9CE9-F845765DE06F}"/>
+                <a16:creationId xmlns:a16="http://schemas.microsoft.com/office/drawing/2014/main" id="{A5BC29A1-FCF5-4C1A-93B4-C2CCA7899442}"/>
               </a:ext>
             </a:extLst>
           </p:cNvPr>
@@ -8776,7 +8776,7 @@
           <p:cNvPr id="27" name="">
             <a:extLst xmlns:a="http://schemas.openxmlformats.org/drawingml/2006/main">
               <a:ext uri="{FF2B5EF4-FFF2-40B4-BE49-F238E27FC236}">
-                <a16:creationId xmlns:a16="http://schemas.microsoft.com/office/drawing/2014/main" id="{4388182D-421E-40CA-A047-DF5A44F2E423}"/>
+                <a16:creationId xmlns:a16="http://schemas.microsoft.com/office/drawing/2014/main" id="{264C2768-A7BF-48B1-ACAC-61BAE2029330}"/>
               </a:ext>
             </a:extLst>
           </p:cNvPr>
@@ -8826,7 +8826,7 @@
           <p:cNvPr id="28" name="">
             <a:extLst xmlns:a="http://schemas.openxmlformats.org/drawingml/2006/main">
               <a:ext uri="{FF2B5EF4-FFF2-40B4-BE49-F238E27FC236}">
-                <a16:creationId xmlns:a16="http://schemas.microsoft.com/office/drawing/2014/main" id="{37F387A3-B04A-43C8-9E10-95426DFCB29E}"/>
+                <a16:creationId xmlns:a16="http://schemas.microsoft.com/office/drawing/2014/main" id="{31C196B5-1CE6-45BD-99F3-0C516A480D41}"/>
               </a:ext>
             </a:extLst>
           </p:cNvPr>
@@ -8876,7 +8876,7 @@
           <p:cNvPr id="29" name="">
             <a:extLst xmlns:a="http://schemas.openxmlformats.org/drawingml/2006/main">
               <a:ext uri="{FF2B5EF4-FFF2-40B4-BE49-F238E27FC236}">
-                <a16:creationId xmlns:a16="http://schemas.microsoft.com/office/drawing/2014/main" id="{9EE2B1AE-5035-4F2B-B073-AA7BCE2DD65A}"/>
+                <a16:creationId xmlns:a16="http://schemas.microsoft.com/office/drawing/2014/main" id="{AAAEE73A-D7B8-4511-8EDD-8763D91D9BFC}"/>
               </a:ext>
             </a:extLst>
           </p:cNvPr>
@@ -8926,7 +8926,7 @@
           <p:cNvPr id="30" name="">
             <a:extLst xmlns:a="http://schemas.openxmlformats.org/drawingml/2006/main">
               <a:ext uri="{FF2B5EF4-FFF2-40B4-BE49-F238E27FC236}">
-                <a16:creationId xmlns:a16="http://schemas.microsoft.com/office/drawing/2014/main" id="{A5A299C0-A837-4C0B-BB5D-07EB205C0B47}"/>
+                <a16:creationId xmlns:a16="http://schemas.microsoft.com/office/drawing/2014/main" id="{7B98D8CF-D013-4E53-A09E-21A8DDC4DED5}"/>
               </a:ext>
             </a:extLst>
           </p:cNvPr>
@@ -8957,7 +8957,7 @@
           <p:cNvPr id="31" name="">
             <a:extLst xmlns:a="http://schemas.openxmlformats.org/drawingml/2006/main">
               <a:ext uri="{FF2B5EF4-FFF2-40B4-BE49-F238E27FC236}">
-                <a16:creationId xmlns:a16="http://schemas.microsoft.com/office/drawing/2014/main" id="{08C95287-7332-4ED6-B9E1-C08F79669AE4}"/>
+                <a16:creationId xmlns:a16="http://schemas.microsoft.com/office/drawing/2014/main" id="{1D016B18-9199-4485-98FA-D113DF84D911}"/>
               </a:ext>
             </a:extLst>
           </p:cNvPr>
@@ -9007,7 +9007,7 @@
           <p:cNvPr id="32" name="">
             <a:extLst xmlns:a="http://schemas.openxmlformats.org/drawingml/2006/main">
               <a:ext uri="{FF2B5EF4-FFF2-40B4-BE49-F238E27FC236}">
-                <a16:creationId xmlns:a16="http://schemas.microsoft.com/office/drawing/2014/main" id="{2CA822DF-885D-400F-BF30-DE5822B842C4}"/>
+                <a16:creationId xmlns:a16="http://schemas.microsoft.com/office/drawing/2014/main" id="{919E01A9-B3CB-43CB-991A-EB8B5E5ECC27}"/>
               </a:ext>
             </a:extLst>
           </p:cNvPr>
@@ -9057,7 +9057,7 @@
           <p:cNvPr id="33" name="">
             <a:extLst xmlns:a="http://schemas.openxmlformats.org/drawingml/2006/main">
               <a:ext uri="{FF2B5EF4-FFF2-40B4-BE49-F238E27FC236}">
-                <a16:creationId xmlns:a16="http://schemas.microsoft.com/office/drawing/2014/main" id="{BF66E494-738A-41B4-8246-E38491728628}"/>
+                <a16:creationId xmlns:a16="http://schemas.microsoft.com/office/drawing/2014/main" id="{35FB5425-945B-4EB2-B0CD-D8CF675DFAC3}"/>
               </a:ext>
             </a:extLst>
           </p:cNvPr>
@@ -9107,7 +9107,7 @@
           <p:cNvPr id="34" name="">
             <a:extLst xmlns:a="http://schemas.openxmlformats.org/drawingml/2006/main">
               <a:ext uri="{FF2B5EF4-FFF2-40B4-BE49-F238E27FC236}">
-                <a16:creationId xmlns:a16="http://schemas.microsoft.com/office/drawing/2014/main" id="{44A90F1C-5930-4FFD-8C21-F89A16FBAF55}"/>
+                <a16:creationId xmlns:a16="http://schemas.microsoft.com/office/drawing/2014/main" id="{5C0E4878-EA87-4185-ACE5-AEC465E6B507}"/>
               </a:ext>
             </a:extLst>
           </p:cNvPr>
@@ -9157,7 +9157,7 @@
           <p:cNvPr id="35" name="">
             <a:extLst xmlns:a="http://schemas.openxmlformats.org/drawingml/2006/main">
               <a:ext uri="{FF2B5EF4-FFF2-40B4-BE49-F238E27FC236}">
-                <a16:creationId xmlns:a16="http://schemas.microsoft.com/office/drawing/2014/main" id="{D6B6A0C6-8AFD-4E54-9674-A2A4B4C9D4A9}"/>
+                <a16:creationId xmlns:a16="http://schemas.microsoft.com/office/drawing/2014/main" id="{3458C2A6-208C-4CB8-AB20-C8A0CC59E909}"/>
               </a:ext>
             </a:extLst>
           </p:cNvPr>
@@ -9192,7 +9192,7 @@
           <p:cNvPr id="36" name="">
             <a:extLst xmlns:a="http://schemas.openxmlformats.org/drawingml/2006/main">
               <a:ext uri="{FF2B5EF4-FFF2-40B4-BE49-F238E27FC236}">
-                <a16:creationId xmlns:a16="http://schemas.microsoft.com/office/drawing/2014/main" id="{5A2A56EE-6A86-4AB9-B628-DA22758CFFC8}"/>
+                <a16:creationId xmlns:a16="http://schemas.microsoft.com/office/drawing/2014/main" id="{7A30677C-182B-4B0B-A649-16A78E81F3F3}"/>
               </a:ext>
             </a:extLst>
           </p:cNvPr>
@@ -9242,7 +9242,7 @@
           <p:cNvPr id="37" name="">
             <a:extLst xmlns:a="http://schemas.openxmlformats.org/drawingml/2006/main">
               <a:ext uri="{FF2B5EF4-FFF2-40B4-BE49-F238E27FC236}">
-                <a16:creationId xmlns:a16="http://schemas.microsoft.com/office/drawing/2014/main" id="{E9B1CDBD-7381-4087-9FAB-CF2B4C5F3E3F}"/>
+                <a16:creationId xmlns:a16="http://schemas.microsoft.com/office/drawing/2014/main" id="{AB4788C6-4E1F-4252-B853-6B3C19CC4A5A}"/>
               </a:ext>
             </a:extLst>
           </p:cNvPr>
@@ -9292,7 +9292,7 @@
           <p:cNvPr id="38" name="">
             <a:extLst xmlns:a="http://schemas.openxmlformats.org/drawingml/2006/main">
               <a:ext uri="{FF2B5EF4-FFF2-40B4-BE49-F238E27FC236}">
-                <a16:creationId xmlns:a16="http://schemas.microsoft.com/office/drawing/2014/main" id="{84047AEF-CA69-41E6-93F9-A4C7D8DD27AA}"/>
+                <a16:creationId xmlns:a16="http://schemas.microsoft.com/office/drawing/2014/main" id="{A37C7F51-F669-412E-9AAB-2081CAA56D43}"/>
               </a:ext>
             </a:extLst>
           </p:cNvPr>
@@ -9342,7 +9342,7 @@
           <p:cNvPr id="39" name="">
             <a:extLst xmlns:a="http://schemas.openxmlformats.org/drawingml/2006/main">
               <a:ext uri="{FF2B5EF4-FFF2-40B4-BE49-F238E27FC236}">
-                <a16:creationId xmlns:a16="http://schemas.microsoft.com/office/drawing/2014/main" id="{BCAA042A-4AB3-49A5-9184-9060F96A25E7}"/>
+                <a16:creationId xmlns:a16="http://schemas.microsoft.com/office/drawing/2014/main" id="{0D86CDD1-91C0-493B-B9B6-A77D7A9659DD}"/>
               </a:ext>
             </a:extLst>
           </p:cNvPr>
@@ -9373,7 +9373,7 @@
           <p:cNvPr id="40" name="">
             <a:extLst xmlns:a="http://schemas.openxmlformats.org/drawingml/2006/main">
               <a:ext uri="{FF2B5EF4-FFF2-40B4-BE49-F238E27FC236}">
-                <a16:creationId xmlns:a16="http://schemas.microsoft.com/office/drawing/2014/main" id="{6CAEEE6D-F911-4CF7-9CE3-10DEFB35FFA0}"/>
+                <a16:creationId xmlns:a16="http://schemas.microsoft.com/office/drawing/2014/main" id="{5787E616-559E-4A28-821F-BD351EC61A30}"/>
               </a:ext>
             </a:extLst>
           </p:cNvPr>
@@ -9423,7 +9423,7 @@
           <p:cNvPr id="41" name="">
             <a:extLst xmlns:a="http://schemas.openxmlformats.org/drawingml/2006/main">
               <a:ext uri="{FF2B5EF4-FFF2-40B4-BE49-F238E27FC236}">
-                <a16:creationId xmlns:a16="http://schemas.microsoft.com/office/drawing/2014/main" id="{7D2B6899-5939-4B20-A1D1-0DED13A44033}"/>
+                <a16:creationId xmlns:a16="http://schemas.microsoft.com/office/drawing/2014/main" id="{8D54588B-B23A-4AA7-A2D9-3636B79E9ED9}"/>
               </a:ext>
             </a:extLst>
           </p:cNvPr>
@@ -9473,7 +9473,7 @@
           <p:cNvPr id="42" name="">
             <a:extLst xmlns:a="http://schemas.openxmlformats.org/drawingml/2006/main">
               <a:ext uri="{FF2B5EF4-FFF2-40B4-BE49-F238E27FC236}">
-                <a16:creationId xmlns:a16="http://schemas.microsoft.com/office/drawing/2014/main" id="{A26790F3-DC3A-47FE-AC23-4D65427BA99D}"/>
+                <a16:creationId xmlns:a16="http://schemas.microsoft.com/office/drawing/2014/main" id="{A066FA4B-42B4-4FCD-A500-C6363A927F2A}"/>
               </a:ext>
             </a:extLst>
           </p:cNvPr>
@@ -9523,7 +9523,7 @@
           <p:cNvPr id="43" name="">
             <a:extLst xmlns:a="http://schemas.openxmlformats.org/drawingml/2006/main">
               <a:ext uri="{FF2B5EF4-FFF2-40B4-BE49-F238E27FC236}">
-                <a16:creationId xmlns:a16="http://schemas.microsoft.com/office/drawing/2014/main" id="{7C5531DC-E0CB-40A3-8451-9B0983FAA264}"/>
+                <a16:creationId xmlns:a16="http://schemas.microsoft.com/office/drawing/2014/main" id="{2C2965D2-1CDA-454D-A3CC-63793348F2F3}"/>
               </a:ext>
             </a:extLst>
           </p:cNvPr>
@@ -9571,7 +9571,7 @@
     </p:spTree>
     <p:extLst>
       <p:ext uri="{BB962C8B-B14F-4D97-AF65-F5344CB8AC3E}">
-        <p14:creationId xmlns:p14="http://schemas.microsoft.com/office/powerpoint/2010/main" val="564898389"/>
+        <p14:creationId xmlns:p14="http://schemas.microsoft.com/office/powerpoint/2010/main" val="752008763"/>
       </p:ext>
     </p:extLst>
   </p:cSld>
@@ -9602,7 +9602,7 @@
           <p:cNvPr id="1" name="">
             <a:extLst xmlns:a="http://schemas.openxmlformats.org/drawingml/2006/main">
               <a:ext uri="{FF2B5EF4-FFF2-40B4-BE49-F238E27FC236}">
-                <a16:creationId xmlns:a16="http://schemas.microsoft.com/office/drawing/2014/main" id="{9DD56AC2-E50B-4677-A9EA-F88D23008841}"/>
+                <a16:creationId xmlns:a16="http://schemas.microsoft.com/office/drawing/2014/main" id="{30FEB9F8-2709-43FC-B364-4400ED0D2A73}"/>
               </a:ext>
             </a:extLst>
           </p:cNvPr>
@@ -9637,7 +9637,7 @@
           <p:nvPr/>
         </p:nvPicPr>
         <p:blipFill>
-          <a:blip xmlns:r="http://schemas.openxmlformats.org/officeDocument/2006/relationships" xmlns:a="http://schemas.openxmlformats.org/drawingml/2006/main" r:embed="Rac007b21327e437b"/>
+          <a:blip xmlns:r="http://schemas.openxmlformats.org/officeDocument/2006/relationships" xmlns:a="http://schemas.openxmlformats.org/drawingml/2006/main" r:embed="Rd9db00bc8c70410a"/>
           <a:stretch xmlns:a="http://schemas.openxmlformats.org/drawingml/2006/main"/>
         </p:blipFill>
         <p:spPr>
@@ -9655,7 +9655,7 @@
           <p:cNvPr id="3" name="">
             <a:extLst xmlns:a="http://schemas.openxmlformats.org/drawingml/2006/main">
               <a:ext uri="{FF2B5EF4-FFF2-40B4-BE49-F238E27FC236}">
-                <a16:creationId xmlns:a16="http://schemas.microsoft.com/office/drawing/2014/main" id="{9BDB1B03-6A2F-4044-87EE-5AF8EEE54C13}"/>
+                <a16:creationId xmlns:a16="http://schemas.microsoft.com/office/drawing/2014/main" id="{EE2E8578-10DB-4197-A5C6-397131079227}"/>
               </a:ext>
             </a:extLst>
           </p:cNvPr>
@@ -9705,7 +9705,7 @@
           <p:cNvPr id="4" name="">
             <a:extLst xmlns:a="http://schemas.openxmlformats.org/drawingml/2006/main">
               <a:ext uri="{FF2B5EF4-FFF2-40B4-BE49-F238E27FC236}">
-                <a16:creationId xmlns:a16="http://schemas.microsoft.com/office/drawing/2014/main" id="{B3951474-B951-43DD-BF5B-E7E0C1222844}"/>
+                <a16:creationId xmlns:a16="http://schemas.microsoft.com/office/drawing/2014/main" id="{88924468-D3D5-4B67-872C-3794DBCC3161}"/>
               </a:ext>
             </a:extLst>
           </p:cNvPr>
@@ -9738,7 +9738,7 @@
           <p:cNvPr id="5" name="">
             <a:extLst xmlns:a="http://schemas.openxmlformats.org/drawingml/2006/main">
               <a:ext uri="{FF2B5EF4-FFF2-40B4-BE49-F238E27FC236}">
-                <a16:creationId xmlns:a16="http://schemas.microsoft.com/office/drawing/2014/main" id="{72BEFE9D-C698-4CBC-BDFF-A21BDB17B895}"/>
+                <a16:creationId xmlns:a16="http://schemas.microsoft.com/office/drawing/2014/main" id="{7AA0010F-D621-4D9C-8CFA-7999F50B0A94}"/>
               </a:ext>
             </a:extLst>
           </p:cNvPr>
@@ -9769,7 +9769,7 @@
           <p:cNvPr id="6" name="">
             <a:extLst xmlns:a="http://schemas.openxmlformats.org/drawingml/2006/main">
               <a:ext uri="{FF2B5EF4-FFF2-40B4-BE49-F238E27FC236}">
-                <a16:creationId xmlns:a16="http://schemas.microsoft.com/office/drawing/2014/main" id="{E15119AF-A4CF-472B-9E2F-F582E2D14FB0}"/>
+                <a16:creationId xmlns:a16="http://schemas.microsoft.com/office/drawing/2014/main" id="{AE491212-1979-4376-8D45-1305B8657334}"/>
               </a:ext>
             </a:extLst>
           </p:cNvPr>
@@ -9819,7 +9819,7 @@
           <p:cNvPr id="7" name="">
             <a:extLst xmlns:a="http://schemas.openxmlformats.org/drawingml/2006/main">
               <a:ext uri="{FF2B5EF4-FFF2-40B4-BE49-F238E27FC236}">
-                <a16:creationId xmlns:a16="http://schemas.microsoft.com/office/drawing/2014/main" id="{16CC8D89-3C6D-4BEF-8F74-D1BDACA96446}"/>
+                <a16:creationId xmlns:a16="http://schemas.microsoft.com/office/drawing/2014/main" id="{2A90FC72-F3E1-4425-893B-B048495D9F5B}"/>
               </a:ext>
             </a:extLst>
           </p:cNvPr>
@@ -9869,7 +9869,7 @@
           <p:cNvPr id="8" name="">
             <a:extLst xmlns:a="http://schemas.openxmlformats.org/drawingml/2006/main">
               <a:ext uri="{FF2B5EF4-FFF2-40B4-BE49-F238E27FC236}">
-                <a16:creationId xmlns:a16="http://schemas.microsoft.com/office/drawing/2014/main" id="{506AE632-4169-45C0-9DF8-89A0D01E8707}"/>
+                <a16:creationId xmlns:a16="http://schemas.microsoft.com/office/drawing/2014/main" id="{6173936C-CEAD-4A27-A7A0-8A7468D51255}"/>
               </a:ext>
             </a:extLst>
           </p:cNvPr>
@@ -9904,7 +9904,7 @@
           <p:cNvPr id="9" name="">
             <a:extLst xmlns:a="http://schemas.openxmlformats.org/drawingml/2006/main">
               <a:ext uri="{FF2B5EF4-FFF2-40B4-BE49-F238E27FC236}">
-                <a16:creationId xmlns:a16="http://schemas.microsoft.com/office/drawing/2014/main" id="{F1F61CAE-C1EA-4E03-BA52-3B4E035B189B}"/>
+                <a16:creationId xmlns:a16="http://schemas.microsoft.com/office/drawing/2014/main" id="{EF2BD424-FB38-4EF4-B906-24FB0EDF1AD4}"/>
               </a:ext>
             </a:extLst>
           </p:cNvPr>
@@ -9954,7 +9954,7 @@
           <p:cNvPr id="10" name="">
             <a:extLst xmlns:a="http://schemas.openxmlformats.org/drawingml/2006/main">
               <a:ext uri="{FF2B5EF4-FFF2-40B4-BE49-F238E27FC236}">
-                <a16:creationId xmlns:a16="http://schemas.microsoft.com/office/drawing/2014/main" id="{64B55EC0-6C0F-4167-B15D-8F5AF78EA8AC}"/>
+                <a16:creationId xmlns:a16="http://schemas.microsoft.com/office/drawing/2014/main" id="{2826C3F7-4BBC-49CE-B4D6-7DA5CF829F14}"/>
               </a:ext>
             </a:extLst>
           </p:cNvPr>
@@ -10004,7 +10004,7 @@
           <p:cNvPr id="11" name="">
             <a:extLst xmlns:a="http://schemas.openxmlformats.org/drawingml/2006/main">
               <a:ext uri="{FF2B5EF4-FFF2-40B4-BE49-F238E27FC236}">
-                <a16:creationId xmlns:a16="http://schemas.microsoft.com/office/drawing/2014/main" id="{0D90AF93-2056-4A56-80A4-802306EDADFE}"/>
+                <a16:creationId xmlns:a16="http://schemas.microsoft.com/office/drawing/2014/main" id="{89BBFD1B-60C8-4111-9072-B63AF3B4AF55}"/>
               </a:ext>
             </a:extLst>
           </p:cNvPr>
@@ -10054,7 +10054,7 @@
           <p:cNvPr id="12" name="">
             <a:extLst xmlns:a="http://schemas.openxmlformats.org/drawingml/2006/main">
               <a:ext uri="{FF2B5EF4-FFF2-40B4-BE49-F238E27FC236}">
-                <a16:creationId xmlns:a16="http://schemas.microsoft.com/office/drawing/2014/main" id="{F9180B7D-6C5A-4D05-9094-9626E9D9A453}"/>
+                <a16:creationId xmlns:a16="http://schemas.microsoft.com/office/drawing/2014/main" id="{C663D79A-47FB-427E-B104-2BA622959390}"/>
               </a:ext>
             </a:extLst>
           </p:cNvPr>
@@ -10085,7 +10085,7 @@
           <p:cNvPr id="13" name="">
             <a:extLst xmlns:a="http://schemas.openxmlformats.org/drawingml/2006/main">
               <a:ext uri="{FF2B5EF4-FFF2-40B4-BE49-F238E27FC236}">
-                <a16:creationId xmlns:a16="http://schemas.microsoft.com/office/drawing/2014/main" id="{DC2FC499-662A-4A96-8511-0602CBCD6E46}"/>
+                <a16:creationId xmlns:a16="http://schemas.microsoft.com/office/drawing/2014/main" id="{C44A3FEB-2D7B-4CBD-A684-6F6303959D75}"/>
               </a:ext>
             </a:extLst>
           </p:cNvPr>
@@ -10135,7 +10135,7 @@
           <p:cNvPr id="14" name="">
             <a:extLst xmlns:a="http://schemas.openxmlformats.org/drawingml/2006/main">
               <a:ext uri="{FF2B5EF4-FFF2-40B4-BE49-F238E27FC236}">
-                <a16:creationId xmlns:a16="http://schemas.microsoft.com/office/drawing/2014/main" id="{5D964AD6-00DD-4F89-9FF0-E9753B5005FF}"/>
+                <a16:creationId xmlns:a16="http://schemas.microsoft.com/office/drawing/2014/main" id="{8EC66929-9F06-4E8A-82DB-382A6EFCCE1F}"/>
               </a:ext>
             </a:extLst>
           </p:cNvPr>
@@ -10185,7 +10185,7 @@
           <p:cNvPr id="15" name="">
             <a:extLst xmlns:a="http://schemas.openxmlformats.org/drawingml/2006/main">
               <a:ext uri="{FF2B5EF4-FFF2-40B4-BE49-F238E27FC236}">
-                <a16:creationId xmlns:a16="http://schemas.microsoft.com/office/drawing/2014/main" id="{D32FF275-325E-4601-8245-D65465B95986}"/>
+                <a16:creationId xmlns:a16="http://schemas.microsoft.com/office/drawing/2014/main" id="{E916E3C5-7FCA-4024-A584-4E7EA9673806}"/>
               </a:ext>
             </a:extLst>
           </p:cNvPr>
@@ -10235,7 +10235,7 @@
           <p:cNvPr id="16" name="">
             <a:extLst xmlns:a="http://schemas.openxmlformats.org/drawingml/2006/main">
               <a:ext uri="{FF2B5EF4-FFF2-40B4-BE49-F238E27FC236}">
-                <a16:creationId xmlns:a16="http://schemas.microsoft.com/office/drawing/2014/main" id="{31CF77F0-8DD8-423D-814A-0C37D068BA32}"/>
+                <a16:creationId xmlns:a16="http://schemas.microsoft.com/office/drawing/2014/main" id="{D16D1E99-45F7-4DFB-ABB2-4B4C236FF508}"/>
               </a:ext>
             </a:extLst>
           </p:cNvPr>
@@ -10285,7 +10285,7 @@
           <p:cNvPr id="17" name="">
             <a:extLst xmlns:a="http://schemas.openxmlformats.org/drawingml/2006/main">
               <a:ext uri="{FF2B5EF4-FFF2-40B4-BE49-F238E27FC236}">
-                <a16:creationId xmlns:a16="http://schemas.microsoft.com/office/drawing/2014/main" id="{5F103E6A-93B4-4906-ABD0-4B5D4B27DE20}"/>
+                <a16:creationId xmlns:a16="http://schemas.microsoft.com/office/drawing/2014/main" id="{BE3FFAEA-5F3F-41D8-9DBA-8C586D98C36E}"/>
               </a:ext>
             </a:extLst>
           </p:cNvPr>
@@ -10320,7 +10320,7 @@
           <p:cNvPr id="18" name="">
             <a:extLst xmlns:a="http://schemas.openxmlformats.org/drawingml/2006/main">
               <a:ext uri="{FF2B5EF4-FFF2-40B4-BE49-F238E27FC236}">
-                <a16:creationId xmlns:a16="http://schemas.microsoft.com/office/drawing/2014/main" id="{36F9A32D-039C-4D00-89D2-715E5F30E4C5}"/>
+                <a16:creationId xmlns:a16="http://schemas.microsoft.com/office/drawing/2014/main" id="{7A360AAD-80EE-44AC-A854-3C0F00C1DC3E}"/>
               </a:ext>
             </a:extLst>
           </p:cNvPr>
@@ -10370,7 +10370,7 @@
           <p:cNvPr id="19" name="">
             <a:extLst xmlns:a="http://schemas.openxmlformats.org/drawingml/2006/main">
               <a:ext uri="{FF2B5EF4-FFF2-40B4-BE49-F238E27FC236}">
-                <a16:creationId xmlns:a16="http://schemas.microsoft.com/office/drawing/2014/main" id="{A17A3EDE-5F8A-49E6-83F9-1CCEE52FD575}"/>
+                <a16:creationId xmlns:a16="http://schemas.microsoft.com/office/drawing/2014/main" id="{9759FE2D-41ED-4F1D-8A2D-D799F78FF57B}"/>
               </a:ext>
             </a:extLst>
           </p:cNvPr>
@@ -10420,7 +10420,7 @@
           <p:cNvPr id="20" name="">
             <a:extLst xmlns:a="http://schemas.openxmlformats.org/drawingml/2006/main">
               <a:ext uri="{FF2B5EF4-FFF2-40B4-BE49-F238E27FC236}">
-                <a16:creationId xmlns:a16="http://schemas.microsoft.com/office/drawing/2014/main" id="{D622C38A-0C4D-40D7-85BA-3F8D3323F707}"/>
+                <a16:creationId xmlns:a16="http://schemas.microsoft.com/office/drawing/2014/main" id="{F0C93E02-840B-4C48-ACFD-D97956C88B10}"/>
               </a:ext>
             </a:extLst>
           </p:cNvPr>
@@ -10470,7 +10470,7 @@
           <p:cNvPr id="21" name="">
             <a:extLst xmlns:a="http://schemas.openxmlformats.org/drawingml/2006/main">
               <a:ext uri="{FF2B5EF4-FFF2-40B4-BE49-F238E27FC236}">
-                <a16:creationId xmlns:a16="http://schemas.microsoft.com/office/drawing/2014/main" id="{D5212DE1-C450-4E3D-BF16-B619C40FE20C}"/>
+                <a16:creationId xmlns:a16="http://schemas.microsoft.com/office/drawing/2014/main" id="{B6B553D5-E942-44AA-9785-59C265007423}"/>
               </a:ext>
             </a:extLst>
           </p:cNvPr>
@@ -10501,7 +10501,7 @@
           <p:cNvPr id="22" name="">
             <a:extLst xmlns:a="http://schemas.openxmlformats.org/drawingml/2006/main">
               <a:ext uri="{FF2B5EF4-FFF2-40B4-BE49-F238E27FC236}">
-                <a16:creationId xmlns:a16="http://schemas.microsoft.com/office/drawing/2014/main" id="{F761C9F4-CD0C-4A33-8A72-7B1D64742E67}"/>
+                <a16:creationId xmlns:a16="http://schemas.microsoft.com/office/drawing/2014/main" id="{67692EC2-3A1E-42B7-959C-4804296AA2C8}"/>
               </a:ext>
             </a:extLst>
           </p:cNvPr>
@@ -10551,7 +10551,7 @@
           <p:cNvPr id="23" name="">
             <a:extLst xmlns:a="http://schemas.openxmlformats.org/drawingml/2006/main">
               <a:ext uri="{FF2B5EF4-FFF2-40B4-BE49-F238E27FC236}">
-                <a16:creationId xmlns:a16="http://schemas.microsoft.com/office/drawing/2014/main" id="{683F3BAA-2F39-4984-8075-8047714ECBA8}"/>
+                <a16:creationId xmlns:a16="http://schemas.microsoft.com/office/drawing/2014/main" id="{36881B94-BDBA-48D1-8133-409DB88E999D}"/>
               </a:ext>
             </a:extLst>
           </p:cNvPr>
@@ -10601,7 +10601,7 @@
           <p:cNvPr id="24" name="">
             <a:extLst xmlns:a="http://schemas.openxmlformats.org/drawingml/2006/main">
               <a:ext uri="{FF2B5EF4-FFF2-40B4-BE49-F238E27FC236}">
-                <a16:creationId xmlns:a16="http://schemas.microsoft.com/office/drawing/2014/main" id="{DE4C9A92-1E59-4A58-B3D7-4D8A4D61FE92}"/>
+                <a16:creationId xmlns:a16="http://schemas.microsoft.com/office/drawing/2014/main" id="{C61F3ECE-9D9B-41A8-9973-E1028A3D1F30}"/>
               </a:ext>
             </a:extLst>
           </p:cNvPr>
@@ -10651,7 +10651,7 @@
           <p:cNvPr id="25" name="">
             <a:extLst xmlns:a="http://schemas.openxmlformats.org/drawingml/2006/main">
               <a:ext uri="{FF2B5EF4-FFF2-40B4-BE49-F238E27FC236}">
-                <a16:creationId xmlns:a16="http://schemas.microsoft.com/office/drawing/2014/main" id="{C83ACDB5-0DDE-4D41-A1D7-2718FD02BE19}"/>
+                <a16:creationId xmlns:a16="http://schemas.microsoft.com/office/drawing/2014/main" id="{B72B1122-5FAD-4781-86A5-EEDC775EF248}"/>
               </a:ext>
             </a:extLst>
           </p:cNvPr>
@@ -10701,7 +10701,7 @@
           <p:cNvPr id="26" name="">
             <a:extLst xmlns:a="http://schemas.openxmlformats.org/drawingml/2006/main">
               <a:ext uri="{FF2B5EF4-FFF2-40B4-BE49-F238E27FC236}">
-                <a16:creationId xmlns:a16="http://schemas.microsoft.com/office/drawing/2014/main" id="{5AE73C22-5C41-4603-B1A3-57C00C802CE9}"/>
+                <a16:creationId xmlns:a16="http://schemas.microsoft.com/office/drawing/2014/main" id="{1464AAF7-D452-4002-880E-A9443B7C59E0}"/>
               </a:ext>
             </a:extLst>
           </p:cNvPr>
@@ -10736,7 +10736,7 @@
           <p:cNvPr id="27" name="">
             <a:extLst xmlns:a="http://schemas.openxmlformats.org/drawingml/2006/main">
               <a:ext uri="{FF2B5EF4-FFF2-40B4-BE49-F238E27FC236}">
-                <a16:creationId xmlns:a16="http://schemas.microsoft.com/office/drawing/2014/main" id="{8D546D5C-1082-4691-9FF9-D45006A94D88}"/>
+                <a16:creationId xmlns:a16="http://schemas.microsoft.com/office/drawing/2014/main" id="{8BA30FD7-EEA1-4C54-A7AE-6D6D13DAD3C3}"/>
               </a:ext>
             </a:extLst>
           </p:cNvPr>
@@ -10786,7 +10786,7 @@
           <p:cNvPr id="28" name="">
             <a:extLst xmlns:a="http://schemas.openxmlformats.org/drawingml/2006/main">
               <a:ext uri="{FF2B5EF4-FFF2-40B4-BE49-F238E27FC236}">
-                <a16:creationId xmlns:a16="http://schemas.microsoft.com/office/drawing/2014/main" id="{EFD49137-6363-459E-BF67-BA7F2D0DC03E}"/>
+                <a16:creationId xmlns:a16="http://schemas.microsoft.com/office/drawing/2014/main" id="{875A8A9C-8FA1-4C46-BCAB-B3A9A4B94066}"/>
               </a:ext>
             </a:extLst>
           </p:cNvPr>
@@ -10836,7 +10836,7 @@
           <p:cNvPr id="29" name="">
             <a:extLst xmlns:a="http://schemas.openxmlformats.org/drawingml/2006/main">
               <a:ext uri="{FF2B5EF4-FFF2-40B4-BE49-F238E27FC236}">
-                <a16:creationId xmlns:a16="http://schemas.microsoft.com/office/drawing/2014/main" id="{CCCB4436-E3A9-44AE-A6C7-B0034161BE10}"/>
+                <a16:creationId xmlns:a16="http://schemas.microsoft.com/office/drawing/2014/main" id="{A06F7A26-9D8A-466F-A325-E92529E116B8}"/>
               </a:ext>
             </a:extLst>
           </p:cNvPr>
@@ -10886,7 +10886,7 @@
           <p:cNvPr id="30" name="">
             <a:extLst xmlns:a="http://schemas.openxmlformats.org/drawingml/2006/main">
               <a:ext uri="{FF2B5EF4-FFF2-40B4-BE49-F238E27FC236}">
-                <a16:creationId xmlns:a16="http://schemas.microsoft.com/office/drawing/2014/main" id="{B47BEC05-C8B8-4087-AF40-FE1448D1B4EA}"/>
+                <a16:creationId xmlns:a16="http://schemas.microsoft.com/office/drawing/2014/main" id="{313FF71F-8CB5-472F-99DD-B34592BEA756}"/>
               </a:ext>
             </a:extLst>
           </p:cNvPr>
@@ -10917,7 +10917,7 @@
           <p:cNvPr id="31" name="">
             <a:extLst xmlns:a="http://schemas.openxmlformats.org/drawingml/2006/main">
               <a:ext uri="{FF2B5EF4-FFF2-40B4-BE49-F238E27FC236}">
-                <a16:creationId xmlns:a16="http://schemas.microsoft.com/office/drawing/2014/main" id="{6F113BB8-FA30-4D47-840C-3217D4C2366D}"/>
+                <a16:creationId xmlns:a16="http://schemas.microsoft.com/office/drawing/2014/main" id="{2FC9F545-3E65-4027-A83B-7471456055B1}"/>
               </a:ext>
             </a:extLst>
           </p:cNvPr>
@@ -10967,7 +10967,7 @@
           <p:cNvPr id="32" name="">
             <a:extLst xmlns:a="http://schemas.openxmlformats.org/drawingml/2006/main">
               <a:ext uri="{FF2B5EF4-FFF2-40B4-BE49-F238E27FC236}">
-                <a16:creationId xmlns:a16="http://schemas.microsoft.com/office/drawing/2014/main" id="{D5F8C244-F2F8-47CD-803A-508CDA329A90}"/>
+                <a16:creationId xmlns:a16="http://schemas.microsoft.com/office/drawing/2014/main" id="{194A3644-1F91-43AF-B2F9-B7E843597700}"/>
               </a:ext>
             </a:extLst>
           </p:cNvPr>
@@ -11017,7 +11017,7 @@
           <p:cNvPr id="33" name="">
             <a:extLst xmlns:a="http://schemas.openxmlformats.org/drawingml/2006/main">
               <a:ext uri="{FF2B5EF4-FFF2-40B4-BE49-F238E27FC236}">
-                <a16:creationId xmlns:a16="http://schemas.microsoft.com/office/drawing/2014/main" id="{CC0F64D9-4EE2-4251-8D2D-51847CF0761C}"/>
+                <a16:creationId xmlns:a16="http://schemas.microsoft.com/office/drawing/2014/main" id="{37675591-00B0-407B-BF19-007D2C3513D1}"/>
               </a:ext>
             </a:extLst>
           </p:cNvPr>
@@ -11067,7 +11067,7 @@
           <p:cNvPr id="34" name="">
             <a:extLst xmlns:a="http://schemas.openxmlformats.org/drawingml/2006/main">
               <a:ext uri="{FF2B5EF4-FFF2-40B4-BE49-F238E27FC236}">
-                <a16:creationId xmlns:a16="http://schemas.microsoft.com/office/drawing/2014/main" id="{ECC593A1-FB7C-4C89-99BB-D24CEDA8B18E}"/>
+                <a16:creationId xmlns:a16="http://schemas.microsoft.com/office/drawing/2014/main" id="{90DBBAFA-CB53-4B79-AC2B-F76F4D4C5518}"/>
               </a:ext>
             </a:extLst>
           </p:cNvPr>
@@ -11117,7 +11117,7 @@
           <p:cNvPr id="35" name="">
             <a:extLst xmlns:a="http://schemas.openxmlformats.org/drawingml/2006/main">
               <a:ext uri="{FF2B5EF4-FFF2-40B4-BE49-F238E27FC236}">
-                <a16:creationId xmlns:a16="http://schemas.microsoft.com/office/drawing/2014/main" id="{5AB147B1-9AF7-4899-BF9F-AAC9B2E90A48}"/>
+                <a16:creationId xmlns:a16="http://schemas.microsoft.com/office/drawing/2014/main" id="{81D6F51F-CA01-4592-BA40-C5E02BF63215}"/>
               </a:ext>
             </a:extLst>
           </p:cNvPr>
@@ -11152,7 +11152,7 @@
           <p:cNvPr id="36" name="">
             <a:extLst xmlns:a="http://schemas.openxmlformats.org/drawingml/2006/main">
               <a:ext uri="{FF2B5EF4-FFF2-40B4-BE49-F238E27FC236}">
-                <a16:creationId xmlns:a16="http://schemas.microsoft.com/office/drawing/2014/main" id="{CA990310-F5B4-4324-9775-57D7E607D7FC}"/>
+                <a16:creationId xmlns:a16="http://schemas.microsoft.com/office/drawing/2014/main" id="{715B7208-D1FB-4AA5-AFD0-2D470DF8A517}"/>
               </a:ext>
             </a:extLst>
           </p:cNvPr>
@@ -11202,7 +11202,7 @@
           <p:cNvPr id="37" name="">
             <a:extLst xmlns:a="http://schemas.openxmlformats.org/drawingml/2006/main">
               <a:ext uri="{FF2B5EF4-FFF2-40B4-BE49-F238E27FC236}">
-                <a16:creationId xmlns:a16="http://schemas.microsoft.com/office/drawing/2014/main" id="{8A51CACD-A02E-4970-89AD-87A6B5FB9E30}"/>
+                <a16:creationId xmlns:a16="http://schemas.microsoft.com/office/drawing/2014/main" id="{5982726E-C471-43B8-980E-CF5E05633915}"/>
               </a:ext>
             </a:extLst>
           </p:cNvPr>
@@ -11252,7 +11252,7 @@
           <p:cNvPr id="38" name="">
             <a:extLst xmlns:a="http://schemas.openxmlformats.org/drawingml/2006/main">
               <a:ext uri="{FF2B5EF4-FFF2-40B4-BE49-F238E27FC236}">
-                <a16:creationId xmlns:a16="http://schemas.microsoft.com/office/drawing/2014/main" id="{767902C3-46F7-4BD3-BD23-239852D17E7A}"/>
+                <a16:creationId xmlns:a16="http://schemas.microsoft.com/office/drawing/2014/main" id="{B92580AE-3DBD-4C54-BECC-C33D183E214A}"/>
               </a:ext>
             </a:extLst>
           </p:cNvPr>
@@ -11302,7 +11302,7 @@
           <p:cNvPr id="39" name="">
             <a:extLst xmlns:a="http://schemas.openxmlformats.org/drawingml/2006/main">
               <a:ext uri="{FF2B5EF4-FFF2-40B4-BE49-F238E27FC236}">
-                <a16:creationId xmlns:a16="http://schemas.microsoft.com/office/drawing/2014/main" id="{F7A99D42-986F-483D-B421-11277E4C1A7D}"/>
+                <a16:creationId xmlns:a16="http://schemas.microsoft.com/office/drawing/2014/main" id="{94F570DD-AE60-4596-970E-71D151040922}"/>
               </a:ext>
             </a:extLst>
           </p:cNvPr>
@@ -11333,7 +11333,7 @@
           <p:cNvPr id="40" name="">
             <a:extLst xmlns:a="http://schemas.openxmlformats.org/drawingml/2006/main">
               <a:ext uri="{FF2B5EF4-FFF2-40B4-BE49-F238E27FC236}">
-                <a16:creationId xmlns:a16="http://schemas.microsoft.com/office/drawing/2014/main" id="{1AFC8F4D-C995-400F-98D4-D07A53FFB6AD}"/>
+                <a16:creationId xmlns:a16="http://schemas.microsoft.com/office/drawing/2014/main" id="{A85440C9-050B-4D01-B16A-794EA598F1C2}"/>
               </a:ext>
             </a:extLst>
           </p:cNvPr>
@@ -11383,7 +11383,7 @@
           <p:cNvPr id="41" name="">
             <a:extLst xmlns:a="http://schemas.openxmlformats.org/drawingml/2006/main">
               <a:ext uri="{FF2B5EF4-FFF2-40B4-BE49-F238E27FC236}">
-                <a16:creationId xmlns:a16="http://schemas.microsoft.com/office/drawing/2014/main" id="{CCD84E4E-F3F3-4C05-ABD6-F50FA0ACD8E7}"/>
+                <a16:creationId xmlns:a16="http://schemas.microsoft.com/office/drawing/2014/main" id="{ACA0CE90-DB3F-4A98-9862-DA9FC21D1CD5}"/>
               </a:ext>
             </a:extLst>
           </p:cNvPr>
@@ -11433,7 +11433,7 @@
           <p:cNvPr id="42" name="">
             <a:extLst xmlns:a="http://schemas.openxmlformats.org/drawingml/2006/main">
               <a:ext uri="{FF2B5EF4-FFF2-40B4-BE49-F238E27FC236}">
-                <a16:creationId xmlns:a16="http://schemas.microsoft.com/office/drawing/2014/main" id="{C984A40B-5171-487E-8F6E-B75F503478E3}"/>
+                <a16:creationId xmlns:a16="http://schemas.microsoft.com/office/drawing/2014/main" id="{1DBEC9CB-D051-4007-8853-76844DA72200}"/>
               </a:ext>
             </a:extLst>
           </p:cNvPr>
@@ -11483,7 +11483,7 @@
           <p:cNvPr id="43" name="">
             <a:extLst xmlns:a="http://schemas.openxmlformats.org/drawingml/2006/main">
               <a:ext uri="{FF2B5EF4-FFF2-40B4-BE49-F238E27FC236}">
-                <a16:creationId xmlns:a16="http://schemas.microsoft.com/office/drawing/2014/main" id="{58D2F5A5-A2EC-4AAA-8922-D14660417D3F}"/>
+                <a16:creationId xmlns:a16="http://schemas.microsoft.com/office/drawing/2014/main" id="{707BB68D-C63F-47C3-8B47-08702E391E4B}"/>
               </a:ext>
             </a:extLst>
           </p:cNvPr>
@@ -11531,7 +11531,7 @@
     </p:spTree>
     <p:extLst>
       <p:ext uri="{BB962C8B-B14F-4D97-AF65-F5344CB8AC3E}">
-        <p14:creationId xmlns:p14="http://schemas.microsoft.com/office/powerpoint/2010/main" val="1283177081"/>
+        <p14:creationId xmlns:p14="http://schemas.microsoft.com/office/powerpoint/2010/main" val="215212517"/>
       </p:ext>
     </p:extLst>
   </p:cSld>
@@ -11562,7 +11562,7 @@
           <p:cNvPr id="1" name="">
             <a:extLst xmlns:a="http://schemas.openxmlformats.org/drawingml/2006/main">
               <a:ext uri="{FF2B5EF4-FFF2-40B4-BE49-F238E27FC236}">
-                <a16:creationId xmlns:a16="http://schemas.microsoft.com/office/drawing/2014/main" id="{6F29D181-410F-4C49-86CB-598DFE9FDC40}"/>
+                <a16:creationId xmlns:a16="http://schemas.microsoft.com/office/drawing/2014/main" id="{1DB271D4-1729-40D5-A80D-8C9FFDC52C39}"/>
               </a:ext>
             </a:extLst>
           </p:cNvPr>
@@ -11597,7 +11597,7 @@
           <p:nvPr/>
         </p:nvPicPr>
         <p:blipFill>
-          <a:blip xmlns:r="http://schemas.openxmlformats.org/officeDocument/2006/relationships" xmlns:a="http://schemas.openxmlformats.org/drawingml/2006/main" r:embed="R9ec4e21eb6f24f22"/>
+          <a:blip xmlns:r="http://schemas.openxmlformats.org/officeDocument/2006/relationships" xmlns:a="http://schemas.openxmlformats.org/drawingml/2006/main" r:embed="R0fe7a1d7e63f4ddf"/>
           <a:stretch xmlns:a="http://schemas.openxmlformats.org/drawingml/2006/main"/>
         </p:blipFill>
         <p:spPr>
@@ -11615,7 +11615,7 @@
           <p:cNvPr id="3" name="">
             <a:extLst xmlns:a="http://schemas.openxmlformats.org/drawingml/2006/main">
               <a:ext uri="{FF2B5EF4-FFF2-40B4-BE49-F238E27FC236}">
-                <a16:creationId xmlns:a16="http://schemas.microsoft.com/office/drawing/2014/main" id="{35CC056C-992B-4854-8964-02F6F22122CC}"/>
+                <a16:creationId xmlns:a16="http://schemas.microsoft.com/office/drawing/2014/main" id="{0334C720-D970-48F6-A99F-7FBC71C547C0}"/>
               </a:ext>
             </a:extLst>
           </p:cNvPr>
@@ -11665,7 +11665,7 @@
           <p:cNvPr id="4" name="">
             <a:extLst xmlns:a="http://schemas.openxmlformats.org/drawingml/2006/main">
               <a:ext uri="{FF2B5EF4-FFF2-40B4-BE49-F238E27FC236}">
-                <a16:creationId xmlns:a16="http://schemas.microsoft.com/office/drawing/2014/main" id="{26618C21-5E36-4525-819A-840314D07EF4}"/>
+                <a16:creationId xmlns:a16="http://schemas.microsoft.com/office/drawing/2014/main" id="{0E5C77CB-ADD8-41DF-9A3D-F782FA7965C3}"/>
               </a:ext>
             </a:extLst>
           </p:cNvPr>
@@ -11698,7 +11698,7 @@
           <p:cNvPr id="5" name="">
             <a:extLst xmlns:a="http://schemas.openxmlformats.org/drawingml/2006/main">
               <a:ext uri="{FF2B5EF4-FFF2-40B4-BE49-F238E27FC236}">
-                <a16:creationId xmlns:a16="http://schemas.microsoft.com/office/drawing/2014/main" id="{5F4547AA-5368-4B38-83C1-51624B069FE0}"/>
+                <a16:creationId xmlns:a16="http://schemas.microsoft.com/office/drawing/2014/main" id="{186F75CD-151E-4722-B915-CE7B5F7AA6A4}"/>
               </a:ext>
             </a:extLst>
           </p:cNvPr>
@@ -11729,7 +11729,7 @@
           <p:cNvPr id="6" name="">
             <a:extLst xmlns:a="http://schemas.openxmlformats.org/drawingml/2006/main">
               <a:ext uri="{FF2B5EF4-FFF2-40B4-BE49-F238E27FC236}">
-                <a16:creationId xmlns:a16="http://schemas.microsoft.com/office/drawing/2014/main" id="{B181FA76-5976-45DA-9469-D7BC483211B3}"/>
+                <a16:creationId xmlns:a16="http://schemas.microsoft.com/office/drawing/2014/main" id="{BA576667-CB9D-4D68-8822-64098E93E354}"/>
               </a:ext>
             </a:extLst>
           </p:cNvPr>
@@ -11779,7 +11779,7 @@
           <p:cNvPr id="7" name="">
             <a:extLst xmlns:a="http://schemas.openxmlformats.org/drawingml/2006/main">
               <a:ext uri="{FF2B5EF4-FFF2-40B4-BE49-F238E27FC236}">
-                <a16:creationId xmlns:a16="http://schemas.microsoft.com/office/drawing/2014/main" id="{7B5FD903-14ED-4743-A398-5AE0551CEA4C}"/>
+                <a16:creationId xmlns:a16="http://schemas.microsoft.com/office/drawing/2014/main" id="{C84E1A19-5517-4999-B908-F60FE07562D0}"/>
               </a:ext>
             </a:extLst>
           </p:cNvPr>
@@ -11829,7 +11829,7 @@
           <p:cNvPr id="8" name="">
             <a:extLst xmlns:a="http://schemas.openxmlformats.org/drawingml/2006/main">
               <a:ext uri="{FF2B5EF4-FFF2-40B4-BE49-F238E27FC236}">
-                <a16:creationId xmlns:a16="http://schemas.microsoft.com/office/drawing/2014/main" id="{ED445247-76DC-4538-9E61-ADC650CA9905}"/>
+                <a16:creationId xmlns:a16="http://schemas.microsoft.com/office/drawing/2014/main" id="{5AC895D3-8E50-4ADB-A39C-6B586305568B}"/>
               </a:ext>
             </a:extLst>
           </p:cNvPr>
@@ -11864,7 +11864,7 @@
           <p:cNvPr id="9" name="">
             <a:extLst xmlns:a="http://schemas.openxmlformats.org/drawingml/2006/main">
               <a:ext uri="{FF2B5EF4-FFF2-40B4-BE49-F238E27FC236}">
-                <a16:creationId xmlns:a16="http://schemas.microsoft.com/office/drawing/2014/main" id="{E76C0BCD-1AE1-4BDE-A129-4B5B5E90F4A3}"/>
+                <a16:creationId xmlns:a16="http://schemas.microsoft.com/office/drawing/2014/main" id="{47B874ED-318A-4D11-AFA4-57F071F4CEFF}"/>
               </a:ext>
             </a:extLst>
           </p:cNvPr>
@@ -11897,7 +11897,7 @@
           <p:cNvPr id="10" name="">
             <a:extLst xmlns:a="http://schemas.openxmlformats.org/drawingml/2006/main">
               <a:ext uri="{FF2B5EF4-FFF2-40B4-BE49-F238E27FC236}">
-                <a16:creationId xmlns:a16="http://schemas.microsoft.com/office/drawing/2014/main" id="{D494F722-7AA0-4DAF-8A93-C722D21A888F}"/>
+                <a16:creationId xmlns:a16="http://schemas.microsoft.com/office/drawing/2014/main" id="{9E782511-C766-4818-A7F0-1A40B7D45455}"/>
               </a:ext>
             </a:extLst>
           </p:cNvPr>
@@ -11947,7 +11947,7 @@
           <p:cNvPr id="11" name="">
             <a:extLst xmlns:a="http://schemas.openxmlformats.org/drawingml/2006/main">
               <a:ext uri="{FF2B5EF4-FFF2-40B4-BE49-F238E27FC236}">
-                <a16:creationId xmlns:a16="http://schemas.microsoft.com/office/drawing/2014/main" id="{91058DF8-B05D-45EB-941C-F81C2D15F2B7}"/>
+                <a16:creationId xmlns:a16="http://schemas.microsoft.com/office/drawing/2014/main" id="{FCAC7E2E-9191-4DCA-B5A7-D4AC669CA641}"/>
               </a:ext>
             </a:extLst>
           </p:cNvPr>
@@ -11997,7 +11997,7 @@
           <p:cNvPr id="12" name="">
             <a:extLst xmlns:a="http://schemas.openxmlformats.org/drawingml/2006/main">
               <a:ext uri="{FF2B5EF4-FFF2-40B4-BE49-F238E27FC236}">
-                <a16:creationId xmlns:a16="http://schemas.microsoft.com/office/drawing/2014/main" id="{F66CB4A5-C0BB-42E2-BA7C-BBF7BAD62FD1}"/>
+                <a16:creationId xmlns:a16="http://schemas.microsoft.com/office/drawing/2014/main" id="{E3EE9506-2961-4750-96DA-0EA2BE245740}"/>
               </a:ext>
             </a:extLst>
           </p:cNvPr>
@@ -12047,7 +12047,7 @@
           <p:cNvPr id="13" name="">
             <a:extLst xmlns:a="http://schemas.openxmlformats.org/drawingml/2006/main">
               <a:ext uri="{FF2B5EF4-FFF2-40B4-BE49-F238E27FC236}">
-                <a16:creationId xmlns:a16="http://schemas.microsoft.com/office/drawing/2014/main" id="{8F6D78B1-7C02-4DBD-9E43-BEA1904DE0AB}"/>
+                <a16:creationId xmlns:a16="http://schemas.microsoft.com/office/drawing/2014/main" id="{28B67CE9-5722-4725-906E-3BF6B9FE5BC2}"/>
               </a:ext>
             </a:extLst>
           </p:cNvPr>
@@ -12078,7 +12078,7 @@
           <p:cNvPr id="14" name="">
             <a:extLst xmlns:a="http://schemas.openxmlformats.org/drawingml/2006/main">
               <a:ext uri="{FF2B5EF4-FFF2-40B4-BE49-F238E27FC236}">
-                <a16:creationId xmlns:a16="http://schemas.microsoft.com/office/drawing/2014/main" id="{9889CB13-67BE-4102-B393-11726E5DF5B2}"/>
+                <a16:creationId xmlns:a16="http://schemas.microsoft.com/office/drawing/2014/main" id="{0778846C-F28B-4A52-A3CA-0C5DACDEEAD0}"/>
               </a:ext>
             </a:extLst>
           </p:cNvPr>
@@ -12128,7 +12128,7 @@
           <p:cNvPr id="15" name="">
             <a:extLst xmlns:a="http://schemas.openxmlformats.org/drawingml/2006/main">
               <a:ext uri="{FF2B5EF4-FFF2-40B4-BE49-F238E27FC236}">
-                <a16:creationId xmlns:a16="http://schemas.microsoft.com/office/drawing/2014/main" id="{805906E8-DA78-427A-8C2B-983666520205}"/>
+                <a16:creationId xmlns:a16="http://schemas.microsoft.com/office/drawing/2014/main" id="{2DAD3BAC-D1BA-49CA-9705-1111CDB851E4}"/>
               </a:ext>
             </a:extLst>
           </p:cNvPr>
@@ -12178,7 +12178,7 @@
           <p:cNvPr id="16" name="">
             <a:extLst xmlns:a="http://schemas.openxmlformats.org/drawingml/2006/main">
               <a:ext uri="{FF2B5EF4-FFF2-40B4-BE49-F238E27FC236}">
-                <a16:creationId xmlns:a16="http://schemas.microsoft.com/office/drawing/2014/main" id="{88A750A9-5260-441C-9143-DBC972BC39EB}"/>
+                <a16:creationId xmlns:a16="http://schemas.microsoft.com/office/drawing/2014/main" id="{971F412D-5C31-4EDB-BDEF-8A0B31838915}"/>
               </a:ext>
             </a:extLst>
           </p:cNvPr>
@@ -12213,7 +12213,7 @@
           <p:cNvPr id="17" name="">
             <a:extLst xmlns:a="http://schemas.openxmlformats.org/drawingml/2006/main">
               <a:ext uri="{FF2B5EF4-FFF2-40B4-BE49-F238E27FC236}">
-                <a16:creationId xmlns:a16="http://schemas.microsoft.com/office/drawing/2014/main" id="{C865B8FE-3FE4-4999-B3CE-DEC727C65FA8}"/>
+                <a16:creationId xmlns:a16="http://schemas.microsoft.com/office/drawing/2014/main" id="{E21C61CA-7ECE-4613-897F-925DAF01C635}"/>
               </a:ext>
             </a:extLst>
           </p:cNvPr>
@@ -12246,7 +12246,7 @@
           <p:cNvPr id="18" name="">
             <a:extLst xmlns:a="http://schemas.openxmlformats.org/drawingml/2006/main">
               <a:ext uri="{FF2B5EF4-FFF2-40B4-BE49-F238E27FC236}">
-                <a16:creationId xmlns:a16="http://schemas.microsoft.com/office/drawing/2014/main" id="{2AA945EF-5437-4686-AFAF-D63C950DCC99}"/>
+                <a16:creationId xmlns:a16="http://schemas.microsoft.com/office/drawing/2014/main" id="{2B690959-D942-4362-B657-68715C484BC6}"/>
               </a:ext>
             </a:extLst>
           </p:cNvPr>
@@ -12296,7 +12296,7 @@
           <p:cNvPr id="19" name="">
             <a:extLst xmlns:a="http://schemas.openxmlformats.org/drawingml/2006/main">
               <a:ext uri="{FF2B5EF4-FFF2-40B4-BE49-F238E27FC236}">
-                <a16:creationId xmlns:a16="http://schemas.microsoft.com/office/drawing/2014/main" id="{DC2CE46E-1D27-4915-9B10-3346C96B0A9D}"/>
+                <a16:creationId xmlns:a16="http://schemas.microsoft.com/office/drawing/2014/main" id="{7E894545-9BAC-4A3C-866E-700656D51781}"/>
               </a:ext>
             </a:extLst>
           </p:cNvPr>
@@ -12346,7 +12346,7 @@
           <p:cNvPr id="20" name="">
             <a:extLst xmlns:a="http://schemas.openxmlformats.org/drawingml/2006/main">
               <a:ext uri="{FF2B5EF4-FFF2-40B4-BE49-F238E27FC236}">
-                <a16:creationId xmlns:a16="http://schemas.microsoft.com/office/drawing/2014/main" id="{28AA5D2E-11EC-440C-A8C2-3F75AD4BFC36}"/>
+                <a16:creationId xmlns:a16="http://schemas.microsoft.com/office/drawing/2014/main" id="{95B82EDD-F09B-463B-A430-31247F7924AD}"/>
               </a:ext>
             </a:extLst>
           </p:cNvPr>
@@ -12396,7 +12396,7 @@
           <p:cNvPr id="21" name="">
             <a:extLst xmlns:a="http://schemas.openxmlformats.org/drawingml/2006/main">
               <a:ext uri="{FF2B5EF4-FFF2-40B4-BE49-F238E27FC236}">
-                <a16:creationId xmlns:a16="http://schemas.microsoft.com/office/drawing/2014/main" id="{CA3044D0-D1A0-40EE-9D81-EF9018DF532C}"/>
+                <a16:creationId xmlns:a16="http://schemas.microsoft.com/office/drawing/2014/main" id="{C890132F-3FB1-4D55-9063-77539D7A1713}"/>
               </a:ext>
             </a:extLst>
           </p:cNvPr>
@@ -12427,7 +12427,7 @@
           <p:cNvPr id="22" name="">
             <a:extLst xmlns:a="http://schemas.openxmlformats.org/drawingml/2006/main">
               <a:ext uri="{FF2B5EF4-FFF2-40B4-BE49-F238E27FC236}">
-                <a16:creationId xmlns:a16="http://schemas.microsoft.com/office/drawing/2014/main" id="{8984BB65-C1CE-46B6-9A58-1B4FC9092D92}"/>
+                <a16:creationId xmlns:a16="http://schemas.microsoft.com/office/drawing/2014/main" id="{59B295D9-3DA6-470F-B42B-10162FB8237A}"/>
               </a:ext>
             </a:extLst>
           </p:cNvPr>
@@ -12477,7 +12477,7 @@
           <p:cNvPr id="23" name="">
             <a:extLst xmlns:a="http://schemas.openxmlformats.org/drawingml/2006/main">
               <a:ext uri="{FF2B5EF4-FFF2-40B4-BE49-F238E27FC236}">
-                <a16:creationId xmlns:a16="http://schemas.microsoft.com/office/drawing/2014/main" id="{F59AC32F-B2F6-40FD-B794-BA37E5ADF12F}"/>
+                <a16:creationId xmlns:a16="http://schemas.microsoft.com/office/drawing/2014/main" id="{025C6F47-DBA2-4654-860E-0AFC321612D6}"/>
               </a:ext>
             </a:extLst>
           </p:cNvPr>
@@ -12527,7 +12527,7 @@
           <p:cNvPr id="24" name="">
             <a:extLst xmlns:a="http://schemas.openxmlformats.org/drawingml/2006/main">
               <a:ext uri="{FF2B5EF4-FFF2-40B4-BE49-F238E27FC236}">
-                <a16:creationId xmlns:a16="http://schemas.microsoft.com/office/drawing/2014/main" id="{969EDB4A-619F-4CA4-836E-9061D670B401}"/>
+                <a16:creationId xmlns:a16="http://schemas.microsoft.com/office/drawing/2014/main" id="{CA839084-6D23-42D8-A0F8-82A929A2CBCE}"/>
               </a:ext>
             </a:extLst>
           </p:cNvPr>
@@ -12562,7 +12562,7 @@
           <p:cNvPr id="25" name="">
             <a:extLst xmlns:a="http://schemas.openxmlformats.org/drawingml/2006/main">
               <a:ext uri="{FF2B5EF4-FFF2-40B4-BE49-F238E27FC236}">
-                <a16:creationId xmlns:a16="http://schemas.microsoft.com/office/drawing/2014/main" id="{878735E6-211A-4502-A1AA-B681CB7BE917}"/>
+                <a16:creationId xmlns:a16="http://schemas.microsoft.com/office/drawing/2014/main" id="{26E39461-BA67-415F-A93E-DE65609C5CB3}"/>
               </a:ext>
             </a:extLst>
           </p:cNvPr>
@@ -12595,7 +12595,7 @@
           <p:cNvPr id="26" name="">
             <a:extLst xmlns:a="http://schemas.openxmlformats.org/drawingml/2006/main">
               <a:ext uri="{FF2B5EF4-FFF2-40B4-BE49-F238E27FC236}">
-                <a16:creationId xmlns:a16="http://schemas.microsoft.com/office/drawing/2014/main" id="{ED21BA86-3936-4FD5-B586-8503F53904C4}"/>
+                <a16:creationId xmlns:a16="http://schemas.microsoft.com/office/drawing/2014/main" id="{F678DBA5-CA8A-439B-BE10-6152A491C110}"/>
               </a:ext>
             </a:extLst>
           </p:cNvPr>
@@ -12645,7 +12645,7 @@
           <p:cNvPr id="27" name="">
             <a:extLst xmlns:a="http://schemas.openxmlformats.org/drawingml/2006/main">
               <a:ext uri="{FF2B5EF4-FFF2-40B4-BE49-F238E27FC236}">
-                <a16:creationId xmlns:a16="http://schemas.microsoft.com/office/drawing/2014/main" id="{3339839F-39AF-4FDD-906A-3E94D0979896}"/>
+                <a16:creationId xmlns:a16="http://schemas.microsoft.com/office/drawing/2014/main" id="{81841292-21E6-4154-B12F-31663869D5CB}"/>
               </a:ext>
             </a:extLst>
           </p:cNvPr>
@@ -12695,7 +12695,7 @@
           <p:cNvPr id="28" name="">
             <a:extLst xmlns:a="http://schemas.openxmlformats.org/drawingml/2006/main">
               <a:ext uri="{FF2B5EF4-FFF2-40B4-BE49-F238E27FC236}">
-                <a16:creationId xmlns:a16="http://schemas.microsoft.com/office/drawing/2014/main" id="{A8CCD744-B0EF-4A0A-8AC3-1B5B505536A3}"/>
+                <a16:creationId xmlns:a16="http://schemas.microsoft.com/office/drawing/2014/main" id="{51C69449-DD81-4326-AC87-7FB9524BFA66}"/>
               </a:ext>
             </a:extLst>
           </p:cNvPr>
@@ -12745,7 +12745,7 @@
           <p:cNvPr id="29" name="">
             <a:extLst xmlns:a="http://schemas.openxmlformats.org/drawingml/2006/main">
               <a:ext uri="{FF2B5EF4-FFF2-40B4-BE49-F238E27FC236}">
-                <a16:creationId xmlns:a16="http://schemas.microsoft.com/office/drawing/2014/main" id="{256AA7CF-5EA6-450F-ABF8-D61B3E51FD09}"/>
+                <a16:creationId xmlns:a16="http://schemas.microsoft.com/office/drawing/2014/main" id="{BB88A1AE-C161-43FC-9265-7023819E6138}"/>
               </a:ext>
             </a:extLst>
           </p:cNvPr>
@@ -12776,7 +12776,7 @@
           <p:cNvPr id="30" name="">
             <a:extLst xmlns:a="http://schemas.openxmlformats.org/drawingml/2006/main">
               <a:ext uri="{FF2B5EF4-FFF2-40B4-BE49-F238E27FC236}">
-                <a16:creationId xmlns:a16="http://schemas.microsoft.com/office/drawing/2014/main" id="{026A746F-5F82-4A05-8EFE-E2D546B75A23}"/>
+                <a16:creationId xmlns:a16="http://schemas.microsoft.com/office/drawing/2014/main" id="{69E6DCEC-9C52-429F-8290-3E086962AF73}"/>
               </a:ext>
             </a:extLst>
           </p:cNvPr>
@@ -12826,7 +12826,7 @@
           <p:cNvPr id="31" name="">
             <a:extLst xmlns:a="http://schemas.openxmlformats.org/drawingml/2006/main">
               <a:ext uri="{FF2B5EF4-FFF2-40B4-BE49-F238E27FC236}">
-                <a16:creationId xmlns:a16="http://schemas.microsoft.com/office/drawing/2014/main" id="{BB6B21F5-2A6E-4B68-B6AA-C94E0C2D80D7}"/>
+                <a16:creationId xmlns:a16="http://schemas.microsoft.com/office/drawing/2014/main" id="{A1647EB2-426A-440B-971C-A86384E036D6}"/>
               </a:ext>
             </a:extLst>
           </p:cNvPr>
@@ -12874,7 +12874,7 @@
     </p:spTree>
     <p:extLst>
       <p:ext uri="{BB962C8B-B14F-4D97-AF65-F5344CB8AC3E}">
-        <p14:creationId xmlns:p14="http://schemas.microsoft.com/office/powerpoint/2010/main" val="1790309836"/>
+        <p14:creationId xmlns:p14="http://schemas.microsoft.com/office/powerpoint/2010/main" val="42072275"/>
       </p:ext>
     </p:extLst>
   </p:cSld>
@@ -12905,7 +12905,7 @@
           <p:cNvPr id="1" name="">
             <a:extLst xmlns:a="http://schemas.openxmlformats.org/drawingml/2006/main">
               <a:ext uri="{FF2B5EF4-FFF2-40B4-BE49-F238E27FC236}">
-                <a16:creationId xmlns:a16="http://schemas.microsoft.com/office/drawing/2014/main" id="{51ACF314-ADE9-4E80-916D-71F9EA4D8019}"/>
+                <a16:creationId xmlns:a16="http://schemas.microsoft.com/office/drawing/2014/main" id="{59C872B4-CAB7-4F37-B3C5-2678129F269F}"/>
               </a:ext>
             </a:extLst>
           </p:cNvPr>
@@ -12940,7 +12940,7 @@
           <p:nvPr/>
         </p:nvPicPr>
         <p:blipFill>
-          <a:blip xmlns:r="http://schemas.openxmlformats.org/officeDocument/2006/relationships" xmlns:a="http://schemas.openxmlformats.org/drawingml/2006/main" r:embed="Rf6c08abcc27d40a3"/>
+          <a:blip xmlns:r="http://schemas.openxmlformats.org/officeDocument/2006/relationships" xmlns:a="http://schemas.openxmlformats.org/drawingml/2006/main" r:embed="Ra4dfd96a6168471f"/>
           <a:stretch xmlns:a="http://schemas.openxmlformats.org/drawingml/2006/main"/>
         </p:blipFill>
         <p:spPr>
@@ -12958,7 +12958,7 @@
           <p:cNvPr id="3" name="">
             <a:extLst xmlns:a="http://schemas.openxmlformats.org/drawingml/2006/main">
               <a:ext uri="{FF2B5EF4-FFF2-40B4-BE49-F238E27FC236}">
-                <a16:creationId xmlns:a16="http://schemas.microsoft.com/office/drawing/2014/main" id="{9889C068-BDCC-4F78-92BB-38342EA6346C}"/>
+                <a16:creationId xmlns:a16="http://schemas.microsoft.com/office/drawing/2014/main" id="{5472EC24-D477-48E3-A2FA-DAAD905450BB}"/>
               </a:ext>
             </a:extLst>
           </p:cNvPr>
@@ -13008,7 +13008,7 @@
           <p:cNvPr id="4" name="">
             <a:extLst xmlns:a="http://schemas.openxmlformats.org/drawingml/2006/main">
               <a:ext uri="{FF2B5EF4-FFF2-40B4-BE49-F238E27FC236}">
-                <a16:creationId xmlns:a16="http://schemas.microsoft.com/office/drawing/2014/main" id="{FA730738-9EFA-460A-AA00-9A35272AB2E2}"/>
+                <a16:creationId xmlns:a16="http://schemas.microsoft.com/office/drawing/2014/main" id="{C8BDA06A-3021-4D33-A09C-4C5B4DB9F660}"/>
               </a:ext>
             </a:extLst>
           </p:cNvPr>
@@ -13041,7 +13041,7 @@
           <p:cNvPr id="5" name="">
             <a:extLst xmlns:a="http://schemas.openxmlformats.org/drawingml/2006/main">
               <a:ext uri="{FF2B5EF4-FFF2-40B4-BE49-F238E27FC236}">
-                <a16:creationId xmlns:a16="http://schemas.microsoft.com/office/drawing/2014/main" id="{7FA124B6-E1B1-4704-A31F-D932EC103BC5}"/>
+                <a16:creationId xmlns:a16="http://schemas.microsoft.com/office/drawing/2014/main" id="{C7935968-40B9-43C7-B3C4-4808C65E65FC}"/>
               </a:ext>
             </a:extLst>
           </p:cNvPr>
@@ -13072,7 +13072,7 @@
           <p:cNvPr id="6" name="">
             <a:extLst xmlns:a="http://schemas.openxmlformats.org/drawingml/2006/main">
               <a:ext uri="{FF2B5EF4-FFF2-40B4-BE49-F238E27FC236}">
-                <a16:creationId xmlns:a16="http://schemas.microsoft.com/office/drawing/2014/main" id="{2E76271F-0D59-475C-A7BA-A62DC40DDDBB}"/>
+                <a16:creationId xmlns:a16="http://schemas.microsoft.com/office/drawing/2014/main" id="{9DEC99F3-08D7-4811-B87A-320BC8C55C0E}"/>
               </a:ext>
             </a:extLst>
           </p:cNvPr>
@@ -13122,7 +13122,7 @@
           <p:cNvPr id="7" name="">
             <a:extLst xmlns:a="http://schemas.openxmlformats.org/drawingml/2006/main">
               <a:ext uri="{FF2B5EF4-FFF2-40B4-BE49-F238E27FC236}">
-                <a16:creationId xmlns:a16="http://schemas.microsoft.com/office/drawing/2014/main" id="{C22D4C01-3787-4E10-96AA-30F4CCDC8319}"/>
+                <a16:creationId xmlns:a16="http://schemas.microsoft.com/office/drawing/2014/main" id="{39C66BD2-0AC0-4F58-BC42-F5BC4B1CA734}"/>
               </a:ext>
             </a:extLst>
           </p:cNvPr>
@@ -13172,7 +13172,7 @@
           <p:cNvPr id="8" name="">
             <a:extLst xmlns:a="http://schemas.openxmlformats.org/drawingml/2006/main">
               <a:ext uri="{FF2B5EF4-FFF2-40B4-BE49-F238E27FC236}">
-                <a16:creationId xmlns:a16="http://schemas.microsoft.com/office/drawing/2014/main" id="{9CA3C657-A9B4-4512-BB66-81A5DFD15CCC}"/>
+                <a16:creationId xmlns:a16="http://schemas.microsoft.com/office/drawing/2014/main" id="{38EA9841-DA5F-4C4C-945C-DB785825BB2C}"/>
               </a:ext>
             </a:extLst>
           </p:cNvPr>
@@ -13222,7 +13222,7 @@
           <p:cNvPr id="9" name="">
             <a:extLst xmlns:a="http://schemas.openxmlformats.org/drawingml/2006/main">
               <a:ext uri="{FF2B5EF4-FFF2-40B4-BE49-F238E27FC236}">
-                <a16:creationId xmlns:a16="http://schemas.microsoft.com/office/drawing/2014/main" id="{23EF79E6-DD14-47DA-A710-01810B541550}"/>
+                <a16:creationId xmlns:a16="http://schemas.microsoft.com/office/drawing/2014/main" id="{F06E58A0-91D7-404A-9C1A-E48DAB4FBF7D}"/>
               </a:ext>
             </a:extLst>
           </p:cNvPr>
@@ -13272,7 +13272,7 @@
           <p:cNvPr id="10" name="">
             <a:extLst xmlns:a="http://schemas.openxmlformats.org/drawingml/2006/main">
               <a:ext uri="{FF2B5EF4-FFF2-40B4-BE49-F238E27FC236}">
-                <a16:creationId xmlns:a16="http://schemas.microsoft.com/office/drawing/2014/main" id="{1B9F3BFA-FAF8-4090-89EB-B0AD60191889}"/>
+                <a16:creationId xmlns:a16="http://schemas.microsoft.com/office/drawing/2014/main" id="{A0948433-841D-4C8F-9154-A8813CB5E7A5}"/>
               </a:ext>
             </a:extLst>
           </p:cNvPr>
@@ -13303,7 +13303,7 @@
           <p:cNvPr id="11" name="">
             <a:extLst xmlns:a="http://schemas.openxmlformats.org/drawingml/2006/main">
               <a:ext uri="{FF2B5EF4-FFF2-40B4-BE49-F238E27FC236}">
-                <a16:creationId xmlns:a16="http://schemas.microsoft.com/office/drawing/2014/main" id="{919ED3AA-E120-4904-BA65-FD8A6033A537}"/>
+                <a16:creationId xmlns:a16="http://schemas.microsoft.com/office/drawing/2014/main" id="{C8B38F68-2F86-438E-9DD2-0AE4820E50E2}"/>
               </a:ext>
             </a:extLst>
           </p:cNvPr>
@@ -13353,7 +13353,7 @@
           <p:cNvPr id="12" name="">
             <a:extLst xmlns:a="http://schemas.openxmlformats.org/drawingml/2006/main">
               <a:ext uri="{FF2B5EF4-FFF2-40B4-BE49-F238E27FC236}">
-                <a16:creationId xmlns:a16="http://schemas.microsoft.com/office/drawing/2014/main" id="{9AFAAEFE-FEB5-4306-8F5A-7E0D23578089}"/>
+                <a16:creationId xmlns:a16="http://schemas.microsoft.com/office/drawing/2014/main" id="{7D5044ED-A60B-496F-AAC1-63C298D643B8}"/>
               </a:ext>
             </a:extLst>
           </p:cNvPr>
@@ -13403,7 +13403,7 @@
           <p:cNvPr id="13" name="">
             <a:extLst xmlns:a="http://schemas.openxmlformats.org/drawingml/2006/main">
               <a:ext uri="{FF2B5EF4-FFF2-40B4-BE49-F238E27FC236}">
-                <a16:creationId xmlns:a16="http://schemas.microsoft.com/office/drawing/2014/main" id="{3C5D8048-F807-4615-B9CA-B34A0741C2D2}"/>
+                <a16:creationId xmlns:a16="http://schemas.microsoft.com/office/drawing/2014/main" id="{ACB0DB61-D438-4256-A88F-1459136C8892}"/>
               </a:ext>
             </a:extLst>
           </p:cNvPr>
@@ -13434,7 +13434,7 @@
           <p:cNvPr id="14" name="">
             <a:extLst xmlns:a="http://schemas.openxmlformats.org/drawingml/2006/main">
               <a:ext uri="{FF2B5EF4-FFF2-40B4-BE49-F238E27FC236}">
-                <a16:creationId xmlns:a16="http://schemas.microsoft.com/office/drawing/2014/main" id="{3F838637-EBEA-4EF4-B89C-2E2EC1068E2B}"/>
+                <a16:creationId xmlns:a16="http://schemas.microsoft.com/office/drawing/2014/main" id="{5076D387-0C2E-4224-8754-0E92D59BB6B5}"/>
               </a:ext>
             </a:extLst>
           </p:cNvPr>
@@ -13484,7 +13484,7 @@
           <p:cNvPr id="15" name="">
             <a:extLst xmlns:a="http://schemas.openxmlformats.org/drawingml/2006/main">
               <a:ext uri="{FF2B5EF4-FFF2-40B4-BE49-F238E27FC236}">
-                <a16:creationId xmlns:a16="http://schemas.microsoft.com/office/drawing/2014/main" id="{14C68896-5BB7-4F0B-803A-AA180CB71D9B}"/>
+                <a16:creationId xmlns:a16="http://schemas.microsoft.com/office/drawing/2014/main" id="{D1B33371-89D7-41AB-A8B0-0AA1EF57EAD0}"/>
               </a:ext>
             </a:extLst>
           </p:cNvPr>
@@ -13534,7 +13534,7 @@
           <p:cNvPr id="16" name="">
             <a:extLst xmlns:a="http://schemas.openxmlformats.org/drawingml/2006/main">
               <a:ext uri="{FF2B5EF4-FFF2-40B4-BE49-F238E27FC236}">
-                <a16:creationId xmlns:a16="http://schemas.microsoft.com/office/drawing/2014/main" id="{2F5C7575-181E-4CD6-88DC-C7C967D6C316}"/>
+                <a16:creationId xmlns:a16="http://schemas.microsoft.com/office/drawing/2014/main" id="{D6ECA677-4CEB-4913-A92C-0DE5A2EAD762}"/>
               </a:ext>
             </a:extLst>
           </p:cNvPr>
@@ -13565,7 +13565,7 @@
           <p:cNvPr id="17" name="">
             <a:extLst xmlns:a="http://schemas.openxmlformats.org/drawingml/2006/main">
               <a:ext uri="{FF2B5EF4-FFF2-40B4-BE49-F238E27FC236}">
-                <a16:creationId xmlns:a16="http://schemas.microsoft.com/office/drawing/2014/main" id="{89D0B3AC-EAFA-4586-839F-2D2E23C81CD1}"/>
+                <a16:creationId xmlns:a16="http://schemas.microsoft.com/office/drawing/2014/main" id="{7FA9DD7F-1C9A-4AF4-B16E-345852635AB5}"/>
               </a:ext>
             </a:extLst>
           </p:cNvPr>
@@ -13615,7 +13615,7 @@
           <p:cNvPr id="18" name="">
             <a:extLst xmlns:a="http://schemas.openxmlformats.org/drawingml/2006/main">
               <a:ext uri="{FF2B5EF4-FFF2-40B4-BE49-F238E27FC236}">
-                <a16:creationId xmlns:a16="http://schemas.microsoft.com/office/drawing/2014/main" id="{4ED9FDA2-D608-4AA1-80FE-F46022D66218}"/>
+                <a16:creationId xmlns:a16="http://schemas.microsoft.com/office/drawing/2014/main" id="{27A1B5E5-B49E-4D13-9B85-9DD23349EC9B}"/>
               </a:ext>
             </a:extLst>
           </p:cNvPr>
@@ -13665,7 +13665,7 @@
           <p:cNvPr id="19" name="">
             <a:extLst xmlns:a="http://schemas.openxmlformats.org/drawingml/2006/main">
               <a:ext uri="{FF2B5EF4-FFF2-40B4-BE49-F238E27FC236}">
-                <a16:creationId xmlns:a16="http://schemas.microsoft.com/office/drawing/2014/main" id="{716F9AED-6CC4-4065-AEC9-5AFB6A99D44A}"/>
+                <a16:creationId xmlns:a16="http://schemas.microsoft.com/office/drawing/2014/main" id="{57E8DBBF-B82B-47D5-807A-D179CD74B7EF}"/>
               </a:ext>
             </a:extLst>
           </p:cNvPr>
@@ -13700,7 +13700,7 @@
           <p:cNvPr id="20" name="">
             <a:extLst xmlns:a="http://schemas.openxmlformats.org/drawingml/2006/main">
               <a:ext uri="{FF2B5EF4-FFF2-40B4-BE49-F238E27FC236}">
-                <a16:creationId xmlns:a16="http://schemas.microsoft.com/office/drawing/2014/main" id="{BB14E259-A4F0-4DCE-A3F4-DED755DA3495}"/>
+                <a16:creationId xmlns:a16="http://schemas.microsoft.com/office/drawing/2014/main" id="{06F68FDD-7B0F-457F-9C8F-67E7788E8F02}"/>
               </a:ext>
             </a:extLst>
           </p:cNvPr>
@@ -13750,7 +13750,7 @@
           <p:cNvPr id="21" name="">
             <a:extLst xmlns:a="http://schemas.openxmlformats.org/drawingml/2006/main">
               <a:ext uri="{FF2B5EF4-FFF2-40B4-BE49-F238E27FC236}">
-                <a16:creationId xmlns:a16="http://schemas.microsoft.com/office/drawing/2014/main" id="{1B862ADE-7627-4631-9861-155038927D86}"/>
+                <a16:creationId xmlns:a16="http://schemas.microsoft.com/office/drawing/2014/main" id="{9FEB5591-C6DA-4510-8227-2DF8D3CB8591}"/>
               </a:ext>
             </a:extLst>
           </p:cNvPr>
@@ -13804,7 +13804,7 @@
           <p:nvPr/>
         </p:nvPicPr>
         <p:blipFill>
-          <a:blip xmlns:r="http://schemas.openxmlformats.org/officeDocument/2006/relationships" xmlns:a="http://schemas.openxmlformats.org/drawingml/2006/main" r:embed="Re74426cf8a644d25"/>
+          <a:blip xmlns:r="http://schemas.openxmlformats.org/officeDocument/2006/relationships" xmlns:a="http://schemas.openxmlformats.org/drawingml/2006/main" r:embed="R19e367d88efe4dd0"/>
           <a:stretch xmlns:a="http://schemas.openxmlformats.org/drawingml/2006/main"/>
         </p:blipFill>
         <p:spPr>
@@ -13822,7 +13822,7 @@
           <p:cNvPr id="23" name="">
             <a:extLst xmlns:a="http://schemas.openxmlformats.org/drawingml/2006/main">
               <a:ext uri="{FF2B5EF4-FFF2-40B4-BE49-F238E27FC236}">
-                <a16:creationId xmlns:a16="http://schemas.microsoft.com/office/drawing/2014/main" id="{803B88B2-68DD-41C3-ADFF-FCED5EDDEEB2}"/>
+                <a16:creationId xmlns:a16="http://schemas.microsoft.com/office/drawing/2014/main" id="{F65A8162-EFF8-4BB7-8BF3-CDE3407AE2E5}"/>
               </a:ext>
             </a:extLst>
           </p:cNvPr>
@@ -13872,7 +13872,7 @@
           <p:cNvPr id="24" name="">
             <a:extLst xmlns:a="http://schemas.openxmlformats.org/drawingml/2006/main">
               <a:ext uri="{FF2B5EF4-FFF2-40B4-BE49-F238E27FC236}">
-                <a16:creationId xmlns:a16="http://schemas.microsoft.com/office/drawing/2014/main" id="{A58F131F-5DEC-443C-869B-2FE4DDDF555F}"/>
+                <a16:creationId xmlns:a16="http://schemas.microsoft.com/office/drawing/2014/main" id="{ED82FCA9-206C-4209-8EF5-208B4AF0A2F3}"/>
               </a:ext>
             </a:extLst>
           </p:cNvPr>
@@ -13922,7 +13922,7 @@
           <p:cNvPr id="25" name="">
             <a:extLst xmlns:a="http://schemas.openxmlformats.org/drawingml/2006/main">
               <a:ext uri="{FF2B5EF4-FFF2-40B4-BE49-F238E27FC236}">
-                <a16:creationId xmlns:a16="http://schemas.microsoft.com/office/drawing/2014/main" id="{F37CF286-3BCC-4A03-B849-37E2F2EA734F}"/>
+                <a16:creationId xmlns:a16="http://schemas.microsoft.com/office/drawing/2014/main" id="{ADC9B736-7948-4D5C-9AE6-2423C978809A}"/>
               </a:ext>
             </a:extLst>
           </p:cNvPr>
@@ -13970,7 +13970,7 @@
     </p:spTree>
     <p:extLst>
       <p:ext uri="{BB962C8B-B14F-4D97-AF65-F5344CB8AC3E}">
-        <p14:creationId xmlns:p14="http://schemas.microsoft.com/office/powerpoint/2010/main" val="508651633"/>
+        <p14:creationId xmlns:p14="http://schemas.microsoft.com/office/powerpoint/2010/main" val="579672665"/>
       </p:ext>
     </p:extLst>
   </p:cSld>

</xml_diff>

<commit_message>
Refine company facts and audit download
</commit_message>
<xml_diff>
--- a/static/audit_presentation_btg.pptx
+++ b/static/audit_presentation_btg.pptx
@@ -2,21 +2,21 @@
 <file path=ppt/presentation.xml><?xml version="1.0" encoding="utf-8"?>
 <p:presentation xmlns:p="http://schemas.openxmlformats.org/presentationml/2006/main">
   <p:sldMasterIdLst>
-    <p:sldMasterId xmlns:r="http://schemas.openxmlformats.org/officeDocument/2006/relationships" id="2147483648" r:id="Ra677fb96f4d84eec"/>
+    <p:sldMasterId xmlns:r="http://schemas.openxmlformats.org/officeDocument/2006/relationships" id="2147483648" r:id="Re9e1dcdeb9f24025"/>
   </p:sldMasterIdLst>
   <p:notesMasterIdLst>
-    <p:notesMasterId xmlns:r="http://schemas.openxmlformats.org/officeDocument/2006/relationships" r:id="Rff7124723e2f4799"/>
+    <p:notesMasterId xmlns:r="http://schemas.openxmlformats.org/officeDocument/2006/relationships" r:id="R5a8a457a88944c92"/>
   </p:notesMasterIdLst>
   <p:sldIdLst>
-    <p:sldId xmlns:r="http://schemas.openxmlformats.org/officeDocument/2006/relationships" id="256" r:id="R68bd021c9c074a0a"/>
-    <p:sldId xmlns:r="http://schemas.openxmlformats.org/officeDocument/2006/relationships" id="257" r:id="R77ae97ec054c4097"/>
-    <p:sldId xmlns:r="http://schemas.openxmlformats.org/officeDocument/2006/relationships" id="258" r:id="Rd4f0fcab170f4a78"/>
-    <p:sldId xmlns:r="http://schemas.openxmlformats.org/officeDocument/2006/relationships" id="259" r:id="Rdc939f6f97174e8c"/>
-    <p:sldId xmlns:r="http://schemas.openxmlformats.org/officeDocument/2006/relationships" id="260" r:id="Rd5be1132e9144d8c"/>
-    <p:sldId xmlns:r="http://schemas.openxmlformats.org/officeDocument/2006/relationships" id="261" r:id="R821dcab061a44fb4"/>
-    <p:sldId xmlns:r="http://schemas.openxmlformats.org/officeDocument/2006/relationships" id="262" r:id="Re8df43ba1b4e4a8f"/>
-    <p:sldId xmlns:r="http://schemas.openxmlformats.org/officeDocument/2006/relationships" id="263" r:id="R91f4723ae5f548ff"/>
-    <p:sldId xmlns:r="http://schemas.openxmlformats.org/officeDocument/2006/relationships" id="264" r:id="R1ef48469a1134a7d"/>
+    <p:sldId xmlns:r="http://schemas.openxmlformats.org/officeDocument/2006/relationships" id="256" r:id="R3f0d107eaaed466f"/>
+    <p:sldId xmlns:r="http://schemas.openxmlformats.org/officeDocument/2006/relationships" id="257" r:id="R9710d22508af418b"/>
+    <p:sldId xmlns:r="http://schemas.openxmlformats.org/officeDocument/2006/relationships" id="258" r:id="R03811bc316224031"/>
+    <p:sldId xmlns:r="http://schemas.openxmlformats.org/officeDocument/2006/relationships" id="259" r:id="R88756a043fae4de0"/>
+    <p:sldId xmlns:r="http://schemas.openxmlformats.org/officeDocument/2006/relationships" id="260" r:id="R9b310c7ca2cb40fa"/>
+    <p:sldId xmlns:r="http://schemas.openxmlformats.org/officeDocument/2006/relationships" id="261" r:id="R674a7fd83bc449e7"/>
+    <p:sldId xmlns:r="http://schemas.openxmlformats.org/officeDocument/2006/relationships" id="262" r:id="R93747b400acd4407"/>
+    <p:sldId xmlns:r="http://schemas.openxmlformats.org/officeDocument/2006/relationships" id="263" r:id="R170fcdff6832404d"/>
+    <p:sldId xmlns:r="http://schemas.openxmlformats.org/officeDocument/2006/relationships" id="264" r:id="R9895b96869c74249"/>
   </p:sldIdLst>
   <p:sldSz cx="12192000" cy="6858000"/>
   <p:notesSz cx="6858000" cy="9144000"/>
@@ -1137,7 +1137,7 @@
   </p:cSld>
   <p:clrMap bg1="lt1" tx1="dk1" bg2="lt2" tx2="dk2" accent1="accent1" accent2="accent2" accent3="accent3" accent4="accent4" accent5="accent5" accent6="accent6" hlink="hlink" folHlink="folHlink"/>
   <p:sldLayoutIdLst>
-    <p:sldLayoutId xmlns:r="http://schemas.openxmlformats.org/officeDocument/2006/relationships" id="2147483649" r:id="R805ff24632c94b2b"/>
+    <p:sldLayoutId xmlns:r="http://schemas.openxmlformats.org/officeDocument/2006/relationships" id="2147483649" r:id="R51efdc50e13f4ca6"/>
   </p:sldLayoutIdLst>
   <p:txStyles>
     <p:titleStyle>
@@ -1688,7 +1688,7 @@
           <p:cNvPr id="1" name="">
             <a:extLst xmlns:a="http://schemas.openxmlformats.org/drawingml/2006/main">
               <a:ext uri="{FF2B5EF4-FFF2-40B4-BE49-F238E27FC236}">
-                <a16:creationId xmlns:a16="http://schemas.microsoft.com/office/drawing/2014/main" id="{DD7E633E-FECD-493A-B990-79DA7BC2EA3F}"/>
+                <a16:creationId xmlns:a16="http://schemas.microsoft.com/office/drawing/2014/main" id="{51E0ACD9-7817-4E59-ABE5-AE1AB81B1A83}"/>
               </a:ext>
             </a:extLst>
           </p:cNvPr>
@@ -1719,7 +1719,7 @@
           <p:cNvPr id="2" name="">
             <a:extLst xmlns:a="http://schemas.openxmlformats.org/drawingml/2006/main">
               <a:ext uri="{FF2B5EF4-FFF2-40B4-BE49-F238E27FC236}">
-                <a16:creationId xmlns:a16="http://schemas.microsoft.com/office/drawing/2014/main" id="{E82E1AD0-57C4-42F2-8AAB-C276BD01D1F0}"/>
+                <a16:creationId xmlns:a16="http://schemas.microsoft.com/office/drawing/2014/main" id="{6D3A391B-D541-4B97-9F08-637A0774B1A6}"/>
               </a:ext>
             </a:extLst>
           </p:cNvPr>
@@ -1754,7 +1754,7 @@
           <p:nvPr/>
         </p:nvPicPr>
         <p:blipFill>
-          <a:blip xmlns:r="http://schemas.openxmlformats.org/officeDocument/2006/relationships" xmlns:a="http://schemas.openxmlformats.org/drawingml/2006/main" r:embed="R5cf247ef377545ca"/>
+          <a:blip xmlns:r="http://schemas.openxmlformats.org/officeDocument/2006/relationships" xmlns:a="http://schemas.openxmlformats.org/drawingml/2006/main" r:embed="Rc08d76d5f2d645ec"/>
           <a:stretch xmlns:a="http://schemas.openxmlformats.org/drawingml/2006/main"/>
         </p:blipFill>
         <p:spPr>
@@ -1772,7 +1772,7 @@
           <p:cNvPr id="4" name="">
             <a:extLst xmlns:a="http://schemas.openxmlformats.org/drawingml/2006/main">
               <a:ext uri="{FF2B5EF4-FFF2-40B4-BE49-F238E27FC236}">
-                <a16:creationId xmlns:a16="http://schemas.microsoft.com/office/drawing/2014/main" id="{957798CA-A8E0-405E-A7C0-9A902A28409C}"/>
+                <a16:creationId xmlns:a16="http://schemas.microsoft.com/office/drawing/2014/main" id="{DC928623-384A-4A9F-BC5E-66F6373DEA74}"/>
               </a:ext>
             </a:extLst>
           </p:cNvPr>
@@ -1822,7 +1822,7 @@
           <p:cNvPr id="5" name="">
             <a:extLst xmlns:a="http://schemas.openxmlformats.org/drawingml/2006/main">
               <a:ext uri="{FF2B5EF4-FFF2-40B4-BE49-F238E27FC236}">
-                <a16:creationId xmlns:a16="http://schemas.microsoft.com/office/drawing/2014/main" id="{377EC194-7FEA-4969-B5AA-82CCEF5758E1}"/>
+                <a16:creationId xmlns:a16="http://schemas.microsoft.com/office/drawing/2014/main" id="{02424EBF-55F5-46FC-84CB-0D48A6C3282F}"/>
               </a:ext>
             </a:extLst>
           </p:cNvPr>
@@ -1872,7 +1872,7 @@
           <p:cNvPr id="6" name="">
             <a:extLst xmlns:a="http://schemas.openxmlformats.org/drawingml/2006/main">
               <a:ext uri="{FF2B5EF4-FFF2-40B4-BE49-F238E27FC236}">
-                <a16:creationId xmlns:a16="http://schemas.microsoft.com/office/drawing/2014/main" id="{3A7BDD4E-FE07-4611-A647-5D5D59342444}"/>
+                <a16:creationId xmlns:a16="http://schemas.microsoft.com/office/drawing/2014/main" id="{A33F675F-40FD-4362-B94E-9AC6E95A5B70}"/>
               </a:ext>
             </a:extLst>
           </p:cNvPr>
@@ -1922,7 +1922,7 @@
           <p:cNvPr id="7" name="">
             <a:extLst xmlns:a="http://schemas.openxmlformats.org/drawingml/2006/main">
               <a:ext uri="{FF2B5EF4-FFF2-40B4-BE49-F238E27FC236}">
-                <a16:creationId xmlns:a16="http://schemas.microsoft.com/office/drawing/2014/main" id="{ACEFD9AB-F08A-4506-9D20-8BECB95795D7}"/>
+                <a16:creationId xmlns:a16="http://schemas.microsoft.com/office/drawing/2014/main" id="{93AACEA4-1855-48BA-B3CB-54A0227FF090}"/>
               </a:ext>
             </a:extLst>
           </p:cNvPr>
@@ -1955,7 +1955,7 @@
           <p:cNvPr id="8" name="">
             <a:extLst xmlns:a="http://schemas.openxmlformats.org/drawingml/2006/main">
               <a:ext uri="{FF2B5EF4-FFF2-40B4-BE49-F238E27FC236}">
-                <a16:creationId xmlns:a16="http://schemas.microsoft.com/office/drawing/2014/main" id="{9E6706B3-29B0-4FF1-AADA-005FD954B802}"/>
+                <a16:creationId xmlns:a16="http://schemas.microsoft.com/office/drawing/2014/main" id="{3F03A26B-09BC-4C07-B15D-2881A5A9849B}"/>
               </a:ext>
             </a:extLst>
           </p:cNvPr>
@@ -2005,7 +2005,7 @@
           <p:cNvPr id="9" name="">
             <a:extLst xmlns:a="http://schemas.openxmlformats.org/drawingml/2006/main">
               <a:ext uri="{FF2B5EF4-FFF2-40B4-BE49-F238E27FC236}">
-                <a16:creationId xmlns:a16="http://schemas.microsoft.com/office/drawing/2014/main" id="{98B749E6-A2FB-4C38-898E-A11D418904F8}"/>
+                <a16:creationId xmlns:a16="http://schemas.microsoft.com/office/drawing/2014/main" id="{AF963A66-374A-4AA3-BC7F-B79481D6680A}"/>
               </a:ext>
             </a:extLst>
           </p:cNvPr>
@@ -2055,7 +2055,7 @@
           <p:cNvPr id="10" name="">
             <a:extLst xmlns:a="http://schemas.openxmlformats.org/drawingml/2006/main">
               <a:ext uri="{FF2B5EF4-FFF2-40B4-BE49-F238E27FC236}">
-                <a16:creationId xmlns:a16="http://schemas.microsoft.com/office/drawing/2014/main" id="{9B4E3B77-806F-437F-8D29-DFED77D77CEE}"/>
+                <a16:creationId xmlns:a16="http://schemas.microsoft.com/office/drawing/2014/main" id="{A501DF4C-3560-487B-9C35-F107C458334B}"/>
               </a:ext>
             </a:extLst>
           </p:cNvPr>
@@ -2088,7 +2088,7 @@
           <p:cNvPr id="11" name="">
             <a:extLst xmlns:a="http://schemas.openxmlformats.org/drawingml/2006/main">
               <a:ext uri="{FF2B5EF4-FFF2-40B4-BE49-F238E27FC236}">
-                <a16:creationId xmlns:a16="http://schemas.microsoft.com/office/drawing/2014/main" id="{B04D1C58-8F37-43AF-AB60-1262F13FF218}"/>
+                <a16:creationId xmlns:a16="http://schemas.microsoft.com/office/drawing/2014/main" id="{C0787550-E20A-4CCE-8E16-0C89AAFEB1FE}"/>
               </a:ext>
             </a:extLst>
           </p:cNvPr>
@@ -2138,7 +2138,7 @@
           <p:cNvPr id="12" name="">
             <a:extLst xmlns:a="http://schemas.openxmlformats.org/drawingml/2006/main">
               <a:ext uri="{FF2B5EF4-FFF2-40B4-BE49-F238E27FC236}">
-                <a16:creationId xmlns:a16="http://schemas.microsoft.com/office/drawing/2014/main" id="{20E15085-2508-41A5-ABE5-53CB18F82453}"/>
+                <a16:creationId xmlns:a16="http://schemas.microsoft.com/office/drawing/2014/main" id="{DA50AB52-FF91-4706-A8A8-7E7CD9C98AD2}"/>
               </a:ext>
             </a:extLst>
           </p:cNvPr>
@@ -2188,7 +2188,7 @@
           <p:cNvPr id="13" name="">
             <a:extLst xmlns:a="http://schemas.openxmlformats.org/drawingml/2006/main">
               <a:ext uri="{FF2B5EF4-FFF2-40B4-BE49-F238E27FC236}">
-                <a16:creationId xmlns:a16="http://schemas.microsoft.com/office/drawing/2014/main" id="{150932CA-0997-4A34-90E8-941DB4A10FD7}"/>
+                <a16:creationId xmlns:a16="http://schemas.microsoft.com/office/drawing/2014/main" id="{FB7F45E6-12F2-4B22-8C75-CC6387DAC6EC}"/>
               </a:ext>
             </a:extLst>
           </p:cNvPr>
@@ -2242,7 +2242,7 @@
           <p:nvPr/>
         </p:nvPicPr>
         <p:blipFill>
-          <a:blip xmlns:r="http://schemas.openxmlformats.org/officeDocument/2006/relationships" xmlns:a="http://schemas.openxmlformats.org/drawingml/2006/main" r:embed="R302f0661e77c4e12"/>
+          <a:blip xmlns:r="http://schemas.openxmlformats.org/officeDocument/2006/relationships" xmlns:a="http://schemas.openxmlformats.org/drawingml/2006/main" r:embed="Rc7ce305609ba4486"/>
           <a:srcRect xmlns:a="http://schemas.openxmlformats.org/drawingml/2006/main" l="0" t="132" r="0" b="132"/>
           <a:stretch xmlns:a="http://schemas.openxmlformats.org/drawingml/2006/main">
             <a:fillRect l="0" t="0" r="0" b="0"/>
@@ -2263,7 +2263,7 @@
           <p:cNvPr id="15" name="">
             <a:extLst xmlns:a="http://schemas.openxmlformats.org/drawingml/2006/main">
               <a:ext uri="{FF2B5EF4-FFF2-40B4-BE49-F238E27FC236}">
-                <a16:creationId xmlns:a16="http://schemas.microsoft.com/office/drawing/2014/main" id="{E73F608D-44B3-44BB-B535-C4D35F444C96}"/>
+                <a16:creationId xmlns:a16="http://schemas.microsoft.com/office/drawing/2014/main" id="{F71DAB60-BF66-4C65-BCC2-FF3B0B824A54}"/>
               </a:ext>
             </a:extLst>
           </p:cNvPr>
@@ -2294,7 +2294,7 @@
           <p:cNvPr id="16" name="">
             <a:extLst xmlns:a="http://schemas.openxmlformats.org/drawingml/2006/main">
               <a:ext uri="{FF2B5EF4-FFF2-40B4-BE49-F238E27FC236}">
-                <a16:creationId xmlns:a16="http://schemas.microsoft.com/office/drawing/2014/main" id="{6816E206-6981-4C96-9EE7-B9FB8612DD46}"/>
+                <a16:creationId xmlns:a16="http://schemas.microsoft.com/office/drawing/2014/main" id="{BD1EB1B3-C0C2-4D45-92D5-A0A595350B3A}"/>
               </a:ext>
             </a:extLst>
           </p:cNvPr>
@@ -2342,7 +2342,7 @@
     </p:spTree>
     <p:extLst>
       <p:ext uri="{BB962C8B-B14F-4D97-AF65-F5344CB8AC3E}">
-        <p14:creationId xmlns:p14="http://schemas.microsoft.com/office/powerpoint/2010/main" val="719718069"/>
+        <p14:creationId xmlns:p14="http://schemas.microsoft.com/office/powerpoint/2010/main" val="884083528"/>
       </p:ext>
     </p:extLst>
   </p:cSld>
@@ -2373,7 +2373,7 @@
           <p:cNvPr id="1" name="">
             <a:extLst xmlns:a="http://schemas.openxmlformats.org/drawingml/2006/main">
               <a:ext uri="{FF2B5EF4-FFF2-40B4-BE49-F238E27FC236}">
-                <a16:creationId xmlns:a16="http://schemas.microsoft.com/office/drawing/2014/main" id="{D8DE08D0-525C-420E-8871-CB41416C88BF}"/>
+                <a16:creationId xmlns:a16="http://schemas.microsoft.com/office/drawing/2014/main" id="{A81B997D-973D-4B61-8455-12B9D8B2476A}"/>
               </a:ext>
             </a:extLst>
           </p:cNvPr>
@@ -2408,7 +2408,7 @@
           <p:nvPr/>
         </p:nvPicPr>
         <p:blipFill>
-          <a:blip xmlns:r="http://schemas.openxmlformats.org/officeDocument/2006/relationships" xmlns:a="http://schemas.openxmlformats.org/drawingml/2006/main" r:embed="R3b7f639393fc425a"/>
+          <a:blip xmlns:r="http://schemas.openxmlformats.org/officeDocument/2006/relationships" xmlns:a="http://schemas.openxmlformats.org/drawingml/2006/main" r:embed="R75a16de7a8354149"/>
           <a:stretch xmlns:a="http://schemas.openxmlformats.org/drawingml/2006/main"/>
         </p:blipFill>
         <p:spPr>
@@ -2426,7 +2426,7 @@
           <p:cNvPr id="3" name="">
             <a:extLst xmlns:a="http://schemas.openxmlformats.org/drawingml/2006/main">
               <a:ext uri="{FF2B5EF4-FFF2-40B4-BE49-F238E27FC236}">
-                <a16:creationId xmlns:a16="http://schemas.microsoft.com/office/drawing/2014/main" id="{A8DA76FE-02D7-4819-960C-E6CFCBEA16C1}"/>
+                <a16:creationId xmlns:a16="http://schemas.microsoft.com/office/drawing/2014/main" id="{AD8C1BC1-EBD5-4164-A62F-E39C8A2A4DD3}"/>
               </a:ext>
             </a:extLst>
           </p:cNvPr>
@@ -2476,7 +2476,7 @@
           <p:cNvPr id="4" name="">
             <a:extLst xmlns:a="http://schemas.openxmlformats.org/drawingml/2006/main">
               <a:ext uri="{FF2B5EF4-FFF2-40B4-BE49-F238E27FC236}">
-                <a16:creationId xmlns:a16="http://schemas.microsoft.com/office/drawing/2014/main" id="{C03682D9-3ECE-4B35-9983-822B317DF4B2}"/>
+                <a16:creationId xmlns:a16="http://schemas.microsoft.com/office/drawing/2014/main" id="{8E5D95EC-41B6-48EC-A11E-BBFB8A806783}"/>
               </a:ext>
             </a:extLst>
           </p:cNvPr>
@@ -2509,7 +2509,7 @@
           <p:cNvPr id="5" name="">
             <a:extLst xmlns:a="http://schemas.openxmlformats.org/drawingml/2006/main">
               <a:ext uri="{FF2B5EF4-FFF2-40B4-BE49-F238E27FC236}">
-                <a16:creationId xmlns:a16="http://schemas.microsoft.com/office/drawing/2014/main" id="{FDB9F145-7D64-4458-B57D-5670F10239CA}"/>
+                <a16:creationId xmlns:a16="http://schemas.microsoft.com/office/drawing/2014/main" id="{68B5624A-D172-4DDF-B74C-6EEDF1BDADFF}"/>
               </a:ext>
             </a:extLst>
           </p:cNvPr>
@@ -2540,7 +2540,7 @@
           <p:cNvPr id="6" name="">
             <a:extLst xmlns:a="http://schemas.openxmlformats.org/drawingml/2006/main">
               <a:ext uri="{FF2B5EF4-FFF2-40B4-BE49-F238E27FC236}">
-                <a16:creationId xmlns:a16="http://schemas.microsoft.com/office/drawing/2014/main" id="{BA65396C-357D-4FC0-ADF7-6AADEEF14320}"/>
+                <a16:creationId xmlns:a16="http://schemas.microsoft.com/office/drawing/2014/main" id="{DB19A93C-6403-4FD8-8B12-AA8F6C466906}"/>
               </a:ext>
             </a:extLst>
           </p:cNvPr>
@@ -2590,7 +2590,7 @@
           <p:cNvPr id="7" name="">
             <a:extLst xmlns:a="http://schemas.openxmlformats.org/drawingml/2006/main">
               <a:ext uri="{FF2B5EF4-FFF2-40B4-BE49-F238E27FC236}">
-                <a16:creationId xmlns:a16="http://schemas.microsoft.com/office/drawing/2014/main" id="{A87FC36A-D01D-48D9-9089-66ECBA4550F0}"/>
+                <a16:creationId xmlns:a16="http://schemas.microsoft.com/office/drawing/2014/main" id="{564B4EE7-B455-4458-A5A9-9D55BD672865}"/>
               </a:ext>
             </a:extLst>
           </p:cNvPr>
@@ -2640,7 +2640,7 @@
           <p:cNvPr id="8" name="">
             <a:extLst xmlns:a="http://schemas.openxmlformats.org/drawingml/2006/main">
               <a:ext uri="{FF2B5EF4-FFF2-40B4-BE49-F238E27FC236}">
-                <a16:creationId xmlns:a16="http://schemas.microsoft.com/office/drawing/2014/main" id="{5EFB76D6-1808-4E29-915E-9FE35AC42AE5}"/>
+                <a16:creationId xmlns:a16="http://schemas.microsoft.com/office/drawing/2014/main" id="{A3EFFD8A-951D-40C6-93D2-50574703E1F3}"/>
               </a:ext>
             </a:extLst>
           </p:cNvPr>
@@ -2690,7 +2690,7 @@
           <p:cNvPr id="9" name="">
             <a:extLst xmlns:a="http://schemas.openxmlformats.org/drawingml/2006/main">
               <a:ext uri="{FF2B5EF4-FFF2-40B4-BE49-F238E27FC236}">
-                <a16:creationId xmlns:a16="http://schemas.microsoft.com/office/drawing/2014/main" id="{B16EDA58-3A30-4AC1-95DC-E5BF6459F31F}"/>
+                <a16:creationId xmlns:a16="http://schemas.microsoft.com/office/drawing/2014/main" id="{DE60698D-C470-455D-A720-FAECF0AA6CFB}"/>
               </a:ext>
             </a:extLst>
           </p:cNvPr>
@@ -2740,7 +2740,7 @@
           <p:cNvPr id="10" name="">
             <a:extLst xmlns:a="http://schemas.openxmlformats.org/drawingml/2006/main">
               <a:ext uri="{FF2B5EF4-FFF2-40B4-BE49-F238E27FC236}">
-                <a16:creationId xmlns:a16="http://schemas.microsoft.com/office/drawing/2014/main" id="{F9EB31A5-6B3B-4C2B-9E84-69A44BC8D658}"/>
+                <a16:creationId xmlns:a16="http://schemas.microsoft.com/office/drawing/2014/main" id="{99BE864B-ECF1-4D9E-A195-57DA32B8ED76}"/>
               </a:ext>
             </a:extLst>
           </p:cNvPr>
@@ -2790,7 +2790,7 @@
           <p:cNvPr id="11" name="">
             <a:extLst xmlns:a="http://schemas.openxmlformats.org/drawingml/2006/main">
               <a:ext uri="{FF2B5EF4-FFF2-40B4-BE49-F238E27FC236}">
-                <a16:creationId xmlns:a16="http://schemas.microsoft.com/office/drawing/2014/main" id="{679BD25A-6720-42A8-88B8-AEF18621F65A}"/>
+                <a16:creationId xmlns:a16="http://schemas.microsoft.com/office/drawing/2014/main" id="{498DCE81-5CA1-4DAC-BA6D-8F08CDDB8E50}"/>
               </a:ext>
             </a:extLst>
           </p:cNvPr>
@@ -2840,7 +2840,7 @@
           <p:cNvPr id="12" name="">
             <a:extLst xmlns:a="http://schemas.openxmlformats.org/drawingml/2006/main">
               <a:ext uri="{FF2B5EF4-FFF2-40B4-BE49-F238E27FC236}">
-                <a16:creationId xmlns:a16="http://schemas.microsoft.com/office/drawing/2014/main" id="{D0FA38F2-ED4D-4586-BC9C-69484CDB7C3D}"/>
+                <a16:creationId xmlns:a16="http://schemas.microsoft.com/office/drawing/2014/main" id="{C16731F3-0E88-4AB1-A1FC-17A504E1D7B2}"/>
               </a:ext>
             </a:extLst>
           </p:cNvPr>
@@ -2890,7 +2890,7 @@
           <p:cNvPr id="13" name="">
             <a:extLst xmlns:a="http://schemas.openxmlformats.org/drawingml/2006/main">
               <a:ext uri="{FF2B5EF4-FFF2-40B4-BE49-F238E27FC236}">
-                <a16:creationId xmlns:a16="http://schemas.microsoft.com/office/drawing/2014/main" id="{C289E1AE-9132-4131-AD0C-81DF3D1E161A}"/>
+                <a16:creationId xmlns:a16="http://schemas.microsoft.com/office/drawing/2014/main" id="{13881CD8-D798-4D41-BB67-83CAA2024163}"/>
               </a:ext>
             </a:extLst>
           </p:cNvPr>
@@ -2940,7 +2940,7 @@
           <p:cNvPr id="14" name="">
             <a:extLst xmlns:a="http://schemas.openxmlformats.org/drawingml/2006/main">
               <a:ext uri="{FF2B5EF4-FFF2-40B4-BE49-F238E27FC236}">
-                <a16:creationId xmlns:a16="http://schemas.microsoft.com/office/drawing/2014/main" id="{AB49A8BC-23A3-48FF-B228-B780C3ECB3EF}"/>
+                <a16:creationId xmlns:a16="http://schemas.microsoft.com/office/drawing/2014/main" id="{1A94A451-A296-41B6-A784-526F477F3BAA}"/>
               </a:ext>
             </a:extLst>
           </p:cNvPr>
@@ -2980,7 +2980,7 @@
                   <a:srgbClr val="596780"/>
                 </a:solidFill>
               </a:rPr>
-              <a:t>крупных ИТ-проектов</a:t>
+              <a:t>крупных проектов</a:t>
             </a:r>
           </a:p>
         </p:txBody>
@@ -2990,7 +2990,7 @@
           <p:cNvPr id="15" name="">
             <a:extLst xmlns:a="http://schemas.openxmlformats.org/drawingml/2006/main">
               <a:ext uri="{FF2B5EF4-FFF2-40B4-BE49-F238E27FC236}">
-                <a16:creationId xmlns:a16="http://schemas.microsoft.com/office/drawing/2014/main" id="{5D6ADA22-4DCA-4798-96A3-2AE5494767CD}"/>
+                <a16:creationId xmlns:a16="http://schemas.microsoft.com/office/drawing/2014/main" id="{0505034F-730B-4E34-9E60-C8365C92F995}"/>
               </a:ext>
             </a:extLst>
           </p:cNvPr>
@@ -3040,7 +3040,7 @@
           <p:cNvPr id="16" name="">
             <a:extLst xmlns:a="http://schemas.openxmlformats.org/drawingml/2006/main">
               <a:ext uri="{FF2B5EF4-FFF2-40B4-BE49-F238E27FC236}">
-                <a16:creationId xmlns:a16="http://schemas.microsoft.com/office/drawing/2014/main" id="{7C2BFAE1-3138-4826-9BE2-00214F94AF1A}"/>
+                <a16:creationId xmlns:a16="http://schemas.microsoft.com/office/drawing/2014/main" id="{F9AAA2F8-7DB4-44FA-949A-EF5E260F779E}"/>
               </a:ext>
             </a:extLst>
           </p:cNvPr>
@@ -3090,7 +3090,7 @@
           <p:cNvPr id="17" name="">
             <a:extLst xmlns:a="http://schemas.openxmlformats.org/drawingml/2006/main">
               <a:ext uri="{FF2B5EF4-FFF2-40B4-BE49-F238E27FC236}">
-                <a16:creationId xmlns:a16="http://schemas.microsoft.com/office/drawing/2014/main" id="{7DE1ED08-30D1-4C19-B353-33EA015F7F1B}"/>
+                <a16:creationId xmlns:a16="http://schemas.microsoft.com/office/drawing/2014/main" id="{EFE3E949-B1F7-4179-A649-FC8CD0755D3C}"/>
               </a:ext>
             </a:extLst>
           </p:cNvPr>
@@ -3125,7 +3125,7 @@
           <p:cNvPr id="18" name="">
             <a:extLst xmlns:a="http://schemas.openxmlformats.org/drawingml/2006/main">
               <a:ext uri="{FF2B5EF4-FFF2-40B4-BE49-F238E27FC236}">
-                <a16:creationId xmlns:a16="http://schemas.microsoft.com/office/drawing/2014/main" id="{28F68918-5884-4A7C-B5D2-69DAFCC9F56C}"/>
+                <a16:creationId xmlns:a16="http://schemas.microsoft.com/office/drawing/2014/main" id="{651CABD9-0D20-42D7-8543-EE76EADB9CB2}"/>
               </a:ext>
             </a:extLst>
           </p:cNvPr>
@@ -3175,7 +3175,7 @@
           <p:cNvPr id="19" name="">
             <a:extLst xmlns:a="http://schemas.openxmlformats.org/drawingml/2006/main">
               <a:ext uri="{FF2B5EF4-FFF2-40B4-BE49-F238E27FC236}">
-                <a16:creationId xmlns:a16="http://schemas.microsoft.com/office/drawing/2014/main" id="{F3D5F5B2-B08C-443D-A148-E5EE6632B45E}"/>
+                <a16:creationId xmlns:a16="http://schemas.microsoft.com/office/drawing/2014/main" id="{677FC1E5-5AB4-40B1-9C17-CABF22C4C2B2}"/>
               </a:ext>
             </a:extLst>
           </p:cNvPr>
@@ -3225,7 +3225,7 @@
           <p:cNvPr id="20" name="">
             <a:extLst xmlns:a="http://schemas.openxmlformats.org/drawingml/2006/main">
               <a:ext uri="{FF2B5EF4-FFF2-40B4-BE49-F238E27FC236}">
-                <a16:creationId xmlns:a16="http://schemas.microsoft.com/office/drawing/2014/main" id="{0BF2753C-3BAE-4E7A-AF2D-CEF3AFF02B0F}"/>
+                <a16:creationId xmlns:a16="http://schemas.microsoft.com/office/drawing/2014/main" id="{F9A7D36B-CC4A-414C-850B-9865B8C4BA67}"/>
               </a:ext>
             </a:extLst>
           </p:cNvPr>
@@ -3275,7 +3275,7 @@
           <p:cNvPr id="21" name="">
             <a:extLst xmlns:a="http://schemas.openxmlformats.org/drawingml/2006/main">
               <a:ext uri="{FF2B5EF4-FFF2-40B4-BE49-F238E27FC236}">
-                <a16:creationId xmlns:a16="http://schemas.microsoft.com/office/drawing/2014/main" id="{8026175F-250F-4A94-84E9-75A3360A8BD7}"/>
+                <a16:creationId xmlns:a16="http://schemas.microsoft.com/office/drawing/2014/main" id="{7E9E80F4-B43A-4452-9E39-826D0E2F4388}"/>
               </a:ext>
             </a:extLst>
           </p:cNvPr>
@@ -3325,7 +3325,7 @@
           <p:cNvPr id="22" name="">
             <a:extLst xmlns:a="http://schemas.openxmlformats.org/drawingml/2006/main">
               <a:ext uri="{FF2B5EF4-FFF2-40B4-BE49-F238E27FC236}">
-                <a16:creationId xmlns:a16="http://schemas.microsoft.com/office/drawing/2014/main" id="{6C468EAA-7034-490C-989E-22D480E32BC2}"/>
+                <a16:creationId xmlns:a16="http://schemas.microsoft.com/office/drawing/2014/main" id="{5ACBD3DE-81E6-4AB3-AA30-29A05B25BF94}"/>
               </a:ext>
             </a:extLst>
           </p:cNvPr>
@@ -3356,7 +3356,7 @@
           <p:cNvPr id="23" name="">
             <a:extLst xmlns:a="http://schemas.openxmlformats.org/drawingml/2006/main">
               <a:ext uri="{FF2B5EF4-FFF2-40B4-BE49-F238E27FC236}">
-                <a16:creationId xmlns:a16="http://schemas.microsoft.com/office/drawing/2014/main" id="{233C6EF7-09CE-415E-9E93-C6C757640B8E}"/>
+                <a16:creationId xmlns:a16="http://schemas.microsoft.com/office/drawing/2014/main" id="{5BFBA0C8-577E-48BB-8E13-54E698EA7DF6}"/>
               </a:ext>
             </a:extLst>
           </p:cNvPr>
@@ -3406,7 +3406,7 @@
           <p:cNvPr id="24" name="">
             <a:extLst xmlns:a="http://schemas.openxmlformats.org/drawingml/2006/main">
               <a:ext uri="{FF2B5EF4-FFF2-40B4-BE49-F238E27FC236}">
-                <a16:creationId xmlns:a16="http://schemas.microsoft.com/office/drawing/2014/main" id="{5EAA35B5-F9F8-4AC0-A895-ED301E8A4AF9}"/>
+                <a16:creationId xmlns:a16="http://schemas.microsoft.com/office/drawing/2014/main" id="{3D6B414B-CA2A-46A3-BB5A-D823AD9B38AE}"/>
               </a:ext>
             </a:extLst>
           </p:cNvPr>
@@ -3456,7 +3456,7 @@
           <p:cNvPr id="25" name="">
             <a:extLst xmlns:a="http://schemas.openxmlformats.org/drawingml/2006/main">
               <a:ext uri="{FF2B5EF4-FFF2-40B4-BE49-F238E27FC236}">
-                <a16:creationId xmlns:a16="http://schemas.microsoft.com/office/drawing/2014/main" id="{73AE7810-06A9-42EA-A700-96C239A01740}"/>
+                <a16:creationId xmlns:a16="http://schemas.microsoft.com/office/drawing/2014/main" id="{582232E5-243A-4A9E-8558-24D2B166FEE8}"/>
               </a:ext>
             </a:extLst>
           </p:cNvPr>
@@ -3506,7 +3506,7 @@
           <p:cNvPr id="26" name="">
             <a:extLst xmlns:a="http://schemas.openxmlformats.org/drawingml/2006/main">
               <a:ext uri="{FF2B5EF4-FFF2-40B4-BE49-F238E27FC236}">
-                <a16:creationId xmlns:a16="http://schemas.microsoft.com/office/drawing/2014/main" id="{D22B4C97-7239-448F-8983-045C9A9B1636}"/>
+                <a16:creationId xmlns:a16="http://schemas.microsoft.com/office/drawing/2014/main" id="{50D21C90-4E44-4948-AD16-E6CAFD018F17}"/>
               </a:ext>
             </a:extLst>
           </p:cNvPr>
@@ -3537,7 +3537,7 @@
           <p:cNvPr id="27" name="">
             <a:extLst xmlns:a="http://schemas.openxmlformats.org/drawingml/2006/main">
               <a:ext uri="{FF2B5EF4-FFF2-40B4-BE49-F238E27FC236}">
-                <a16:creationId xmlns:a16="http://schemas.microsoft.com/office/drawing/2014/main" id="{911EDDD5-CFBA-4FA9-A197-67D942FCEE11}"/>
+                <a16:creationId xmlns:a16="http://schemas.microsoft.com/office/drawing/2014/main" id="{EB632313-C087-41C3-AF87-ED1BB863D7E0}"/>
               </a:ext>
             </a:extLst>
           </p:cNvPr>
@@ -3587,7 +3587,7 @@
           <p:cNvPr id="28" name="">
             <a:extLst xmlns:a="http://schemas.openxmlformats.org/drawingml/2006/main">
               <a:ext uri="{FF2B5EF4-FFF2-40B4-BE49-F238E27FC236}">
-                <a16:creationId xmlns:a16="http://schemas.microsoft.com/office/drawing/2014/main" id="{6C697E01-B51C-45DD-8C50-502275E859A7}"/>
+                <a16:creationId xmlns:a16="http://schemas.microsoft.com/office/drawing/2014/main" id="{E71DFC39-9D58-4746-8ADD-7846D2AA5A64}"/>
               </a:ext>
             </a:extLst>
           </p:cNvPr>
@@ -3637,7 +3637,7 @@
           <p:cNvPr id="29" name="">
             <a:extLst xmlns:a="http://schemas.openxmlformats.org/drawingml/2006/main">
               <a:ext uri="{FF2B5EF4-FFF2-40B4-BE49-F238E27FC236}">
-                <a16:creationId xmlns:a16="http://schemas.microsoft.com/office/drawing/2014/main" id="{F8B4D951-5B94-45E7-9BC5-9F8FCC12235B}"/>
+                <a16:creationId xmlns:a16="http://schemas.microsoft.com/office/drawing/2014/main" id="{354F0B55-0B54-41A8-9551-780B089F50E8}"/>
               </a:ext>
             </a:extLst>
           </p:cNvPr>
@@ -3687,7 +3687,7 @@
           <p:cNvPr id="30" name="">
             <a:extLst xmlns:a="http://schemas.openxmlformats.org/drawingml/2006/main">
               <a:ext uri="{FF2B5EF4-FFF2-40B4-BE49-F238E27FC236}">
-                <a16:creationId xmlns:a16="http://schemas.microsoft.com/office/drawing/2014/main" id="{0A162806-3C25-4C29-A11B-62212FD6D1E0}"/>
+                <a16:creationId xmlns:a16="http://schemas.microsoft.com/office/drawing/2014/main" id="{EC70828A-7FAA-464B-9D2D-43180111DF68}"/>
               </a:ext>
             </a:extLst>
           </p:cNvPr>
@@ -3718,7 +3718,7 @@
           <p:cNvPr id="31" name="">
             <a:extLst xmlns:a="http://schemas.openxmlformats.org/drawingml/2006/main">
               <a:ext uri="{FF2B5EF4-FFF2-40B4-BE49-F238E27FC236}">
-                <a16:creationId xmlns:a16="http://schemas.microsoft.com/office/drawing/2014/main" id="{2D303E68-9379-437C-89CD-624C18E43280}"/>
+                <a16:creationId xmlns:a16="http://schemas.microsoft.com/office/drawing/2014/main" id="{4C0B97D6-9B23-4009-96C7-AD89A3C663F7}"/>
               </a:ext>
             </a:extLst>
           </p:cNvPr>
@@ -3768,7 +3768,7 @@
           <p:cNvPr id="32" name="">
             <a:extLst xmlns:a="http://schemas.openxmlformats.org/drawingml/2006/main">
               <a:ext uri="{FF2B5EF4-FFF2-40B4-BE49-F238E27FC236}">
-                <a16:creationId xmlns:a16="http://schemas.microsoft.com/office/drawing/2014/main" id="{B35A2B8F-D73C-4F78-A73C-041B531C153F}"/>
+                <a16:creationId xmlns:a16="http://schemas.microsoft.com/office/drawing/2014/main" id="{FF5A427E-24DA-4E40-BB03-549C1FAEBC98}"/>
               </a:ext>
             </a:extLst>
           </p:cNvPr>
@@ -3818,7 +3818,7 @@
           <p:cNvPr id="33" name="">
             <a:extLst xmlns:a="http://schemas.openxmlformats.org/drawingml/2006/main">
               <a:ext uri="{FF2B5EF4-FFF2-40B4-BE49-F238E27FC236}">
-                <a16:creationId xmlns:a16="http://schemas.microsoft.com/office/drawing/2014/main" id="{3AB26118-4D14-467B-8094-645569EB54C7}"/>
+                <a16:creationId xmlns:a16="http://schemas.microsoft.com/office/drawing/2014/main" id="{AFEE87E2-9BB5-40C6-8B5B-A3F375D48E9A}"/>
               </a:ext>
             </a:extLst>
           </p:cNvPr>
@@ -3866,7 +3866,7 @@
     </p:spTree>
     <p:extLst>
       <p:ext uri="{BB962C8B-B14F-4D97-AF65-F5344CB8AC3E}">
-        <p14:creationId xmlns:p14="http://schemas.microsoft.com/office/powerpoint/2010/main" val="813448134"/>
+        <p14:creationId xmlns:p14="http://schemas.microsoft.com/office/powerpoint/2010/main" val="1170439292"/>
       </p:ext>
     </p:extLst>
   </p:cSld>
@@ -3897,7 +3897,7 @@
           <p:cNvPr id="1" name="">
             <a:extLst xmlns:a="http://schemas.openxmlformats.org/drawingml/2006/main">
               <a:ext uri="{FF2B5EF4-FFF2-40B4-BE49-F238E27FC236}">
-                <a16:creationId xmlns:a16="http://schemas.microsoft.com/office/drawing/2014/main" id="{7E1D6E64-608E-4AFE-A247-5F75C72A995F}"/>
+                <a16:creationId xmlns:a16="http://schemas.microsoft.com/office/drawing/2014/main" id="{D575781F-A9C2-4787-B10B-0D252854799D}"/>
               </a:ext>
             </a:extLst>
           </p:cNvPr>
@@ -3932,7 +3932,7 @@
           <p:nvPr/>
         </p:nvPicPr>
         <p:blipFill>
-          <a:blip xmlns:r="http://schemas.openxmlformats.org/officeDocument/2006/relationships" xmlns:a="http://schemas.openxmlformats.org/drawingml/2006/main" r:embed="Rd69feda7fd6943ec"/>
+          <a:blip xmlns:r="http://schemas.openxmlformats.org/officeDocument/2006/relationships" xmlns:a="http://schemas.openxmlformats.org/drawingml/2006/main" r:embed="R8fdfd7f799904102"/>
           <a:stretch xmlns:a="http://schemas.openxmlformats.org/drawingml/2006/main"/>
         </p:blipFill>
         <p:spPr>
@@ -3950,7 +3950,7 @@
           <p:cNvPr id="3" name="">
             <a:extLst xmlns:a="http://schemas.openxmlformats.org/drawingml/2006/main">
               <a:ext uri="{FF2B5EF4-FFF2-40B4-BE49-F238E27FC236}">
-                <a16:creationId xmlns:a16="http://schemas.microsoft.com/office/drawing/2014/main" id="{B147EF62-ED3D-4623-9377-625342315484}"/>
+                <a16:creationId xmlns:a16="http://schemas.microsoft.com/office/drawing/2014/main" id="{E02F054B-C460-40FF-A6B3-2C88E04EE742}"/>
               </a:ext>
             </a:extLst>
           </p:cNvPr>
@@ -4000,7 +4000,7 @@
           <p:cNvPr id="4" name="">
             <a:extLst xmlns:a="http://schemas.openxmlformats.org/drawingml/2006/main">
               <a:ext uri="{FF2B5EF4-FFF2-40B4-BE49-F238E27FC236}">
-                <a16:creationId xmlns:a16="http://schemas.microsoft.com/office/drawing/2014/main" id="{5665F893-252F-4A5F-A005-56C3A47A973D}"/>
+                <a16:creationId xmlns:a16="http://schemas.microsoft.com/office/drawing/2014/main" id="{371E3211-E972-4FA4-A67A-37DEA072F9A9}"/>
               </a:ext>
             </a:extLst>
           </p:cNvPr>
@@ -4033,7 +4033,7 @@
           <p:cNvPr id="5" name="">
             <a:extLst xmlns:a="http://schemas.openxmlformats.org/drawingml/2006/main">
               <a:ext uri="{FF2B5EF4-FFF2-40B4-BE49-F238E27FC236}">
-                <a16:creationId xmlns:a16="http://schemas.microsoft.com/office/drawing/2014/main" id="{3A7853B1-DDB0-493F-81A4-16B860C972AF}"/>
+                <a16:creationId xmlns:a16="http://schemas.microsoft.com/office/drawing/2014/main" id="{5017C176-0B6D-4458-B958-886558EA5FAC}"/>
               </a:ext>
             </a:extLst>
           </p:cNvPr>
@@ -4064,7 +4064,7 @@
           <p:cNvPr id="6" name="">
             <a:extLst xmlns:a="http://schemas.openxmlformats.org/drawingml/2006/main">
               <a:ext uri="{FF2B5EF4-FFF2-40B4-BE49-F238E27FC236}">
-                <a16:creationId xmlns:a16="http://schemas.microsoft.com/office/drawing/2014/main" id="{BB9878FC-CCBE-4C2B-B2AD-D3640DD02352}"/>
+                <a16:creationId xmlns:a16="http://schemas.microsoft.com/office/drawing/2014/main" id="{F8C30A59-30B4-46C4-99CF-7B80C8B41E10}"/>
               </a:ext>
             </a:extLst>
           </p:cNvPr>
@@ -4114,7 +4114,7 @@
           <p:cNvPr id="7" name="">
             <a:extLst xmlns:a="http://schemas.openxmlformats.org/drawingml/2006/main">
               <a:ext uri="{FF2B5EF4-FFF2-40B4-BE49-F238E27FC236}">
-                <a16:creationId xmlns:a16="http://schemas.microsoft.com/office/drawing/2014/main" id="{B30A6BA6-E05C-4925-88BC-7734AD2F85FF}"/>
+                <a16:creationId xmlns:a16="http://schemas.microsoft.com/office/drawing/2014/main" id="{CF7CD4E5-33BC-42F7-AB7E-BDFC9B6F1F7F}"/>
               </a:ext>
             </a:extLst>
           </p:cNvPr>
@@ -4164,7 +4164,7 @@
           <p:cNvPr id="8" name="">
             <a:extLst xmlns:a="http://schemas.openxmlformats.org/drawingml/2006/main">
               <a:ext uri="{FF2B5EF4-FFF2-40B4-BE49-F238E27FC236}">
-                <a16:creationId xmlns:a16="http://schemas.microsoft.com/office/drawing/2014/main" id="{6669804A-ED5F-443E-950D-63998CEF43BC}"/>
+                <a16:creationId xmlns:a16="http://schemas.microsoft.com/office/drawing/2014/main" id="{BEDA2FD6-16AB-44E3-9EFD-9BEB6A225290}"/>
               </a:ext>
             </a:extLst>
           </p:cNvPr>
@@ -4214,7 +4214,7 @@
           <p:cNvPr id="9" name="">
             <a:extLst xmlns:a="http://schemas.openxmlformats.org/drawingml/2006/main">
               <a:ext uri="{FF2B5EF4-FFF2-40B4-BE49-F238E27FC236}">
-                <a16:creationId xmlns:a16="http://schemas.microsoft.com/office/drawing/2014/main" id="{9DC4F9E1-FAC3-453C-AF65-A3156B1A0F4A}"/>
+                <a16:creationId xmlns:a16="http://schemas.microsoft.com/office/drawing/2014/main" id="{5E17409D-ED99-48D1-A41E-0D290B016712}"/>
               </a:ext>
             </a:extLst>
           </p:cNvPr>
@@ -4264,7 +4264,7 @@
           <p:cNvPr id="10" name="">
             <a:extLst xmlns:a="http://schemas.openxmlformats.org/drawingml/2006/main">
               <a:ext uri="{FF2B5EF4-FFF2-40B4-BE49-F238E27FC236}">
-                <a16:creationId xmlns:a16="http://schemas.microsoft.com/office/drawing/2014/main" id="{AD83A6F7-818B-469B-907D-A9A9FCD61B0D}"/>
+                <a16:creationId xmlns:a16="http://schemas.microsoft.com/office/drawing/2014/main" id="{0E9C4987-C791-4D97-BA12-25BE18DA06A4}"/>
               </a:ext>
             </a:extLst>
           </p:cNvPr>
@@ -4314,7 +4314,7 @@
           <p:cNvPr id="11" name="">
             <a:extLst xmlns:a="http://schemas.openxmlformats.org/drawingml/2006/main">
               <a:ext uri="{FF2B5EF4-FFF2-40B4-BE49-F238E27FC236}">
-                <a16:creationId xmlns:a16="http://schemas.microsoft.com/office/drawing/2014/main" id="{10AB61FB-B52B-4F6F-9945-6679B2F2108A}"/>
+                <a16:creationId xmlns:a16="http://schemas.microsoft.com/office/drawing/2014/main" id="{2B62F2E4-CC1D-481C-BE0F-064892830549}"/>
               </a:ext>
             </a:extLst>
           </p:cNvPr>
@@ -4345,7 +4345,7 @@
           <p:cNvPr id="12" name="">
             <a:extLst xmlns:a="http://schemas.openxmlformats.org/drawingml/2006/main">
               <a:ext uri="{FF2B5EF4-FFF2-40B4-BE49-F238E27FC236}">
-                <a16:creationId xmlns:a16="http://schemas.microsoft.com/office/drawing/2014/main" id="{D0E48DDB-4657-4AA8-B123-1DD3E0CD4855}"/>
+                <a16:creationId xmlns:a16="http://schemas.microsoft.com/office/drawing/2014/main" id="{037B752D-0BB8-4259-903B-21528CD64B71}"/>
               </a:ext>
             </a:extLst>
           </p:cNvPr>
@@ -4395,7 +4395,7 @@
           <p:cNvPr id="13" name="">
             <a:extLst xmlns:a="http://schemas.openxmlformats.org/drawingml/2006/main">
               <a:ext uri="{FF2B5EF4-FFF2-40B4-BE49-F238E27FC236}">
-                <a16:creationId xmlns:a16="http://schemas.microsoft.com/office/drawing/2014/main" id="{66139BD5-0DA7-48E4-A6AB-90D59403F6AD}"/>
+                <a16:creationId xmlns:a16="http://schemas.microsoft.com/office/drawing/2014/main" id="{F059E6BE-F3B8-4C12-9A83-729125265E74}"/>
               </a:ext>
             </a:extLst>
           </p:cNvPr>
@@ -4445,7 +4445,7 @@
           <p:cNvPr id="14" name="">
             <a:extLst xmlns:a="http://schemas.openxmlformats.org/drawingml/2006/main">
               <a:ext uri="{FF2B5EF4-FFF2-40B4-BE49-F238E27FC236}">
-                <a16:creationId xmlns:a16="http://schemas.microsoft.com/office/drawing/2014/main" id="{2BC63F8A-FE3A-43EF-BDC1-F97F168EB9EA}"/>
+                <a16:creationId xmlns:a16="http://schemas.microsoft.com/office/drawing/2014/main" id="{B26B58E3-1943-408D-9321-07B03B024E42}"/>
               </a:ext>
             </a:extLst>
           </p:cNvPr>
@@ -4476,7 +4476,7 @@
           <p:cNvPr id="15" name="">
             <a:extLst xmlns:a="http://schemas.openxmlformats.org/drawingml/2006/main">
               <a:ext uri="{FF2B5EF4-FFF2-40B4-BE49-F238E27FC236}">
-                <a16:creationId xmlns:a16="http://schemas.microsoft.com/office/drawing/2014/main" id="{241A7983-BE2C-4D78-8BF6-DE80EED9DAA4}"/>
+                <a16:creationId xmlns:a16="http://schemas.microsoft.com/office/drawing/2014/main" id="{7684AB50-A3E0-4947-A621-5E0EA7EEB3C7}"/>
               </a:ext>
             </a:extLst>
           </p:cNvPr>
@@ -4526,7 +4526,7 @@
           <p:cNvPr id="16" name="">
             <a:extLst xmlns:a="http://schemas.openxmlformats.org/drawingml/2006/main">
               <a:ext uri="{FF2B5EF4-FFF2-40B4-BE49-F238E27FC236}">
-                <a16:creationId xmlns:a16="http://schemas.microsoft.com/office/drawing/2014/main" id="{CC2AFF33-EF11-439E-B4B3-475D8CF841DE}"/>
+                <a16:creationId xmlns:a16="http://schemas.microsoft.com/office/drawing/2014/main" id="{78B0287E-E1AD-4A8D-985C-92370459DBE8}"/>
               </a:ext>
             </a:extLst>
           </p:cNvPr>
@@ -4576,7 +4576,7 @@
           <p:cNvPr id="17" name="">
             <a:extLst xmlns:a="http://schemas.openxmlformats.org/drawingml/2006/main">
               <a:ext uri="{FF2B5EF4-FFF2-40B4-BE49-F238E27FC236}">
-                <a16:creationId xmlns:a16="http://schemas.microsoft.com/office/drawing/2014/main" id="{988C559B-0890-4D5C-9D2E-772B1BB88ABF}"/>
+                <a16:creationId xmlns:a16="http://schemas.microsoft.com/office/drawing/2014/main" id="{9AF6752F-6E8B-436B-9B74-12C323F24BD6}"/>
               </a:ext>
             </a:extLst>
           </p:cNvPr>
@@ -4607,7 +4607,7 @@
           <p:cNvPr id="18" name="">
             <a:extLst xmlns:a="http://schemas.openxmlformats.org/drawingml/2006/main">
               <a:ext uri="{FF2B5EF4-FFF2-40B4-BE49-F238E27FC236}">
-                <a16:creationId xmlns:a16="http://schemas.microsoft.com/office/drawing/2014/main" id="{B29BCFE9-16D9-4DA3-89F0-BF77CB8FAF3F}"/>
+                <a16:creationId xmlns:a16="http://schemas.microsoft.com/office/drawing/2014/main" id="{19572A67-CF4B-4FA3-BC1B-3B7FEF36484A}"/>
               </a:ext>
             </a:extLst>
           </p:cNvPr>
@@ -4657,7 +4657,7 @@
           <p:cNvPr id="19" name="">
             <a:extLst xmlns:a="http://schemas.openxmlformats.org/drawingml/2006/main">
               <a:ext uri="{FF2B5EF4-FFF2-40B4-BE49-F238E27FC236}">
-                <a16:creationId xmlns:a16="http://schemas.microsoft.com/office/drawing/2014/main" id="{DDB33183-991E-48EB-BA51-DF3714D0E4F8}"/>
+                <a16:creationId xmlns:a16="http://schemas.microsoft.com/office/drawing/2014/main" id="{05DAAD97-E76E-4D42-B5AE-2C44BD72A3BC}"/>
               </a:ext>
             </a:extLst>
           </p:cNvPr>
@@ -4705,7 +4705,7 @@
     </p:spTree>
     <p:extLst>
       <p:ext uri="{BB962C8B-B14F-4D97-AF65-F5344CB8AC3E}">
-        <p14:creationId xmlns:p14="http://schemas.microsoft.com/office/powerpoint/2010/main" val="1619790579"/>
+        <p14:creationId xmlns:p14="http://schemas.microsoft.com/office/powerpoint/2010/main" val="79102955"/>
       </p:ext>
     </p:extLst>
   </p:cSld>
@@ -4736,7 +4736,7 @@
           <p:cNvPr id="1" name="">
             <a:extLst xmlns:a="http://schemas.openxmlformats.org/drawingml/2006/main">
               <a:ext uri="{FF2B5EF4-FFF2-40B4-BE49-F238E27FC236}">
-                <a16:creationId xmlns:a16="http://schemas.microsoft.com/office/drawing/2014/main" id="{B781270B-2F8B-4360-8272-8E6569538146}"/>
+                <a16:creationId xmlns:a16="http://schemas.microsoft.com/office/drawing/2014/main" id="{DBBF6472-24CA-4963-BC5B-C54863DBC97F}"/>
               </a:ext>
             </a:extLst>
           </p:cNvPr>
@@ -4771,7 +4771,7 @@
           <p:nvPr/>
         </p:nvPicPr>
         <p:blipFill>
-          <a:blip xmlns:r="http://schemas.openxmlformats.org/officeDocument/2006/relationships" xmlns:a="http://schemas.openxmlformats.org/drawingml/2006/main" r:embed="R86c6408cb75e4985"/>
+          <a:blip xmlns:r="http://schemas.openxmlformats.org/officeDocument/2006/relationships" xmlns:a="http://schemas.openxmlformats.org/drawingml/2006/main" r:embed="R9c3b4b4292c6492e"/>
           <a:stretch xmlns:a="http://schemas.openxmlformats.org/drawingml/2006/main"/>
         </p:blipFill>
         <p:spPr>
@@ -4789,7 +4789,7 @@
           <p:cNvPr id="3" name="">
             <a:extLst xmlns:a="http://schemas.openxmlformats.org/drawingml/2006/main">
               <a:ext uri="{FF2B5EF4-FFF2-40B4-BE49-F238E27FC236}">
-                <a16:creationId xmlns:a16="http://schemas.microsoft.com/office/drawing/2014/main" id="{99E6BB26-0D9A-43D1-AA44-D51E315D0BE5}"/>
+                <a16:creationId xmlns:a16="http://schemas.microsoft.com/office/drawing/2014/main" id="{38F8FE3A-DC15-4715-9D09-2D481A2C29DF}"/>
               </a:ext>
             </a:extLst>
           </p:cNvPr>
@@ -4839,7 +4839,7 @@
           <p:cNvPr id="4" name="">
             <a:extLst xmlns:a="http://schemas.openxmlformats.org/drawingml/2006/main">
               <a:ext uri="{FF2B5EF4-FFF2-40B4-BE49-F238E27FC236}">
-                <a16:creationId xmlns:a16="http://schemas.microsoft.com/office/drawing/2014/main" id="{2C9FD7CC-A67C-4979-BE84-E41C18FB6BD9}"/>
+                <a16:creationId xmlns:a16="http://schemas.microsoft.com/office/drawing/2014/main" id="{9C3A7BE5-3F98-49D0-A913-924A4C7CF5DE}"/>
               </a:ext>
             </a:extLst>
           </p:cNvPr>
@@ -4872,7 +4872,7 @@
           <p:cNvPr id="5" name="">
             <a:extLst xmlns:a="http://schemas.openxmlformats.org/drawingml/2006/main">
               <a:ext uri="{FF2B5EF4-FFF2-40B4-BE49-F238E27FC236}">
-                <a16:creationId xmlns:a16="http://schemas.microsoft.com/office/drawing/2014/main" id="{72E69065-8836-4BA2-B975-5147CE9184A2}"/>
+                <a16:creationId xmlns:a16="http://schemas.microsoft.com/office/drawing/2014/main" id="{F99F953B-8E4E-4095-8871-07C44BF67417}"/>
               </a:ext>
             </a:extLst>
           </p:cNvPr>
@@ -4903,7 +4903,7 @@
           <p:cNvPr id="6" name="">
             <a:extLst xmlns:a="http://schemas.openxmlformats.org/drawingml/2006/main">
               <a:ext uri="{FF2B5EF4-FFF2-40B4-BE49-F238E27FC236}">
-                <a16:creationId xmlns:a16="http://schemas.microsoft.com/office/drawing/2014/main" id="{AED69761-CF64-412B-9D81-1A7CC912FA4A}"/>
+                <a16:creationId xmlns:a16="http://schemas.microsoft.com/office/drawing/2014/main" id="{E181245E-94EF-45EB-B1FB-876513B579D2}"/>
               </a:ext>
             </a:extLst>
           </p:cNvPr>
@@ -4953,7 +4953,7 @@
           <p:cNvPr id="7" name="">
             <a:extLst xmlns:a="http://schemas.openxmlformats.org/drawingml/2006/main">
               <a:ext uri="{FF2B5EF4-FFF2-40B4-BE49-F238E27FC236}">
-                <a16:creationId xmlns:a16="http://schemas.microsoft.com/office/drawing/2014/main" id="{87D6965A-9BA4-47B6-AD8C-D9F30D2F7AEC}"/>
+                <a16:creationId xmlns:a16="http://schemas.microsoft.com/office/drawing/2014/main" id="{948BC06C-8C20-4502-BF0B-2B05CCD8F53E}"/>
               </a:ext>
             </a:extLst>
           </p:cNvPr>
@@ -5003,7 +5003,7 @@
           <p:cNvPr id="8" name="">
             <a:extLst xmlns:a="http://schemas.openxmlformats.org/drawingml/2006/main">
               <a:ext uri="{FF2B5EF4-FFF2-40B4-BE49-F238E27FC236}">
-                <a16:creationId xmlns:a16="http://schemas.microsoft.com/office/drawing/2014/main" id="{4221C610-9E71-48B9-A384-67E29DCCD516}"/>
+                <a16:creationId xmlns:a16="http://schemas.microsoft.com/office/drawing/2014/main" id="{A9885844-143A-4991-9B7D-3AE87DDCE6ED}"/>
               </a:ext>
             </a:extLst>
           </p:cNvPr>
@@ -5038,7 +5038,7 @@
           <p:cNvPr id="9" name="">
             <a:extLst xmlns:a="http://schemas.openxmlformats.org/drawingml/2006/main">
               <a:ext uri="{FF2B5EF4-FFF2-40B4-BE49-F238E27FC236}">
-                <a16:creationId xmlns:a16="http://schemas.microsoft.com/office/drawing/2014/main" id="{000E7E47-D393-45C9-9B1E-C5AA88BFBDA8}"/>
+                <a16:creationId xmlns:a16="http://schemas.microsoft.com/office/drawing/2014/main" id="{653F32CA-40DA-4521-AA8A-F755E41318AA}"/>
               </a:ext>
             </a:extLst>
           </p:cNvPr>
@@ -5088,7 +5088,7 @@
           <p:cNvPr id="10" name="">
             <a:extLst xmlns:a="http://schemas.openxmlformats.org/drawingml/2006/main">
               <a:ext uri="{FF2B5EF4-FFF2-40B4-BE49-F238E27FC236}">
-                <a16:creationId xmlns:a16="http://schemas.microsoft.com/office/drawing/2014/main" id="{67EE0111-B702-42CE-86DF-5DE638263970}"/>
+                <a16:creationId xmlns:a16="http://schemas.microsoft.com/office/drawing/2014/main" id="{22DE48D5-C0A5-4000-B6D8-94438FAF349A}"/>
               </a:ext>
             </a:extLst>
           </p:cNvPr>
@@ -5138,7 +5138,7 @@
           <p:cNvPr id="11" name="">
             <a:extLst xmlns:a="http://schemas.openxmlformats.org/drawingml/2006/main">
               <a:ext uri="{FF2B5EF4-FFF2-40B4-BE49-F238E27FC236}">
-                <a16:creationId xmlns:a16="http://schemas.microsoft.com/office/drawing/2014/main" id="{DE59876C-46F3-4C04-A68B-45ED3550B50F}"/>
+                <a16:creationId xmlns:a16="http://schemas.microsoft.com/office/drawing/2014/main" id="{E2B0BC1D-438C-492D-ADBE-2C047C53632B}"/>
               </a:ext>
             </a:extLst>
           </p:cNvPr>
@@ -5173,7 +5173,7 @@
           <p:cNvPr id="12" name="">
             <a:extLst xmlns:a="http://schemas.openxmlformats.org/drawingml/2006/main">
               <a:ext uri="{FF2B5EF4-FFF2-40B4-BE49-F238E27FC236}">
-                <a16:creationId xmlns:a16="http://schemas.microsoft.com/office/drawing/2014/main" id="{50313A14-9D02-4C60-840F-AC0F59A76602}"/>
+                <a16:creationId xmlns:a16="http://schemas.microsoft.com/office/drawing/2014/main" id="{A86C096F-4E78-43FB-BACF-DCBB47085CE2}"/>
               </a:ext>
             </a:extLst>
           </p:cNvPr>
@@ -5223,7 +5223,7 @@
           <p:cNvPr id="13" name="">
             <a:extLst xmlns:a="http://schemas.openxmlformats.org/drawingml/2006/main">
               <a:ext uri="{FF2B5EF4-FFF2-40B4-BE49-F238E27FC236}">
-                <a16:creationId xmlns:a16="http://schemas.microsoft.com/office/drawing/2014/main" id="{E3101F3F-C3A4-4C96-8935-D1FC025F04AF}"/>
+                <a16:creationId xmlns:a16="http://schemas.microsoft.com/office/drawing/2014/main" id="{3CAFFC82-E80E-4BD2-9256-8A7DE5EDBC4F}"/>
               </a:ext>
             </a:extLst>
           </p:cNvPr>
@@ -5273,7 +5273,7 @@
           <p:cNvPr id="14" name="">
             <a:extLst xmlns:a="http://schemas.openxmlformats.org/drawingml/2006/main">
               <a:ext uri="{FF2B5EF4-FFF2-40B4-BE49-F238E27FC236}">
-                <a16:creationId xmlns:a16="http://schemas.microsoft.com/office/drawing/2014/main" id="{08C199D8-E5E1-4703-9AC2-1890A87B0669}"/>
+                <a16:creationId xmlns:a16="http://schemas.microsoft.com/office/drawing/2014/main" id="{B2A84E13-8231-44C7-B999-3F3F483C2E3B}"/>
               </a:ext>
             </a:extLst>
           </p:cNvPr>
@@ -5308,7 +5308,7 @@
           <p:cNvPr id="15" name="">
             <a:extLst xmlns:a="http://schemas.openxmlformats.org/drawingml/2006/main">
               <a:ext uri="{FF2B5EF4-FFF2-40B4-BE49-F238E27FC236}">
-                <a16:creationId xmlns:a16="http://schemas.microsoft.com/office/drawing/2014/main" id="{7450AB77-F8F9-447B-AE62-0B4B89D9C1F7}"/>
+                <a16:creationId xmlns:a16="http://schemas.microsoft.com/office/drawing/2014/main" id="{B1A2C628-8267-4C59-9186-8727C3F9E169}"/>
               </a:ext>
             </a:extLst>
           </p:cNvPr>
@@ -5358,7 +5358,7 @@
           <p:cNvPr id="16" name="">
             <a:extLst xmlns:a="http://schemas.openxmlformats.org/drawingml/2006/main">
               <a:ext uri="{FF2B5EF4-FFF2-40B4-BE49-F238E27FC236}">
-                <a16:creationId xmlns:a16="http://schemas.microsoft.com/office/drawing/2014/main" id="{148E5812-35FE-4DF8-A779-4F8C3FF53092}"/>
+                <a16:creationId xmlns:a16="http://schemas.microsoft.com/office/drawing/2014/main" id="{4C6927E8-9B2D-4E50-A365-BBEFFF468C83}"/>
               </a:ext>
             </a:extLst>
           </p:cNvPr>
@@ -5408,7 +5408,7 @@
           <p:cNvPr id="17" name="">
             <a:extLst xmlns:a="http://schemas.openxmlformats.org/drawingml/2006/main">
               <a:ext uri="{FF2B5EF4-FFF2-40B4-BE49-F238E27FC236}">
-                <a16:creationId xmlns:a16="http://schemas.microsoft.com/office/drawing/2014/main" id="{98D54E86-CBB4-41B3-A3CC-05A280288067}"/>
+                <a16:creationId xmlns:a16="http://schemas.microsoft.com/office/drawing/2014/main" id="{BDDFC20A-C3F6-4035-AB1C-EFC117BD4560}"/>
               </a:ext>
             </a:extLst>
           </p:cNvPr>
@@ -5443,7 +5443,7 @@
           <p:cNvPr id="18" name="">
             <a:extLst xmlns:a="http://schemas.openxmlformats.org/drawingml/2006/main">
               <a:ext uri="{FF2B5EF4-FFF2-40B4-BE49-F238E27FC236}">
-                <a16:creationId xmlns:a16="http://schemas.microsoft.com/office/drawing/2014/main" id="{D28DA4D9-E368-44C2-AD43-F8895BEC4D42}"/>
+                <a16:creationId xmlns:a16="http://schemas.microsoft.com/office/drawing/2014/main" id="{E7C9149D-5072-4E02-9CF2-99DE3D6C316A}"/>
               </a:ext>
             </a:extLst>
           </p:cNvPr>
@@ -5493,7 +5493,7 @@
           <p:cNvPr id="19" name="">
             <a:extLst xmlns:a="http://schemas.openxmlformats.org/drawingml/2006/main">
               <a:ext uri="{FF2B5EF4-FFF2-40B4-BE49-F238E27FC236}">
-                <a16:creationId xmlns:a16="http://schemas.microsoft.com/office/drawing/2014/main" id="{21CBAB27-837E-43F8-9FDF-FA04EC1FD9F6}"/>
+                <a16:creationId xmlns:a16="http://schemas.microsoft.com/office/drawing/2014/main" id="{DE0C11E1-A581-4F72-9074-483FEEC9F630}"/>
               </a:ext>
             </a:extLst>
           </p:cNvPr>
@@ -5543,7 +5543,7 @@
           <p:cNvPr id="20" name="">
             <a:extLst xmlns:a="http://schemas.openxmlformats.org/drawingml/2006/main">
               <a:ext uri="{FF2B5EF4-FFF2-40B4-BE49-F238E27FC236}">
-                <a16:creationId xmlns:a16="http://schemas.microsoft.com/office/drawing/2014/main" id="{7151DD97-AF39-4FD3-A673-427AED88EA6C}"/>
+                <a16:creationId xmlns:a16="http://schemas.microsoft.com/office/drawing/2014/main" id="{67BCE147-A207-4C14-BED8-200056119BF1}"/>
               </a:ext>
             </a:extLst>
           </p:cNvPr>
@@ -5593,7 +5593,7 @@
           <p:cNvPr id="21" name="">
             <a:extLst xmlns:a="http://schemas.openxmlformats.org/drawingml/2006/main">
               <a:ext uri="{FF2B5EF4-FFF2-40B4-BE49-F238E27FC236}">
-                <a16:creationId xmlns:a16="http://schemas.microsoft.com/office/drawing/2014/main" id="{175721AA-0AED-4F0D-A665-B7546897B9E3}"/>
+                <a16:creationId xmlns:a16="http://schemas.microsoft.com/office/drawing/2014/main" id="{BC9A73BB-C64E-4B46-8380-4B7709B6B364}"/>
               </a:ext>
             </a:extLst>
           </p:cNvPr>
@@ -5643,7 +5643,7 @@
           <p:cNvPr id="22" name="">
             <a:extLst xmlns:a="http://schemas.openxmlformats.org/drawingml/2006/main">
               <a:ext uri="{FF2B5EF4-FFF2-40B4-BE49-F238E27FC236}">
-                <a16:creationId xmlns:a16="http://schemas.microsoft.com/office/drawing/2014/main" id="{23F7E3C9-34CC-4096-92DF-EE2D8CB627F8}"/>
+                <a16:creationId xmlns:a16="http://schemas.microsoft.com/office/drawing/2014/main" id="{489C8707-95A1-4C70-BE4B-470D4AC084CD}"/>
               </a:ext>
             </a:extLst>
           </p:cNvPr>
@@ -5693,7 +5693,7 @@
           <p:cNvPr id="23" name="">
             <a:extLst xmlns:a="http://schemas.openxmlformats.org/drawingml/2006/main">
               <a:ext uri="{FF2B5EF4-FFF2-40B4-BE49-F238E27FC236}">
-                <a16:creationId xmlns:a16="http://schemas.microsoft.com/office/drawing/2014/main" id="{87AC026C-244B-4187-9B90-519CA882D2B0}"/>
+                <a16:creationId xmlns:a16="http://schemas.microsoft.com/office/drawing/2014/main" id="{CEC3D707-F914-4133-AE23-896C6F011E25}"/>
               </a:ext>
             </a:extLst>
           </p:cNvPr>
@@ -5726,7 +5726,7 @@
           <p:cNvPr id="24" name="">
             <a:extLst xmlns:a="http://schemas.openxmlformats.org/drawingml/2006/main">
               <a:ext uri="{FF2B5EF4-FFF2-40B4-BE49-F238E27FC236}">
-                <a16:creationId xmlns:a16="http://schemas.microsoft.com/office/drawing/2014/main" id="{60DA643A-DEE3-41D6-98E6-1DB69A36D059}"/>
+                <a16:creationId xmlns:a16="http://schemas.microsoft.com/office/drawing/2014/main" id="{D6DBD709-0EE5-43FB-AB64-5E828BADF5D9}"/>
               </a:ext>
             </a:extLst>
           </p:cNvPr>
@@ -5776,7 +5776,7 @@
           <p:cNvPr id="25" name="">
             <a:extLst xmlns:a="http://schemas.openxmlformats.org/drawingml/2006/main">
               <a:ext uri="{FF2B5EF4-FFF2-40B4-BE49-F238E27FC236}">
-                <a16:creationId xmlns:a16="http://schemas.microsoft.com/office/drawing/2014/main" id="{5B98BAA0-B8E3-4174-9834-90B04BF67D43}"/>
+                <a16:creationId xmlns:a16="http://schemas.microsoft.com/office/drawing/2014/main" id="{B732594D-D3EF-4BB1-9297-2F188294E415}"/>
               </a:ext>
             </a:extLst>
           </p:cNvPr>
@@ -5826,7 +5826,7 @@
           <p:cNvPr id="26" name="">
             <a:extLst xmlns:a="http://schemas.openxmlformats.org/drawingml/2006/main">
               <a:ext uri="{FF2B5EF4-FFF2-40B4-BE49-F238E27FC236}">
-                <a16:creationId xmlns:a16="http://schemas.microsoft.com/office/drawing/2014/main" id="{5DF525C7-D957-4E87-B5E2-0CB63ED89245}"/>
+                <a16:creationId xmlns:a16="http://schemas.microsoft.com/office/drawing/2014/main" id="{9083A6B4-3470-4ED4-B032-C065ED707AB9}"/>
               </a:ext>
             </a:extLst>
           </p:cNvPr>
@@ -5859,7 +5859,7 @@
           <p:cNvPr id="27" name="">
             <a:extLst xmlns:a="http://schemas.openxmlformats.org/drawingml/2006/main">
               <a:ext uri="{FF2B5EF4-FFF2-40B4-BE49-F238E27FC236}">
-                <a16:creationId xmlns:a16="http://schemas.microsoft.com/office/drawing/2014/main" id="{F477756F-4734-4A96-B040-3961CDD6CBAD}"/>
+                <a16:creationId xmlns:a16="http://schemas.microsoft.com/office/drawing/2014/main" id="{68456291-BF68-434F-9EC0-6D5F3F196123}"/>
               </a:ext>
             </a:extLst>
           </p:cNvPr>
@@ -5909,7 +5909,7 @@
           <p:cNvPr id="28" name="">
             <a:extLst xmlns:a="http://schemas.openxmlformats.org/drawingml/2006/main">
               <a:ext uri="{FF2B5EF4-FFF2-40B4-BE49-F238E27FC236}">
-                <a16:creationId xmlns:a16="http://schemas.microsoft.com/office/drawing/2014/main" id="{B050CC48-FCF2-43A9-8821-449DAEE0F45A}"/>
+                <a16:creationId xmlns:a16="http://schemas.microsoft.com/office/drawing/2014/main" id="{98F65A14-6900-43F2-B12D-19125318709E}"/>
               </a:ext>
             </a:extLst>
           </p:cNvPr>
@@ -5959,7 +5959,7 @@
           <p:cNvPr id="29" name="">
             <a:extLst xmlns:a="http://schemas.openxmlformats.org/drawingml/2006/main">
               <a:ext uri="{FF2B5EF4-FFF2-40B4-BE49-F238E27FC236}">
-                <a16:creationId xmlns:a16="http://schemas.microsoft.com/office/drawing/2014/main" id="{0AAEF66A-C1F2-4A36-AD51-D59B17CB25FE}"/>
+                <a16:creationId xmlns:a16="http://schemas.microsoft.com/office/drawing/2014/main" id="{C4B8DEDE-09C9-44F8-8F5D-ABF4B62B87B7}"/>
               </a:ext>
             </a:extLst>
           </p:cNvPr>
@@ -5992,7 +5992,7 @@
           <p:cNvPr id="30" name="">
             <a:extLst xmlns:a="http://schemas.openxmlformats.org/drawingml/2006/main">
               <a:ext uri="{FF2B5EF4-FFF2-40B4-BE49-F238E27FC236}">
-                <a16:creationId xmlns:a16="http://schemas.microsoft.com/office/drawing/2014/main" id="{EAFDC7F5-F6EB-414E-98A6-81FB6C695151}"/>
+                <a16:creationId xmlns:a16="http://schemas.microsoft.com/office/drawing/2014/main" id="{0B7F9A80-E2E3-4538-8F3A-2452DADA7745}"/>
               </a:ext>
             </a:extLst>
           </p:cNvPr>
@@ -6042,7 +6042,7 @@
           <p:cNvPr id="31" name="">
             <a:extLst xmlns:a="http://schemas.openxmlformats.org/drawingml/2006/main">
               <a:ext uri="{FF2B5EF4-FFF2-40B4-BE49-F238E27FC236}">
-                <a16:creationId xmlns:a16="http://schemas.microsoft.com/office/drawing/2014/main" id="{6FF05BEE-2321-42C1-8150-749374628CC4}"/>
+                <a16:creationId xmlns:a16="http://schemas.microsoft.com/office/drawing/2014/main" id="{DC03A88E-8420-4761-9716-582126D71318}"/>
               </a:ext>
             </a:extLst>
           </p:cNvPr>
@@ -6090,7 +6090,7 @@
     </p:spTree>
     <p:extLst>
       <p:ext uri="{BB962C8B-B14F-4D97-AF65-F5344CB8AC3E}">
-        <p14:creationId xmlns:p14="http://schemas.microsoft.com/office/powerpoint/2010/main" val="1532343062"/>
+        <p14:creationId xmlns:p14="http://schemas.microsoft.com/office/powerpoint/2010/main" val="1248014869"/>
       </p:ext>
     </p:extLst>
   </p:cSld>
@@ -6121,7 +6121,7 @@
           <p:cNvPr id="1" name="">
             <a:extLst xmlns:a="http://schemas.openxmlformats.org/drawingml/2006/main">
               <a:ext uri="{FF2B5EF4-FFF2-40B4-BE49-F238E27FC236}">
-                <a16:creationId xmlns:a16="http://schemas.microsoft.com/office/drawing/2014/main" id="{BFAC9A0E-2682-426D-B560-A520DD5D2F74}"/>
+                <a16:creationId xmlns:a16="http://schemas.microsoft.com/office/drawing/2014/main" id="{C162980B-EBAF-4653-B9D7-D10CB90EB629}"/>
               </a:ext>
             </a:extLst>
           </p:cNvPr>
@@ -6156,7 +6156,7 @@
           <p:nvPr/>
         </p:nvPicPr>
         <p:blipFill>
-          <a:blip xmlns:r="http://schemas.openxmlformats.org/officeDocument/2006/relationships" xmlns:a="http://schemas.openxmlformats.org/drawingml/2006/main" r:embed="R9ff71eef40114adf"/>
+          <a:blip xmlns:r="http://schemas.openxmlformats.org/officeDocument/2006/relationships" xmlns:a="http://schemas.openxmlformats.org/drawingml/2006/main" r:embed="R8e94366b9a0242ca"/>
           <a:stretch xmlns:a="http://schemas.openxmlformats.org/drawingml/2006/main"/>
         </p:blipFill>
         <p:spPr>
@@ -6174,7 +6174,7 @@
           <p:cNvPr id="3" name="">
             <a:extLst xmlns:a="http://schemas.openxmlformats.org/drawingml/2006/main">
               <a:ext uri="{FF2B5EF4-FFF2-40B4-BE49-F238E27FC236}">
-                <a16:creationId xmlns:a16="http://schemas.microsoft.com/office/drawing/2014/main" id="{C7FDF7EC-D8ED-4286-B4EE-5CE34F82A9A1}"/>
+                <a16:creationId xmlns:a16="http://schemas.microsoft.com/office/drawing/2014/main" id="{1C18BBFF-7FC0-4BF1-8CCC-87E03ED85068}"/>
               </a:ext>
             </a:extLst>
           </p:cNvPr>
@@ -6224,7 +6224,7 @@
           <p:cNvPr id="4" name="">
             <a:extLst xmlns:a="http://schemas.openxmlformats.org/drawingml/2006/main">
               <a:ext uri="{FF2B5EF4-FFF2-40B4-BE49-F238E27FC236}">
-                <a16:creationId xmlns:a16="http://schemas.microsoft.com/office/drawing/2014/main" id="{6105637F-83BA-4247-A7E7-D4DAE8B54F3E}"/>
+                <a16:creationId xmlns:a16="http://schemas.microsoft.com/office/drawing/2014/main" id="{E5EB4426-9622-4F84-B14A-09CCD5647ED5}"/>
               </a:ext>
             </a:extLst>
           </p:cNvPr>
@@ -6257,7 +6257,7 @@
           <p:cNvPr id="5" name="">
             <a:extLst xmlns:a="http://schemas.openxmlformats.org/drawingml/2006/main">
               <a:ext uri="{FF2B5EF4-FFF2-40B4-BE49-F238E27FC236}">
-                <a16:creationId xmlns:a16="http://schemas.microsoft.com/office/drawing/2014/main" id="{D34B97AF-68CB-470C-B61D-49EC1576F548}"/>
+                <a16:creationId xmlns:a16="http://schemas.microsoft.com/office/drawing/2014/main" id="{6D84C630-D0EA-4AB8-97FC-C41E495CC446}"/>
               </a:ext>
             </a:extLst>
           </p:cNvPr>
@@ -6288,7 +6288,7 @@
           <p:cNvPr id="6" name="">
             <a:extLst xmlns:a="http://schemas.openxmlformats.org/drawingml/2006/main">
               <a:ext uri="{FF2B5EF4-FFF2-40B4-BE49-F238E27FC236}">
-                <a16:creationId xmlns:a16="http://schemas.microsoft.com/office/drawing/2014/main" id="{142352EA-DC8E-4250-86E7-BED2380D69D0}"/>
+                <a16:creationId xmlns:a16="http://schemas.microsoft.com/office/drawing/2014/main" id="{95FE119D-08D5-44C6-A618-E89BB74D9B1D}"/>
               </a:ext>
             </a:extLst>
           </p:cNvPr>
@@ -6338,7 +6338,7 @@
           <p:cNvPr id="7" name="">
             <a:extLst xmlns:a="http://schemas.openxmlformats.org/drawingml/2006/main">
               <a:ext uri="{FF2B5EF4-FFF2-40B4-BE49-F238E27FC236}">
-                <a16:creationId xmlns:a16="http://schemas.microsoft.com/office/drawing/2014/main" id="{A7B87033-C9C4-4B31-A2AD-C8D98C027F21}"/>
+                <a16:creationId xmlns:a16="http://schemas.microsoft.com/office/drawing/2014/main" id="{DD726EC6-E25A-47BD-9187-58976966EF0C}"/>
               </a:ext>
             </a:extLst>
           </p:cNvPr>
@@ -6388,7 +6388,7 @@
           <p:cNvPr id="8" name="">
             <a:extLst xmlns:a="http://schemas.openxmlformats.org/drawingml/2006/main">
               <a:ext uri="{FF2B5EF4-FFF2-40B4-BE49-F238E27FC236}">
-                <a16:creationId xmlns:a16="http://schemas.microsoft.com/office/drawing/2014/main" id="{2DD6D595-313C-4F67-8EDA-9DBB2C3E5142}"/>
+                <a16:creationId xmlns:a16="http://schemas.microsoft.com/office/drawing/2014/main" id="{E6E20E81-AD23-46CD-8411-62FEA7F5BF16}"/>
               </a:ext>
             </a:extLst>
           </p:cNvPr>
@@ -6421,7 +6421,7 @@
           <p:cNvPr id="9" name="">
             <a:extLst xmlns:a="http://schemas.openxmlformats.org/drawingml/2006/main">
               <a:ext uri="{FF2B5EF4-FFF2-40B4-BE49-F238E27FC236}">
-                <a16:creationId xmlns:a16="http://schemas.microsoft.com/office/drawing/2014/main" id="{C0A6383E-8684-4684-BBFE-0CF86CA3878D}"/>
+                <a16:creationId xmlns:a16="http://schemas.microsoft.com/office/drawing/2014/main" id="{A54A2BBC-088A-40CD-9052-1D30C8797EB3}"/>
               </a:ext>
             </a:extLst>
           </p:cNvPr>
@@ -6471,7 +6471,7 @@
           <p:cNvPr id="10" name="">
             <a:extLst xmlns:a="http://schemas.openxmlformats.org/drawingml/2006/main">
               <a:ext uri="{FF2B5EF4-FFF2-40B4-BE49-F238E27FC236}">
-                <a16:creationId xmlns:a16="http://schemas.microsoft.com/office/drawing/2014/main" id="{9003DD58-D29E-4403-A07F-6BA10CF98935}"/>
+                <a16:creationId xmlns:a16="http://schemas.microsoft.com/office/drawing/2014/main" id="{8F0EA229-1F86-4162-8C7F-7F7F49969155}"/>
               </a:ext>
             </a:extLst>
           </p:cNvPr>
@@ -6521,7 +6521,7 @@
           <p:cNvPr id="11" name="">
             <a:extLst xmlns:a="http://schemas.openxmlformats.org/drawingml/2006/main">
               <a:ext uri="{FF2B5EF4-FFF2-40B4-BE49-F238E27FC236}">
-                <a16:creationId xmlns:a16="http://schemas.microsoft.com/office/drawing/2014/main" id="{300048E2-C240-4CF7-94AD-54535BF22A55}"/>
+                <a16:creationId xmlns:a16="http://schemas.microsoft.com/office/drawing/2014/main" id="{BAB421CE-D08B-4192-964F-D5CC1C9E7C7D}"/>
               </a:ext>
             </a:extLst>
           </p:cNvPr>
@@ -6571,7 +6571,7 @@
           <p:cNvPr id="12" name="">
             <a:extLst xmlns:a="http://schemas.openxmlformats.org/drawingml/2006/main">
               <a:ext uri="{FF2B5EF4-FFF2-40B4-BE49-F238E27FC236}">
-                <a16:creationId xmlns:a16="http://schemas.microsoft.com/office/drawing/2014/main" id="{9BB8583F-E814-4E91-A0F3-03F521639520}"/>
+                <a16:creationId xmlns:a16="http://schemas.microsoft.com/office/drawing/2014/main" id="{EC457D01-8D59-4A6A-B4B8-9885D4032CD2}"/>
               </a:ext>
             </a:extLst>
           </p:cNvPr>
@@ -6621,7 +6621,7 @@
           <p:cNvPr id="13" name="">
             <a:extLst xmlns:a="http://schemas.openxmlformats.org/drawingml/2006/main">
               <a:ext uri="{FF2B5EF4-FFF2-40B4-BE49-F238E27FC236}">
-                <a16:creationId xmlns:a16="http://schemas.microsoft.com/office/drawing/2014/main" id="{0AA13C5D-3871-43D5-8292-240F857704C5}"/>
+                <a16:creationId xmlns:a16="http://schemas.microsoft.com/office/drawing/2014/main" id="{F4CE8147-421B-46EB-8990-555475A9F132}"/>
               </a:ext>
             </a:extLst>
           </p:cNvPr>
@@ -6671,7 +6671,7 @@
           <p:cNvPr id="14" name="">
             <a:extLst xmlns:a="http://schemas.openxmlformats.org/drawingml/2006/main">
               <a:ext uri="{FF2B5EF4-FFF2-40B4-BE49-F238E27FC236}">
-                <a16:creationId xmlns:a16="http://schemas.microsoft.com/office/drawing/2014/main" id="{44919460-861F-4DB9-A2B2-C5C51F7923E4}"/>
+                <a16:creationId xmlns:a16="http://schemas.microsoft.com/office/drawing/2014/main" id="{157109FF-9B98-40DE-BC32-BC6CC73D9930}"/>
               </a:ext>
             </a:extLst>
           </p:cNvPr>
@@ -6702,7 +6702,7 @@
           <p:cNvPr id="15" name="">
             <a:extLst xmlns:a="http://schemas.openxmlformats.org/drawingml/2006/main">
               <a:ext uri="{FF2B5EF4-FFF2-40B4-BE49-F238E27FC236}">
-                <a16:creationId xmlns:a16="http://schemas.microsoft.com/office/drawing/2014/main" id="{9F5DCB6B-E69F-48CC-9F97-D9A0292D2EC6}"/>
+                <a16:creationId xmlns:a16="http://schemas.microsoft.com/office/drawing/2014/main" id="{3454C0A0-D63F-4278-9C45-FC6FC1038F4B}"/>
               </a:ext>
             </a:extLst>
           </p:cNvPr>
@@ -6735,7 +6735,7 @@
           <p:cNvPr id="16" name="">
             <a:extLst xmlns:a="http://schemas.openxmlformats.org/drawingml/2006/main">
               <a:ext uri="{FF2B5EF4-FFF2-40B4-BE49-F238E27FC236}">
-                <a16:creationId xmlns:a16="http://schemas.microsoft.com/office/drawing/2014/main" id="{81E3BFCD-518C-4DEF-ADEE-CD7A07656098}"/>
+                <a16:creationId xmlns:a16="http://schemas.microsoft.com/office/drawing/2014/main" id="{D90167AC-A9D1-45F6-B369-4ABCB7FB4FF1}"/>
               </a:ext>
             </a:extLst>
           </p:cNvPr>
@@ -6785,7 +6785,7 @@
           <p:cNvPr id="17" name="">
             <a:extLst xmlns:a="http://schemas.openxmlformats.org/drawingml/2006/main">
               <a:ext uri="{FF2B5EF4-FFF2-40B4-BE49-F238E27FC236}">
-                <a16:creationId xmlns:a16="http://schemas.microsoft.com/office/drawing/2014/main" id="{F7C33FA8-7DF5-4735-8370-EA96A4E98B84}"/>
+                <a16:creationId xmlns:a16="http://schemas.microsoft.com/office/drawing/2014/main" id="{C24EE988-8240-427F-BBCF-FDFBFB463D6F}"/>
               </a:ext>
             </a:extLst>
           </p:cNvPr>
@@ -6835,7 +6835,7 @@
           <p:cNvPr id="18" name="">
             <a:extLst xmlns:a="http://schemas.openxmlformats.org/drawingml/2006/main">
               <a:ext uri="{FF2B5EF4-FFF2-40B4-BE49-F238E27FC236}">
-                <a16:creationId xmlns:a16="http://schemas.microsoft.com/office/drawing/2014/main" id="{5BF8EF3B-EAB6-4435-BB40-BF57A64AAA17}"/>
+                <a16:creationId xmlns:a16="http://schemas.microsoft.com/office/drawing/2014/main" id="{C73B0386-415F-49CA-AD33-9326177D89D4}"/>
               </a:ext>
             </a:extLst>
           </p:cNvPr>
@@ -6885,7 +6885,7 @@
           <p:cNvPr id="19" name="">
             <a:extLst xmlns:a="http://schemas.openxmlformats.org/drawingml/2006/main">
               <a:ext uri="{FF2B5EF4-FFF2-40B4-BE49-F238E27FC236}">
-                <a16:creationId xmlns:a16="http://schemas.microsoft.com/office/drawing/2014/main" id="{F87C1598-7F03-45F7-81A9-8112976F0396}"/>
+                <a16:creationId xmlns:a16="http://schemas.microsoft.com/office/drawing/2014/main" id="{DBDEBE1B-3359-425F-AC3A-F5E51E8EC27E}"/>
               </a:ext>
             </a:extLst>
           </p:cNvPr>
@@ -6935,7 +6935,7 @@
           <p:cNvPr id="20" name="">
             <a:extLst xmlns:a="http://schemas.openxmlformats.org/drawingml/2006/main">
               <a:ext uri="{FF2B5EF4-FFF2-40B4-BE49-F238E27FC236}">
-                <a16:creationId xmlns:a16="http://schemas.microsoft.com/office/drawing/2014/main" id="{F5518C4B-3741-4694-A201-AF5D7FC84852}"/>
+                <a16:creationId xmlns:a16="http://schemas.microsoft.com/office/drawing/2014/main" id="{A4CE21BD-E29E-4E9C-B006-750E332BF66F}"/>
               </a:ext>
             </a:extLst>
           </p:cNvPr>
@@ -6985,7 +6985,7 @@
           <p:cNvPr id="21" name="">
             <a:extLst xmlns:a="http://schemas.openxmlformats.org/drawingml/2006/main">
               <a:ext uri="{FF2B5EF4-FFF2-40B4-BE49-F238E27FC236}">
-                <a16:creationId xmlns:a16="http://schemas.microsoft.com/office/drawing/2014/main" id="{2C722705-AB80-49F0-A2A2-2899901E185C}"/>
+                <a16:creationId xmlns:a16="http://schemas.microsoft.com/office/drawing/2014/main" id="{20BFD0C5-1469-496A-B6B7-5F0184BEA2A8}"/>
               </a:ext>
             </a:extLst>
           </p:cNvPr>
@@ -7016,7 +7016,7 @@
           <p:cNvPr id="22" name="">
             <a:extLst xmlns:a="http://schemas.openxmlformats.org/drawingml/2006/main">
               <a:ext uri="{FF2B5EF4-FFF2-40B4-BE49-F238E27FC236}">
-                <a16:creationId xmlns:a16="http://schemas.microsoft.com/office/drawing/2014/main" id="{6F14C373-7D1A-4324-8636-51402C9F7259}"/>
+                <a16:creationId xmlns:a16="http://schemas.microsoft.com/office/drawing/2014/main" id="{8CE0B9BB-CB0E-44C7-A5BA-F34179445499}"/>
               </a:ext>
             </a:extLst>
           </p:cNvPr>
@@ -7049,7 +7049,7 @@
           <p:cNvPr id="23" name="">
             <a:extLst xmlns:a="http://schemas.openxmlformats.org/drawingml/2006/main">
               <a:ext uri="{FF2B5EF4-FFF2-40B4-BE49-F238E27FC236}">
-                <a16:creationId xmlns:a16="http://schemas.microsoft.com/office/drawing/2014/main" id="{2D9195EF-BBDF-45E4-A563-67321F56C64C}"/>
+                <a16:creationId xmlns:a16="http://schemas.microsoft.com/office/drawing/2014/main" id="{161E7F11-3A6B-4C7F-929D-19E6FB453739}"/>
               </a:ext>
             </a:extLst>
           </p:cNvPr>
@@ -7099,7 +7099,7 @@
           <p:cNvPr id="24" name="">
             <a:extLst xmlns:a="http://schemas.openxmlformats.org/drawingml/2006/main">
               <a:ext uri="{FF2B5EF4-FFF2-40B4-BE49-F238E27FC236}">
-                <a16:creationId xmlns:a16="http://schemas.microsoft.com/office/drawing/2014/main" id="{CB350DAD-D5A4-4C2C-9896-63B8773A688B}"/>
+                <a16:creationId xmlns:a16="http://schemas.microsoft.com/office/drawing/2014/main" id="{F78DEA02-F3AD-4768-8C03-665247B2052B}"/>
               </a:ext>
             </a:extLst>
           </p:cNvPr>
@@ -7149,7 +7149,7 @@
           <p:cNvPr id="25" name="">
             <a:extLst xmlns:a="http://schemas.openxmlformats.org/drawingml/2006/main">
               <a:ext uri="{FF2B5EF4-FFF2-40B4-BE49-F238E27FC236}">
-                <a16:creationId xmlns:a16="http://schemas.microsoft.com/office/drawing/2014/main" id="{6B008DBE-CBC9-45FE-A2D3-BDA450624006}"/>
+                <a16:creationId xmlns:a16="http://schemas.microsoft.com/office/drawing/2014/main" id="{00A85718-726C-413A-B0C5-311C591DE0D2}"/>
               </a:ext>
             </a:extLst>
           </p:cNvPr>
@@ -7199,7 +7199,7 @@
           <p:cNvPr id="26" name="">
             <a:extLst xmlns:a="http://schemas.openxmlformats.org/drawingml/2006/main">
               <a:ext uri="{FF2B5EF4-FFF2-40B4-BE49-F238E27FC236}">
-                <a16:creationId xmlns:a16="http://schemas.microsoft.com/office/drawing/2014/main" id="{ADEE6DD2-85AC-4A4C-BA91-CE00022F03E7}"/>
+                <a16:creationId xmlns:a16="http://schemas.microsoft.com/office/drawing/2014/main" id="{6BB3A2F2-796B-42CB-9B56-2B9B72F62A92}"/>
               </a:ext>
             </a:extLst>
           </p:cNvPr>
@@ -7249,7 +7249,7 @@
           <p:cNvPr id="27" name="">
             <a:extLst xmlns:a="http://schemas.openxmlformats.org/drawingml/2006/main">
               <a:ext uri="{FF2B5EF4-FFF2-40B4-BE49-F238E27FC236}">
-                <a16:creationId xmlns:a16="http://schemas.microsoft.com/office/drawing/2014/main" id="{22D56DA4-2934-43E1-B073-E937C09B4A25}"/>
+                <a16:creationId xmlns:a16="http://schemas.microsoft.com/office/drawing/2014/main" id="{D705CB99-70E0-4EFC-ADF0-94A2ADE8CC09}"/>
               </a:ext>
             </a:extLst>
           </p:cNvPr>
@@ -7299,7 +7299,7 @@
           <p:cNvPr id="28" name="">
             <a:extLst xmlns:a="http://schemas.openxmlformats.org/drawingml/2006/main">
               <a:ext uri="{FF2B5EF4-FFF2-40B4-BE49-F238E27FC236}">
-                <a16:creationId xmlns:a16="http://schemas.microsoft.com/office/drawing/2014/main" id="{66BFDBB5-85B5-4121-AB22-0FC49D929B78}"/>
+                <a16:creationId xmlns:a16="http://schemas.microsoft.com/office/drawing/2014/main" id="{ED281430-0C99-4637-A2A8-BBB3A42A7DDC}"/>
               </a:ext>
             </a:extLst>
           </p:cNvPr>
@@ -7330,7 +7330,7 @@
           <p:cNvPr id="29" name="">
             <a:extLst xmlns:a="http://schemas.openxmlformats.org/drawingml/2006/main">
               <a:ext uri="{FF2B5EF4-FFF2-40B4-BE49-F238E27FC236}">
-                <a16:creationId xmlns:a16="http://schemas.microsoft.com/office/drawing/2014/main" id="{DC078230-6AFA-494D-A549-042EB9BF4DDD}"/>
+                <a16:creationId xmlns:a16="http://schemas.microsoft.com/office/drawing/2014/main" id="{57E5DD79-9BA1-42C0-8C49-288F62803988}"/>
               </a:ext>
             </a:extLst>
           </p:cNvPr>
@@ -7363,7 +7363,7 @@
           <p:cNvPr id="30" name="">
             <a:extLst xmlns:a="http://schemas.openxmlformats.org/drawingml/2006/main">
               <a:ext uri="{FF2B5EF4-FFF2-40B4-BE49-F238E27FC236}">
-                <a16:creationId xmlns:a16="http://schemas.microsoft.com/office/drawing/2014/main" id="{8B4AF1A3-BF64-45F5-8222-C4F49243D4AA}"/>
+                <a16:creationId xmlns:a16="http://schemas.microsoft.com/office/drawing/2014/main" id="{D59C70DA-A6A3-4926-87B7-3675496D7048}"/>
               </a:ext>
             </a:extLst>
           </p:cNvPr>
@@ -7413,7 +7413,7 @@
           <p:cNvPr id="31" name="">
             <a:extLst xmlns:a="http://schemas.openxmlformats.org/drawingml/2006/main">
               <a:ext uri="{FF2B5EF4-FFF2-40B4-BE49-F238E27FC236}">
-                <a16:creationId xmlns:a16="http://schemas.microsoft.com/office/drawing/2014/main" id="{2BE8AF71-2981-4771-95CF-42B5FBD489CC}"/>
+                <a16:creationId xmlns:a16="http://schemas.microsoft.com/office/drawing/2014/main" id="{6447E14E-C317-4600-9762-DB809A08F9F1}"/>
               </a:ext>
             </a:extLst>
           </p:cNvPr>
@@ -7463,7 +7463,7 @@
           <p:cNvPr id="32" name="">
             <a:extLst xmlns:a="http://schemas.openxmlformats.org/drawingml/2006/main">
               <a:ext uri="{FF2B5EF4-FFF2-40B4-BE49-F238E27FC236}">
-                <a16:creationId xmlns:a16="http://schemas.microsoft.com/office/drawing/2014/main" id="{AFCCB569-C7EE-473D-A117-59712923D163}"/>
+                <a16:creationId xmlns:a16="http://schemas.microsoft.com/office/drawing/2014/main" id="{5DD63B95-EBB7-482A-8E02-D92B674EC88D}"/>
               </a:ext>
             </a:extLst>
           </p:cNvPr>
@@ -7513,7 +7513,7 @@
           <p:cNvPr id="33" name="">
             <a:extLst xmlns:a="http://schemas.openxmlformats.org/drawingml/2006/main">
               <a:ext uri="{FF2B5EF4-FFF2-40B4-BE49-F238E27FC236}">
-                <a16:creationId xmlns:a16="http://schemas.microsoft.com/office/drawing/2014/main" id="{CFB2BEE3-50BD-4F1C-A0E0-AA06AE461A59}"/>
+                <a16:creationId xmlns:a16="http://schemas.microsoft.com/office/drawing/2014/main" id="{A71BA078-B292-4428-853B-DA54E8FD1E6E}"/>
               </a:ext>
             </a:extLst>
           </p:cNvPr>
@@ -7563,7 +7563,7 @@
           <p:cNvPr id="34" name="">
             <a:extLst xmlns:a="http://schemas.openxmlformats.org/drawingml/2006/main">
               <a:ext uri="{FF2B5EF4-FFF2-40B4-BE49-F238E27FC236}">
-                <a16:creationId xmlns:a16="http://schemas.microsoft.com/office/drawing/2014/main" id="{D1859288-F2A6-45D1-9288-B53BA4827E63}"/>
+                <a16:creationId xmlns:a16="http://schemas.microsoft.com/office/drawing/2014/main" id="{FE76687A-0A0E-4C82-B1A5-1BBBF1BBAFC9}"/>
               </a:ext>
             </a:extLst>
           </p:cNvPr>
@@ -7611,7 +7611,7 @@
     </p:spTree>
     <p:extLst>
       <p:ext uri="{BB962C8B-B14F-4D97-AF65-F5344CB8AC3E}">
-        <p14:creationId xmlns:p14="http://schemas.microsoft.com/office/powerpoint/2010/main" val="1781785763"/>
+        <p14:creationId xmlns:p14="http://schemas.microsoft.com/office/powerpoint/2010/main" val="760516806"/>
       </p:ext>
     </p:extLst>
   </p:cSld>
@@ -7642,7 +7642,7 @@
           <p:cNvPr id="1" name="">
             <a:extLst xmlns:a="http://schemas.openxmlformats.org/drawingml/2006/main">
               <a:ext uri="{FF2B5EF4-FFF2-40B4-BE49-F238E27FC236}">
-                <a16:creationId xmlns:a16="http://schemas.microsoft.com/office/drawing/2014/main" id="{612807D8-546F-4D65-AB08-655F15213C58}"/>
+                <a16:creationId xmlns:a16="http://schemas.microsoft.com/office/drawing/2014/main" id="{EACD4B50-0031-4029-9103-520F5DDA4EBA}"/>
               </a:ext>
             </a:extLst>
           </p:cNvPr>
@@ -7677,7 +7677,7 @@
           <p:nvPr/>
         </p:nvPicPr>
         <p:blipFill>
-          <a:blip xmlns:r="http://schemas.openxmlformats.org/officeDocument/2006/relationships" xmlns:a="http://schemas.openxmlformats.org/drawingml/2006/main" r:embed="R814df443ed7a43c0"/>
+          <a:blip xmlns:r="http://schemas.openxmlformats.org/officeDocument/2006/relationships" xmlns:a="http://schemas.openxmlformats.org/drawingml/2006/main" r:embed="Rf91210db05ee4f02"/>
           <a:stretch xmlns:a="http://schemas.openxmlformats.org/drawingml/2006/main"/>
         </p:blipFill>
         <p:spPr>
@@ -7695,7 +7695,7 @@
           <p:cNvPr id="3" name="">
             <a:extLst xmlns:a="http://schemas.openxmlformats.org/drawingml/2006/main">
               <a:ext uri="{FF2B5EF4-FFF2-40B4-BE49-F238E27FC236}">
-                <a16:creationId xmlns:a16="http://schemas.microsoft.com/office/drawing/2014/main" id="{C585F69D-B4BE-4265-B618-DB0DD524759C}"/>
+                <a16:creationId xmlns:a16="http://schemas.microsoft.com/office/drawing/2014/main" id="{074FBBF3-0D73-4A4C-9B81-6120EC8E7FAB}"/>
               </a:ext>
             </a:extLst>
           </p:cNvPr>
@@ -7745,7 +7745,7 @@
           <p:cNvPr id="4" name="">
             <a:extLst xmlns:a="http://schemas.openxmlformats.org/drawingml/2006/main">
               <a:ext uri="{FF2B5EF4-FFF2-40B4-BE49-F238E27FC236}">
-                <a16:creationId xmlns:a16="http://schemas.microsoft.com/office/drawing/2014/main" id="{3120442A-E2C6-4DD3-9FD4-D44DE706445C}"/>
+                <a16:creationId xmlns:a16="http://schemas.microsoft.com/office/drawing/2014/main" id="{2564B4FC-2319-448B-9879-007C265B83E5}"/>
               </a:ext>
             </a:extLst>
           </p:cNvPr>
@@ -7778,7 +7778,7 @@
           <p:cNvPr id="5" name="">
             <a:extLst xmlns:a="http://schemas.openxmlformats.org/drawingml/2006/main">
               <a:ext uri="{FF2B5EF4-FFF2-40B4-BE49-F238E27FC236}">
-                <a16:creationId xmlns:a16="http://schemas.microsoft.com/office/drawing/2014/main" id="{62E4C730-83A3-41B3-A84E-C17C60C210DA}"/>
+                <a16:creationId xmlns:a16="http://schemas.microsoft.com/office/drawing/2014/main" id="{6970F37E-46E1-408B-99F0-D8462B224008}"/>
               </a:ext>
             </a:extLst>
           </p:cNvPr>
@@ -7809,7 +7809,7 @@
           <p:cNvPr id="6" name="">
             <a:extLst xmlns:a="http://schemas.openxmlformats.org/drawingml/2006/main">
               <a:ext uri="{FF2B5EF4-FFF2-40B4-BE49-F238E27FC236}">
-                <a16:creationId xmlns:a16="http://schemas.microsoft.com/office/drawing/2014/main" id="{B9BC8E47-4832-4893-A9B5-D88A2FC024AE}"/>
+                <a16:creationId xmlns:a16="http://schemas.microsoft.com/office/drawing/2014/main" id="{6AC3FCF6-550D-4EB8-B586-4E77B85F17E1}"/>
               </a:ext>
             </a:extLst>
           </p:cNvPr>
@@ -7859,7 +7859,7 @@
           <p:cNvPr id="7" name="">
             <a:extLst xmlns:a="http://schemas.openxmlformats.org/drawingml/2006/main">
               <a:ext uri="{FF2B5EF4-FFF2-40B4-BE49-F238E27FC236}">
-                <a16:creationId xmlns:a16="http://schemas.microsoft.com/office/drawing/2014/main" id="{D6FF3005-E3D0-44E1-AF9B-3E76A046F181}"/>
+                <a16:creationId xmlns:a16="http://schemas.microsoft.com/office/drawing/2014/main" id="{3BFAB9F2-5EAC-4117-BA30-8A50FE3269DB}"/>
               </a:ext>
             </a:extLst>
           </p:cNvPr>
@@ -7909,7 +7909,7 @@
           <p:cNvPr id="8" name="">
             <a:extLst xmlns:a="http://schemas.openxmlformats.org/drawingml/2006/main">
               <a:ext uri="{FF2B5EF4-FFF2-40B4-BE49-F238E27FC236}">
-                <a16:creationId xmlns:a16="http://schemas.microsoft.com/office/drawing/2014/main" id="{E0F50E79-0672-4110-B64A-590F78219565}"/>
+                <a16:creationId xmlns:a16="http://schemas.microsoft.com/office/drawing/2014/main" id="{949E4DE0-44A1-4083-A9B6-B34F69162BEA}"/>
               </a:ext>
             </a:extLst>
           </p:cNvPr>
@@ -7944,7 +7944,7 @@
           <p:cNvPr id="9" name="">
             <a:extLst xmlns:a="http://schemas.openxmlformats.org/drawingml/2006/main">
               <a:ext uri="{FF2B5EF4-FFF2-40B4-BE49-F238E27FC236}">
-                <a16:creationId xmlns:a16="http://schemas.microsoft.com/office/drawing/2014/main" id="{6306B3B1-B374-46D5-8DF6-36432F170DDF}"/>
+                <a16:creationId xmlns:a16="http://schemas.microsoft.com/office/drawing/2014/main" id="{0CBF31BA-3AA1-4E5E-A423-69CF556352A8}"/>
               </a:ext>
             </a:extLst>
           </p:cNvPr>
@@ -7994,7 +7994,7 @@
           <p:cNvPr id="10" name="">
             <a:extLst xmlns:a="http://schemas.openxmlformats.org/drawingml/2006/main">
               <a:ext uri="{FF2B5EF4-FFF2-40B4-BE49-F238E27FC236}">
-                <a16:creationId xmlns:a16="http://schemas.microsoft.com/office/drawing/2014/main" id="{FBA64B0F-966D-48A9-BAC6-375B38E829E7}"/>
+                <a16:creationId xmlns:a16="http://schemas.microsoft.com/office/drawing/2014/main" id="{09378161-F34D-4E49-B306-7AA46645C00B}"/>
               </a:ext>
             </a:extLst>
           </p:cNvPr>
@@ -8044,7 +8044,7 @@
           <p:cNvPr id="11" name="">
             <a:extLst xmlns:a="http://schemas.openxmlformats.org/drawingml/2006/main">
               <a:ext uri="{FF2B5EF4-FFF2-40B4-BE49-F238E27FC236}">
-                <a16:creationId xmlns:a16="http://schemas.microsoft.com/office/drawing/2014/main" id="{D5215E32-5BEC-4A1F-A8DB-13DC5E298378}"/>
+                <a16:creationId xmlns:a16="http://schemas.microsoft.com/office/drawing/2014/main" id="{CFF97530-357E-42B4-845E-C3B5287BA8F9}"/>
               </a:ext>
             </a:extLst>
           </p:cNvPr>
@@ -8094,7 +8094,7 @@
           <p:cNvPr id="12" name="">
             <a:extLst xmlns:a="http://schemas.openxmlformats.org/drawingml/2006/main">
               <a:ext uri="{FF2B5EF4-FFF2-40B4-BE49-F238E27FC236}">
-                <a16:creationId xmlns:a16="http://schemas.microsoft.com/office/drawing/2014/main" id="{24A615D5-3282-431C-B76B-30812A1DCDE7}"/>
+                <a16:creationId xmlns:a16="http://schemas.microsoft.com/office/drawing/2014/main" id="{4840DF49-AD89-43C8-9938-DDF243D27E35}"/>
               </a:ext>
             </a:extLst>
           </p:cNvPr>
@@ -8125,7 +8125,7 @@
           <p:cNvPr id="13" name="">
             <a:extLst xmlns:a="http://schemas.openxmlformats.org/drawingml/2006/main">
               <a:ext uri="{FF2B5EF4-FFF2-40B4-BE49-F238E27FC236}">
-                <a16:creationId xmlns:a16="http://schemas.microsoft.com/office/drawing/2014/main" id="{A3565492-A95D-4BA1-ADF0-EBEA45E85674}"/>
+                <a16:creationId xmlns:a16="http://schemas.microsoft.com/office/drawing/2014/main" id="{F012933B-E821-4D7B-81E8-018620347C2B}"/>
               </a:ext>
             </a:extLst>
           </p:cNvPr>
@@ -8175,7 +8175,7 @@
           <p:cNvPr id="14" name="">
             <a:extLst xmlns:a="http://schemas.openxmlformats.org/drawingml/2006/main">
               <a:ext uri="{FF2B5EF4-FFF2-40B4-BE49-F238E27FC236}">
-                <a16:creationId xmlns:a16="http://schemas.microsoft.com/office/drawing/2014/main" id="{AD8A958C-1E2E-443F-A5C7-E650707D2ABA}"/>
+                <a16:creationId xmlns:a16="http://schemas.microsoft.com/office/drawing/2014/main" id="{42AAF263-7518-47A7-B0F9-DEDFD584A38B}"/>
               </a:ext>
             </a:extLst>
           </p:cNvPr>
@@ -8225,7 +8225,7 @@
           <p:cNvPr id="15" name="">
             <a:extLst xmlns:a="http://schemas.openxmlformats.org/drawingml/2006/main">
               <a:ext uri="{FF2B5EF4-FFF2-40B4-BE49-F238E27FC236}">
-                <a16:creationId xmlns:a16="http://schemas.microsoft.com/office/drawing/2014/main" id="{39228D5F-B728-478C-B879-464E7F2818EC}"/>
+                <a16:creationId xmlns:a16="http://schemas.microsoft.com/office/drawing/2014/main" id="{06B8833E-9A52-4B99-B554-C35D21B442DA}"/>
               </a:ext>
             </a:extLst>
           </p:cNvPr>
@@ -8275,7 +8275,7 @@
           <p:cNvPr id="16" name="">
             <a:extLst xmlns:a="http://schemas.openxmlformats.org/drawingml/2006/main">
               <a:ext uri="{FF2B5EF4-FFF2-40B4-BE49-F238E27FC236}">
-                <a16:creationId xmlns:a16="http://schemas.microsoft.com/office/drawing/2014/main" id="{243A1FA2-95B4-415D-9EB3-E5C6EFE8559D}"/>
+                <a16:creationId xmlns:a16="http://schemas.microsoft.com/office/drawing/2014/main" id="{7707536A-012C-4BB5-8BF4-722985FA8F12}"/>
               </a:ext>
             </a:extLst>
           </p:cNvPr>
@@ -8325,7 +8325,7 @@
           <p:cNvPr id="17" name="">
             <a:extLst xmlns:a="http://schemas.openxmlformats.org/drawingml/2006/main">
               <a:ext uri="{FF2B5EF4-FFF2-40B4-BE49-F238E27FC236}">
-                <a16:creationId xmlns:a16="http://schemas.microsoft.com/office/drawing/2014/main" id="{50040F34-9BA9-4195-A844-1543FA5EA1A8}"/>
+                <a16:creationId xmlns:a16="http://schemas.microsoft.com/office/drawing/2014/main" id="{B4FFA2CC-9D59-4A28-A7AF-AF6D40EBC6C5}"/>
               </a:ext>
             </a:extLst>
           </p:cNvPr>
@@ -8360,7 +8360,7 @@
           <p:cNvPr id="18" name="">
             <a:extLst xmlns:a="http://schemas.openxmlformats.org/drawingml/2006/main">
               <a:ext uri="{FF2B5EF4-FFF2-40B4-BE49-F238E27FC236}">
-                <a16:creationId xmlns:a16="http://schemas.microsoft.com/office/drawing/2014/main" id="{4472998A-0729-40E5-95DC-5F54688CB852}"/>
+                <a16:creationId xmlns:a16="http://schemas.microsoft.com/office/drawing/2014/main" id="{27A66984-0401-4DA1-8033-D0A386F2D720}"/>
               </a:ext>
             </a:extLst>
           </p:cNvPr>
@@ -8410,7 +8410,7 @@
           <p:cNvPr id="19" name="">
             <a:extLst xmlns:a="http://schemas.openxmlformats.org/drawingml/2006/main">
               <a:ext uri="{FF2B5EF4-FFF2-40B4-BE49-F238E27FC236}">
-                <a16:creationId xmlns:a16="http://schemas.microsoft.com/office/drawing/2014/main" id="{C9EAB7FF-AC5D-4236-A5C0-0CCD8BD1BC4E}"/>
+                <a16:creationId xmlns:a16="http://schemas.microsoft.com/office/drawing/2014/main" id="{AD1E1489-E24B-47E4-AA26-257AC7591F85}"/>
               </a:ext>
             </a:extLst>
           </p:cNvPr>
@@ -8460,7 +8460,7 @@
           <p:cNvPr id="20" name="">
             <a:extLst xmlns:a="http://schemas.openxmlformats.org/drawingml/2006/main">
               <a:ext uri="{FF2B5EF4-FFF2-40B4-BE49-F238E27FC236}">
-                <a16:creationId xmlns:a16="http://schemas.microsoft.com/office/drawing/2014/main" id="{A0916907-C5DD-471D-8AFC-BE0AEB173FC8}"/>
+                <a16:creationId xmlns:a16="http://schemas.microsoft.com/office/drawing/2014/main" id="{80F0013C-C7B7-4353-AA3B-3724BF426C3E}"/>
               </a:ext>
             </a:extLst>
           </p:cNvPr>
@@ -8510,7 +8510,7 @@
           <p:cNvPr id="21" name="">
             <a:extLst xmlns:a="http://schemas.openxmlformats.org/drawingml/2006/main">
               <a:ext uri="{FF2B5EF4-FFF2-40B4-BE49-F238E27FC236}">
-                <a16:creationId xmlns:a16="http://schemas.microsoft.com/office/drawing/2014/main" id="{BE55749F-AF9E-4604-9C78-A875A3B88B50}"/>
+                <a16:creationId xmlns:a16="http://schemas.microsoft.com/office/drawing/2014/main" id="{06BB671B-5BCC-4FC9-8B39-45D95464A4FC}"/>
               </a:ext>
             </a:extLst>
           </p:cNvPr>
@@ -8541,7 +8541,7 @@
           <p:cNvPr id="22" name="">
             <a:extLst xmlns:a="http://schemas.openxmlformats.org/drawingml/2006/main">
               <a:ext uri="{FF2B5EF4-FFF2-40B4-BE49-F238E27FC236}">
-                <a16:creationId xmlns:a16="http://schemas.microsoft.com/office/drawing/2014/main" id="{EDF30C8E-78A6-4CD7-8DA4-7445D0E7D066}"/>
+                <a16:creationId xmlns:a16="http://schemas.microsoft.com/office/drawing/2014/main" id="{61CABCB2-DB86-47EF-AD14-28DA22D1BD73}"/>
               </a:ext>
             </a:extLst>
           </p:cNvPr>
@@ -8591,7 +8591,7 @@
           <p:cNvPr id="23" name="">
             <a:extLst xmlns:a="http://schemas.openxmlformats.org/drawingml/2006/main">
               <a:ext uri="{FF2B5EF4-FFF2-40B4-BE49-F238E27FC236}">
-                <a16:creationId xmlns:a16="http://schemas.microsoft.com/office/drawing/2014/main" id="{8955096B-B4DF-4D1F-965B-6AA67312EBCF}"/>
+                <a16:creationId xmlns:a16="http://schemas.microsoft.com/office/drawing/2014/main" id="{A8B6288F-90FC-42BD-9988-F33092C8105D}"/>
               </a:ext>
             </a:extLst>
           </p:cNvPr>
@@ -8641,7 +8641,7 @@
           <p:cNvPr id="24" name="">
             <a:extLst xmlns:a="http://schemas.openxmlformats.org/drawingml/2006/main">
               <a:ext uri="{FF2B5EF4-FFF2-40B4-BE49-F238E27FC236}">
-                <a16:creationId xmlns:a16="http://schemas.microsoft.com/office/drawing/2014/main" id="{2AB341EA-452C-4162-BBDE-E29F727FB680}"/>
+                <a16:creationId xmlns:a16="http://schemas.microsoft.com/office/drawing/2014/main" id="{14FA4F1D-E11A-475C-9697-73EC049800B6}"/>
               </a:ext>
             </a:extLst>
           </p:cNvPr>
@@ -8691,7 +8691,7 @@
           <p:cNvPr id="25" name="">
             <a:extLst xmlns:a="http://schemas.openxmlformats.org/drawingml/2006/main">
               <a:ext uri="{FF2B5EF4-FFF2-40B4-BE49-F238E27FC236}">
-                <a16:creationId xmlns:a16="http://schemas.microsoft.com/office/drawing/2014/main" id="{7A1866DF-E07D-4BF4-B028-C407FAC4DE26}"/>
+                <a16:creationId xmlns:a16="http://schemas.microsoft.com/office/drawing/2014/main" id="{47968AC9-93DD-4E25-8623-A239EF2C731E}"/>
               </a:ext>
             </a:extLst>
           </p:cNvPr>
@@ -8741,7 +8741,7 @@
           <p:cNvPr id="26" name="">
             <a:extLst xmlns:a="http://schemas.openxmlformats.org/drawingml/2006/main">
               <a:ext uri="{FF2B5EF4-FFF2-40B4-BE49-F238E27FC236}">
-                <a16:creationId xmlns:a16="http://schemas.microsoft.com/office/drawing/2014/main" id="{A5BC29A1-FCF5-4C1A-93B4-C2CCA7899442}"/>
+                <a16:creationId xmlns:a16="http://schemas.microsoft.com/office/drawing/2014/main" id="{7B13CBAB-36F2-434A-A99B-70F583FBA7DC}"/>
               </a:ext>
             </a:extLst>
           </p:cNvPr>
@@ -8776,7 +8776,7 @@
           <p:cNvPr id="27" name="">
             <a:extLst xmlns:a="http://schemas.openxmlformats.org/drawingml/2006/main">
               <a:ext uri="{FF2B5EF4-FFF2-40B4-BE49-F238E27FC236}">
-                <a16:creationId xmlns:a16="http://schemas.microsoft.com/office/drawing/2014/main" id="{264C2768-A7BF-48B1-ACAC-61BAE2029330}"/>
+                <a16:creationId xmlns:a16="http://schemas.microsoft.com/office/drawing/2014/main" id="{C9D101E8-19E2-48A5-8EF8-73B11735EE7B}"/>
               </a:ext>
             </a:extLst>
           </p:cNvPr>
@@ -8826,7 +8826,7 @@
           <p:cNvPr id="28" name="">
             <a:extLst xmlns:a="http://schemas.openxmlformats.org/drawingml/2006/main">
               <a:ext uri="{FF2B5EF4-FFF2-40B4-BE49-F238E27FC236}">
-                <a16:creationId xmlns:a16="http://schemas.microsoft.com/office/drawing/2014/main" id="{31C196B5-1CE6-45BD-99F3-0C516A480D41}"/>
+                <a16:creationId xmlns:a16="http://schemas.microsoft.com/office/drawing/2014/main" id="{BB46E4CB-6707-4654-9344-939BE81C8880}"/>
               </a:ext>
             </a:extLst>
           </p:cNvPr>
@@ -8876,7 +8876,7 @@
           <p:cNvPr id="29" name="">
             <a:extLst xmlns:a="http://schemas.openxmlformats.org/drawingml/2006/main">
               <a:ext uri="{FF2B5EF4-FFF2-40B4-BE49-F238E27FC236}">
-                <a16:creationId xmlns:a16="http://schemas.microsoft.com/office/drawing/2014/main" id="{AAAEE73A-D7B8-4511-8EDD-8763D91D9BFC}"/>
+                <a16:creationId xmlns:a16="http://schemas.microsoft.com/office/drawing/2014/main" id="{4428D944-5E03-4DA4-AA68-A23A530B6BC8}"/>
               </a:ext>
             </a:extLst>
           </p:cNvPr>
@@ -8926,7 +8926,7 @@
           <p:cNvPr id="30" name="">
             <a:extLst xmlns:a="http://schemas.openxmlformats.org/drawingml/2006/main">
               <a:ext uri="{FF2B5EF4-FFF2-40B4-BE49-F238E27FC236}">
-                <a16:creationId xmlns:a16="http://schemas.microsoft.com/office/drawing/2014/main" id="{7B98D8CF-D013-4E53-A09E-21A8DDC4DED5}"/>
+                <a16:creationId xmlns:a16="http://schemas.microsoft.com/office/drawing/2014/main" id="{8E8AD9F8-A088-46E0-93BB-A82D8E8E7EDA}"/>
               </a:ext>
             </a:extLst>
           </p:cNvPr>
@@ -8957,7 +8957,7 @@
           <p:cNvPr id="31" name="">
             <a:extLst xmlns:a="http://schemas.openxmlformats.org/drawingml/2006/main">
               <a:ext uri="{FF2B5EF4-FFF2-40B4-BE49-F238E27FC236}">
-                <a16:creationId xmlns:a16="http://schemas.microsoft.com/office/drawing/2014/main" id="{1D016B18-9199-4485-98FA-D113DF84D911}"/>
+                <a16:creationId xmlns:a16="http://schemas.microsoft.com/office/drawing/2014/main" id="{7BDFE9C5-55DA-42BC-BE3C-54D5EE0FA81D}"/>
               </a:ext>
             </a:extLst>
           </p:cNvPr>
@@ -9007,7 +9007,7 @@
           <p:cNvPr id="32" name="">
             <a:extLst xmlns:a="http://schemas.openxmlformats.org/drawingml/2006/main">
               <a:ext uri="{FF2B5EF4-FFF2-40B4-BE49-F238E27FC236}">
-                <a16:creationId xmlns:a16="http://schemas.microsoft.com/office/drawing/2014/main" id="{919E01A9-B3CB-43CB-991A-EB8B5E5ECC27}"/>
+                <a16:creationId xmlns:a16="http://schemas.microsoft.com/office/drawing/2014/main" id="{3481E88B-FD2F-4CCC-B281-7BC22BF16313}"/>
               </a:ext>
             </a:extLst>
           </p:cNvPr>
@@ -9057,7 +9057,7 @@
           <p:cNvPr id="33" name="">
             <a:extLst xmlns:a="http://schemas.openxmlformats.org/drawingml/2006/main">
               <a:ext uri="{FF2B5EF4-FFF2-40B4-BE49-F238E27FC236}">
-                <a16:creationId xmlns:a16="http://schemas.microsoft.com/office/drawing/2014/main" id="{35FB5425-945B-4EB2-B0CD-D8CF675DFAC3}"/>
+                <a16:creationId xmlns:a16="http://schemas.microsoft.com/office/drawing/2014/main" id="{41E22C46-30F8-40D8-B9DA-02204B394F4C}"/>
               </a:ext>
             </a:extLst>
           </p:cNvPr>
@@ -9107,7 +9107,7 @@
           <p:cNvPr id="34" name="">
             <a:extLst xmlns:a="http://schemas.openxmlformats.org/drawingml/2006/main">
               <a:ext uri="{FF2B5EF4-FFF2-40B4-BE49-F238E27FC236}">
-                <a16:creationId xmlns:a16="http://schemas.microsoft.com/office/drawing/2014/main" id="{5C0E4878-EA87-4185-ACE5-AEC465E6B507}"/>
+                <a16:creationId xmlns:a16="http://schemas.microsoft.com/office/drawing/2014/main" id="{B1C43CF9-A53B-4B41-819C-190DA1964710}"/>
               </a:ext>
             </a:extLst>
           </p:cNvPr>
@@ -9157,7 +9157,7 @@
           <p:cNvPr id="35" name="">
             <a:extLst xmlns:a="http://schemas.openxmlformats.org/drawingml/2006/main">
               <a:ext uri="{FF2B5EF4-FFF2-40B4-BE49-F238E27FC236}">
-                <a16:creationId xmlns:a16="http://schemas.microsoft.com/office/drawing/2014/main" id="{3458C2A6-208C-4CB8-AB20-C8A0CC59E909}"/>
+                <a16:creationId xmlns:a16="http://schemas.microsoft.com/office/drawing/2014/main" id="{A8805F73-7FB1-439A-9BAB-3D68FCF9A722}"/>
               </a:ext>
             </a:extLst>
           </p:cNvPr>
@@ -9192,7 +9192,7 @@
           <p:cNvPr id="36" name="">
             <a:extLst xmlns:a="http://schemas.openxmlformats.org/drawingml/2006/main">
               <a:ext uri="{FF2B5EF4-FFF2-40B4-BE49-F238E27FC236}">
-                <a16:creationId xmlns:a16="http://schemas.microsoft.com/office/drawing/2014/main" id="{7A30677C-182B-4B0B-A649-16A78E81F3F3}"/>
+                <a16:creationId xmlns:a16="http://schemas.microsoft.com/office/drawing/2014/main" id="{94E865F2-CC26-4A1E-AD14-F16753C8B1CC}"/>
               </a:ext>
             </a:extLst>
           </p:cNvPr>
@@ -9242,7 +9242,7 @@
           <p:cNvPr id="37" name="">
             <a:extLst xmlns:a="http://schemas.openxmlformats.org/drawingml/2006/main">
               <a:ext uri="{FF2B5EF4-FFF2-40B4-BE49-F238E27FC236}">
-                <a16:creationId xmlns:a16="http://schemas.microsoft.com/office/drawing/2014/main" id="{AB4788C6-4E1F-4252-B853-6B3C19CC4A5A}"/>
+                <a16:creationId xmlns:a16="http://schemas.microsoft.com/office/drawing/2014/main" id="{C216B952-7601-406E-8A6C-F35C051B3A21}"/>
               </a:ext>
             </a:extLst>
           </p:cNvPr>
@@ -9292,7 +9292,7 @@
           <p:cNvPr id="38" name="">
             <a:extLst xmlns:a="http://schemas.openxmlformats.org/drawingml/2006/main">
               <a:ext uri="{FF2B5EF4-FFF2-40B4-BE49-F238E27FC236}">
-                <a16:creationId xmlns:a16="http://schemas.microsoft.com/office/drawing/2014/main" id="{A37C7F51-F669-412E-9AAB-2081CAA56D43}"/>
+                <a16:creationId xmlns:a16="http://schemas.microsoft.com/office/drawing/2014/main" id="{E37DEE80-4B3C-4029-9962-772E0A9E66D5}"/>
               </a:ext>
             </a:extLst>
           </p:cNvPr>
@@ -9342,7 +9342,7 @@
           <p:cNvPr id="39" name="">
             <a:extLst xmlns:a="http://schemas.openxmlformats.org/drawingml/2006/main">
               <a:ext uri="{FF2B5EF4-FFF2-40B4-BE49-F238E27FC236}">
-                <a16:creationId xmlns:a16="http://schemas.microsoft.com/office/drawing/2014/main" id="{0D86CDD1-91C0-493B-B9B6-A77D7A9659DD}"/>
+                <a16:creationId xmlns:a16="http://schemas.microsoft.com/office/drawing/2014/main" id="{D63FFCB4-F20A-4E69-A818-892BAE1F5775}"/>
               </a:ext>
             </a:extLst>
           </p:cNvPr>
@@ -9373,7 +9373,7 @@
           <p:cNvPr id="40" name="">
             <a:extLst xmlns:a="http://schemas.openxmlformats.org/drawingml/2006/main">
               <a:ext uri="{FF2B5EF4-FFF2-40B4-BE49-F238E27FC236}">
-                <a16:creationId xmlns:a16="http://schemas.microsoft.com/office/drawing/2014/main" id="{5787E616-559E-4A28-821F-BD351EC61A30}"/>
+                <a16:creationId xmlns:a16="http://schemas.microsoft.com/office/drawing/2014/main" id="{1FD6F8DD-DEE6-4C80-AAC1-30E63C513C3A}"/>
               </a:ext>
             </a:extLst>
           </p:cNvPr>
@@ -9423,7 +9423,7 @@
           <p:cNvPr id="41" name="">
             <a:extLst xmlns:a="http://schemas.openxmlformats.org/drawingml/2006/main">
               <a:ext uri="{FF2B5EF4-FFF2-40B4-BE49-F238E27FC236}">
-                <a16:creationId xmlns:a16="http://schemas.microsoft.com/office/drawing/2014/main" id="{8D54588B-B23A-4AA7-A2D9-3636B79E9ED9}"/>
+                <a16:creationId xmlns:a16="http://schemas.microsoft.com/office/drawing/2014/main" id="{042EB54D-8DF6-4419-A7EF-4765B9C306CA}"/>
               </a:ext>
             </a:extLst>
           </p:cNvPr>
@@ -9473,7 +9473,7 @@
           <p:cNvPr id="42" name="">
             <a:extLst xmlns:a="http://schemas.openxmlformats.org/drawingml/2006/main">
               <a:ext uri="{FF2B5EF4-FFF2-40B4-BE49-F238E27FC236}">
-                <a16:creationId xmlns:a16="http://schemas.microsoft.com/office/drawing/2014/main" id="{A066FA4B-42B4-4FCD-A500-C6363A927F2A}"/>
+                <a16:creationId xmlns:a16="http://schemas.microsoft.com/office/drawing/2014/main" id="{95EC3BA2-2D68-4E63-AA6D-5FC02217E13F}"/>
               </a:ext>
             </a:extLst>
           </p:cNvPr>
@@ -9523,7 +9523,7 @@
           <p:cNvPr id="43" name="">
             <a:extLst xmlns:a="http://schemas.openxmlformats.org/drawingml/2006/main">
               <a:ext uri="{FF2B5EF4-FFF2-40B4-BE49-F238E27FC236}">
-                <a16:creationId xmlns:a16="http://schemas.microsoft.com/office/drawing/2014/main" id="{2C2965D2-1CDA-454D-A3CC-63793348F2F3}"/>
+                <a16:creationId xmlns:a16="http://schemas.microsoft.com/office/drawing/2014/main" id="{AD6FC530-8CD3-4082-B914-FB679858BC4E}"/>
               </a:ext>
             </a:extLst>
           </p:cNvPr>
@@ -9571,7 +9571,7 @@
     </p:spTree>
     <p:extLst>
       <p:ext uri="{BB962C8B-B14F-4D97-AF65-F5344CB8AC3E}">
-        <p14:creationId xmlns:p14="http://schemas.microsoft.com/office/powerpoint/2010/main" val="752008763"/>
+        <p14:creationId xmlns:p14="http://schemas.microsoft.com/office/powerpoint/2010/main" val="1092589643"/>
       </p:ext>
     </p:extLst>
   </p:cSld>
@@ -9602,7 +9602,7 @@
           <p:cNvPr id="1" name="">
             <a:extLst xmlns:a="http://schemas.openxmlformats.org/drawingml/2006/main">
               <a:ext uri="{FF2B5EF4-FFF2-40B4-BE49-F238E27FC236}">
-                <a16:creationId xmlns:a16="http://schemas.microsoft.com/office/drawing/2014/main" id="{30FEB9F8-2709-43FC-B364-4400ED0D2A73}"/>
+                <a16:creationId xmlns:a16="http://schemas.microsoft.com/office/drawing/2014/main" id="{A3173D83-03F8-4E10-8010-8654851F2A14}"/>
               </a:ext>
             </a:extLst>
           </p:cNvPr>
@@ -9637,7 +9637,7 @@
           <p:nvPr/>
         </p:nvPicPr>
         <p:blipFill>
-          <a:blip xmlns:r="http://schemas.openxmlformats.org/officeDocument/2006/relationships" xmlns:a="http://schemas.openxmlformats.org/drawingml/2006/main" r:embed="Rd9db00bc8c70410a"/>
+          <a:blip xmlns:r="http://schemas.openxmlformats.org/officeDocument/2006/relationships" xmlns:a="http://schemas.openxmlformats.org/drawingml/2006/main" r:embed="R9d08e60b60c542c3"/>
           <a:stretch xmlns:a="http://schemas.openxmlformats.org/drawingml/2006/main"/>
         </p:blipFill>
         <p:spPr>
@@ -9655,7 +9655,7 @@
           <p:cNvPr id="3" name="">
             <a:extLst xmlns:a="http://schemas.openxmlformats.org/drawingml/2006/main">
               <a:ext uri="{FF2B5EF4-FFF2-40B4-BE49-F238E27FC236}">
-                <a16:creationId xmlns:a16="http://schemas.microsoft.com/office/drawing/2014/main" id="{EE2E8578-10DB-4197-A5C6-397131079227}"/>
+                <a16:creationId xmlns:a16="http://schemas.microsoft.com/office/drawing/2014/main" id="{AE3F0AA2-7969-49C7-BC9C-1624770B4191}"/>
               </a:ext>
             </a:extLst>
           </p:cNvPr>
@@ -9705,7 +9705,7 @@
           <p:cNvPr id="4" name="">
             <a:extLst xmlns:a="http://schemas.openxmlformats.org/drawingml/2006/main">
               <a:ext uri="{FF2B5EF4-FFF2-40B4-BE49-F238E27FC236}">
-                <a16:creationId xmlns:a16="http://schemas.microsoft.com/office/drawing/2014/main" id="{88924468-D3D5-4B67-872C-3794DBCC3161}"/>
+                <a16:creationId xmlns:a16="http://schemas.microsoft.com/office/drawing/2014/main" id="{9AFE5A83-08E2-4075-80C7-D0DE0651AAEC}"/>
               </a:ext>
             </a:extLst>
           </p:cNvPr>
@@ -9738,7 +9738,7 @@
           <p:cNvPr id="5" name="">
             <a:extLst xmlns:a="http://schemas.openxmlformats.org/drawingml/2006/main">
               <a:ext uri="{FF2B5EF4-FFF2-40B4-BE49-F238E27FC236}">
-                <a16:creationId xmlns:a16="http://schemas.microsoft.com/office/drawing/2014/main" id="{7AA0010F-D621-4D9C-8CFA-7999F50B0A94}"/>
+                <a16:creationId xmlns:a16="http://schemas.microsoft.com/office/drawing/2014/main" id="{B02DF000-5D33-429D-B768-559112CA8180}"/>
               </a:ext>
             </a:extLst>
           </p:cNvPr>
@@ -9769,7 +9769,7 @@
           <p:cNvPr id="6" name="">
             <a:extLst xmlns:a="http://schemas.openxmlformats.org/drawingml/2006/main">
               <a:ext uri="{FF2B5EF4-FFF2-40B4-BE49-F238E27FC236}">
-                <a16:creationId xmlns:a16="http://schemas.microsoft.com/office/drawing/2014/main" id="{AE491212-1979-4376-8D45-1305B8657334}"/>
+                <a16:creationId xmlns:a16="http://schemas.microsoft.com/office/drawing/2014/main" id="{69FC5D91-7743-40C3-8EA2-4D7B32400E94}"/>
               </a:ext>
             </a:extLst>
           </p:cNvPr>
@@ -9819,7 +9819,7 @@
           <p:cNvPr id="7" name="">
             <a:extLst xmlns:a="http://schemas.openxmlformats.org/drawingml/2006/main">
               <a:ext uri="{FF2B5EF4-FFF2-40B4-BE49-F238E27FC236}">
-                <a16:creationId xmlns:a16="http://schemas.microsoft.com/office/drawing/2014/main" id="{2A90FC72-F3E1-4425-893B-B048495D9F5B}"/>
+                <a16:creationId xmlns:a16="http://schemas.microsoft.com/office/drawing/2014/main" id="{C1193BDE-7FA8-4BE1-A366-3990B7E701B0}"/>
               </a:ext>
             </a:extLst>
           </p:cNvPr>
@@ -9869,7 +9869,7 @@
           <p:cNvPr id="8" name="">
             <a:extLst xmlns:a="http://schemas.openxmlformats.org/drawingml/2006/main">
               <a:ext uri="{FF2B5EF4-FFF2-40B4-BE49-F238E27FC236}">
-                <a16:creationId xmlns:a16="http://schemas.microsoft.com/office/drawing/2014/main" id="{6173936C-CEAD-4A27-A7A0-8A7468D51255}"/>
+                <a16:creationId xmlns:a16="http://schemas.microsoft.com/office/drawing/2014/main" id="{305BC97B-C697-409D-BBED-D479642B7654}"/>
               </a:ext>
             </a:extLst>
           </p:cNvPr>
@@ -9904,7 +9904,7 @@
           <p:cNvPr id="9" name="">
             <a:extLst xmlns:a="http://schemas.openxmlformats.org/drawingml/2006/main">
               <a:ext uri="{FF2B5EF4-FFF2-40B4-BE49-F238E27FC236}">
-                <a16:creationId xmlns:a16="http://schemas.microsoft.com/office/drawing/2014/main" id="{EF2BD424-FB38-4EF4-B906-24FB0EDF1AD4}"/>
+                <a16:creationId xmlns:a16="http://schemas.microsoft.com/office/drawing/2014/main" id="{11F9D21D-2C00-4631-B86E-7EB06495EDB9}"/>
               </a:ext>
             </a:extLst>
           </p:cNvPr>
@@ -9954,7 +9954,7 @@
           <p:cNvPr id="10" name="">
             <a:extLst xmlns:a="http://schemas.openxmlformats.org/drawingml/2006/main">
               <a:ext uri="{FF2B5EF4-FFF2-40B4-BE49-F238E27FC236}">
-                <a16:creationId xmlns:a16="http://schemas.microsoft.com/office/drawing/2014/main" id="{2826C3F7-4BBC-49CE-B4D6-7DA5CF829F14}"/>
+                <a16:creationId xmlns:a16="http://schemas.microsoft.com/office/drawing/2014/main" id="{6DA57478-1D77-4B43-BF97-080C2E2346A9}"/>
               </a:ext>
             </a:extLst>
           </p:cNvPr>
@@ -10004,7 +10004,7 @@
           <p:cNvPr id="11" name="">
             <a:extLst xmlns:a="http://schemas.openxmlformats.org/drawingml/2006/main">
               <a:ext uri="{FF2B5EF4-FFF2-40B4-BE49-F238E27FC236}">
-                <a16:creationId xmlns:a16="http://schemas.microsoft.com/office/drawing/2014/main" id="{89BBFD1B-60C8-4111-9072-B63AF3B4AF55}"/>
+                <a16:creationId xmlns:a16="http://schemas.microsoft.com/office/drawing/2014/main" id="{54A89920-5305-43E1-93E4-E262E83E5C73}"/>
               </a:ext>
             </a:extLst>
           </p:cNvPr>
@@ -10054,7 +10054,7 @@
           <p:cNvPr id="12" name="">
             <a:extLst xmlns:a="http://schemas.openxmlformats.org/drawingml/2006/main">
               <a:ext uri="{FF2B5EF4-FFF2-40B4-BE49-F238E27FC236}">
-                <a16:creationId xmlns:a16="http://schemas.microsoft.com/office/drawing/2014/main" id="{C663D79A-47FB-427E-B104-2BA622959390}"/>
+                <a16:creationId xmlns:a16="http://schemas.microsoft.com/office/drawing/2014/main" id="{3D92AD69-ACAC-47F3-81EF-4A791CE7C880}"/>
               </a:ext>
             </a:extLst>
           </p:cNvPr>
@@ -10085,7 +10085,7 @@
           <p:cNvPr id="13" name="">
             <a:extLst xmlns:a="http://schemas.openxmlformats.org/drawingml/2006/main">
               <a:ext uri="{FF2B5EF4-FFF2-40B4-BE49-F238E27FC236}">
-                <a16:creationId xmlns:a16="http://schemas.microsoft.com/office/drawing/2014/main" id="{C44A3FEB-2D7B-4CBD-A684-6F6303959D75}"/>
+                <a16:creationId xmlns:a16="http://schemas.microsoft.com/office/drawing/2014/main" id="{5D23A4EE-8854-4EC0-A4A8-E5D2D751883A}"/>
               </a:ext>
             </a:extLst>
           </p:cNvPr>
@@ -10135,7 +10135,7 @@
           <p:cNvPr id="14" name="">
             <a:extLst xmlns:a="http://schemas.openxmlformats.org/drawingml/2006/main">
               <a:ext uri="{FF2B5EF4-FFF2-40B4-BE49-F238E27FC236}">
-                <a16:creationId xmlns:a16="http://schemas.microsoft.com/office/drawing/2014/main" id="{8EC66929-9F06-4E8A-82DB-382A6EFCCE1F}"/>
+                <a16:creationId xmlns:a16="http://schemas.microsoft.com/office/drawing/2014/main" id="{156C5E8F-A7B1-4D4B-8537-2D8599FD8384}"/>
               </a:ext>
             </a:extLst>
           </p:cNvPr>
@@ -10185,7 +10185,7 @@
           <p:cNvPr id="15" name="">
             <a:extLst xmlns:a="http://schemas.openxmlformats.org/drawingml/2006/main">
               <a:ext uri="{FF2B5EF4-FFF2-40B4-BE49-F238E27FC236}">
-                <a16:creationId xmlns:a16="http://schemas.microsoft.com/office/drawing/2014/main" id="{E916E3C5-7FCA-4024-A584-4E7EA9673806}"/>
+                <a16:creationId xmlns:a16="http://schemas.microsoft.com/office/drawing/2014/main" id="{CE4572B3-859C-4B89-BB8A-FD76D7F58925}"/>
               </a:ext>
             </a:extLst>
           </p:cNvPr>
@@ -10235,7 +10235,7 @@
           <p:cNvPr id="16" name="">
             <a:extLst xmlns:a="http://schemas.openxmlformats.org/drawingml/2006/main">
               <a:ext uri="{FF2B5EF4-FFF2-40B4-BE49-F238E27FC236}">
-                <a16:creationId xmlns:a16="http://schemas.microsoft.com/office/drawing/2014/main" id="{D16D1E99-45F7-4DFB-ABB2-4B4C236FF508}"/>
+                <a16:creationId xmlns:a16="http://schemas.microsoft.com/office/drawing/2014/main" id="{F8C48050-86FB-4CD1-9114-BE616CCBE427}"/>
               </a:ext>
             </a:extLst>
           </p:cNvPr>
@@ -10285,7 +10285,7 @@
           <p:cNvPr id="17" name="">
             <a:extLst xmlns:a="http://schemas.openxmlformats.org/drawingml/2006/main">
               <a:ext uri="{FF2B5EF4-FFF2-40B4-BE49-F238E27FC236}">
-                <a16:creationId xmlns:a16="http://schemas.microsoft.com/office/drawing/2014/main" id="{BE3FFAEA-5F3F-41D8-9DBA-8C586D98C36E}"/>
+                <a16:creationId xmlns:a16="http://schemas.microsoft.com/office/drawing/2014/main" id="{BEE5C7ED-BB59-4FB4-A314-5827695F3F18}"/>
               </a:ext>
             </a:extLst>
           </p:cNvPr>
@@ -10320,7 +10320,7 @@
           <p:cNvPr id="18" name="">
             <a:extLst xmlns:a="http://schemas.openxmlformats.org/drawingml/2006/main">
               <a:ext uri="{FF2B5EF4-FFF2-40B4-BE49-F238E27FC236}">
-                <a16:creationId xmlns:a16="http://schemas.microsoft.com/office/drawing/2014/main" id="{7A360AAD-80EE-44AC-A854-3C0F00C1DC3E}"/>
+                <a16:creationId xmlns:a16="http://schemas.microsoft.com/office/drawing/2014/main" id="{F88F9388-71D0-47ED-87CD-EE50B95524B1}"/>
               </a:ext>
             </a:extLst>
           </p:cNvPr>
@@ -10370,7 +10370,7 @@
           <p:cNvPr id="19" name="">
             <a:extLst xmlns:a="http://schemas.openxmlformats.org/drawingml/2006/main">
               <a:ext uri="{FF2B5EF4-FFF2-40B4-BE49-F238E27FC236}">
-                <a16:creationId xmlns:a16="http://schemas.microsoft.com/office/drawing/2014/main" id="{9759FE2D-41ED-4F1D-8A2D-D799F78FF57B}"/>
+                <a16:creationId xmlns:a16="http://schemas.microsoft.com/office/drawing/2014/main" id="{3302BBAD-26F2-4D06-A3E1-5144C90A882E}"/>
               </a:ext>
             </a:extLst>
           </p:cNvPr>
@@ -10420,7 +10420,7 @@
           <p:cNvPr id="20" name="">
             <a:extLst xmlns:a="http://schemas.openxmlformats.org/drawingml/2006/main">
               <a:ext uri="{FF2B5EF4-FFF2-40B4-BE49-F238E27FC236}">
-                <a16:creationId xmlns:a16="http://schemas.microsoft.com/office/drawing/2014/main" id="{F0C93E02-840B-4C48-ACFD-D97956C88B10}"/>
+                <a16:creationId xmlns:a16="http://schemas.microsoft.com/office/drawing/2014/main" id="{3D0CB97B-CBB3-455E-9172-0961C363B9D4}"/>
               </a:ext>
             </a:extLst>
           </p:cNvPr>
@@ -10470,7 +10470,7 @@
           <p:cNvPr id="21" name="">
             <a:extLst xmlns:a="http://schemas.openxmlformats.org/drawingml/2006/main">
               <a:ext uri="{FF2B5EF4-FFF2-40B4-BE49-F238E27FC236}">
-                <a16:creationId xmlns:a16="http://schemas.microsoft.com/office/drawing/2014/main" id="{B6B553D5-E942-44AA-9785-59C265007423}"/>
+                <a16:creationId xmlns:a16="http://schemas.microsoft.com/office/drawing/2014/main" id="{109470DA-BD4E-4C33-858F-E4CE567F357C}"/>
               </a:ext>
             </a:extLst>
           </p:cNvPr>
@@ -10501,7 +10501,7 @@
           <p:cNvPr id="22" name="">
             <a:extLst xmlns:a="http://schemas.openxmlformats.org/drawingml/2006/main">
               <a:ext uri="{FF2B5EF4-FFF2-40B4-BE49-F238E27FC236}">
-                <a16:creationId xmlns:a16="http://schemas.microsoft.com/office/drawing/2014/main" id="{67692EC2-3A1E-42B7-959C-4804296AA2C8}"/>
+                <a16:creationId xmlns:a16="http://schemas.microsoft.com/office/drawing/2014/main" id="{1D492A12-6E9F-4491-B8C2-02BDF06A142C}"/>
               </a:ext>
             </a:extLst>
           </p:cNvPr>
@@ -10551,7 +10551,7 @@
           <p:cNvPr id="23" name="">
             <a:extLst xmlns:a="http://schemas.openxmlformats.org/drawingml/2006/main">
               <a:ext uri="{FF2B5EF4-FFF2-40B4-BE49-F238E27FC236}">
-                <a16:creationId xmlns:a16="http://schemas.microsoft.com/office/drawing/2014/main" id="{36881B94-BDBA-48D1-8133-409DB88E999D}"/>
+                <a16:creationId xmlns:a16="http://schemas.microsoft.com/office/drawing/2014/main" id="{14429D8D-2AC1-4D07-802F-5645EA866653}"/>
               </a:ext>
             </a:extLst>
           </p:cNvPr>
@@ -10601,7 +10601,7 @@
           <p:cNvPr id="24" name="">
             <a:extLst xmlns:a="http://schemas.openxmlformats.org/drawingml/2006/main">
               <a:ext uri="{FF2B5EF4-FFF2-40B4-BE49-F238E27FC236}">
-                <a16:creationId xmlns:a16="http://schemas.microsoft.com/office/drawing/2014/main" id="{C61F3ECE-9D9B-41A8-9973-E1028A3D1F30}"/>
+                <a16:creationId xmlns:a16="http://schemas.microsoft.com/office/drawing/2014/main" id="{721C3C21-681B-4062-BA0E-8B2FFD83362C}"/>
               </a:ext>
             </a:extLst>
           </p:cNvPr>
@@ -10651,7 +10651,7 @@
           <p:cNvPr id="25" name="">
             <a:extLst xmlns:a="http://schemas.openxmlformats.org/drawingml/2006/main">
               <a:ext uri="{FF2B5EF4-FFF2-40B4-BE49-F238E27FC236}">
-                <a16:creationId xmlns:a16="http://schemas.microsoft.com/office/drawing/2014/main" id="{B72B1122-5FAD-4781-86A5-EEDC775EF248}"/>
+                <a16:creationId xmlns:a16="http://schemas.microsoft.com/office/drawing/2014/main" id="{50089A15-96F3-4CEF-92F3-9CB4E4DB70C9}"/>
               </a:ext>
             </a:extLst>
           </p:cNvPr>
@@ -10701,7 +10701,7 @@
           <p:cNvPr id="26" name="">
             <a:extLst xmlns:a="http://schemas.openxmlformats.org/drawingml/2006/main">
               <a:ext uri="{FF2B5EF4-FFF2-40B4-BE49-F238E27FC236}">
-                <a16:creationId xmlns:a16="http://schemas.microsoft.com/office/drawing/2014/main" id="{1464AAF7-D452-4002-880E-A9443B7C59E0}"/>
+                <a16:creationId xmlns:a16="http://schemas.microsoft.com/office/drawing/2014/main" id="{392ACD9C-1B72-4DDF-99AB-ED92E62DC38E}"/>
               </a:ext>
             </a:extLst>
           </p:cNvPr>
@@ -10736,7 +10736,7 @@
           <p:cNvPr id="27" name="">
             <a:extLst xmlns:a="http://schemas.openxmlformats.org/drawingml/2006/main">
               <a:ext uri="{FF2B5EF4-FFF2-40B4-BE49-F238E27FC236}">
-                <a16:creationId xmlns:a16="http://schemas.microsoft.com/office/drawing/2014/main" id="{8BA30FD7-EEA1-4C54-A7AE-6D6D13DAD3C3}"/>
+                <a16:creationId xmlns:a16="http://schemas.microsoft.com/office/drawing/2014/main" id="{E4BA7DF6-A44E-4D6B-9F03-65B72E9A7BB9}"/>
               </a:ext>
             </a:extLst>
           </p:cNvPr>
@@ -10786,7 +10786,7 @@
           <p:cNvPr id="28" name="">
             <a:extLst xmlns:a="http://schemas.openxmlformats.org/drawingml/2006/main">
               <a:ext uri="{FF2B5EF4-FFF2-40B4-BE49-F238E27FC236}">
-                <a16:creationId xmlns:a16="http://schemas.microsoft.com/office/drawing/2014/main" id="{875A8A9C-8FA1-4C46-BCAB-B3A9A4B94066}"/>
+                <a16:creationId xmlns:a16="http://schemas.microsoft.com/office/drawing/2014/main" id="{FD93AF1E-D694-41AA-92E8-E90B1E284A7B}"/>
               </a:ext>
             </a:extLst>
           </p:cNvPr>
@@ -10836,7 +10836,7 @@
           <p:cNvPr id="29" name="">
             <a:extLst xmlns:a="http://schemas.openxmlformats.org/drawingml/2006/main">
               <a:ext uri="{FF2B5EF4-FFF2-40B4-BE49-F238E27FC236}">
-                <a16:creationId xmlns:a16="http://schemas.microsoft.com/office/drawing/2014/main" id="{A06F7A26-9D8A-466F-A325-E92529E116B8}"/>
+                <a16:creationId xmlns:a16="http://schemas.microsoft.com/office/drawing/2014/main" id="{59400B16-96C6-46E5-989A-BBEACE387088}"/>
               </a:ext>
             </a:extLst>
           </p:cNvPr>
@@ -10886,7 +10886,7 @@
           <p:cNvPr id="30" name="">
             <a:extLst xmlns:a="http://schemas.openxmlformats.org/drawingml/2006/main">
               <a:ext uri="{FF2B5EF4-FFF2-40B4-BE49-F238E27FC236}">
-                <a16:creationId xmlns:a16="http://schemas.microsoft.com/office/drawing/2014/main" id="{313FF71F-8CB5-472F-99DD-B34592BEA756}"/>
+                <a16:creationId xmlns:a16="http://schemas.microsoft.com/office/drawing/2014/main" id="{6102E351-F33A-4857-A1BF-9CC218E6F567}"/>
               </a:ext>
             </a:extLst>
           </p:cNvPr>
@@ -10917,7 +10917,7 @@
           <p:cNvPr id="31" name="">
             <a:extLst xmlns:a="http://schemas.openxmlformats.org/drawingml/2006/main">
               <a:ext uri="{FF2B5EF4-FFF2-40B4-BE49-F238E27FC236}">
-                <a16:creationId xmlns:a16="http://schemas.microsoft.com/office/drawing/2014/main" id="{2FC9F545-3E65-4027-A83B-7471456055B1}"/>
+                <a16:creationId xmlns:a16="http://schemas.microsoft.com/office/drawing/2014/main" id="{8998CF72-8395-4726-B2FE-D9FAAA260554}"/>
               </a:ext>
             </a:extLst>
           </p:cNvPr>
@@ -10967,7 +10967,7 @@
           <p:cNvPr id="32" name="">
             <a:extLst xmlns:a="http://schemas.openxmlformats.org/drawingml/2006/main">
               <a:ext uri="{FF2B5EF4-FFF2-40B4-BE49-F238E27FC236}">
-                <a16:creationId xmlns:a16="http://schemas.microsoft.com/office/drawing/2014/main" id="{194A3644-1F91-43AF-B2F9-B7E843597700}"/>
+                <a16:creationId xmlns:a16="http://schemas.microsoft.com/office/drawing/2014/main" id="{21D5E29E-D798-4044-A1C3-1CA1B844781B}"/>
               </a:ext>
             </a:extLst>
           </p:cNvPr>
@@ -11017,7 +11017,7 @@
           <p:cNvPr id="33" name="">
             <a:extLst xmlns:a="http://schemas.openxmlformats.org/drawingml/2006/main">
               <a:ext uri="{FF2B5EF4-FFF2-40B4-BE49-F238E27FC236}">
-                <a16:creationId xmlns:a16="http://schemas.microsoft.com/office/drawing/2014/main" id="{37675591-00B0-407B-BF19-007D2C3513D1}"/>
+                <a16:creationId xmlns:a16="http://schemas.microsoft.com/office/drawing/2014/main" id="{C75BA0A3-C31F-4C96-8F8C-3F015F807029}"/>
               </a:ext>
             </a:extLst>
           </p:cNvPr>
@@ -11067,7 +11067,7 @@
           <p:cNvPr id="34" name="">
             <a:extLst xmlns:a="http://schemas.openxmlformats.org/drawingml/2006/main">
               <a:ext uri="{FF2B5EF4-FFF2-40B4-BE49-F238E27FC236}">
-                <a16:creationId xmlns:a16="http://schemas.microsoft.com/office/drawing/2014/main" id="{90DBBAFA-CB53-4B79-AC2B-F76F4D4C5518}"/>
+                <a16:creationId xmlns:a16="http://schemas.microsoft.com/office/drawing/2014/main" id="{6CB2515E-6C98-4AF3-9D97-C7C935337E02}"/>
               </a:ext>
             </a:extLst>
           </p:cNvPr>
@@ -11117,7 +11117,7 @@
           <p:cNvPr id="35" name="">
             <a:extLst xmlns:a="http://schemas.openxmlformats.org/drawingml/2006/main">
               <a:ext uri="{FF2B5EF4-FFF2-40B4-BE49-F238E27FC236}">
-                <a16:creationId xmlns:a16="http://schemas.microsoft.com/office/drawing/2014/main" id="{81D6F51F-CA01-4592-BA40-C5E02BF63215}"/>
+                <a16:creationId xmlns:a16="http://schemas.microsoft.com/office/drawing/2014/main" id="{D921A9D7-61B8-43C6-87DA-1A8F32D56E16}"/>
               </a:ext>
             </a:extLst>
           </p:cNvPr>
@@ -11152,7 +11152,7 @@
           <p:cNvPr id="36" name="">
             <a:extLst xmlns:a="http://schemas.openxmlformats.org/drawingml/2006/main">
               <a:ext uri="{FF2B5EF4-FFF2-40B4-BE49-F238E27FC236}">
-                <a16:creationId xmlns:a16="http://schemas.microsoft.com/office/drawing/2014/main" id="{715B7208-D1FB-4AA5-AFD0-2D470DF8A517}"/>
+                <a16:creationId xmlns:a16="http://schemas.microsoft.com/office/drawing/2014/main" id="{2E0D4418-A90B-4C02-8803-C1CA0A5F592E}"/>
               </a:ext>
             </a:extLst>
           </p:cNvPr>
@@ -11202,7 +11202,7 @@
           <p:cNvPr id="37" name="">
             <a:extLst xmlns:a="http://schemas.openxmlformats.org/drawingml/2006/main">
               <a:ext uri="{FF2B5EF4-FFF2-40B4-BE49-F238E27FC236}">
-                <a16:creationId xmlns:a16="http://schemas.microsoft.com/office/drawing/2014/main" id="{5982726E-C471-43B8-980E-CF5E05633915}"/>
+                <a16:creationId xmlns:a16="http://schemas.microsoft.com/office/drawing/2014/main" id="{C93C24F0-FEAD-461F-A721-3548B0343DDB}"/>
               </a:ext>
             </a:extLst>
           </p:cNvPr>
@@ -11252,7 +11252,7 @@
           <p:cNvPr id="38" name="">
             <a:extLst xmlns:a="http://schemas.openxmlformats.org/drawingml/2006/main">
               <a:ext uri="{FF2B5EF4-FFF2-40B4-BE49-F238E27FC236}">
-                <a16:creationId xmlns:a16="http://schemas.microsoft.com/office/drawing/2014/main" id="{B92580AE-3DBD-4C54-BECC-C33D183E214A}"/>
+                <a16:creationId xmlns:a16="http://schemas.microsoft.com/office/drawing/2014/main" id="{ABA831C2-E2F4-413E-985D-59C42B12152F}"/>
               </a:ext>
             </a:extLst>
           </p:cNvPr>
@@ -11302,7 +11302,7 @@
           <p:cNvPr id="39" name="">
             <a:extLst xmlns:a="http://schemas.openxmlformats.org/drawingml/2006/main">
               <a:ext uri="{FF2B5EF4-FFF2-40B4-BE49-F238E27FC236}">
-                <a16:creationId xmlns:a16="http://schemas.microsoft.com/office/drawing/2014/main" id="{94F570DD-AE60-4596-970E-71D151040922}"/>
+                <a16:creationId xmlns:a16="http://schemas.microsoft.com/office/drawing/2014/main" id="{042FD63B-86E6-4749-9C02-48C9AB583D25}"/>
               </a:ext>
             </a:extLst>
           </p:cNvPr>
@@ -11333,7 +11333,7 @@
           <p:cNvPr id="40" name="">
             <a:extLst xmlns:a="http://schemas.openxmlformats.org/drawingml/2006/main">
               <a:ext uri="{FF2B5EF4-FFF2-40B4-BE49-F238E27FC236}">
-                <a16:creationId xmlns:a16="http://schemas.microsoft.com/office/drawing/2014/main" id="{A85440C9-050B-4D01-B16A-794EA598F1C2}"/>
+                <a16:creationId xmlns:a16="http://schemas.microsoft.com/office/drawing/2014/main" id="{1B91843E-89EF-4705-9579-FCC9762C8595}"/>
               </a:ext>
             </a:extLst>
           </p:cNvPr>
@@ -11383,7 +11383,7 @@
           <p:cNvPr id="41" name="">
             <a:extLst xmlns:a="http://schemas.openxmlformats.org/drawingml/2006/main">
               <a:ext uri="{FF2B5EF4-FFF2-40B4-BE49-F238E27FC236}">
-                <a16:creationId xmlns:a16="http://schemas.microsoft.com/office/drawing/2014/main" id="{ACA0CE90-DB3F-4A98-9862-DA9FC21D1CD5}"/>
+                <a16:creationId xmlns:a16="http://schemas.microsoft.com/office/drawing/2014/main" id="{71087939-8213-4151-9F57-862B49AA1F71}"/>
               </a:ext>
             </a:extLst>
           </p:cNvPr>
@@ -11433,7 +11433,7 @@
           <p:cNvPr id="42" name="">
             <a:extLst xmlns:a="http://schemas.openxmlformats.org/drawingml/2006/main">
               <a:ext uri="{FF2B5EF4-FFF2-40B4-BE49-F238E27FC236}">
-                <a16:creationId xmlns:a16="http://schemas.microsoft.com/office/drawing/2014/main" id="{1DBEC9CB-D051-4007-8853-76844DA72200}"/>
+                <a16:creationId xmlns:a16="http://schemas.microsoft.com/office/drawing/2014/main" id="{01754668-1AA1-4F71-B0B1-DD5CBBBB5DD4}"/>
               </a:ext>
             </a:extLst>
           </p:cNvPr>
@@ -11483,7 +11483,7 @@
           <p:cNvPr id="43" name="">
             <a:extLst xmlns:a="http://schemas.openxmlformats.org/drawingml/2006/main">
               <a:ext uri="{FF2B5EF4-FFF2-40B4-BE49-F238E27FC236}">
-                <a16:creationId xmlns:a16="http://schemas.microsoft.com/office/drawing/2014/main" id="{707BB68D-C63F-47C3-8B47-08702E391E4B}"/>
+                <a16:creationId xmlns:a16="http://schemas.microsoft.com/office/drawing/2014/main" id="{674861B6-2C3A-47D4-8B19-70262D5B0C50}"/>
               </a:ext>
             </a:extLst>
           </p:cNvPr>
@@ -11531,7 +11531,7 @@
     </p:spTree>
     <p:extLst>
       <p:ext uri="{BB962C8B-B14F-4D97-AF65-F5344CB8AC3E}">
-        <p14:creationId xmlns:p14="http://schemas.microsoft.com/office/powerpoint/2010/main" val="215212517"/>
+        <p14:creationId xmlns:p14="http://schemas.microsoft.com/office/powerpoint/2010/main" val="1849648486"/>
       </p:ext>
     </p:extLst>
   </p:cSld>
@@ -11562,7 +11562,7 @@
           <p:cNvPr id="1" name="">
             <a:extLst xmlns:a="http://schemas.openxmlformats.org/drawingml/2006/main">
               <a:ext uri="{FF2B5EF4-FFF2-40B4-BE49-F238E27FC236}">
-                <a16:creationId xmlns:a16="http://schemas.microsoft.com/office/drawing/2014/main" id="{1DB271D4-1729-40D5-A80D-8C9FFDC52C39}"/>
+                <a16:creationId xmlns:a16="http://schemas.microsoft.com/office/drawing/2014/main" id="{B30E5952-5003-48BC-B214-87C68C0FF4E6}"/>
               </a:ext>
             </a:extLst>
           </p:cNvPr>
@@ -11597,7 +11597,7 @@
           <p:nvPr/>
         </p:nvPicPr>
         <p:blipFill>
-          <a:blip xmlns:r="http://schemas.openxmlformats.org/officeDocument/2006/relationships" xmlns:a="http://schemas.openxmlformats.org/drawingml/2006/main" r:embed="R0fe7a1d7e63f4ddf"/>
+          <a:blip xmlns:r="http://schemas.openxmlformats.org/officeDocument/2006/relationships" xmlns:a="http://schemas.openxmlformats.org/drawingml/2006/main" r:embed="R174d3b86651e4bd5"/>
           <a:stretch xmlns:a="http://schemas.openxmlformats.org/drawingml/2006/main"/>
         </p:blipFill>
         <p:spPr>
@@ -11615,7 +11615,7 @@
           <p:cNvPr id="3" name="">
             <a:extLst xmlns:a="http://schemas.openxmlformats.org/drawingml/2006/main">
               <a:ext uri="{FF2B5EF4-FFF2-40B4-BE49-F238E27FC236}">
-                <a16:creationId xmlns:a16="http://schemas.microsoft.com/office/drawing/2014/main" id="{0334C720-D970-48F6-A99F-7FBC71C547C0}"/>
+                <a16:creationId xmlns:a16="http://schemas.microsoft.com/office/drawing/2014/main" id="{8A3284F9-382E-4067-9E47-D7D3E2102B79}"/>
               </a:ext>
             </a:extLst>
           </p:cNvPr>
@@ -11665,7 +11665,7 @@
           <p:cNvPr id="4" name="">
             <a:extLst xmlns:a="http://schemas.openxmlformats.org/drawingml/2006/main">
               <a:ext uri="{FF2B5EF4-FFF2-40B4-BE49-F238E27FC236}">
-                <a16:creationId xmlns:a16="http://schemas.microsoft.com/office/drawing/2014/main" id="{0E5C77CB-ADD8-41DF-9A3D-F782FA7965C3}"/>
+                <a16:creationId xmlns:a16="http://schemas.microsoft.com/office/drawing/2014/main" id="{EB784C58-6C14-4F99-89A5-D6595521D19A}"/>
               </a:ext>
             </a:extLst>
           </p:cNvPr>
@@ -11698,7 +11698,7 @@
           <p:cNvPr id="5" name="">
             <a:extLst xmlns:a="http://schemas.openxmlformats.org/drawingml/2006/main">
               <a:ext uri="{FF2B5EF4-FFF2-40B4-BE49-F238E27FC236}">
-                <a16:creationId xmlns:a16="http://schemas.microsoft.com/office/drawing/2014/main" id="{186F75CD-151E-4722-B915-CE7B5F7AA6A4}"/>
+                <a16:creationId xmlns:a16="http://schemas.microsoft.com/office/drawing/2014/main" id="{6453DDD5-8599-43AB-B857-B416F0649B7A}"/>
               </a:ext>
             </a:extLst>
           </p:cNvPr>
@@ -11729,7 +11729,7 @@
           <p:cNvPr id="6" name="">
             <a:extLst xmlns:a="http://schemas.openxmlformats.org/drawingml/2006/main">
               <a:ext uri="{FF2B5EF4-FFF2-40B4-BE49-F238E27FC236}">
-                <a16:creationId xmlns:a16="http://schemas.microsoft.com/office/drawing/2014/main" id="{BA576667-CB9D-4D68-8822-64098E93E354}"/>
+                <a16:creationId xmlns:a16="http://schemas.microsoft.com/office/drawing/2014/main" id="{29002768-E40E-46E9-A306-4683FBBA08BB}"/>
               </a:ext>
             </a:extLst>
           </p:cNvPr>
@@ -11779,7 +11779,7 @@
           <p:cNvPr id="7" name="">
             <a:extLst xmlns:a="http://schemas.openxmlformats.org/drawingml/2006/main">
               <a:ext uri="{FF2B5EF4-FFF2-40B4-BE49-F238E27FC236}">
-                <a16:creationId xmlns:a16="http://schemas.microsoft.com/office/drawing/2014/main" id="{C84E1A19-5517-4999-B908-F60FE07562D0}"/>
+                <a16:creationId xmlns:a16="http://schemas.microsoft.com/office/drawing/2014/main" id="{9D4B1E84-DD5B-4764-BD16-A26085F00E39}"/>
               </a:ext>
             </a:extLst>
           </p:cNvPr>
@@ -11829,7 +11829,7 @@
           <p:cNvPr id="8" name="">
             <a:extLst xmlns:a="http://schemas.openxmlformats.org/drawingml/2006/main">
               <a:ext uri="{FF2B5EF4-FFF2-40B4-BE49-F238E27FC236}">
-                <a16:creationId xmlns:a16="http://schemas.microsoft.com/office/drawing/2014/main" id="{5AC895D3-8E50-4ADB-A39C-6B586305568B}"/>
+                <a16:creationId xmlns:a16="http://schemas.microsoft.com/office/drawing/2014/main" id="{91A4B69C-07E3-439F-BA21-F0386EB6A82D}"/>
               </a:ext>
             </a:extLst>
           </p:cNvPr>
@@ -11864,7 +11864,7 @@
           <p:cNvPr id="9" name="">
             <a:extLst xmlns:a="http://schemas.openxmlformats.org/drawingml/2006/main">
               <a:ext uri="{FF2B5EF4-FFF2-40B4-BE49-F238E27FC236}">
-                <a16:creationId xmlns:a16="http://schemas.microsoft.com/office/drawing/2014/main" id="{47B874ED-318A-4D11-AFA4-57F071F4CEFF}"/>
+                <a16:creationId xmlns:a16="http://schemas.microsoft.com/office/drawing/2014/main" id="{61A35BF6-938E-4181-9E80-760BEE89C21B}"/>
               </a:ext>
             </a:extLst>
           </p:cNvPr>
@@ -11897,7 +11897,7 @@
           <p:cNvPr id="10" name="">
             <a:extLst xmlns:a="http://schemas.openxmlformats.org/drawingml/2006/main">
               <a:ext uri="{FF2B5EF4-FFF2-40B4-BE49-F238E27FC236}">
-                <a16:creationId xmlns:a16="http://schemas.microsoft.com/office/drawing/2014/main" id="{9E782511-C766-4818-A7F0-1A40B7D45455}"/>
+                <a16:creationId xmlns:a16="http://schemas.microsoft.com/office/drawing/2014/main" id="{A2774FE4-9EAF-4BC6-8E52-B4D8E8B26632}"/>
               </a:ext>
             </a:extLst>
           </p:cNvPr>
@@ -11947,7 +11947,7 @@
           <p:cNvPr id="11" name="">
             <a:extLst xmlns:a="http://schemas.openxmlformats.org/drawingml/2006/main">
               <a:ext uri="{FF2B5EF4-FFF2-40B4-BE49-F238E27FC236}">
-                <a16:creationId xmlns:a16="http://schemas.microsoft.com/office/drawing/2014/main" id="{FCAC7E2E-9191-4DCA-B5A7-D4AC669CA641}"/>
+                <a16:creationId xmlns:a16="http://schemas.microsoft.com/office/drawing/2014/main" id="{7E585CCC-984D-4CF4-82C5-237E8FD9F464}"/>
               </a:ext>
             </a:extLst>
           </p:cNvPr>
@@ -11997,7 +11997,7 @@
           <p:cNvPr id="12" name="">
             <a:extLst xmlns:a="http://schemas.openxmlformats.org/drawingml/2006/main">
               <a:ext uri="{FF2B5EF4-FFF2-40B4-BE49-F238E27FC236}">
-                <a16:creationId xmlns:a16="http://schemas.microsoft.com/office/drawing/2014/main" id="{E3EE9506-2961-4750-96DA-0EA2BE245740}"/>
+                <a16:creationId xmlns:a16="http://schemas.microsoft.com/office/drawing/2014/main" id="{08C7CE2A-9D45-4A96-AC7B-0C96EABA5739}"/>
               </a:ext>
             </a:extLst>
           </p:cNvPr>
@@ -12047,7 +12047,7 @@
           <p:cNvPr id="13" name="">
             <a:extLst xmlns:a="http://schemas.openxmlformats.org/drawingml/2006/main">
               <a:ext uri="{FF2B5EF4-FFF2-40B4-BE49-F238E27FC236}">
-                <a16:creationId xmlns:a16="http://schemas.microsoft.com/office/drawing/2014/main" id="{28B67CE9-5722-4725-906E-3BF6B9FE5BC2}"/>
+                <a16:creationId xmlns:a16="http://schemas.microsoft.com/office/drawing/2014/main" id="{AAFC4DAA-2895-44FA-861C-0FAA780CA65A}"/>
               </a:ext>
             </a:extLst>
           </p:cNvPr>
@@ -12078,7 +12078,7 @@
           <p:cNvPr id="14" name="">
             <a:extLst xmlns:a="http://schemas.openxmlformats.org/drawingml/2006/main">
               <a:ext uri="{FF2B5EF4-FFF2-40B4-BE49-F238E27FC236}">
-                <a16:creationId xmlns:a16="http://schemas.microsoft.com/office/drawing/2014/main" id="{0778846C-F28B-4A52-A3CA-0C5DACDEEAD0}"/>
+                <a16:creationId xmlns:a16="http://schemas.microsoft.com/office/drawing/2014/main" id="{9D162B27-AF9E-4257-A7FF-94401DD4A49E}"/>
               </a:ext>
             </a:extLst>
           </p:cNvPr>
@@ -12128,7 +12128,7 @@
           <p:cNvPr id="15" name="">
             <a:extLst xmlns:a="http://schemas.openxmlformats.org/drawingml/2006/main">
               <a:ext uri="{FF2B5EF4-FFF2-40B4-BE49-F238E27FC236}">
-                <a16:creationId xmlns:a16="http://schemas.microsoft.com/office/drawing/2014/main" id="{2DAD3BAC-D1BA-49CA-9705-1111CDB851E4}"/>
+                <a16:creationId xmlns:a16="http://schemas.microsoft.com/office/drawing/2014/main" id="{FAEF1566-4D64-4259-8631-B1EDA1D247B9}"/>
               </a:ext>
             </a:extLst>
           </p:cNvPr>
@@ -12178,7 +12178,7 @@
           <p:cNvPr id="16" name="">
             <a:extLst xmlns:a="http://schemas.openxmlformats.org/drawingml/2006/main">
               <a:ext uri="{FF2B5EF4-FFF2-40B4-BE49-F238E27FC236}">
-                <a16:creationId xmlns:a16="http://schemas.microsoft.com/office/drawing/2014/main" id="{971F412D-5C31-4EDB-BDEF-8A0B31838915}"/>
+                <a16:creationId xmlns:a16="http://schemas.microsoft.com/office/drawing/2014/main" id="{5BA11A85-4D30-4BE2-9359-7873CFC5CDAE}"/>
               </a:ext>
             </a:extLst>
           </p:cNvPr>
@@ -12213,7 +12213,7 @@
           <p:cNvPr id="17" name="">
             <a:extLst xmlns:a="http://schemas.openxmlformats.org/drawingml/2006/main">
               <a:ext uri="{FF2B5EF4-FFF2-40B4-BE49-F238E27FC236}">
-                <a16:creationId xmlns:a16="http://schemas.microsoft.com/office/drawing/2014/main" id="{E21C61CA-7ECE-4613-897F-925DAF01C635}"/>
+                <a16:creationId xmlns:a16="http://schemas.microsoft.com/office/drawing/2014/main" id="{48FDC769-5FDC-4A3B-BF82-87C601CF29EF}"/>
               </a:ext>
             </a:extLst>
           </p:cNvPr>
@@ -12246,7 +12246,7 @@
           <p:cNvPr id="18" name="">
             <a:extLst xmlns:a="http://schemas.openxmlformats.org/drawingml/2006/main">
               <a:ext uri="{FF2B5EF4-FFF2-40B4-BE49-F238E27FC236}">
-                <a16:creationId xmlns:a16="http://schemas.microsoft.com/office/drawing/2014/main" id="{2B690959-D942-4362-B657-68715C484BC6}"/>
+                <a16:creationId xmlns:a16="http://schemas.microsoft.com/office/drawing/2014/main" id="{844240EB-F642-4CD0-A86E-21B3A0810A5E}"/>
               </a:ext>
             </a:extLst>
           </p:cNvPr>
@@ -12296,7 +12296,7 @@
           <p:cNvPr id="19" name="">
             <a:extLst xmlns:a="http://schemas.openxmlformats.org/drawingml/2006/main">
               <a:ext uri="{FF2B5EF4-FFF2-40B4-BE49-F238E27FC236}">
-                <a16:creationId xmlns:a16="http://schemas.microsoft.com/office/drawing/2014/main" id="{7E894545-9BAC-4A3C-866E-700656D51781}"/>
+                <a16:creationId xmlns:a16="http://schemas.microsoft.com/office/drawing/2014/main" id="{A605DBBF-A6FB-4EF1-90B1-12BE859187D8}"/>
               </a:ext>
             </a:extLst>
           </p:cNvPr>
@@ -12346,7 +12346,7 @@
           <p:cNvPr id="20" name="">
             <a:extLst xmlns:a="http://schemas.openxmlformats.org/drawingml/2006/main">
               <a:ext uri="{FF2B5EF4-FFF2-40B4-BE49-F238E27FC236}">
-                <a16:creationId xmlns:a16="http://schemas.microsoft.com/office/drawing/2014/main" id="{95B82EDD-F09B-463B-A430-31247F7924AD}"/>
+                <a16:creationId xmlns:a16="http://schemas.microsoft.com/office/drawing/2014/main" id="{3FBF1492-08BB-4A29-8C9B-CCC987990AEA}"/>
               </a:ext>
             </a:extLst>
           </p:cNvPr>
@@ -12396,7 +12396,7 @@
           <p:cNvPr id="21" name="">
             <a:extLst xmlns:a="http://schemas.openxmlformats.org/drawingml/2006/main">
               <a:ext uri="{FF2B5EF4-FFF2-40B4-BE49-F238E27FC236}">
-                <a16:creationId xmlns:a16="http://schemas.microsoft.com/office/drawing/2014/main" id="{C890132F-3FB1-4D55-9063-77539D7A1713}"/>
+                <a16:creationId xmlns:a16="http://schemas.microsoft.com/office/drawing/2014/main" id="{899E959A-AD55-4D9A-AB0B-F792522864A5}"/>
               </a:ext>
             </a:extLst>
           </p:cNvPr>
@@ -12427,7 +12427,7 @@
           <p:cNvPr id="22" name="">
             <a:extLst xmlns:a="http://schemas.openxmlformats.org/drawingml/2006/main">
               <a:ext uri="{FF2B5EF4-FFF2-40B4-BE49-F238E27FC236}">
-                <a16:creationId xmlns:a16="http://schemas.microsoft.com/office/drawing/2014/main" id="{59B295D9-3DA6-470F-B42B-10162FB8237A}"/>
+                <a16:creationId xmlns:a16="http://schemas.microsoft.com/office/drawing/2014/main" id="{CE659E4C-5619-4B60-8AE9-21EAC8785AC2}"/>
               </a:ext>
             </a:extLst>
           </p:cNvPr>
@@ -12477,7 +12477,7 @@
           <p:cNvPr id="23" name="">
             <a:extLst xmlns:a="http://schemas.openxmlformats.org/drawingml/2006/main">
               <a:ext uri="{FF2B5EF4-FFF2-40B4-BE49-F238E27FC236}">
-                <a16:creationId xmlns:a16="http://schemas.microsoft.com/office/drawing/2014/main" id="{025C6F47-DBA2-4654-860E-0AFC321612D6}"/>
+                <a16:creationId xmlns:a16="http://schemas.microsoft.com/office/drawing/2014/main" id="{93C73CBA-A40C-4A17-9414-7C238535A853}"/>
               </a:ext>
             </a:extLst>
           </p:cNvPr>
@@ -12527,7 +12527,7 @@
           <p:cNvPr id="24" name="">
             <a:extLst xmlns:a="http://schemas.openxmlformats.org/drawingml/2006/main">
               <a:ext uri="{FF2B5EF4-FFF2-40B4-BE49-F238E27FC236}">
-                <a16:creationId xmlns:a16="http://schemas.microsoft.com/office/drawing/2014/main" id="{CA839084-6D23-42D8-A0F8-82A929A2CBCE}"/>
+                <a16:creationId xmlns:a16="http://schemas.microsoft.com/office/drawing/2014/main" id="{DD57E13E-0FAC-4779-B10D-93934DC597FB}"/>
               </a:ext>
             </a:extLst>
           </p:cNvPr>
@@ -12562,7 +12562,7 @@
           <p:cNvPr id="25" name="">
             <a:extLst xmlns:a="http://schemas.openxmlformats.org/drawingml/2006/main">
               <a:ext uri="{FF2B5EF4-FFF2-40B4-BE49-F238E27FC236}">
-                <a16:creationId xmlns:a16="http://schemas.microsoft.com/office/drawing/2014/main" id="{26E39461-BA67-415F-A93E-DE65609C5CB3}"/>
+                <a16:creationId xmlns:a16="http://schemas.microsoft.com/office/drawing/2014/main" id="{3EF939B9-7C84-474C-B0A4-D955E91AF8BD}"/>
               </a:ext>
             </a:extLst>
           </p:cNvPr>
@@ -12595,7 +12595,7 @@
           <p:cNvPr id="26" name="">
             <a:extLst xmlns:a="http://schemas.openxmlformats.org/drawingml/2006/main">
               <a:ext uri="{FF2B5EF4-FFF2-40B4-BE49-F238E27FC236}">
-                <a16:creationId xmlns:a16="http://schemas.microsoft.com/office/drawing/2014/main" id="{F678DBA5-CA8A-439B-BE10-6152A491C110}"/>
+                <a16:creationId xmlns:a16="http://schemas.microsoft.com/office/drawing/2014/main" id="{990B2CE9-0B64-495A-B4EE-78360EAB5E39}"/>
               </a:ext>
             </a:extLst>
           </p:cNvPr>
@@ -12645,7 +12645,7 @@
           <p:cNvPr id="27" name="">
             <a:extLst xmlns:a="http://schemas.openxmlformats.org/drawingml/2006/main">
               <a:ext uri="{FF2B5EF4-FFF2-40B4-BE49-F238E27FC236}">
-                <a16:creationId xmlns:a16="http://schemas.microsoft.com/office/drawing/2014/main" id="{81841292-21E6-4154-B12F-31663869D5CB}"/>
+                <a16:creationId xmlns:a16="http://schemas.microsoft.com/office/drawing/2014/main" id="{0F884ABE-0288-4CCD-9F48-D743C956A22E}"/>
               </a:ext>
             </a:extLst>
           </p:cNvPr>
@@ -12695,7 +12695,7 @@
           <p:cNvPr id="28" name="">
             <a:extLst xmlns:a="http://schemas.openxmlformats.org/drawingml/2006/main">
               <a:ext uri="{FF2B5EF4-FFF2-40B4-BE49-F238E27FC236}">
-                <a16:creationId xmlns:a16="http://schemas.microsoft.com/office/drawing/2014/main" id="{51C69449-DD81-4326-AC87-7FB9524BFA66}"/>
+                <a16:creationId xmlns:a16="http://schemas.microsoft.com/office/drawing/2014/main" id="{CBB68942-413D-4517-8484-081686B0F88A}"/>
               </a:ext>
             </a:extLst>
           </p:cNvPr>
@@ -12745,7 +12745,7 @@
           <p:cNvPr id="29" name="">
             <a:extLst xmlns:a="http://schemas.openxmlformats.org/drawingml/2006/main">
               <a:ext uri="{FF2B5EF4-FFF2-40B4-BE49-F238E27FC236}">
-                <a16:creationId xmlns:a16="http://schemas.microsoft.com/office/drawing/2014/main" id="{BB88A1AE-C161-43FC-9265-7023819E6138}"/>
+                <a16:creationId xmlns:a16="http://schemas.microsoft.com/office/drawing/2014/main" id="{AB1082BD-3C95-4BC4-BCD2-EBDBB64CBD62}"/>
               </a:ext>
             </a:extLst>
           </p:cNvPr>
@@ -12776,7 +12776,7 @@
           <p:cNvPr id="30" name="">
             <a:extLst xmlns:a="http://schemas.openxmlformats.org/drawingml/2006/main">
               <a:ext uri="{FF2B5EF4-FFF2-40B4-BE49-F238E27FC236}">
-                <a16:creationId xmlns:a16="http://schemas.microsoft.com/office/drawing/2014/main" id="{69E6DCEC-9C52-429F-8290-3E086962AF73}"/>
+                <a16:creationId xmlns:a16="http://schemas.microsoft.com/office/drawing/2014/main" id="{46548D08-469C-4E74-BD9B-15E5D2CB4E6B}"/>
               </a:ext>
             </a:extLst>
           </p:cNvPr>
@@ -12826,7 +12826,7 @@
           <p:cNvPr id="31" name="">
             <a:extLst xmlns:a="http://schemas.openxmlformats.org/drawingml/2006/main">
               <a:ext uri="{FF2B5EF4-FFF2-40B4-BE49-F238E27FC236}">
-                <a16:creationId xmlns:a16="http://schemas.microsoft.com/office/drawing/2014/main" id="{A1647EB2-426A-440B-971C-A86384E036D6}"/>
+                <a16:creationId xmlns:a16="http://schemas.microsoft.com/office/drawing/2014/main" id="{D9C237A6-7D78-4551-B173-EC406077ED96}"/>
               </a:ext>
             </a:extLst>
           </p:cNvPr>
@@ -12874,7 +12874,7 @@
     </p:spTree>
     <p:extLst>
       <p:ext uri="{BB962C8B-B14F-4D97-AF65-F5344CB8AC3E}">
-        <p14:creationId xmlns:p14="http://schemas.microsoft.com/office/powerpoint/2010/main" val="42072275"/>
+        <p14:creationId xmlns:p14="http://schemas.microsoft.com/office/powerpoint/2010/main" val="1295805741"/>
       </p:ext>
     </p:extLst>
   </p:cSld>
@@ -12905,7 +12905,7 @@
           <p:cNvPr id="1" name="">
             <a:extLst xmlns:a="http://schemas.openxmlformats.org/drawingml/2006/main">
               <a:ext uri="{FF2B5EF4-FFF2-40B4-BE49-F238E27FC236}">
-                <a16:creationId xmlns:a16="http://schemas.microsoft.com/office/drawing/2014/main" id="{59C872B4-CAB7-4F37-B3C5-2678129F269F}"/>
+                <a16:creationId xmlns:a16="http://schemas.microsoft.com/office/drawing/2014/main" id="{FB311ED7-91E4-44AF-B414-194F76B51FE3}"/>
               </a:ext>
             </a:extLst>
           </p:cNvPr>
@@ -12940,7 +12940,7 @@
           <p:nvPr/>
         </p:nvPicPr>
         <p:blipFill>
-          <a:blip xmlns:r="http://schemas.openxmlformats.org/officeDocument/2006/relationships" xmlns:a="http://schemas.openxmlformats.org/drawingml/2006/main" r:embed="Ra4dfd96a6168471f"/>
+          <a:blip xmlns:r="http://schemas.openxmlformats.org/officeDocument/2006/relationships" xmlns:a="http://schemas.openxmlformats.org/drawingml/2006/main" r:embed="R6b615db394d54316"/>
           <a:stretch xmlns:a="http://schemas.openxmlformats.org/drawingml/2006/main"/>
         </p:blipFill>
         <p:spPr>
@@ -12958,7 +12958,7 @@
           <p:cNvPr id="3" name="">
             <a:extLst xmlns:a="http://schemas.openxmlformats.org/drawingml/2006/main">
               <a:ext uri="{FF2B5EF4-FFF2-40B4-BE49-F238E27FC236}">
-                <a16:creationId xmlns:a16="http://schemas.microsoft.com/office/drawing/2014/main" id="{5472EC24-D477-48E3-A2FA-DAAD905450BB}"/>
+                <a16:creationId xmlns:a16="http://schemas.microsoft.com/office/drawing/2014/main" id="{99D9B229-6FC3-49BD-92B2-72BFFEECD31A}"/>
               </a:ext>
             </a:extLst>
           </p:cNvPr>
@@ -13008,7 +13008,7 @@
           <p:cNvPr id="4" name="">
             <a:extLst xmlns:a="http://schemas.openxmlformats.org/drawingml/2006/main">
               <a:ext uri="{FF2B5EF4-FFF2-40B4-BE49-F238E27FC236}">
-                <a16:creationId xmlns:a16="http://schemas.microsoft.com/office/drawing/2014/main" id="{C8BDA06A-3021-4D33-A09C-4C5B4DB9F660}"/>
+                <a16:creationId xmlns:a16="http://schemas.microsoft.com/office/drawing/2014/main" id="{C21DEE1C-7B7C-49D2-9850-EB8F7AE0F09D}"/>
               </a:ext>
             </a:extLst>
           </p:cNvPr>
@@ -13041,7 +13041,7 @@
           <p:cNvPr id="5" name="">
             <a:extLst xmlns:a="http://schemas.openxmlformats.org/drawingml/2006/main">
               <a:ext uri="{FF2B5EF4-FFF2-40B4-BE49-F238E27FC236}">
-                <a16:creationId xmlns:a16="http://schemas.microsoft.com/office/drawing/2014/main" id="{C7935968-40B9-43C7-B3C4-4808C65E65FC}"/>
+                <a16:creationId xmlns:a16="http://schemas.microsoft.com/office/drawing/2014/main" id="{5CD76CE4-410E-4FE1-BE19-2863FAB40B63}"/>
               </a:ext>
             </a:extLst>
           </p:cNvPr>
@@ -13072,7 +13072,7 @@
           <p:cNvPr id="6" name="">
             <a:extLst xmlns:a="http://schemas.openxmlformats.org/drawingml/2006/main">
               <a:ext uri="{FF2B5EF4-FFF2-40B4-BE49-F238E27FC236}">
-                <a16:creationId xmlns:a16="http://schemas.microsoft.com/office/drawing/2014/main" id="{9DEC99F3-08D7-4811-B87A-320BC8C55C0E}"/>
+                <a16:creationId xmlns:a16="http://schemas.microsoft.com/office/drawing/2014/main" id="{1D5AB591-ED3E-455C-82D3-23CE1AEACD23}"/>
               </a:ext>
             </a:extLst>
           </p:cNvPr>
@@ -13122,7 +13122,7 @@
           <p:cNvPr id="7" name="">
             <a:extLst xmlns:a="http://schemas.openxmlformats.org/drawingml/2006/main">
               <a:ext uri="{FF2B5EF4-FFF2-40B4-BE49-F238E27FC236}">
-                <a16:creationId xmlns:a16="http://schemas.microsoft.com/office/drawing/2014/main" id="{39C66BD2-0AC0-4F58-BC42-F5BC4B1CA734}"/>
+                <a16:creationId xmlns:a16="http://schemas.microsoft.com/office/drawing/2014/main" id="{F9751A3C-E0E6-4FF0-8673-57372B227FD9}"/>
               </a:ext>
             </a:extLst>
           </p:cNvPr>
@@ -13172,7 +13172,7 @@
           <p:cNvPr id="8" name="">
             <a:extLst xmlns:a="http://schemas.openxmlformats.org/drawingml/2006/main">
               <a:ext uri="{FF2B5EF4-FFF2-40B4-BE49-F238E27FC236}">
-                <a16:creationId xmlns:a16="http://schemas.microsoft.com/office/drawing/2014/main" id="{38EA9841-DA5F-4C4C-945C-DB785825BB2C}"/>
+                <a16:creationId xmlns:a16="http://schemas.microsoft.com/office/drawing/2014/main" id="{6A5C9749-A68E-433E-A54C-9CF55FC934DF}"/>
               </a:ext>
             </a:extLst>
           </p:cNvPr>
@@ -13222,7 +13222,7 @@
           <p:cNvPr id="9" name="">
             <a:extLst xmlns:a="http://schemas.openxmlformats.org/drawingml/2006/main">
               <a:ext uri="{FF2B5EF4-FFF2-40B4-BE49-F238E27FC236}">
-                <a16:creationId xmlns:a16="http://schemas.microsoft.com/office/drawing/2014/main" id="{F06E58A0-91D7-404A-9C1A-E48DAB4FBF7D}"/>
+                <a16:creationId xmlns:a16="http://schemas.microsoft.com/office/drawing/2014/main" id="{A67F892B-68C6-494E-9349-A1D248EF0AC8}"/>
               </a:ext>
             </a:extLst>
           </p:cNvPr>
@@ -13272,7 +13272,7 @@
           <p:cNvPr id="10" name="">
             <a:extLst xmlns:a="http://schemas.openxmlformats.org/drawingml/2006/main">
               <a:ext uri="{FF2B5EF4-FFF2-40B4-BE49-F238E27FC236}">
-                <a16:creationId xmlns:a16="http://schemas.microsoft.com/office/drawing/2014/main" id="{A0948433-841D-4C8F-9154-A8813CB5E7A5}"/>
+                <a16:creationId xmlns:a16="http://schemas.microsoft.com/office/drawing/2014/main" id="{ED92ABE1-C6A3-4FC8-8CC8-734C532CC6C4}"/>
               </a:ext>
             </a:extLst>
           </p:cNvPr>
@@ -13303,7 +13303,7 @@
           <p:cNvPr id="11" name="">
             <a:extLst xmlns:a="http://schemas.openxmlformats.org/drawingml/2006/main">
               <a:ext uri="{FF2B5EF4-FFF2-40B4-BE49-F238E27FC236}">
-                <a16:creationId xmlns:a16="http://schemas.microsoft.com/office/drawing/2014/main" id="{C8B38F68-2F86-438E-9DD2-0AE4820E50E2}"/>
+                <a16:creationId xmlns:a16="http://schemas.microsoft.com/office/drawing/2014/main" id="{B06D550B-3466-455A-9362-58A4A6C86F9B}"/>
               </a:ext>
             </a:extLst>
           </p:cNvPr>
@@ -13353,7 +13353,7 @@
           <p:cNvPr id="12" name="">
             <a:extLst xmlns:a="http://schemas.openxmlformats.org/drawingml/2006/main">
               <a:ext uri="{FF2B5EF4-FFF2-40B4-BE49-F238E27FC236}">
-                <a16:creationId xmlns:a16="http://schemas.microsoft.com/office/drawing/2014/main" id="{7D5044ED-A60B-496F-AAC1-63C298D643B8}"/>
+                <a16:creationId xmlns:a16="http://schemas.microsoft.com/office/drawing/2014/main" id="{E21E3E6D-6612-41B3-AD7A-234D6FA864AE}"/>
               </a:ext>
             </a:extLst>
           </p:cNvPr>
@@ -13403,7 +13403,7 @@
           <p:cNvPr id="13" name="">
             <a:extLst xmlns:a="http://schemas.openxmlformats.org/drawingml/2006/main">
               <a:ext uri="{FF2B5EF4-FFF2-40B4-BE49-F238E27FC236}">
-                <a16:creationId xmlns:a16="http://schemas.microsoft.com/office/drawing/2014/main" id="{ACB0DB61-D438-4256-A88F-1459136C8892}"/>
+                <a16:creationId xmlns:a16="http://schemas.microsoft.com/office/drawing/2014/main" id="{71EB3EDA-CEEC-40F8-9CE0-6B4E867F64B5}"/>
               </a:ext>
             </a:extLst>
           </p:cNvPr>
@@ -13434,7 +13434,7 @@
           <p:cNvPr id="14" name="">
             <a:extLst xmlns:a="http://schemas.openxmlformats.org/drawingml/2006/main">
               <a:ext uri="{FF2B5EF4-FFF2-40B4-BE49-F238E27FC236}">
-                <a16:creationId xmlns:a16="http://schemas.microsoft.com/office/drawing/2014/main" id="{5076D387-0C2E-4224-8754-0E92D59BB6B5}"/>
+                <a16:creationId xmlns:a16="http://schemas.microsoft.com/office/drawing/2014/main" id="{96AB4149-2D21-4CDE-AF01-50A264583CDB}"/>
               </a:ext>
             </a:extLst>
           </p:cNvPr>
@@ -13484,7 +13484,7 @@
           <p:cNvPr id="15" name="">
             <a:extLst xmlns:a="http://schemas.openxmlformats.org/drawingml/2006/main">
               <a:ext uri="{FF2B5EF4-FFF2-40B4-BE49-F238E27FC236}">
-                <a16:creationId xmlns:a16="http://schemas.microsoft.com/office/drawing/2014/main" id="{D1B33371-89D7-41AB-A8B0-0AA1EF57EAD0}"/>
+                <a16:creationId xmlns:a16="http://schemas.microsoft.com/office/drawing/2014/main" id="{0233F9E0-876D-4EAD-9385-04A8909BE8C2}"/>
               </a:ext>
             </a:extLst>
           </p:cNvPr>
@@ -13534,7 +13534,7 @@
           <p:cNvPr id="16" name="">
             <a:extLst xmlns:a="http://schemas.openxmlformats.org/drawingml/2006/main">
               <a:ext uri="{FF2B5EF4-FFF2-40B4-BE49-F238E27FC236}">
-                <a16:creationId xmlns:a16="http://schemas.microsoft.com/office/drawing/2014/main" id="{D6ECA677-4CEB-4913-A92C-0DE5A2EAD762}"/>
+                <a16:creationId xmlns:a16="http://schemas.microsoft.com/office/drawing/2014/main" id="{2994D882-C6A2-475B-A8B5-14D8ED587EDD}"/>
               </a:ext>
             </a:extLst>
           </p:cNvPr>
@@ -13565,7 +13565,7 @@
           <p:cNvPr id="17" name="">
             <a:extLst xmlns:a="http://schemas.openxmlformats.org/drawingml/2006/main">
               <a:ext uri="{FF2B5EF4-FFF2-40B4-BE49-F238E27FC236}">
-                <a16:creationId xmlns:a16="http://schemas.microsoft.com/office/drawing/2014/main" id="{7FA9DD7F-1C9A-4AF4-B16E-345852635AB5}"/>
+                <a16:creationId xmlns:a16="http://schemas.microsoft.com/office/drawing/2014/main" id="{54E6219C-6F6C-41AE-8B91-E153CAA75BC5}"/>
               </a:ext>
             </a:extLst>
           </p:cNvPr>
@@ -13615,7 +13615,7 @@
           <p:cNvPr id="18" name="">
             <a:extLst xmlns:a="http://schemas.openxmlformats.org/drawingml/2006/main">
               <a:ext uri="{FF2B5EF4-FFF2-40B4-BE49-F238E27FC236}">
-                <a16:creationId xmlns:a16="http://schemas.microsoft.com/office/drawing/2014/main" id="{27A1B5E5-B49E-4D13-9B85-9DD23349EC9B}"/>
+                <a16:creationId xmlns:a16="http://schemas.microsoft.com/office/drawing/2014/main" id="{5DFF6413-AC80-4D9F-9EFA-589ABB869816}"/>
               </a:ext>
             </a:extLst>
           </p:cNvPr>
@@ -13665,7 +13665,7 @@
           <p:cNvPr id="19" name="">
             <a:extLst xmlns:a="http://schemas.openxmlformats.org/drawingml/2006/main">
               <a:ext uri="{FF2B5EF4-FFF2-40B4-BE49-F238E27FC236}">
-                <a16:creationId xmlns:a16="http://schemas.microsoft.com/office/drawing/2014/main" id="{57E8DBBF-B82B-47D5-807A-D179CD74B7EF}"/>
+                <a16:creationId xmlns:a16="http://schemas.microsoft.com/office/drawing/2014/main" id="{BF33F9F5-36AA-4F59-9926-69B11E806392}"/>
               </a:ext>
             </a:extLst>
           </p:cNvPr>
@@ -13700,7 +13700,7 @@
           <p:cNvPr id="20" name="">
             <a:extLst xmlns:a="http://schemas.openxmlformats.org/drawingml/2006/main">
               <a:ext uri="{FF2B5EF4-FFF2-40B4-BE49-F238E27FC236}">
-                <a16:creationId xmlns:a16="http://schemas.microsoft.com/office/drawing/2014/main" id="{06F68FDD-7B0F-457F-9C8F-67E7788E8F02}"/>
+                <a16:creationId xmlns:a16="http://schemas.microsoft.com/office/drawing/2014/main" id="{8826B28E-9F46-4581-8FAE-1293C3A52AAC}"/>
               </a:ext>
             </a:extLst>
           </p:cNvPr>
@@ -13750,7 +13750,7 @@
           <p:cNvPr id="21" name="">
             <a:extLst xmlns:a="http://schemas.openxmlformats.org/drawingml/2006/main">
               <a:ext uri="{FF2B5EF4-FFF2-40B4-BE49-F238E27FC236}">
-                <a16:creationId xmlns:a16="http://schemas.microsoft.com/office/drawing/2014/main" id="{9FEB5591-C6DA-4510-8227-2DF8D3CB8591}"/>
+                <a16:creationId xmlns:a16="http://schemas.microsoft.com/office/drawing/2014/main" id="{0399DA6A-C3DE-4384-A8F7-07B49F975BD8}"/>
               </a:ext>
             </a:extLst>
           </p:cNvPr>
@@ -13804,7 +13804,7 @@
           <p:nvPr/>
         </p:nvPicPr>
         <p:blipFill>
-          <a:blip xmlns:r="http://schemas.openxmlformats.org/officeDocument/2006/relationships" xmlns:a="http://schemas.openxmlformats.org/drawingml/2006/main" r:embed="R19e367d88efe4dd0"/>
+          <a:blip xmlns:r="http://schemas.openxmlformats.org/officeDocument/2006/relationships" xmlns:a="http://schemas.openxmlformats.org/drawingml/2006/main" r:embed="R3f9c73364f024654"/>
           <a:stretch xmlns:a="http://schemas.openxmlformats.org/drawingml/2006/main"/>
         </p:blipFill>
         <p:spPr>
@@ -13822,7 +13822,7 @@
           <p:cNvPr id="23" name="">
             <a:extLst xmlns:a="http://schemas.openxmlformats.org/drawingml/2006/main">
               <a:ext uri="{FF2B5EF4-FFF2-40B4-BE49-F238E27FC236}">
-                <a16:creationId xmlns:a16="http://schemas.microsoft.com/office/drawing/2014/main" id="{F65A8162-EFF8-4BB7-8BF3-CDE3407AE2E5}"/>
+                <a16:creationId xmlns:a16="http://schemas.microsoft.com/office/drawing/2014/main" id="{D0698D56-F58D-41A1-9F79-0DEECB951B8B}"/>
               </a:ext>
             </a:extLst>
           </p:cNvPr>
@@ -13872,7 +13872,7 @@
           <p:cNvPr id="24" name="">
             <a:extLst xmlns:a="http://schemas.openxmlformats.org/drawingml/2006/main">
               <a:ext uri="{FF2B5EF4-FFF2-40B4-BE49-F238E27FC236}">
-                <a16:creationId xmlns:a16="http://schemas.microsoft.com/office/drawing/2014/main" id="{ED82FCA9-206C-4209-8EF5-208B4AF0A2F3}"/>
+                <a16:creationId xmlns:a16="http://schemas.microsoft.com/office/drawing/2014/main" id="{2F339F28-F9B7-4898-9330-8D1C493F3BCA}"/>
               </a:ext>
             </a:extLst>
           </p:cNvPr>
@@ -13922,7 +13922,7 @@
           <p:cNvPr id="25" name="">
             <a:extLst xmlns:a="http://schemas.openxmlformats.org/drawingml/2006/main">
               <a:ext uri="{FF2B5EF4-FFF2-40B4-BE49-F238E27FC236}">
-                <a16:creationId xmlns:a16="http://schemas.microsoft.com/office/drawing/2014/main" id="{ADC9B736-7948-4D5C-9AE6-2423C978809A}"/>
+                <a16:creationId xmlns:a16="http://schemas.microsoft.com/office/drawing/2014/main" id="{42C9DD09-00D5-4719-9413-E079E8A840CB}"/>
               </a:ext>
             </a:extLst>
           </p:cNvPr>
@@ -13970,7 +13970,7 @@
     </p:spTree>
     <p:extLst>
       <p:ext uri="{BB962C8B-B14F-4D97-AF65-F5344CB8AC3E}">
-        <p14:creationId xmlns:p14="http://schemas.microsoft.com/office/powerpoint/2010/main" val="579672665"/>
+        <p14:creationId xmlns:p14="http://schemas.microsoft.com/office/powerpoint/2010/main" val="1724789130"/>
       </p:ext>
     </p:extLst>
   </p:cSld>

</xml_diff>

<commit_message>
Polish audit conclusion call to action
</commit_message>
<xml_diff>
--- a/static/audit_presentation_btg.pptx
+++ b/static/audit_presentation_btg.pptx
@@ -2,21 +2,21 @@
 <file path=ppt/presentation.xml><?xml version="1.0" encoding="utf-8"?>
 <p:presentation xmlns:p="http://schemas.openxmlformats.org/presentationml/2006/main">
   <p:sldMasterIdLst>
-    <p:sldMasterId xmlns:r="http://schemas.openxmlformats.org/officeDocument/2006/relationships" id="2147483648" r:id="Re9e1dcdeb9f24025"/>
+    <p:sldMasterId xmlns:r="http://schemas.openxmlformats.org/officeDocument/2006/relationships" id="2147483648" r:id="Rc9400c7a960b4190"/>
   </p:sldMasterIdLst>
   <p:notesMasterIdLst>
-    <p:notesMasterId xmlns:r="http://schemas.openxmlformats.org/officeDocument/2006/relationships" r:id="R5a8a457a88944c92"/>
+    <p:notesMasterId xmlns:r="http://schemas.openxmlformats.org/officeDocument/2006/relationships" r:id="Ra70e922d7ed84361"/>
   </p:notesMasterIdLst>
   <p:sldIdLst>
-    <p:sldId xmlns:r="http://schemas.openxmlformats.org/officeDocument/2006/relationships" id="256" r:id="R3f0d107eaaed466f"/>
-    <p:sldId xmlns:r="http://schemas.openxmlformats.org/officeDocument/2006/relationships" id="257" r:id="R9710d22508af418b"/>
-    <p:sldId xmlns:r="http://schemas.openxmlformats.org/officeDocument/2006/relationships" id="258" r:id="R03811bc316224031"/>
-    <p:sldId xmlns:r="http://schemas.openxmlformats.org/officeDocument/2006/relationships" id="259" r:id="R88756a043fae4de0"/>
-    <p:sldId xmlns:r="http://schemas.openxmlformats.org/officeDocument/2006/relationships" id="260" r:id="R9b310c7ca2cb40fa"/>
-    <p:sldId xmlns:r="http://schemas.openxmlformats.org/officeDocument/2006/relationships" id="261" r:id="R674a7fd83bc449e7"/>
-    <p:sldId xmlns:r="http://schemas.openxmlformats.org/officeDocument/2006/relationships" id="262" r:id="R93747b400acd4407"/>
-    <p:sldId xmlns:r="http://schemas.openxmlformats.org/officeDocument/2006/relationships" id="263" r:id="R170fcdff6832404d"/>
-    <p:sldId xmlns:r="http://schemas.openxmlformats.org/officeDocument/2006/relationships" id="264" r:id="R9895b96869c74249"/>
+    <p:sldId xmlns:r="http://schemas.openxmlformats.org/officeDocument/2006/relationships" id="256" r:id="Rd898fa7079f44fdb"/>
+    <p:sldId xmlns:r="http://schemas.openxmlformats.org/officeDocument/2006/relationships" id="257" r:id="R8290faea1b5f4cdf"/>
+    <p:sldId xmlns:r="http://schemas.openxmlformats.org/officeDocument/2006/relationships" id="258" r:id="Re1498fff4cb940ad"/>
+    <p:sldId xmlns:r="http://schemas.openxmlformats.org/officeDocument/2006/relationships" id="259" r:id="Rff9c10596361490b"/>
+    <p:sldId xmlns:r="http://schemas.openxmlformats.org/officeDocument/2006/relationships" id="260" r:id="Rae7fb8a0053a49b3"/>
+    <p:sldId xmlns:r="http://schemas.openxmlformats.org/officeDocument/2006/relationships" id="261" r:id="Ra242e5986b2f42d6"/>
+    <p:sldId xmlns:r="http://schemas.openxmlformats.org/officeDocument/2006/relationships" id="262" r:id="Ra1771e1241a546ff"/>
+    <p:sldId xmlns:r="http://schemas.openxmlformats.org/officeDocument/2006/relationships" id="263" r:id="R7622386e685f4881"/>
+    <p:sldId xmlns:r="http://schemas.openxmlformats.org/officeDocument/2006/relationships" id="264" r:id="R7610a889db7f4623"/>
   </p:sldIdLst>
   <p:sldSz cx="12192000" cy="6858000"/>
   <p:notesSz cx="6858000" cy="9144000"/>
@@ -1137,7 +1137,7 @@
   </p:cSld>
   <p:clrMap bg1="lt1" tx1="dk1" bg2="lt2" tx2="dk2" accent1="accent1" accent2="accent2" accent3="accent3" accent4="accent4" accent5="accent5" accent6="accent6" hlink="hlink" folHlink="folHlink"/>
   <p:sldLayoutIdLst>
-    <p:sldLayoutId xmlns:r="http://schemas.openxmlformats.org/officeDocument/2006/relationships" id="2147483649" r:id="R51efdc50e13f4ca6"/>
+    <p:sldLayoutId xmlns:r="http://schemas.openxmlformats.org/officeDocument/2006/relationships" id="2147483649" r:id="R73e68cdb59b744e9"/>
   </p:sldLayoutIdLst>
   <p:txStyles>
     <p:titleStyle>
@@ -1688,7 +1688,7 @@
           <p:cNvPr id="1" name="">
             <a:extLst xmlns:a="http://schemas.openxmlformats.org/drawingml/2006/main">
               <a:ext uri="{FF2B5EF4-FFF2-40B4-BE49-F238E27FC236}">
-                <a16:creationId xmlns:a16="http://schemas.microsoft.com/office/drawing/2014/main" id="{51E0ACD9-7817-4E59-ABE5-AE1AB81B1A83}"/>
+                <a16:creationId xmlns:a16="http://schemas.microsoft.com/office/drawing/2014/main" id="{3E06586B-5118-42E2-8AF9-A318E6865301}"/>
               </a:ext>
             </a:extLst>
           </p:cNvPr>
@@ -1719,7 +1719,7 @@
           <p:cNvPr id="2" name="">
             <a:extLst xmlns:a="http://schemas.openxmlformats.org/drawingml/2006/main">
               <a:ext uri="{FF2B5EF4-FFF2-40B4-BE49-F238E27FC236}">
-                <a16:creationId xmlns:a16="http://schemas.microsoft.com/office/drawing/2014/main" id="{6D3A391B-D541-4B97-9F08-637A0774B1A6}"/>
+                <a16:creationId xmlns:a16="http://schemas.microsoft.com/office/drawing/2014/main" id="{1C337145-7CD5-43D9-9D82-6AA51E68FDFB}"/>
               </a:ext>
             </a:extLst>
           </p:cNvPr>
@@ -1754,7 +1754,7 @@
           <p:nvPr/>
         </p:nvPicPr>
         <p:blipFill>
-          <a:blip xmlns:r="http://schemas.openxmlformats.org/officeDocument/2006/relationships" xmlns:a="http://schemas.openxmlformats.org/drawingml/2006/main" r:embed="Rc08d76d5f2d645ec"/>
+          <a:blip xmlns:r="http://schemas.openxmlformats.org/officeDocument/2006/relationships" xmlns:a="http://schemas.openxmlformats.org/drawingml/2006/main" r:embed="R18e03ce4cd2e4f7f"/>
           <a:stretch xmlns:a="http://schemas.openxmlformats.org/drawingml/2006/main"/>
         </p:blipFill>
         <p:spPr>
@@ -1772,7 +1772,7 @@
           <p:cNvPr id="4" name="">
             <a:extLst xmlns:a="http://schemas.openxmlformats.org/drawingml/2006/main">
               <a:ext uri="{FF2B5EF4-FFF2-40B4-BE49-F238E27FC236}">
-                <a16:creationId xmlns:a16="http://schemas.microsoft.com/office/drawing/2014/main" id="{DC928623-384A-4A9F-BC5E-66F6373DEA74}"/>
+                <a16:creationId xmlns:a16="http://schemas.microsoft.com/office/drawing/2014/main" id="{F76E4626-F8C1-4EDB-87DD-F6297664258C}"/>
               </a:ext>
             </a:extLst>
           </p:cNvPr>
@@ -1822,7 +1822,7 @@
           <p:cNvPr id="5" name="">
             <a:extLst xmlns:a="http://schemas.openxmlformats.org/drawingml/2006/main">
               <a:ext uri="{FF2B5EF4-FFF2-40B4-BE49-F238E27FC236}">
-                <a16:creationId xmlns:a16="http://schemas.microsoft.com/office/drawing/2014/main" id="{02424EBF-55F5-46FC-84CB-0D48A6C3282F}"/>
+                <a16:creationId xmlns:a16="http://schemas.microsoft.com/office/drawing/2014/main" id="{53010BB7-96AA-488E-BD4B-007323B2CCE8}"/>
               </a:ext>
             </a:extLst>
           </p:cNvPr>
@@ -1872,7 +1872,7 @@
           <p:cNvPr id="6" name="">
             <a:extLst xmlns:a="http://schemas.openxmlformats.org/drawingml/2006/main">
               <a:ext uri="{FF2B5EF4-FFF2-40B4-BE49-F238E27FC236}">
-                <a16:creationId xmlns:a16="http://schemas.microsoft.com/office/drawing/2014/main" id="{A33F675F-40FD-4362-B94E-9AC6E95A5B70}"/>
+                <a16:creationId xmlns:a16="http://schemas.microsoft.com/office/drawing/2014/main" id="{D480869B-DBAA-4B82-ACEB-146049337F62}"/>
               </a:ext>
             </a:extLst>
           </p:cNvPr>
@@ -1922,7 +1922,7 @@
           <p:cNvPr id="7" name="">
             <a:extLst xmlns:a="http://schemas.openxmlformats.org/drawingml/2006/main">
               <a:ext uri="{FF2B5EF4-FFF2-40B4-BE49-F238E27FC236}">
-                <a16:creationId xmlns:a16="http://schemas.microsoft.com/office/drawing/2014/main" id="{93AACEA4-1855-48BA-B3CB-54A0227FF090}"/>
+                <a16:creationId xmlns:a16="http://schemas.microsoft.com/office/drawing/2014/main" id="{818CE886-CCEA-46B0-80FD-F1D59B50A513}"/>
               </a:ext>
             </a:extLst>
           </p:cNvPr>
@@ -1955,7 +1955,7 @@
           <p:cNvPr id="8" name="">
             <a:extLst xmlns:a="http://schemas.openxmlformats.org/drawingml/2006/main">
               <a:ext uri="{FF2B5EF4-FFF2-40B4-BE49-F238E27FC236}">
-                <a16:creationId xmlns:a16="http://schemas.microsoft.com/office/drawing/2014/main" id="{3F03A26B-09BC-4C07-B15D-2881A5A9849B}"/>
+                <a16:creationId xmlns:a16="http://schemas.microsoft.com/office/drawing/2014/main" id="{459DA684-DD6B-4F70-97D3-5622F3FD0E26}"/>
               </a:ext>
             </a:extLst>
           </p:cNvPr>
@@ -2005,7 +2005,7 @@
           <p:cNvPr id="9" name="">
             <a:extLst xmlns:a="http://schemas.openxmlformats.org/drawingml/2006/main">
               <a:ext uri="{FF2B5EF4-FFF2-40B4-BE49-F238E27FC236}">
-                <a16:creationId xmlns:a16="http://schemas.microsoft.com/office/drawing/2014/main" id="{AF963A66-374A-4AA3-BC7F-B79481D6680A}"/>
+                <a16:creationId xmlns:a16="http://schemas.microsoft.com/office/drawing/2014/main" id="{ECDE484E-0520-4ACD-9464-FD72DDB8EA31}"/>
               </a:ext>
             </a:extLst>
           </p:cNvPr>
@@ -2055,7 +2055,7 @@
           <p:cNvPr id="10" name="">
             <a:extLst xmlns:a="http://schemas.openxmlformats.org/drawingml/2006/main">
               <a:ext uri="{FF2B5EF4-FFF2-40B4-BE49-F238E27FC236}">
-                <a16:creationId xmlns:a16="http://schemas.microsoft.com/office/drawing/2014/main" id="{A501DF4C-3560-487B-9C35-F107C458334B}"/>
+                <a16:creationId xmlns:a16="http://schemas.microsoft.com/office/drawing/2014/main" id="{1FC386D5-53D5-4AD2-B169-BFB6AC53ECCA}"/>
               </a:ext>
             </a:extLst>
           </p:cNvPr>
@@ -2088,7 +2088,7 @@
           <p:cNvPr id="11" name="">
             <a:extLst xmlns:a="http://schemas.openxmlformats.org/drawingml/2006/main">
               <a:ext uri="{FF2B5EF4-FFF2-40B4-BE49-F238E27FC236}">
-                <a16:creationId xmlns:a16="http://schemas.microsoft.com/office/drawing/2014/main" id="{C0787550-E20A-4CCE-8E16-0C89AAFEB1FE}"/>
+                <a16:creationId xmlns:a16="http://schemas.microsoft.com/office/drawing/2014/main" id="{AC96E099-C63E-4E8C-9096-2E03686932B1}"/>
               </a:ext>
             </a:extLst>
           </p:cNvPr>
@@ -2138,7 +2138,7 @@
           <p:cNvPr id="12" name="">
             <a:extLst xmlns:a="http://schemas.openxmlformats.org/drawingml/2006/main">
               <a:ext uri="{FF2B5EF4-FFF2-40B4-BE49-F238E27FC236}">
-                <a16:creationId xmlns:a16="http://schemas.microsoft.com/office/drawing/2014/main" id="{DA50AB52-FF91-4706-A8A8-7E7CD9C98AD2}"/>
+                <a16:creationId xmlns:a16="http://schemas.microsoft.com/office/drawing/2014/main" id="{832FF761-581F-400F-A600-01F597FC3F2A}"/>
               </a:ext>
             </a:extLst>
           </p:cNvPr>
@@ -2188,7 +2188,7 @@
           <p:cNvPr id="13" name="">
             <a:extLst xmlns:a="http://schemas.openxmlformats.org/drawingml/2006/main">
               <a:ext uri="{FF2B5EF4-FFF2-40B4-BE49-F238E27FC236}">
-                <a16:creationId xmlns:a16="http://schemas.microsoft.com/office/drawing/2014/main" id="{FB7F45E6-12F2-4B22-8C75-CC6387DAC6EC}"/>
+                <a16:creationId xmlns:a16="http://schemas.microsoft.com/office/drawing/2014/main" id="{87E55568-E151-493F-BDA0-DDFEEAAB94B4}"/>
               </a:ext>
             </a:extLst>
           </p:cNvPr>
@@ -2242,7 +2242,7 @@
           <p:nvPr/>
         </p:nvPicPr>
         <p:blipFill>
-          <a:blip xmlns:r="http://schemas.openxmlformats.org/officeDocument/2006/relationships" xmlns:a="http://schemas.openxmlformats.org/drawingml/2006/main" r:embed="Rc7ce305609ba4486"/>
+          <a:blip xmlns:r="http://schemas.openxmlformats.org/officeDocument/2006/relationships" xmlns:a="http://schemas.openxmlformats.org/drawingml/2006/main" r:embed="R581d80b518b64cbf"/>
           <a:srcRect xmlns:a="http://schemas.openxmlformats.org/drawingml/2006/main" l="0" t="132" r="0" b="132"/>
           <a:stretch xmlns:a="http://schemas.openxmlformats.org/drawingml/2006/main">
             <a:fillRect l="0" t="0" r="0" b="0"/>
@@ -2263,7 +2263,7 @@
           <p:cNvPr id="15" name="">
             <a:extLst xmlns:a="http://schemas.openxmlformats.org/drawingml/2006/main">
               <a:ext uri="{FF2B5EF4-FFF2-40B4-BE49-F238E27FC236}">
-                <a16:creationId xmlns:a16="http://schemas.microsoft.com/office/drawing/2014/main" id="{F71DAB60-BF66-4C65-BCC2-FF3B0B824A54}"/>
+                <a16:creationId xmlns:a16="http://schemas.microsoft.com/office/drawing/2014/main" id="{2CE22B84-9A92-4EA9-B3C7-B15F337B97C6}"/>
               </a:ext>
             </a:extLst>
           </p:cNvPr>
@@ -2294,7 +2294,7 @@
           <p:cNvPr id="16" name="">
             <a:extLst xmlns:a="http://schemas.openxmlformats.org/drawingml/2006/main">
               <a:ext uri="{FF2B5EF4-FFF2-40B4-BE49-F238E27FC236}">
-                <a16:creationId xmlns:a16="http://schemas.microsoft.com/office/drawing/2014/main" id="{BD1EB1B3-C0C2-4D45-92D5-A0A595350B3A}"/>
+                <a16:creationId xmlns:a16="http://schemas.microsoft.com/office/drawing/2014/main" id="{1992E69C-5238-49CD-A5D3-6E6FC8B91293}"/>
               </a:ext>
             </a:extLst>
           </p:cNvPr>
@@ -2342,7 +2342,7 @@
     </p:spTree>
     <p:extLst>
       <p:ext uri="{BB962C8B-B14F-4D97-AF65-F5344CB8AC3E}">
-        <p14:creationId xmlns:p14="http://schemas.microsoft.com/office/powerpoint/2010/main" val="884083528"/>
+        <p14:creationId xmlns:p14="http://schemas.microsoft.com/office/powerpoint/2010/main" val="760663254"/>
       </p:ext>
     </p:extLst>
   </p:cSld>
@@ -2373,7 +2373,7 @@
           <p:cNvPr id="1" name="">
             <a:extLst xmlns:a="http://schemas.openxmlformats.org/drawingml/2006/main">
               <a:ext uri="{FF2B5EF4-FFF2-40B4-BE49-F238E27FC236}">
-                <a16:creationId xmlns:a16="http://schemas.microsoft.com/office/drawing/2014/main" id="{A81B997D-973D-4B61-8455-12B9D8B2476A}"/>
+                <a16:creationId xmlns:a16="http://schemas.microsoft.com/office/drawing/2014/main" id="{7132A5D8-1639-4A9F-B8D1-C379A536D62F}"/>
               </a:ext>
             </a:extLst>
           </p:cNvPr>
@@ -2408,7 +2408,7 @@
           <p:nvPr/>
         </p:nvPicPr>
         <p:blipFill>
-          <a:blip xmlns:r="http://schemas.openxmlformats.org/officeDocument/2006/relationships" xmlns:a="http://schemas.openxmlformats.org/drawingml/2006/main" r:embed="R75a16de7a8354149"/>
+          <a:blip xmlns:r="http://schemas.openxmlformats.org/officeDocument/2006/relationships" xmlns:a="http://schemas.openxmlformats.org/drawingml/2006/main" r:embed="Ra762a970bdb94f5d"/>
           <a:stretch xmlns:a="http://schemas.openxmlformats.org/drawingml/2006/main"/>
         </p:blipFill>
         <p:spPr>
@@ -2426,7 +2426,7 @@
           <p:cNvPr id="3" name="">
             <a:extLst xmlns:a="http://schemas.openxmlformats.org/drawingml/2006/main">
               <a:ext uri="{FF2B5EF4-FFF2-40B4-BE49-F238E27FC236}">
-                <a16:creationId xmlns:a16="http://schemas.microsoft.com/office/drawing/2014/main" id="{AD8C1BC1-EBD5-4164-A62F-E39C8A2A4DD3}"/>
+                <a16:creationId xmlns:a16="http://schemas.microsoft.com/office/drawing/2014/main" id="{E878BBC5-9632-4896-BE51-7A244E110081}"/>
               </a:ext>
             </a:extLst>
           </p:cNvPr>
@@ -2476,7 +2476,7 @@
           <p:cNvPr id="4" name="">
             <a:extLst xmlns:a="http://schemas.openxmlformats.org/drawingml/2006/main">
               <a:ext uri="{FF2B5EF4-FFF2-40B4-BE49-F238E27FC236}">
-                <a16:creationId xmlns:a16="http://schemas.microsoft.com/office/drawing/2014/main" id="{8E5D95EC-41B6-48EC-A11E-BBFB8A806783}"/>
+                <a16:creationId xmlns:a16="http://schemas.microsoft.com/office/drawing/2014/main" id="{FC43CBD7-35CE-4211-85A3-37D4A09D7BA1}"/>
               </a:ext>
             </a:extLst>
           </p:cNvPr>
@@ -2509,7 +2509,7 @@
           <p:cNvPr id="5" name="">
             <a:extLst xmlns:a="http://schemas.openxmlformats.org/drawingml/2006/main">
               <a:ext uri="{FF2B5EF4-FFF2-40B4-BE49-F238E27FC236}">
-                <a16:creationId xmlns:a16="http://schemas.microsoft.com/office/drawing/2014/main" id="{68B5624A-D172-4DDF-B74C-6EEDF1BDADFF}"/>
+                <a16:creationId xmlns:a16="http://schemas.microsoft.com/office/drawing/2014/main" id="{1971E512-A5B2-475C-8EBB-406FDA158360}"/>
               </a:ext>
             </a:extLst>
           </p:cNvPr>
@@ -2540,7 +2540,7 @@
           <p:cNvPr id="6" name="">
             <a:extLst xmlns:a="http://schemas.openxmlformats.org/drawingml/2006/main">
               <a:ext uri="{FF2B5EF4-FFF2-40B4-BE49-F238E27FC236}">
-                <a16:creationId xmlns:a16="http://schemas.microsoft.com/office/drawing/2014/main" id="{DB19A93C-6403-4FD8-8B12-AA8F6C466906}"/>
+                <a16:creationId xmlns:a16="http://schemas.microsoft.com/office/drawing/2014/main" id="{7B61AF03-6948-456F-9454-7D3BF67E2054}"/>
               </a:ext>
             </a:extLst>
           </p:cNvPr>
@@ -2590,7 +2590,7 @@
           <p:cNvPr id="7" name="">
             <a:extLst xmlns:a="http://schemas.openxmlformats.org/drawingml/2006/main">
               <a:ext uri="{FF2B5EF4-FFF2-40B4-BE49-F238E27FC236}">
-                <a16:creationId xmlns:a16="http://schemas.microsoft.com/office/drawing/2014/main" id="{564B4EE7-B455-4458-A5A9-9D55BD672865}"/>
+                <a16:creationId xmlns:a16="http://schemas.microsoft.com/office/drawing/2014/main" id="{94176BD9-D22F-41FA-ADE5-B2EBF01D5551}"/>
               </a:ext>
             </a:extLst>
           </p:cNvPr>
@@ -2640,7 +2640,7 @@
           <p:cNvPr id="8" name="">
             <a:extLst xmlns:a="http://schemas.openxmlformats.org/drawingml/2006/main">
               <a:ext uri="{FF2B5EF4-FFF2-40B4-BE49-F238E27FC236}">
-                <a16:creationId xmlns:a16="http://schemas.microsoft.com/office/drawing/2014/main" id="{A3EFFD8A-951D-40C6-93D2-50574703E1F3}"/>
+                <a16:creationId xmlns:a16="http://schemas.microsoft.com/office/drawing/2014/main" id="{1975A663-38A7-48F0-8DD8-CF23B21C7AFE}"/>
               </a:ext>
             </a:extLst>
           </p:cNvPr>
@@ -2690,7 +2690,7 @@
           <p:cNvPr id="9" name="">
             <a:extLst xmlns:a="http://schemas.openxmlformats.org/drawingml/2006/main">
               <a:ext uri="{FF2B5EF4-FFF2-40B4-BE49-F238E27FC236}">
-                <a16:creationId xmlns:a16="http://schemas.microsoft.com/office/drawing/2014/main" id="{DE60698D-C470-455D-A720-FAECF0AA6CFB}"/>
+                <a16:creationId xmlns:a16="http://schemas.microsoft.com/office/drawing/2014/main" id="{9FA83597-4DB8-4ECB-B15A-74BFBE88BD83}"/>
               </a:ext>
             </a:extLst>
           </p:cNvPr>
@@ -2740,7 +2740,7 @@
           <p:cNvPr id="10" name="">
             <a:extLst xmlns:a="http://schemas.openxmlformats.org/drawingml/2006/main">
               <a:ext uri="{FF2B5EF4-FFF2-40B4-BE49-F238E27FC236}">
-                <a16:creationId xmlns:a16="http://schemas.microsoft.com/office/drawing/2014/main" id="{99BE864B-ECF1-4D9E-A195-57DA32B8ED76}"/>
+                <a16:creationId xmlns:a16="http://schemas.microsoft.com/office/drawing/2014/main" id="{E4B9C82F-B13D-4202-A66D-0B13F5776D70}"/>
               </a:ext>
             </a:extLst>
           </p:cNvPr>
@@ -2790,7 +2790,7 @@
           <p:cNvPr id="11" name="">
             <a:extLst xmlns:a="http://schemas.openxmlformats.org/drawingml/2006/main">
               <a:ext uri="{FF2B5EF4-FFF2-40B4-BE49-F238E27FC236}">
-                <a16:creationId xmlns:a16="http://schemas.microsoft.com/office/drawing/2014/main" id="{498DCE81-5CA1-4DAC-BA6D-8F08CDDB8E50}"/>
+                <a16:creationId xmlns:a16="http://schemas.microsoft.com/office/drawing/2014/main" id="{E9DD4773-B924-451D-A8C7-33649DD2E911}"/>
               </a:ext>
             </a:extLst>
           </p:cNvPr>
@@ -2840,7 +2840,7 @@
           <p:cNvPr id="12" name="">
             <a:extLst xmlns:a="http://schemas.openxmlformats.org/drawingml/2006/main">
               <a:ext uri="{FF2B5EF4-FFF2-40B4-BE49-F238E27FC236}">
-                <a16:creationId xmlns:a16="http://schemas.microsoft.com/office/drawing/2014/main" id="{C16731F3-0E88-4AB1-A1FC-17A504E1D7B2}"/>
+                <a16:creationId xmlns:a16="http://schemas.microsoft.com/office/drawing/2014/main" id="{4081D715-4FA5-4D3A-BDC0-0B23BCF631BA}"/>
               </a:ext>
             </a:extLst>
           </p:cNvPr>
@@ -2890,7 +2890,7 @@
           <p:cNvPr id="13" name="">
             <a:extLst xmlns:a="http://schemas.openxmlformats.org/drawingml/2006/main">
               <a:ext uri="{FF2B5EF4-FFF2-40B4-BE49-F238E27FC236}">
-                <a16:creationId xmlns:a16="http://schemas.microsoft.com/office/drawing/2014/main" id="{13881CD8-D798-4D41-BB67-83CAA2024163}"/>
+                <a16:creationId xmlns:a16="http://schemas.microsoft.com/office/drawing/2014/main" id="{69A00E4A-DA43-43B2-9FD8-25B23CB9C967}"/>
               </a:ext>
             </a:extLst>
           </p:cNvPr>
@@ -2920,14 +2920,14 @@
             <a:pPr>
               <a:defRPr sz="2700" b="1">
                 <a:solidFill>
-                  <a:srgbClr val="2048A8"/>
+                  <a:srgbClr val="102A63"/>
                 </a:solidFill>
               </a:defRPr>
             </a:pPr>
             <a:r>
               <a:rPr sz="2700" b="1">
                 <a:solidFill>
-                  <a:srgbClr val="2048A8"/>
+                  <a:srgbClr val="102A63"/>
                 </a:solidFill>
               </a:rPr>
               <a:t>70+</a:t>
@@ -2940,7 +2940,7 @@
           <p:cNvPr id="14" name="">
             <a:extLst xmlns:a="http://schemas.openxmlformats.org/drawingml/2006/main">
               <a:ext uri="{FF2B5EF4-FFF2-40B4-BE49-F238E27FC236}">
-                <a16:creationId xmlns:a16="http://schemas.microsoft.com/office/drawing/2014/main" id="{1A94A451-A296-41B6-A784-526F477F3BAA}"/>
+                <a16:creationId xmlns:a16="http://schemas.microsoft.com/office/drawing/2014/main" id="{3321E914-2F95-42E1-9306-B4F136ED9B67}"/>
               </a:ext>
             </a:extLst>
           </p:cNvPr>
@@ -2990,7 +2990,7 @@
           <p:cNvPr id="15" name="">
             <a:extLst xmlns:a="http://schemas.openxmlformats.org/drawingml/2006/main">
               <a:ext uri="{FF2B5EF4-FFF2-40B4-BE49-F238E27FC236}">
-                <a16:creationId xmlns:a16="http://schemas.microsoft.com/office/drawing/2014/main" id="{0505034F-730B-4E34-9E60-C8365C92F995}"/>
+                <a16:creationId xmlns:a16="http://schemas.microsoft.com/office/drawing/2014/main" id="{B39AC5A6-C76B-4DCE-BBE7-EB7FB48C1374}"/>
               </a:ext>
             </a:extLst>
           </p:cNvPr>
@@ -3040,7 +3040,7 @@
           <p:cNvPr id="16" name="">
             <a:extLst xmlns:a="http://schemas.openxmlformats.org/drawingml/2006/main">
               <a:ext uri="{FF2B5EF4-FFF2-40B4-BE49-F238E27FC236}">
-                <a16:creationId xmlns:a16="http://schemas.microsoft.com/office/drawing/2014/main" id="{F9AAA2F8-7DB4-44FA-949A-EF5E260F779E}"/>
+                <a16:creationId xmlns:a16="http://schemas.microsoft.com/office/drawing/2014/main" id="{25CF57BB-E599-424D-B7C6-F7BBDE2B2C9A}"/>
               </a:ext>
             </a:extLst>
           </p:cNvPr>
@@ -3090,7 +3090,7 @@
           <p:cNvPr id="17" name="">
             <a:extLst xmlns:a="http://schemas.openxmlformats.org/drawingml/2006/main">
               <a:ext uri="{FF2B5EF4-FFF2-40B4-BE49-F238E27FC236}">
-                <a16:creationId xmlns:a16="http://schemas.microsoft.com/office/drawing/2014/main" id="{EFE3E949-B1F7-4179-A649-FC8CD0755D3C}"/>
+                <a16:creationId xmlns:a16="http://schemas.microsoft.com/office/drawing/2014/main" id="{78FF7609-3207-476F-8F06-803757DF3F74}"/>
               </a:ext>
             </a:extLst>
           </p:cNvPr>
@@ -3125,7 +3125,7 @@
           <p:cNvPr id="18" name="">
             <a:extLst xmlns:a="http://schemas.openxmlformats.org/drawingml/2006/main">
               <a:ext uri="{FF2B5EF4-FFF2-40B4-BE49-F238E27FC236}">
-                <a16:creationId xmlns:a16="http://schemas.microsoft.com/office/drawing/2014/main" id="{651CABD9-0D20-42D7-8543-EE76EADB9CB2}"/>
+                <a16:creationId xmlns:a16="http://schemas.microsoft.com/office/drawing/2014/main" id="{D196303E-0488-4560-9CB3-8902A358EA13}"/>
               </a:ext>
             </a:extLst>
           </p:cNvPr>
@@ -3175,7 +3175,7 @@
           <p:cNvPr id="19" name="">
             <a:extLst xmlns:a="http://schemas.openxmlformats.org/drawingml/2006/main">
               <a:ext uri="{FF2B5EF4-FFF2-40B4-BE49-F238E27FC236}">
-                <a16:creationId xmlns:a16="http://schemas.microsoft.com/office/drawing/2014/main" id="{677FC1E5-5AB4-40B1-9C17-CABF22C4C2B2}"/>
+                <a16:creationId xmlns:a16="http://schemas.microsoft.com/office/drawing/2014/main" id="{4D324711-3EC8-4104-B31F-4A34C667FC19}"/>
               </a:ext>
             </a:extLst>
           </p:cNvPr>
@@ -3225,7 +3225,7 @@
           <p:cNvPr id="20" name="">
             <a:extLst xmlns:a="http://schemas.openxmlformats.org/drawingml/2006/main">
               <a:ext uri="{FF2B5EF4-FFF2-40B4-BE49-F238E27FC236}">
-                <a16:creationId xmlns:a16="http://schemas.microsoft.com/office/drawing/2014/main" id="{F9A7D36B-CC4A-414C-850B-9865B8C4BA67}"/>
+                <a16:creationId xmlns:a16="http://schemas.microsoft.com/office/drawing/2014/main" id="{4389F435-A60A-4960-8708-62F0E482F723}"/>
               </a:ext>
             </a:extLst>
           </p:cNvPr>
@@ -3275,7 +3275,7 @@
           <p:cNvPr id="21" name="">
             <a:extLst xmlns:a="http://schemas.openxmlformats.org/drawingml/2006/main">
               <a:ext uri="{FF2B5EF4-FFF2-40B4-BE49-F238E27FC236}">
-                <a16:creationId xmlns:a16="http://schemas.microsoft.com/office/drawing/2014/main" id="{7E9E80F4-B43A-4452-9E39-826D0E2F4388}"/>
+                <a16:creationId xmlns:a16="http://schemas.microsoft.com/office/drawing/2014/main" id="{6ACB0A61-789B-4BF3-A3BE-3FB254784EDC}"/>
               </a:ext>
             </a:extLst>
           </p:cNvPr>
@@ -3325,7 +3325,7 @@
           <p:cNvPr id="22" name="">
             <a:extLst xmlns:a="http://schemas.openxmlformats.org/drawingml/2006/main">
               <a:ext uri="{FF2B5EF4-FFF2-40B4-BE49-F238E27FC236}">
-                <a16:creationId xmlns:a16="http://schemas.microsoft.com/office/drawing/2014/main" id="{5ACBD3DE-81E6-4AB3-AA30-29A05B25BF94}"/>
+                <a16:creationId xmlns:a16="http://schemas.microsoft.com/office/drawing/2014/main" id="{20A9925C-432C-4A3E-B951-BEC212363809}"/>
               </a:ext>
             </a:extLst>
           </p:cNvPr>
@@ -3356,7 +3356,7 @@
           <p:cNvPr id="23" name="">
             <a:extLst xmlns:a="http://schemas.openxmlformats.org/drawingml/2006/main">
               <a:ext uri="{FF2B5EF4-FFF2-40B4-BE49-F238E27FC236}">
-                <a16:creationId xmlns:a16="http://schemas.microsoft.com/office/drawing/2014/main" id="{5BFBA0C8-577E-48BB-8E13-54E698EA7DF6}"/>
+                <a16:creationId xmlns:a16="http://schemas.microsoft.com/office/drawing/2014/main" id="{5E3A2E69-082F-45B9-94F4-E4518DC9B48D}"/>
               </a:ext>
             </a:extLst>
           </p:cNvPr>
@@ -3406,7 +3406,7 @@
           <p:cNvPr id="24" name="">
             <a:extLst xmlns:a="http://schemas.openxmlformats.org/drawingml/2006/main">
               <a:ext uri="{FF2B5EF4-FFF2-40B4-BE49-F238E27FC236}">
-                <a16:creationId xmlns:a16="http://schemas.microsoft.com/office/drawing/2014/main" id="{3D6B414B-CA2A-46A3-BB5A-D823AD9B38AE}"/>
+                <a16:creationId xmlns:a16="http://schemas.microsoft.com/office/drawing/2014/main" id="{501B934C-0F54-4A30-BBA6-FDD73DF01459}"/>
               </a:ext>
             </a:extLst>
           </p:cNvPr>
@@ -3456,7 +3456,7 @@
           <p:cNvPr id="25" name="">
             <a:extLst xmlns:a="http://schemas.openxmlformats.org/drawingml/2006/main">
               <a:ext uri="{FF2B5EF4-FFF2-40B4-BE49-F238E27FC236}">
-                <a16:creationId xmlns:a16="http://schemas.microsoft.com/office/drawing/2014/main" id="{582232E5-243A-4A9E-8558-24D2B166FEE8}"/>
+                <a16:creationId xmlns:a16="http://schemas.microsoft.com/office/drawing/2014/main" id="{34CED2FA-CE6B-4FA9-8F10-A85BFB908340}"/>
               </a:ext>
             </a:extLst>
           </p:cNvPr>
@@ -3506,7 +3506,7 @@
           <p:cNvPr id="26" name="">
             <a:extLst xmlns:a="http://schemas.openxmlformats.org/drawingml/2006/main">
               <a:ext uri="{FF2B5EF4-FFF2-40B4-BE49-F238E27FC236}">
-                <a16:creationId xmlns:a16="http://schemas.microsoft.com/office/drawing/2014/main" id="{50D21C90-4E44-4948-AD16-E6CAFD018F17}"/>
+                <a16:creationId xmlns:a16="http://schemas.microsoft.com/office/drawing/2014/main" id="{A7CCA6A3-A0E7-41EA-A45E-E841F1138B3D}"/>
               </a:ext>
             </a:extLst>
           </p:cNvPr>
@@ -3537,7 +3537,7 @@
           <p:cNvPr id="27" name="">
             <a:extLst xmlns:a="http://schemas.openxmlformats.org/drawingml/2006/main">
               <a:ext uri="{FF2B5EF4-FFF2-40B4-BE49-F238E27FC236}">
-                <a16:creationId xmlns:a16="http://schemas.microsoft.com/office/drawing/2014/main" id="{EB632313-C087-41C3-AF87-ED1BB863D7E0}"/>
+                <a16:creationId xmlns:a16="http://schemas.microsoft.com/office/drawing/2014/main" id="{B8604886-8970-4E34-B10D-C526A5B6B272}"/>
               </a:ext>
             </a:extLst>
           </p:cNvPr>
@@ -3587,7 +3587,7 @@
           <p:cNvPr id="28" name="">
             <a:extLst xmlns:a="http://schemas.openxmlformats.org/drawingml/2006/main">
               <a:ext uri="{FF2B5EF4-FFF2-40B4-BE49-F238E27FC236}">
-                <a16:creationId xmlns:a16="http://schemas.microsoft.com/office/drawing/2014/main" id="{E71DFC39-9D58-4746-8ADD-7846D2AA5A64}"/>
+                <a16:creationId xmlns:a16="http://schemas.microsoft.com/office/drawing/2014/main" id="{31CC16B3-F550-4B94-B7D4-B14C8C053C13}"/>
               </a:ext>
             </a:extLst>
           </p:cNvPr>
@@ -3637,7 +3637,7 @@
           <p:cNvPr id="29" name="">
             <a:extLst xmlns:a="http://schemas.openxmlformats.org/drawingml/2006/main">
               <a:ext uri="{FF2B5EF4-FFF2-40B4-BE49-F238E27FC236}">
-                <a16:creationId xmlns:a16="http://schemas.microsoft.com/office/drawing/2014/main" id="{354F0B55-0B54-41A8-9551-780B089F50E8}"/>
+                <a16:creationId xmlns:a16="http://schemas.microsoft.com/office/drawing/2014/main" id="{BD74CF22-4E94-4877-B486-80ECEDD05B5D}"/>
               </a:ext>
             </a:extLst>
           </p:cNvPr>
@@ -3687,7 +3687,7 @@
           <p:cNvPr id="30" name="">
             <a:extLst xmlns:a="http://schemas.openxmlformats.org/drawingml/2006/main">
               <a:ext uri="{FF2B5EF4-FFF2-40B4-BE49-F238E27FC236}">
-                <a16:creationId xmlns:a16="http://schemas.microsoft.com/office/drawing/2014/main" id="{EC70828A-7FAA-464B-9D2D-43180111DF68}"/>
+                <a16:creationId xmlns:a16="http://schemas.microsoft.com/office/drawing/2014/main" id="{D6A9DA99-7A5A-415A-8DB9-F09296199104}"/>
               </a:ext>
             </a:extLst>
           </p:cNvPr>
@@ -3718,7 +3718,7 @@
           <p:cNvPr id="31" name="">
             <a:extLst xmlns:a="http://schemas.openxmlformats.org/drawingml/2006/main">
               <a:ext uri="{FF2B5EF4-FFF2-40B4-BE49-F238E27FC236}">
-                <a16:creationId xmlns:a16="http://schemas.microsoft.com/office/drawing/2014/main" id="{4C0B97D6-9B23-4009-96C7-AD89A3C663F7}"/>
+                <a16:creationId xmlns:a16="http://schemas.microsoft.com/office/drawing/2014/main" id="{5FA9CB11-78E4-46A1-B724-E7B4785E49E7}"/>
               </a:ext>
             </a:extLst>
           </p:cNvPr>
@@ -3768,7 +3768,7 @@
           <p:cNvPr id="32" name="">
             <a:extLst xmlns:a="http://schemas.openxmlformats.org/drawingml/2006/main">
               <a:ext uri="{FF2B5EF4-FFF2-40B4-BE49-F238E27FC236}">
-                <a16:creationId xmlns:a16="http://schemas.microsoft.com/office/drawing/2014/main" id="{FF5A427E-24DA-4E40-BB03-549C1FAEBC98}"/>
+                <a16:creationId xmlns:a16="http://schemas.microsoft.com/office/drawing/2014/main" id="{D3E57390-BA4A-4D9E-AA91-D54A1D8B1CE6}"/>
               </a:ext>
             </a:extLst>
           </p:cNvPr>
@@ -3818,7 +3818,7 @@
           <p:cNvPr id="33" name="">
             <a:extLst xmlns:a="http://schemas.openxmlformats.org/drawingml/2006/main">
               <a:ext uri="{FF2B5EF4-FFF2-40B4-BE49-F238E27FC236}">
-                <a16:creationId xmlns:a16="http://schemas.microsoft.com/office/drawing/2014/main" id="{AFEE87E2-9BB5-40C6-8B5B-A3F375D48E9A}"/>
+                <a16:creationId xmlns:a16="http://schemas.microsoft.com/office/drawing/2014/main" id="{FA0946E1-38E6-4B21-85B6-C8C1AE7D656D}"/>
               </a:ext>
             </a:extLst>
           </p:cNvPr>
@@ -3866,7 +3866,7 @@
     </p:spTree>
     <p:extLst>
       <p:ext uri="{BB962C8B-B14F-4D97-AF65-F5344CB8AC3E}">
-        <p14:creationId xmlns:p14="http://schemas.microsoft.com/office/powerpoint/2010/main" val="1170439292"/>
+        <p14:creationId xmlns:p14="http://schemas.microsoft.com/office/powerpoint/2010/main" val="667052829"/>
       </p:ext>
     </p:extLst>
   </p:cSld>
@@ -3897,7 +3897,7 @@
           <p:cNvPr id="1" name="">
             <a:extLst xmlns:a="http://schemas.openxmlformats.org/drawingml/2006/main">
               <a:ext uri="{FF2B5EF4-FFF2-40B4-BE49-F238E27FC236}">
-                <a16:creationId xmlns:a16="http://schemas.microsoft.com/office/drawing/2014/main" id="{D575781F-A9C2-4787-B10B-0D252854799D}"/>
+                <a16:creationId xmlns:a16="http://schemas.microsoft.com/office/drawing/2014/main" id="{DD2F793D-83AA-48A6-BC73-AF6EA87F6DA1}"/>
               </a:ext>
             </a:extLst>
           </p:cNvPr>
@@ -3932,7 +3932,7 @@
           <p:nvPr/>
         </p:nvPicPr>
         <p:blipFill>
-          <a:blip xmlns:r="http://schemas.openxmlformats.org/officeDocument/2006/relationships" xmlns:a="http://schemas.openxmlformats.org/drawingml/2006/main" r:embed="R8fdfd7f799904102"/>
+          <a:blip xmlns:r="http://schemas.openxmlformats.org/officeDocument/2006/relationships" xmlns:a="http://schemas.openxmlformats.org/drawingml/2006/main" r:embed="Rc10e6052686541a0"/>
           <a:stretch xmlns:a="http://schemas.openxmlformats.org/drawingml/2006/main"/>
         </p:blipFill>
         <p:spPr>
@@ -3950,7 +3950,7 @@
           <p:cNvPr id="3" name="">
             <a:extLst xmlns:a="http://schemas.openxmlformats.org/drawingml/2006/main">
               <a:ext uri="{FF2B5EF4-FFF2-40B4-BE49-F238E27FC236}">
-                <a16:creationId xmlns:a16="http://schemas.microsoft.com/office/drawing/2014/main" id="{E02F054B-C460-40FF-A6B3-2C88E04EE742}"/>
+                <a16:creationId xmlns:a16="http://schemas.microsoft.com/office/drawing/2014/main" id="{42C9EBE1-791C-4E90-BB4E-A93C759F1E2A}"/>
               </a:ext>
             </a:extLst>
           </p:cNvPr>
@@ -4000,7 +4000,7 @@
           <p:cNvPr id="4" name="">
             <a:extLst xmlns:a="http://schemas.openxmlformats.org/drawingml/2006/main">
               <a:ext uri="{FF2B5EF4-FFF2-40B4-BE49-F238E27FC236}">
-                <a16:creationId xmlns:a16="http://schemas.microsoft.com/office/drawing/2014/main" id="{371E3211-E972-4FA4-A67A-37DEA072F9A9}"/>
+                <a16:creationId xmlns:a16="http://schemas.microsoft.com/office/drawing/2014/main" id="{C42F4299-4179-482F-A19B-2CEB83106F1E}"/>
               </a:ext>
             </a:extLst>
           </p:cNvPr>
@@ -4033,7 +4033,7 @@
           <p:cNvPr id="5" name="">
             <a:extLst xmlns:a="http://schemas.openxmlformats.org/drawingml/2006/main">
               <a:ext uri="{FF2B5EF4-FFF2-40B4-BE49-F238E27FC236}">
-                <a16:creationId xmlns:a16="http://schemas.microsoft.com/office/drawing/2014/main" id="{5017C176-0B6D-4458-B958-886558EA5FAC}"/>
+                <a16:creationId xmlns:a16="http://schemas.microsoft.com/office/drawing/2014/main" id="{D4E421B8-1E4D-4699-83DD-B2DA7E2B335E}"/>
               </a:ext>
             </a:extLst>
           </p:cNvPr>
@@ -4064,7 +4064,7 @@
           <p:cNvPr id="6" name="">
             <a:extLst xmlns:a="http://schemas.openxmlformats.org/drawingml/2006/main">
               <a:ext uri="{FF2B5EF4-FFF2-40B4-BE49-F238E27FC236}">
-                <a16:creationId xmlns:a16="http://schemas.microsoft.com/office/drawing/2014/main" id="{F8C30A59-30B4-46C4-99CF-7B80C8B41E10}"/>
+                <a16:creationId xmlns:a16="http://schemas.microsoft.com/office/drawing/2014/main" id="{A82EF018-4EAC-40C8-B7A7-D94B2ADA9E1D}"/>
               </a:ext>
             </a:extLst>
           </p:cNvPr>
@@ -4114,7 +4114,7 @@
           <p:cNvPr id="7" name="">
             <a:extLst xmlns:a="http://schemas.openxmlformats.org/drawingml/2006/main">
               <a:ext uri="{FF2B5EF4-FFF2-40B4-BE49-F238E27FC236}">
-                <a16:creationId xmlns:a16="http://schemas.microsoft.com/office/drawing/2014/main" id="{CF7CD4E5-33BC-42F7-AB7E-BDFC9B6F1F7F}"/>
+                <a16:creationId xmlns:a16="http://schemas.microsoft.com/office/drawing/2014/main" id="{5B5B65E5-A4C3-4115-975D-02FD4801557E}"/>
               </a:ext>
             </a:extLst>
           </p:cNvPr>
@@ -4164,7 +4164,7 @@
           <p:cNvPr id="8" name="">
             <a:extLst xmlns:a="http://schemas.openxmlformats.org/drawingml/2006/main">
               <a:ext uri="{FF2B5EF4-FFF2-40B4-BE49-F238E27FC236}">
-                <a16:creationId xmlns:a16="http://schemas.microsoft.com/office/drawing/2014/main" id="{BEDA2FD6-16AB-44E3-9EFD-9BEB6A225290}"/>
+                <a16:creationId xmlns:a16="http://schemas.microsoft.com/office/drawing/2014/main" id="{A4C9AFE7-0384-48D6-9C4A-032DC2D3C152}"/>
               </a:ext>
             </a:extLst>
           </p:cNvPr>
@@ -4214,7 +4214,7 @@
           <p:cNvPr id="9" name="">
             <a:extLst xmlns:a="http://schemas.openxmlformats.org/drawingml/2006/main">
               <a:ext uri="{FF2B5EF4-FFF2-40B4-BE49-F238E27FC236}">
-                <a16:creationId xmlns:a16="http://schemas.microsoft.com/office/drawing/2014/main" id="{5E17409D-ED99-48D1-A41E-0D290B016712}"/>
+                <a16:creationId xmlns:a16="http://schemas.microsoft.com/office/drawing/2014/main" id="{67420C6C-D66E-403C-864D-B2C8BAFA1C4B}"/>
               </a:ext>
             </a:extLst>
           </p:cNvPr>
@@ -4264,7 +4264,7 @@
           <p:cNvPr id="10" name="">
             <a:extLst xmlns:a="http://schemas.openxmlformats.org/drawingml/2006/main">
               <a:ext uri="{FF2B5EF4-FFF2-40B4-BE49-F238E27FC236}">
-                <a16:creationId xmlns:a16="http://schemas.microsoft.com/office/drawing/2014/main" id="{0E9C4987-C791-4D97-BA12-25BE18DA06A4}"/>
+                <a16:creationId xmlns:a16="http://schemas.microsoft.com/office/drawing/2014/main" id="{C9BDB7C1-5EED-4554-A1AD-A562072B822A}"/>
               </a:ext>
             </a:extLst>
           </p:cNvPr>
@@ -4314,7 +4314,7 @@
           <p:cNvPr id="11" name="">
             <a:extLst xmlns:a="http://schemas.openxmlformats.org/drawingml/2006/main">
               <a:ext uri="{FF2B5EF4-FFF2-40B4-BE49-F238E27FC236}">
-                <a16:creationId xmlns:a16="http://schemas.microsoft.com/office/drawing/2014/main" id="{2B62F2E4-CC1D-481C-BE0F-064892830549}"/>
+                <a16:creationId xmlns:a16="http://schemas.microsoft.com/office/drawing/2014/main" id="{92306D55-AA52-45DE-9351-397BF4A16942}"/>
               </a:ext>
             </a:extLst>
           </p:cNvPr>
@@ -4345,7 +4345,7 @@
           <p:cNvPr id="12" name="">
             <a:extLst xmlns:a="http://schemas.openxmlformats.org/drawingml/2006/main">
               <a:ext uri="{FF2B5EF4-FFF2-40B4-BE49-F238E27FC236}">
-                <a16:creationId xmlns:a16="http://schemas.microsoft.com/office/drawing/2014/main" id="{037B752D-0BB8-4259-903B-21528CD64B71}"/>
+                <a16:creationId xmlns:a16="http://schemas.microsoft.com/office/drawing/2014/main" id="{698595BC-9B88-4E38-B553-BBEF3D16CE33}"/>
               </a:ext>
             </a:extLst>
           </p:cNvPr>
@@ -4395,7 +4395,7 @@
           <p:cNvPr id="13" name="">
             <a:extLst xmlns:a="http://schemas.openxmlformats.org/drawingml/2006/main">
               <a:ext uri="{FF2B5EF4-FFF2-40B4-BE49-F238E27FC236}">
-                <a16:creationId xmlns:a16="http://schemas.microsoft.com/office/drawing/2014/main" id="{F059E6BE-F3B8-4C12-9A83-729125265E74}"/>
+                <a16:creationId xmlns:a16="http://schemas.microsoft.com/office/drawing/2014/main" id="{DAAF0D99-5EE0-480F-A8FE-F0B9C95E4E7C}"/>
               </a:ext>
             </a:extLst>
           </p:cNvPr>
@@ -4445,7 +4445,7 @@
           <p:cNvPr id="14" name="">
             <a:extLst xmlns:a="http://schemas.openxmlformats.org/drawingml/2006/main">
               <a:ext uri="{FF2B5EF4-FFF2-40B4-BE49-F238E27FC236}">
-                <a16:creationId xmlns:a16="http://schemas.microsoft.com/office/drawing/2014/main" id="{B26B58E3-1943-408D-9321-07B03B024E42}"/>
+                <a16:creationId xmlns:a16="http://schemas.microsoft.com/office/drawing/2014/main" id="{CACF825A-CD60-4817-8058-A0AC36B07CA8}"/>
               </a:ext>
             </a:extLst>
           </p:cNvPr>
@@ -4476,7 +4476,7 @@
           <p:cNvPr id="15" name="">
             <a:extLst xmlns:a="http://schemas.openxmlformats.org/drawingml/2006/main">
               <a:ext uri="{FF2B5EF4-FFF2-40B4-BE49-F238E27FC236}">
-                <a16:creationId xmlns:a16="http://schemas.microsoft.com/office/drawing/2014/main" id="{7684AB50-A3E0-4947-A621-5E0EA7EEB3C7}"/>
+                <a16:creationId xmlns:a16="http://schemas.microsoft.com/office/drawing/2014/main" id="{B364D5D4-20D1-4EA5-B6CD-9D5C88A8DF10}"/>
               </a:ext>
             </a:extLst>
           </p:cNvPr>
@@ -4526,7 +4526,7 @@
           <p:cNvPr id="16" name="">
             <a:extLst xmlns:a="http://schemas.openxmlformats.org/drawingml/2006/main">
               <a:ext uri="{FF2B5EF4-FFF2-40B4-BE49-F238E27FC236}">
-                <a16:creationId xmlns:a16="http://schemas.microsoft.com/office/drawing/2014/main" id="{78B0287E-E1AD-4A8D-985C-92370459DBE8}"/>
+                <a16:creationId xmlns:a16="http://schemas.microsoft.com/office/drawing/2014/main" id="{93E83DD5-D940-4E06-9A3D-0FABE9AB2AE8}"/>
               </a:ext>
             </a:extLst>
           </p:cNvPr>
@@ -4576,7 +4576,7 @@
           <p:cNvPr id="17" name="">
             <a:extLst xmlns:a="http://schemas.openxmlformats.org/drawingml/2006/main">
               <a:ext uri="{FF2B5EF4-FFF2-40B4-BE49-F238E27FC236}">
-                <a16:creationId xmlns:a16="http://schemas.microsoft.com/office/drawing/2014/main" id="{9AF6752F-6E8B-436B-9B74-12C323F24BD6}"/>
+                <a16:creationId xmlns:a16="http://schemas.microsoft.com/office/drawing/2014/main" id="{7AF2395B-1130-4BB1-ABE3-78B0643D5322}"/>
               </a:ext>
             </a:extLst>
           </p:cNvPr>
@@ -4607,7 +4607,7 @@
           <p:cNvPr id="18" name="">
             <a:extLst xmlns:a="http://schemas.openxmlformats.org/drawingml/2006/main">
               <a:ext uri="{FF2B5EF4-FFF2-40B4-BE49-F238E27FC236}">
-                <a16:creationId xmlns:a16="http://schemas.microsoft.com/office/drawing/2014/main" id="{19572A67-CF4B-4FA3-BC1B-3B7FEF36484A}"/>
+                <a16:creationId xmlns:a16="http://schemas.microsoft.com/office/drawing/2014/main" id="{F2A31BC7-D54E-4BD4-AD65-92A89CCDEDAB}"/>
               </a:ext>
             </a:extLst>
           </p:cNvPr>
@@ -4657,7 +4657,7 @@
           <p:cNvPr id="19" name="">
             <a:extLst xmlns:a="http://schemas.openxmlformats.org/drawingml/2006/main">
               <a:ext uri="{FF2B5EF4-FFF2-40B4-BE49-F238E27FC236}">
-                <a16:creationId xmlns:a16="http://schemas.microsoft.com/office/drawing/2014/main" id="{05DAAD97-E76E-4D42-B5AE-2C44BD72A3BC}"/>
+                <a16:creationId xmlns:a16="http://schemas.microsoft.com/office/drawing/2014/main" id="{2D67EC57-C545-4604-830D-AE6FD4C3BF3E}"/>
               </a:ext>
             </a:extLst>
           </p:cNvPr>
@@ -4705,7 +4705,7 @@
     </p:spTree>
     <p:extLst>
       <p:ext uri="{BB962C8B-B14F-4D97-AF65-F5344CB8AC3E}">
-        <p14:creationId xmlns:p14="http://schemas.microsoft.com/office/powerpoint/2010/main" val="79102955"/>
+        <p14:creationId xmlns:p14="http://schemas.microsoft.com/office/powerpoint/2010/main" val="601282642"/>
       </p:ext>
     </p:extLst>
   </p:cSld>
@@ -4736,7 +4736,7 @@
           <p:cNvPr id="1" name="">
             <a:extLst xmlns:a="http://schemas.openxmlformats.org/drawingml/2006/main">
               <a:ext uri="{FF2B5EF4-FFF2-40B4-BE49-F238E27FC236}">
-                <a16:creationId xmlns:a16="http://schemas.microsoft.com/office/drawing/2014/main" id="{DBBF6472-24CA-4963-BC5B-C54863DBC97F}"/>
+                <a16:creationId xmlns:a16="http://schemas.microsoft.com/office/drawing/2014/main" id="{90F9EB2A-BA0C-4515-9E01-D20F24ECE6FC}"/>
               </a:ext>
             </a:extLst>
           </p:cNvPr>
@@ -4771,7 +4771,7 @@
           <p:nvPr/>
         </p:nvPicPr>
         <p:blipFill>
-          <a:blip xmlns:r="http://schemas.openxmlformats.org/officeDocument/2006/relationships" xmlns:a="http://schemas.openxmlformats.org/drawingml/2006/main" r:embed="R9c3b4b4292c6492e"/>
+          <a:blip xmlns:r="http://schemas.openxmlformats.org/officeDocument/2006/relationships" xmlns:a="http://schemas.openxmlformats.org/drawingml/2006/main" r:embed="R3b608b44967442ff"/>
           <a:stretch xmlns:a="http://schemas.openxmlformats.org/drawingml/2006/main"/>
         </p:blipFill>
         <p:spPr>
@@ -4789,7 +4789,7 @@
           <p:cNvPr id="3" name="">
             <a:extLst xmlns:a="http://schemas.openxmlformats.org/drawingml/2006/main">
               <a:ext uri="{FF2B5EF4-FFF2-40B4-BE49-F238E27FC236}">
-                <a16:creationId xmlns:a16="http://schemas.microsoft.com/office/drawing/2014/main" id="{38F8FE3A-DC15-4715-9D09-2D481A2C29DF}"/>
+                <a16:creationId xmlns:a16="http://schemas.microsoft.com/office/drawing/2014/main" id="{310A4EAC-E58B-4B31-BA5B-E0D585048CC1}"/>
               </a:ext>
             </a:extLst>
           </p:cNvPr>
@@ -4839,7 +4839,7 @@
           <p:cNvPr id="4" name="">
             <a:extLst xmlns:a="http://schemas.openxmlformats.org/drawingml/2006/main">
               <a:ext uri="{FF2B5EF4-FFF2-40B4-BE49-F238E27FC236}">
-                <a16:creationId xmlns:a16="http://schemas.microsoft.com/office/drawing/2014/main" id="{9C3A7BE5-3F98-49D0-A913-924A4C7CF5DE}"/>
+                <a16:creationId xmlns:a16="http://schemas.microsoft.com/office/drawing/2014/main" id="{93895A08-C17C-4633-9A6B-097698C03E1B}"/>
               </a:ext>
             </a:extLst>
           </p:cNvPr>
@@ -4872,7 +4872,7 @@
           <p:cNvPr id="5" name="">
             <a:extLst xmlns:a="http://schemas.openxmlformats.org/drawingml/2006/main">
               <a:ext uri="{FF2B5EF4-FFF2-40B4-BE49-F238E27FC236}">
-                <a16:creationId xmlns:a16="http://schemas.microsoft.com/office/drawing/2014/main" id="{F99F953B-8E4E-4095-8871-07C44BF67417}"/>
+                <a16:creationId xmlns:a16="http://schemas.microsoft.com/office/drawing/2014/main" id="{86176C95-37D2-4C41-BBD2-111BE3A0C1B2}"/>
               </a:ext>
             </a:extLst>
           </p:cNvPr>
@@ -4903,7 +4903,7 @@
           <p:cNvPr id="6" name="">
             <a:extLst xmlns:a="http://schemas.openxmlformats.org/drawingml/2006/main">
               <a:ext uri="{FF2B5EF4-FFF2-40B4-BE49-F238E27FC236}">
-                <a16:creationId xmlns:a16="http://schemas.microsoft.com/office/drawing/2014/main" id="{E181245E-94EF-45EB-B1FB-876513B579D2}"/>
+                <a16:creationId xmlns:a16="http://schemas.microsoft.com/office/drawing/2014/main" id="{4BC64D7E-0AEE-481F-BA26-3BA8FCCD9B21}"/>
               </a:ext>
             </a:extLst>
           </p:cNvPr>
@@ -4953,7 +4953,7 @@
           <p:cNvPr id="7" name="">
             <a:extLst xmlns:a="http://schemas.openxmlformats.org/drawingml/2006/main">
               <a:ext uri="{FF2B5EF4-FFF2-40B4-BE49-F238E27FC236}">
-                <a16:creationId xmlns:a16="http://schemas.microsoft.com/office/drawing/2014/main" id="{948BC06C-8C20-4502-BF0B-2B05CCD8F53E}"/>
+                <a16:creationId xmlns:a16="http://schemas.microsoft.com/office/drawing/2014/main" id="{E1101E7F-81E6-4F4C-A6DB-1A8D113DD4E7}"/>
               </a:ext>
             </a:extLst>
           </p:cNvPr>
@@ -5003,7 +5003,7 @@
           <p:cNvPr id="8" name="">
             <a:extLst xmlns:a="http://schemas.openxmlformats.org/drawingml/2006/main">
               <a:ext uri="{FF2B5EF4-FFF2-40B4-BE49-F238E27FC236}">
-                <a16:creationId xmlns:a16="http://schemas.microsoft.com/office/drawing/2014/main" id="{A9885844-143A-4991-9B7D-3AE87DDCE6ED}"/>
+                <a16:creationId xmlns:a16="http://schemas.microsoft.com/office/drawing/2014/main" id="{A915637A-9CB7-4C49-A320-3B450EB64DCC}"/>
               </a:ext>
             </a:extLst>
           </p:cNvPr>
@@ -5038,7 +5038,7 @@
           <p:cNvPr id="9" name="">
             <a:extLst xmlns:a="http://schemas.openxmlformats.org/drawingml/2006/main">
               <a:ext uri="{FF2B5EF4-FFF2-40B4-BE49-F238E27FC236}">
-                <a16:creationId xmlns:a16="http://schemas.microsoft.com/office/drawing/2014/main" id="{653F32CA-40DA-4521-AA8A-F755E41318AA}"/>
+                <a16:creationId xmlns:a16="http://schemas.microsoft.com/office/drawing/2014/main" id="{6B176273-0B6F-41EB-8C95-46491BBF29A8}"/>
               </a:ext>
             </a:extLst>
           </p:cNvPr>
@@ -5088,7 +5088,7 @@
           <p:cNvPr id="10" name="">
             <a:extLst xmlns:a="http://schemas.openxmlformats.org/drawingml/2006/main">
               <a:ext uri="{FF2B5EF4-FFF2-40B4-BE49-F238E27FC236}">
-                <a16:creationId xmlns:a16="http://schemas.microsoft.com/office/drawing/2014/main" id="{22DE48D5-C0A5-4000-B6D8-94438FAF349A}"/>
+                <a16:creationId xmlns:a16="http://schemas.microsoft.com/office/drawing/2014/main" id="{395FA9E4-F3FF-4E4B-9461-C13B978A3533}"/>
               </a:ext>
             </a:extLst>
           </p:cNvPr>
@@ -5138,7 +5138,7 @@
           <p:cNvPr id="11" name="">
             <a:extLst xmlns:a="http://schemas.openxmlformats.org/drawingml/2006/main">
               <a:ext uri="{FF2B5EF4-FFF2-40B4-BE49-F238E27FC236}">
-                <a16:creationId xmlns:a16="http://schemas.microsoft.com/office/drawing/2014/main" id="{E2B0BC1D-438C-492D-ADBE-2C047C53632B}"/>
+                <a16:creationId xmlns:a16="http://schemas.microsoft.com/office/drawing/2014/main" id="{C6432D86-B693-42AD-8C85-397965202E3E}"/>
               </a:ext>
             </a:extLst>
           </p:cNvPr>
@@ -5173,7 +5173,7 @@
           <p:cNvPr id="12" name="">
             <a:extLst xmlns:a="http://schemas.openxmlformats.org/drawingml/2006/main">
               <a:ext uri="{FF2B5EF4-FFF2-40B4-BE49-F238E27FC236}">
-                <a16:creationId xmlns:a16="http://schemas.microsoft.com/office/drawing/2014/main" id="{A86C096F-4E78-43FB-BACF-DCBB47085CE2}"/>
+                <a16:creationId xmlns:a16="http://schemas.microsoft.com/office/drawing/2014/main" id="{17BCDBCA-4BC6-44E4-8901-EE2E3C22023F}"/>
               </a:ext>
             </a:extLst>
           </p:cNvPr>
@@ -5223,7 +5223,7 @@
           <p:cNvPr id="13" name="">
             <a:extLst xmlns:a="http://schemas.openxmlformats.org/drawingml/2006/main">
               <a:ext uri="{FF2B5EF4-FFF2-40B4-BE49-F238E27FC236}">
-                <a16:creationId xmlns:a16="http://schemas.microsoft.com/office/drawing/2014/main" id="{3CAFFC82-E80E-4BD2-9256-8A7DE5EDBC4F}"/>
+                <a16:creationId xmlns:a16="http://schemas.microsoft.com/office/drawing/2014/main" id="{115AFCDF-2BA5-4605-BD8B-23741D5966E0}"/>
               </a:ext>
             </a:extLst>
           </p:cNvPr>
@@ -5273,7 +5273,7 @@
           <p:cNvPr id="14" name="">
             <a:extLst xmlns:a="http://schemas.openxmlformats.org/drawingml/2006/main">
               <a:ext uri="{FF2B5EF4-FFF2-40B4-BE49-F238E27FC236}">
-                <a16:creationId xmlns:a16="http://schemas.microsoft.com/office/drawing/2014/main" id="{B2A84E13-8231-44C7-B999-3F3F483C2E3B}"/>
+                <a16:creationId xmlns:a16="http://schemas.microsoft.com/office/drawing/2014/main" id="{047E5471-61FF-42E0-9476-BD92EA4E95C8}"/>
               </a:ext>
             </a:extLst>
           </p:cNvPr>
@@ -5308,7 +5308,7 @@
           <p:cNvPr id="15" name="">
             <a:extLst xmlns:a="http://schemas.openxmlformats.org/drawingml/2006/main">
               <a:ext uri="{FF2B5EF4-FFF2-40B4-BE49-F238E27FC236}">
-                <a16:creationId xmlns:a16="http://schemas.microsoft.com/office/drawing/2014/main" id="{B1A2C628-8267-4C59-9186-8727C3F9E169}"/>
+                <a16:creationId xmlns:a16="http://schemas.microsoft.com/office/drawing/2014/main" id="{9F9F3B31-2C55-4BB2-ADEE-3BF6DA1A1084}"/>
               </a:ext>
             </a:extLst>
           </p:cNvPr>
@@ -5358,7 +5358,7 @@
           <p:cNvPr id="16" name="">
             <a:extLst xmlns:a="http://schemas.openxmlformats.org/drawingml/2006/main">
               <a:ext uri="{FF2B5EF4-FFF2-40B4-BE49-F238E27FC236}">
-                <a16:creationId xmlns:a16="http://schemas.microsoft.com/office/drawing/2014/main" id="{4C6927E8-9B2D-4E50-A365-BBEFFF468C83}"/>
+                <a16:creationId xmlns:a16="http://schemas.microsoft.com/office/drawing/2014/main" id="{6AC01FF7-B02A-4329-BE19-48245DCCD50A}"/>
               </a:ext>
             </a:extLst>
           </p:cNvPr>
@@ -5408,7 +5408,7 @@
           <p:cNvPr id="17" name="">
             <a:extLst xmlns:a="http://schemas.openxmlformats.org/drawingml/2006/main">
               <a:ext uri="{FF2B5EF4-FFF2-40B4-BE49-F238E27FC236}">
-                <a16:creationId xmlns:a16="http://schemas.microsoft.com/office/drawing/2014/main" id="{BDDFC20A-C3F6-4035-AB1C-EFC117BD4560}"/>
+                <a16:creationId xmlns:a16="http://schemas.microsoft.com/office/drawing/2014/main" id="{6AAF8E00-11E8-4BE4-B14E-C65D3C0AD5AB}"/>
               </a:ext>
             </a:extLst>
           </p:cNvPr>
@@ -5443,7 +5443,7 @@
           <p:cNvPr id="18" name="">
             <a:extLst xmlns:a="http://schemas.openxmlformats.org/drawingml/2006/main">
               <a:ext uri="{FF2B5EF4-FFF2-40B4-BE49-F238E27FC236}">
-                <a16:creationId xmlns:a16="http://schemas.microsoft.com/office/drawing/2014/main" id="{E7C9149D-5072-4E02-9CF2-99DE3D6C316A}"/>
+                <a16:creationId xmlns:a16="http://schemas.microsoft.com/office/drawing/2014/main" id="{43E41C8C-910D-4E7E-AEA4-C84C05A3CB84}"/>
               </a:ext>
             </a:extLst>
           </p:cNvPr>
@@ -5493,7 +5493,7 @@
           <p:cNvPr id="19" name="">
             <a:extLst xmlns:a="http://schemas.openxmlformats.org/drawingml/2006/main">
               <a:ext uri="{FF2B5EF4-FFF2-40B4-BE49-F238E27FC236}">
-                <a16:creationId xmlns:a16="http://schemas.microsoft.com/office/drawing/2014/main" id="{DE0C11E1-A581-4F72-9074-483FEEC9F630}"/>
+                <a16:creationId xmlns:a16="http://schemas.microsoft.com/office/drawing/2014/main" id="{19C47B47-BE62-4819-8A23-A73064AAABED}"/>
               </a:ext>
             </a:extLst>
           </p:cNvPr>
@@ -5543,7 +5543,7 @@
           <p:cNvPr id="20" name="">
             <a:extLst xmlns:a="http://schemas.openxmlformats.org/drawingml/2006/main">
               <a:ext uri="{FF2B5EF4-FFF2-40B4-BE49-F238E27FC236}">
-                <a16:creationId xmlns:a16="http://schemas.microsoft.com/office/drawing/2014/main" id="{67BCE147-A207-4C14-BED8-200056119BF1}"/>
+                <a16:creationId xmlns:a16="http://schemas.microsoft.com/office/drawing/2014/main" id="{AE9B836D-726C-4B3C-9B01-E2F593F30B50}"/>
               </a:ext>
             </a:extLst>
           </p:cNvPr>
@@ -5593,7 +5593,7 @@
           <p:cNvPr id="21" name="">
             <a:extLst xmlns:a="http://schemas.openxmlformats.org/drawingml/2006/main">
               <a:ext uri="{FF2B5EF4-FFF2-40B4-BE49-F238E27FC236}">
-                <a16:creationId xmlns:a16="http://schemas.microsoft.com/office/drawing/2014/main" id="{BC9A73BB-C64E-4B46-8380-4B7709B6B364}"/>
+                <a16:creationId xmlns:a16="http://schemas.microsoft.com/office/drawing/2014/main" id="{B474D450-F705-4546-AE49-CC427F5F30D7}"/>
               </a:ext>
             </a:extLst>
           </p:cNvPr>
@@ -5643,7 +5643,7 @@
           <p:cNvPr id="22" name="">
             <a:extLst xmlns:a="http://schemas.openxmlformats.org/drawingml/2006/main">
               <a:ext uri="{FF2B5EF4-FFF2-40B4-BE49-F238E27FC236}">
-                <a16:creationId xmlns:a16="http://schemas.microsoft.com/office/drawing/2014/main" id="{489C8707-95A1-4C70-BE4B-470D4AC084CD}"/>
+                <a16:creationId xmlns:a16="http://schemas.microsoft.com/office/drawing/2014/main" id="{FADB3A2F-7559-4C7F-B202-73738C0A1376}"/>
               </a:ext>
             </a:extLst>
           </p:cNvPr>
@@ -5693,7 +5693,7 @@
           <p:cNvPr id="23" name="">
             <a:extLst xmlns:a="http://schemas.openxmlformats.org/drawingml/2006/main">
               <a:ext uri="{FF2B5EF4-FFF2-40B4-BE49-F238E27FC236}">
-                <a16:creationId xmlns:a16="http://schemas.microsoft.com/office/drawing/2014/main" id="{CEC3D707-F914-4133-AE23-896C6F011E25}"/>
+                <a16:creationId xmlns:a16="http://schemas.microsoft.com/office/drawing/2014/main" id="{BAB6F36D-FABE-4458-B796-A8F94DC78DCB}"/>
               </a:ext>
             </a:extLst>
           </p:cNvPr>
@@ -5726,7 +5726,7 @@
           <p:cNvPr id="24" name="">
             <a:extLst xmlns:a="http://schemas.openxmlformats.org/drawingml/2006/main">
               <a:ext uri="{FF2B5EF4-FFF2-40B4-BE49-F238E27FC236}">
-                <a16:creationId xmlns:a16="http://schemas.microsoft.com/office/drawing/2014/main" id="{D6DBD709-0EE5-43FB-AB64-5E828BADF5D9}"/>
+                <a16:creationId xmlns:a16="http://schemas.microsoft.com/office/drawing/2014/main" id="{58ECF1CC-4DA8-43F5-9377-4F31BCEACF83}"/>
               </a:ext>
             </a:extLst>
           </p:cNvPr>
@@ -5776,7 +5776,7 @@
           <p:cNvPr id="25" name="">
             <a:extLst xmlns:a="http://schemas.openxmlformats.org/drawingml/2006/main">
               <a:ext uri="{FF2B5EF4-FFF2-40B4-BE49-F238E27FC236}">
-                <a16:creationId xmlns:a16="http://schemas.microsoft.com/office/drawing/2014/main" id="{B732594D-D3EF-4BB1-9297-2F188294E415}"/>
+                <a16:creationId xmlns:a16="http://schemas.microsoft.com/office/drawing/2014/main" id="{1C6757FD-65A5-4550-B3ED-C1364B6103C8}"/>
               </a:ext>
             </a:extLst>
           </p:cNvPr>
@@ -5826,7 +5826,7 @@
           <p:cNvPr id="26" name="">
             <a:extLst xmlns:a="http://schemas.openxmlformats.org/drawingml/2006/main">
               <a:ext uri="{FF2B5EF4-FFF2-40B4-BE49-F238E27FC236}">
-                <a16:creationId xmlns:a16="http://schemas.microsoft.com/office/drawing/2014/main" id="{9083A6B4-3470-4ED4-B032-C065ED707AB9}"/>
+                <a16:creationId xmlns:a16="http://schemas.microsoft.com/office/drawing/2014/main" id="{C4094728-F0C8-43A6-AB46-E0A43A1C93A7}"/>
               </a:ext>
             </a:extLst>
           </p:cNvPr>
@@ -5859,7 +5859,7 @@
           <p:cNvPr id="27" name="">
             <a:extLst xmlns:a="http://schemas.openxmlformats.org/drawingml/2006/main">
               <a:ext uri="{FF2B5EF4-FFF2-40B4-BE49-F238E27FC236}">
-                <a16:creationId xmlns:a16="http://schemas.microsoft.com/office/drawing/2014/main" id="{68456291-BF68-434F-9EC0-6D5F3F196123}"/>
+                <a16:creationId xmlns:a16="http://schemas.microsoft.com/office/drawing/2014/main" id="{A205BE41-C947-490E-A56B-C2DB31D0B60B}"/>
               </a:ext>
             </a:extLst>
           </p:cNvPr>
@@ -5909,7 +5909,7 @@
           <p:cNvPr id="28" name="">
             <a:extLst xmlns:a="http://schemas.openxmlformats.org/drawingml/2006/main">
               <a:ext uri="{FF2B5EF4-FFF2-40B4-BE49-F238E27FC236}">
-                <a16:creationId xmlns:a16="http://schemas.microsoft.com/office/drawing/2014/main" id="{98F65A14-6900-43F2-B12D-19125318709E}"/>
+                <a16:creationId xmlns:a16="http://schemas.microsoft.com/office/drawing/2014/main" id="{67326B29-0379-4BAB-A81C-A7D6BB3772D8}"/>
               </a:ext>
             </a:extLst>
           </p:cNvPr>
@@ -5959,7 +5959,7 @@
           <p:cNvPr id="29" name="">
             <a:extLst xmlns:a="http://schemas.openxmlformats.org/drawingml/2006/main">
               <a:ext uri="{FF2B5EF4-FFF2-40B4-BE49-F238E27FC236}">
-                <a16:creationId xmlns:a16="http://schemas.microsoft.com/office/drawing/2014/main" id="{C4B8DEDE-09C9-44F8-8F5D-ABF4B62B87B7}"/>
+                <a16:creationId xmlns:a16="http://schemas.microsoft.com/office/drawing/2014/main" id="{2BE931C2-5ED1-4C14-9C0B-1A811317D8B5}"/>
               </a:ext>
             </a:extLst>
           </p:cNvPr>
@@ -5992,7 +5992,7 @@
           <p:cNvPr id="30" name="">
             <a:extLst xmlns:a="http://schemas.openxmlformats.org/drawingml/2006/main">
               <a:ext uri="{FF2B5EF4-FFF2-40B4-BE49-F238E27FC236}">
-                <a16:creationId xmlns:a16="http://schemas.microsoft.com/office/drawing/2014/main" id="{0B7F9A80-E2E3-4538-8F3A-2452DADA7745}"/>
+                <a16:creationId xmlns:a16="http://schemas.microsoft.com/office/drawing/2014/main" id="{2AA2FB37-E581-4919-950D-06FDF6826E68}"/>
               </a:ext>
             </a:extLst>
           </p:cNvPr>
@@ -6042,7 +6042,7 @@
           <p:cNvPr id="31" name="">
             <a:extLst xmlns:a="http://schemas.openxmlformats.org/drawingml/2006/main">
               <a:ext uri="{FF2B5EF4-FFF2-40B4-BE49-F238E27FC236}">
-                <a16:creationId xmlns:a16="http://schemas.microsoft.com/office/drawing/2014/main" id="{DC03A88E-8420-4761-9716-582126D71318}"/>
+                <a16:creationId xmlns:a16="http://schemas.microsoft.com/office/drawing/2014/main" id="{9F4923DD-5FDE-4678-BF86-80E0EFD4FE3C}"/>
               </a:ext>
             </a:extLst>
           </p:cNvPr>
@@ -6090,7 +6090,7 @@
     </p:spTree>
     <p:extLst>
       <p:ext uri="{BB962C8B-B14F-4D97-AF65-F5344CB8AC3E}">
-        <p14:creationId xmlns:p14="http://schemas.microsoft.com/office/powerpoint/2010/main" val="1248014869"/>
+        <p14:creationId xmlns:p14="http://schemas.microsoft.com/office/powerpoint/2010/main" val="1176172675"/>
       </p:ext>
     </p:extLst>
   </p:cSld>
@@ -6121,7 +6121,7 @@
           <p:cNvPr id="1" name="">
             <a:extLst xmlns:a="http://schemas.openxmlformats.org/drawingml/2006/main">
               <a:ext uri="{FF2B5EF4-FFF2-40B4-BE49-F238E27FC236}">
-                <a16:creationId xmlns:a16="http://schemas.microsoft.com/office/drawing/2014/main" id="{C162980B-EBAF-4653-B9D7-D10CB90EB629}"/>
+                <a16:creationId xmlns:a16="http://schemas.microsoft.com/office/drawing/2014/main" id="{48833123-3AE7-4FC9-ADFB-0ADBCD51F221}"/>
               </a:ext>
             </a:extLst>
           </p:cNvPr>
@@ -6156,7 +6156,7 @@
           <p:nvPr/>
         </p:nvPicPr>
         <p:blipFill>
-          <a:blip xmlns:r="http://schemas.openxmlformats.org/officeDocument/2006/relationships" xmlns:a="http://schemas.openxmlformats.org/drawingml/2006/main" r:embed="R8e94366b9a0242ca"/>
+          <a:blip xmlns:r="http://schemas.openxmlformats.org/officeDocument/2006/relationships" xmlns:a="http://schemas.openxmlformats.org/drawingml/2006/main" r:embed="Rba08c0dd1feb466d"/>
           <a:stretch xmlns:a="http://schemas.openxmlformats.org/drawingml/2006/main"/>
         </p:blipFill>
         <p:spPr>
@@ -6174,7 +6174,7 @@
           <p:cNvPr id="3" name="">
             <a:extLst xmlns:a="http://schemas.openxmlformats.org/drawingml/2006/main">
               <a:ext uri="{FF2B5EF4-FFF2-40B4-BE49-F238E27FC236}">
-                <a16:creationId xmlns:a16="http://schemas.microsoft.com/office/drawing/2014/main" id="{1C18BBFF-7FC0-4BF1-8CCC-87E03ED85068}"/>
+                <a16:creationId xmlns:a16="http://schemas.microsoft.com/office/drawing/2014/main" id="{E8A9FE63-84A1-4A98-AA79-6E3B4BC3BDA7}"/>
               </a:ext>
             </a:extLst>
           </p:cNvPr>
@@ -6224,7 +6224,7 @@
           <p:cNvPr id="4" name="">
             <a:extLst xmlns:a="http://schemas.openxmlformats.org/drawingml/2006/main">
               <a:ext uri="{FF2B5EF4-FFF2-40B4-BE49-F238E27FC236}">
-                <a16:creationId xmlns:a16="http://schemas.microsoft.com/office/drawing/2014/main" id="{E5EB4426-9622-4F84-B14A-09CCD5647ED5}"/>
+                <a16:creationId xmlns:a16="http://schemas.microsoft.com/office/drawing/2014/main" id="{AA058598-A3D1-4C23-A2DC-444B5E3C2186}"/>
               </a:ext>
             </a:extLst>
           </p:cNvPr>
@@ -6257,7 +6257,7 @@
           <p:cNvPr id="5" name="">
             <a:extLst xmlns:a="http://schemas.openxmlformats.org/drawingml/2006/main">
               <a:ext uri="{FF2B5EF4-FFF2-40B4-BE49-F238E27FC236}">
-                <a16:creationId xmlns:a16="http://schemas.microsoft.com/office/drawing/2014/main" id="{6D84C630-D0EA-4AB8-97FC-C41E495CC446}"/>
+                <a16:creationId xmlns:a16="http://schemas.microsoft.com/office/drawing/2014/main" id="{3853FF94-74D5-4059-A77A-92C9F39A085A}"/>
               </a:ext>
             </a:extLst>
           </p:cNvPr>
@@ -6288,7 +6288,7 @@
           <p:cNvPr id="6" name="">
             <a:extLst xmlns:a="http://schemas.openxmlformats.org/drawingml/2006/main">
               <a:ext uri="{FF2B5EF4-FFF2-40B4-BE49-F238E27FC236}">
-                <a16:creationId xmlns:a16="http://schemas.microsoft.com/office/drawing/2014/main" id="{95FE119D-08D5-44C6-A618-E89BB74D9B1D}"/>
+                <a16:creationId xmlns:a16="http://schemas.microsoft.com/office/drawing/2014/main" id="{1828387F-2D11-4E6B-BEFB-9EB40CD7D5EC}"/>
               </a:ext>
             </a:extLst>
           </p:cNvPr>
@@ -6338,7 +6338,7 @@
           <p:cNvPr id="7" name="">
             <a:extLst xmlns:a="http://schemas.openxmlformats.org/drawingml/2006/main">
               <a:ext uri="{FF2B5EF4-FFF2-40B4-BE49-F238E27FC236}">
-                <a16:creationId xmlns:a16="http://schemas.microsoft.com/office/drawing/2014/main" id="{DD726EC6-E25A-47BD-9187-58976966EF0C}"/>
+                <a16:creationId xmlns:a16="http://schemas.microsoft.com/office/drawing/2014/main" id="{DC6338BC-BDFA-4CF1-8B20-9DEAAF9FC5F3}"/>
               </a:ext>
             </a:extLst>
           </p:cNvPr>
@@ -6388,7 +6388,7 @@
           <p:cNvPr id="8" name="">
             <a:extLst xmlns:a="http://schemas.openxmlformats.org/drawingml/2006/main">
               <a:ext uri="{FF2B5EF4-FFF2-40B4-BE49-F238E27FC236}">
-                <a16:creationId xmlns:a16="http://schemas.microsoft.com/office/drawing/2014/main" id="{E6E20E81-AD23-46CD-8411-62FEA7F5BF16}"/>
+                <a16:creationId xmlns:a16="http://schemas.microsoft.com/office/drawing/2014/main" id="{A5FED42C-CB6F-480E-A70A-D1F9BF2A65CF}"/>
               </a:ext>
             </a:extLst>
           </p:cNvPr>
@@ -6421,7 +6421,7 @@
           <p:cNvPr id="9" name="">
             <a:extLst xmlns:a="http://schemas.openxmlformats.org/drawingml/2006/main">
               <a:ext uri="{FF2B5EF4-FFF2-40B4-BE49-F238E27FC236}">
-                <a16:creationId xmlns:a16="http://schemas.microsoft.com/office/drawing/2014/main" id="{A54A2BBC-088A-40CD-9052-1D30C8797EB3}"/>
+                <a16:creationId xmlns:a16="http://schemas.microsoft.com/office/drawing/2014/main" id="{E4E63278-0A6E-4F92-BF3B-86EEDFCDAA8E}"/>
               </a:ext>
             </a:extLst>
           </p:cNvPr>
@@ -6471,7 +6471,7 @@
           <p:cNvPr id="10" name="">
             <a:extLst xmlns:a="http://schemas.openxmlformats.org/drawingml/2006/main">
               <a:ext uri="{FF2B5EF4-FFF2-40B4-BE49-F238E27FC236}">
-                <a16:creationId xmlns:a16="http://schemas.microsoft.com/office/drawing/2014/main" id="{8F0EA229-1F86-4162-8C7F-7F7F49969155}"/>
+                <a16:creationId xmlns:a16="http://schemas.microsoft.com/office/drawing/2014/main" id="{AE0580B6-CC7C-43C9-BE5F-367ABD5D6CFF}"/>
               </a:ext>
             </a:extLst>
           </p:cNvPr>
@@ -6521,7 +6521,7 @@
           <p:cNvPr id="11" name="">
             <a:extLst xmlns:a="http://schemas.openxmlformats.org/drawingml/2006/main">
               <a:ext uri="{FF2B5EF4-FFF2-40B4-BE49-F238E27FC236}">
-                <a16:creationId xmlns:a16="http://schemas.microsoft.com/office/drawing/2014/main" id="{BAB421CE-D08B-4192-964F-D5CC1C9E7C7D}"/>
+                <a16:creationId xmlns:a16="http://schemas.microsoft.com/office/drawing/2014/main" id="{0DFE710B-5797-4520-B7DA-CE9F180B87BD}"/>
               </a:ext>
             </a:extLst>
           </p:cNvPr>
@@ -6571,7 +6571,7 @@
           <p:cNvPr id="12" name="">
             <a:extLst xmlns:a="http://schemas.openxmlformats.org/drawingml/2006/main">
               <a:ext uri="{FF2B5EF4-FFF2-40B4-BE49-F238E27FC236}">
-                <a16:creationId xmlns:a16="http://schemas.microsoft.com/office/drawing/2014/main" id="{EC457D01-8D59-4A6A-B4B8-9885D4032CD2}"/>
+                <a16:creationId xmlns:a16="http://schemas.microsoft.com/office/drawing/2014/main" id="{8592FB1D-46B9-4BCF-8EDE-4C7548867295}"/>
               </a:ext>
             </a:extLst>
           </p:cNvPr>
@@ -6621,7 +6621,7 @@
           <p:cNvPr id="13" name="">
             <a:extLst xmlns:a="http://schemas.openxmlformats.org/drawingml/2006/main">
               <a:ext uri="{FF2B5EF4-FFF2-40B4-BE49-F238E27FC236}">
-                <a16:creationId xmlns:a16="http://schemas.microsoft.com/office/drawing/2014/main" id="{F4CE8147-421B-46EB-8990-555475A9F132}"/>
+                <a16:creationId xmlns:a16="http://schemas.microsoft.com/office/drawing/2014/main" id="{C4380464-D27C-484E-9D31-6F814A931544}"/>
               </a:ext>
             </a:extLst>
           </p:cNvPr>
@@ -6671,7 +6671,7 @@
           <p:cNvPr id="14" name="">
             <a:extLst xmlns:a="http://schemas.openxmlformats.org/drawingml/2006/main">
               <a:ext uri="{FF2B5EF4-FFF2-40B4-BE49-F238E27FC236}">
-                <a16:creationId xmlns:a16="http://schemas.microsoft.com/office/drawing/2014/main" id="{157109FF-9B98-40DE-BC32-BC6CC73D9930}"/>
+                <a16:creationId xmlns:a16="http://schemas.microsoft.com/office/drawing/2014/main" id="{D9D07B57-CA13-4CC8-A750-E1C954FB5704}"/>
               </a:ext>
             </a:extLst>
           </p:cNvPr>
@@ -6702,7 +6702,7 @@
           <p:cNvPr id="15" name="">
             <a:extLst xmlns:a="http://schemas.openxmlformats.org/drawingml/2006/main">
               <a:ext uri="{FF2B5EF4-FFF2-40B4-BE49-F238E27FC236}">
-                <a16:creationId xmlns:a16="http://schemas.microsoft.com/office/drawing/2014/main" id="{3454C0A0-D63F-4278-9C45-FC6FC1038F4B}"/>
+                <a16:creationId xmlns:a16="http://schemas.microsoft.com/office/drawing/2014/main" id="{098C0F75-92C1-483B-BB24-A348D129CC04}"/>
               </a:ext>
             </a:extLst>
           </p:cNvPr>
@@ -6735,7 +6735,7 @@
           <p:cNvPr id="16" name="">
             <a:extLst xmlns:a="http://schemas.openxmlformats.org/drawingml/2006/main">
               <a:ext uri="{FF2B5EF4-FFF2-40B4-BE49-F238E27FC236}">
-                <a16:creationId xmlns:a16="http://schemas.microsoft.com/office/drawing/2014/main" id="{D90167AC-A9D1-45F6-B369-4ABCB7FB4FF1}"/>
+                <a16:creationId xmlns:a16="http://schemas.microsoft.com/office/drawing/2014/main" id="{05B04572-FA7A-4C9B-B05F-F4485F1592AA}"/>
               </a:ext>
             </a:extLst>
           </p:cNvPr>
@@ -6785,7 +6785,7 @@
           <p:cNvPr id="17" name="">
             <a:extLst xmlns:a="http://schemas.openxmlformats.org/drawingml/2006/main">
               <a:ext uri="{FF2B5EF4-FFF2-40B4-BE49-F238E27FC236}">
-                <a16:creationId xmlns:a16="http://schemas.microsoft.com/office/drawing/2014/main" id="{C24EE988-8240-427F-BBCF-FDFBFB463D6F}"/>
+                <a16:creationId xmlns:a16="http://schemas.microsoft.com/office/drawing/2014/main" id="{9E274D47-B7FE-4E99-B8D3-D428278F1C2E}"/>
               </a:ext>
             </a:extLst>
           </p:cNvPr>
@@ -6835,7 +6835,7 @@
           <p:cNvPr id="18" name="">
             <a:extLst xmlns:a="http://schemas.openxmlformats.org/drawingml/2006/main">
               <a:ext uri="{FF2B5EF4-FFF2-40B4-BE49-F238E27FC236}">
-                <a16:creationId xmlns:a16="http://schemas.microsoft.com/office/drawing/2014/main" id="{C73B0386-415F-49CA-AD33-9326177D89D4}"/>
+                <a16:creationId xmlns:a16="http://schemas.microsoft.com/office/drawing/2014/main" id="{8E34A355-4E6A-4914-89FE-E227BF8E5B73}"/>
               </a:ext>
             </a:extLst>
           </p:cNvPr>
@@ -6885,7 +6885,7 @@
           <p:cNvPr id="19" name="">
             <a:extLst xmlns:a="http://schemas.openxmlformats.org/drawingml/2006/main">
               <a:ext uri="{FF2B5EF4-FFF2-40B4-BE49-F238E27FC236}">
-                <a16:creationId xmlns:a16="http://schemas.microsoft.com/office/drawing/2014/main" id="{DBDEBE1B-3359-425F-AC3A-F5E51E8EC27E}"/>
+                <a16:creationId xmlns:a16="http://schemas.microsoft.com/office/drawing/2014/main" id="{4980C211-5DBB-464D-9074-6CB4722C31D9}"/>
               </a:ext>
             </a:extLst>
           </p:cNvPr>
@@ -6935,7 +6935,7 @@
           <p:cNvPr id="20" name="">
             <a:extLst xmlns:a="http://schemas.openxmlformats.org/drawingml/2006/main">
               <a:ext uri="{FF2B5EF4-FFF2-40B4-BE49-F238E27FC236}">
-                <a16:creationId xmlns:a16="http://schemas.microsoft.com/office/drawing/2014/main" id="{A4CE21BD-E29E-4E9C-B006-750E332BF66F}"/>
+                <a16:creationId xmlns:a16="http://schemas.microsoft.com/office/drawing/2014/main" id="{054E158A-1950-4C9D-84D4-06C514CB6E96}"/>
               </a:ext>
             </a:extLst>
           </p:cNvPr>
@@ -6985,7 +6985,7 @@
           <p:cNvPr id="21" name="">
             <a:extLst xmlns:a="http://schemas.openxmlformats.org/drawingml/2006/main">
               <a:ext uri="{FF2B5EF4-FFF2-40B4-BE49-F238E27FC236}">
-                <a16:creationId xmlns:a16="http://schemas.microsoft.com/office/drawing/2014/main" id="{20BFD0C5-1469-496A-B6B7-5F0184BEA2A8}"/>
+                <a16:creationId xmlns:a16="http://schemas.microsoft.com/office/drawing/2014/main" id="{03C8674D-EC03-496E-976B-F93CD5B26C7B}"/>
               </a:ext>
             </a:extLst>
           </p:cNvPr>
@@ -7016,7 +7016,7 @@
           <p:cNvPr id="22" name="">
             <a:extLst xmlns:a="http://schemas.openxmlformats.org/drawingml/2006/main">
               <a:ext uri="{FF2B5EF4-FFF2-40B4-BE49-F238E27FC236}">
-                <a16:creationId xmlns:a16="http://schemas.microsoft.com/office/drawing/2014/main" id="{8CE0B9BB-CB0E-44C7-A5BA-F34179445499}"/>
+                <a16:creationId xmlns:a16="http://schemas.microsoft.com/office/drawing/2014/main" id="{4F8D9284-9902-4F4F-9786-176EFDC71E0C}"/>
               </a:ext>
             </a:extLst>
           </p:cNvPr>
@@ -7049,7 +7049,7 @@
           <p:cNvPr id="23" name="">
             <a:extLst xmlns:a="http://schemas.openxmlformats.org/drawingml/2006/main">
               <a:ext uri="{FF2B5EF4-FFF2-40B4-BE49-F238E27FC236}">
-                <a16:creationId xmlns:a16="http://schemas.microsoft.com/office/drawing/2014/main" id="{161E7F11-3A6B-4C7F-929D-19E6FB453739}"/>
+                <a16:creationId xmlns:a16="http://schemas.microsoft.com/office/drawing/2014/main" id="{F13A99AF-FC0D-434E-A5C4-366168F00045}"/>
               </a:ext>
             </a:extLst>
           </p:cNvPr>
@@ -7099,7 +7099,7 @@
           <p:cNvPr id="24" name="">
             <a:extLst xmlns:a="http://schemas.openxmlformats.org/drawingml/2006/main">
               <a:ext uri="{FF2B5EF4-FFF2-40B4-BE49-F238E27FC236}">
-                <a16:creationId xmlns:a16="http://schemas.microsoft.com/office/drawing/2014/main" id="{F78DEA02-F3AD-4768-8C03-665247B2052B}"/>
+                <a16:creationId xmlns:a16="http://schemas.microsoft.com/office/drawing/2014/main" id="{E6DC3C27-FFFE-472D-9B72-51460A25E0FA}"/>
               </a:ext>
             </a:extLst>
           </p:cNvPr>
@@ -7149,7 +7149,7 @@
           <p:cNvPr id="25" name="">
             <a:extLst xmlns:a="http://schemas.openxmlformats.org/drawingml/2006/main">
               <a:ext uri="{FF2B5EF4-FFF2-40B4-BE49-F238E27FC236}">
-                <a16:creationId xmlns:a16="http://schemas.microsoft.com/office/drawing/2014/main" id="{00A85718-726C-413A-B0C5-311C591DE0D2}"/>
+                <a16:creationId xmlns:a16="http://schemas.microsoft.com/office/drawing/2014/main" id="{0E69DE02-80F6-44CD-A3FA-F11DB06CAA3E}"/>
               </a:ext>
             </a:extLst>
           </p:cNvPr>
@@ -7199,7 +7199,7 @@
           <p:cNvPr id="26" name="">
             <a:extLst xmlns:a="http://schemas.openxmlformats.org/drawingml/2006/main">
               <a:ext uri="{FF2B5EF4-FFF2-40B4-BE49-F238E27FC236}">
-                <a16:creationId xmlns:a16="http://schemas.microsoft.com/office/drawing/2014/main" id="{6BB3A2F2-796B-42CB-9B56-2B9B72F62A92}"/>
+                <a16:creationId xmlns:a16="http://schemas.microsoft.com/office/drawing/2014/main" id="{E295D70A-20A6-43D8-B0CC-C9C6B52794F0}"/>
               </a:ext>
             </a:extLst>
           </p:cNvPr>
@@ -7249,7 +7249,7 @@
           <p:cNvPr id="27" name="">
             <a:extLst xmlns:a="http://schemas.openxmlformats.org/drawingml/2006/main">
               <a:ext uri="{FF2B5EF4-FFF2-40B4-BE49-F238E27FC236}">
-                <a16:creationId xmlns:a16="http://schemas.microsoft.com/office/drawing/2014/main" id="{D705CB99-70E0-4EFC-ADF0-94A2ADE8CC09}"/>
+                <a16:creationId xmlns:a16="http://schemas.microsoft.com/office/drawing/2014/main" id="{A5D04B8B-04DC-4C48-8659-57EB1941B765}"/>
               </a:ext>
             </a:extLst>
           </p:cNvPr>
@@ -7299,7 +7299,7 @@
           <p:cNvPr id="28" name="">
             <a:extLst xmlns:a="http://schemas.openxmlformats.org/drawingml/2006/main">
               <a:ext uri="{FF2B5EF4-FFF2-40B4-BE49-F238E27FC236}">
-                <a16:creationId xmlns:a16="http://schemas.microsoft.com/office/drawing/2014/main" id="{ED281430-0C99-4637-A2A8-BBB3A42A7DDC}"/>
+                <a16:creationId xmlns:a16="http://schemas.microsoft.com/office/drawing/2014/main" id="{9BDB66AE-089F-4FD5-B31E-47F07DEFCDAC}"/>
               </a:ext>
             </a:extLst>
           </p:cNvPr>
@@ -7330,7 +7330,7 @@
           <p:cNvPr id="29" name="">
             <a:extLst xmlns:a="http://schemas.openxmlformats.org/drawingml/2006/main">
               <a:ext uri="{FF2B5EF4-FFF2-40B4-BE49-F238E27FC236}">
-                <a16:creationId xmlns:a16="http://schemas.microsoft.com/office/drawing/2014/main" id="{57E5DD79-9BA1-42C0-8C49-288F62803988}"/>
+                <a16:creationId xmlns:a16="http://schemas.microsoft.com/office/drawing/2014/main" id="{5F3F2163-19A5-4C57-813F-D30BC8C2B548}"/>
               </a:ext>
             </a:extLst>
           </p:cNvPr>
@@ -7363,7 +7363,7 @@
           <p:cNvPr id="30" name="">
             <a:extLst xmlns:a="http://schemas.openxmlformats.org/drawingml/2006/main">
               <a:ext uri="{FF2B5EF4-FFF2-40B4-BE49-F238E27FC236}">
-                <a16:creationId xmlns:a16="http://schemas.microsoft.com/office/drawing/2014/main" id="{D59C70DA-A6A3-4926-87B7-3675496D7048}"/>
+                <a16:creationId xmlns:a16="http://schemas.microsoft.com/office/drawing/2014/main" id="{7B42FA55-A643-43A6-BB1E-A040381214E5}"/>
               </a:ext>
             </a:extLst>
           </p:cNvPr>
@@ -7413,7 +7413,7 @@
           <p:cNvPr id="31" name="">
             <a:extLst xmlns:a="http://schemas.openxmlformats.org/drawingml/2006/main">
               <a:ext uri="{FF2B5EF4-FFF2-40B4-BE49-F238E27FC236}">
-                <a16:creationId xmlns:a16="http://schemas.microsoft.com/office/drawing/2014/main" id="{6447E14E-C317-4600-9762-DB809A08F9F1}"/>
+                <a16:creationId xmlns:a16="http://schemas.microsoft.com/office/drawing/2014/main" id="{CCE9DE54-C924-417B-AA31-194FFCE0E426}"/>
               </a:ext>
             </a:extLst>
           </p:cNvPr>
@@ -7463,7 +7463,7 @@
           <p:cNvPr id="32" name="">
             <a:extLst xmlns:a="http://schemas.openxmlformats.org/drawingml/2006/main">
               <a:ext uri="{FF2B5EF4-FFF2-40B4-BE49-F238E27FC236}">
-                <a16:creationId xmlns:a16="http://schemas.microsoft.com/office/drawing/2014/main" id="{5DD63B95-EBB7-482A-8E02-D92B674EC88D}"/>
+                <a16:creationId xmlns:a16="http://schemas.microsoft.com/office/drawing/2014/main" id="{3CD6C1FA-09C4-4300-8BBA-C78AC9BF68CA}"/>
               </a:ext>
             </a:extLst>
           </p:cNvPr>
@@ -7513,7 +7513,7 @@
           <p:cNvPr id="33" name="">
             <a:extLst xmlns:a="http://schemas.openxmlformats.org/drawingml/2006/main">
               <a:ext uri="{FF2B5EF4-FFF2-40B4-BE49-F238E27FC236}">
-                <a16:creationId xmlns:a16="http://schemas.microsoft.com/office/drawing/2014/main" id="{A71BA078-B292-4428-853B-DA54E8FD1E6E}"/>
+                <a16:creationId xmlns:a16="http://schemas.microsoft.com/office/drawing/2014/main" id="{7F7E1E85-5E58-4072-A66D-DCB2D67C0906}"/>
               </a:ext>
             </a:extLst>
           </p:cNvPr>
@@ -7563,7 +7563,7 @@
           <p:cNvPr id="34" name="">
             <a:extLst xmlns:a="http://schemas.openxmlformats.org/drawingml/2006/main">
               <a:ext uri="{FF2B5EF4-FFF2-40B4-BE49-F238E27FC236}">
-                <a16:creationId xmlns:a16="http://schemas.microsoft.com/office/drawing/2014/main" id="{FE76687A-0A0E-4C82-B1A5-1BBBF1BBAFC9}"/>
+                <a16:creationId xmlns:a16="http://schemas.microsoft.com/office/drawing/2014/main" id="{F8BD62FC-4456-43BB-9D67-7DCC4CA31599}"/>
               </a:ext>
             </a:extLst>
           </p:cNvPr>
@@ -7611,7 +7611,7 @@
     </p:spTree>
     <p:extLst>
       <p:ext uri="{BB962C8B-B14F-4D97-AF65-F5344CB8AC3E}">
-        <p14:creationId xmlns:p14="http://schemas.microsoft.com/office/powerpoint/2010/main" val="760516806"/>
+        <p14:creationId xmlns:p14="http://schemas.microsoft.com/office/powerpoint/2010/main" val="1447540326"/>
       </p:ext>
     </p:extLst>
   </p:cSld>
@@ -7642,7 +7642,7 @@
           <p:cNvPr id="1" name="">
             <a:extLst xmlns:a="http://schemas.openxmlformats.org/drawingml/2006/main">
               <a:ext uri="{FF2B5EF4-FFF2-40B4-BE49-F238E27FC236}">
-                <a16:creationId xmlns:a16="http://schemas.microsoft.com/office/drawing/2014/main" id="{EACD4B50-0031-4029-9103-520F5DDA4EBA}"/>
+                <a16:creationId xmlns:a16="http://schemas.microsoft.com/office/drawing/2014/main" id="{FD1D36F2-9C74-40F7-A589-636EBAD3F7B6}"/>
               </a:ext>
             </a:extLst>
           </p:cNvPr>
@@ -7677,7 +7677,7 @@
           <p:nvPr/>
         </p:nvPicPr>
         <p:blipFill>
-          <a:blip xmlns:r="http://schemas.openxmlformats.org/officeDocument/2006/relationships" xmlns:a="http://schemas.openxmlformats.org/drawingml/2006/main" r:embed="Rf91210db05ee4f02"/>
+          <a:blip xmlns:r="http://schemas.openxmlformats.org/officeDocument/2006/relationships" xmlns:a="http://schemas.openxmlformats.org/drawingml/2006/main" r:embed="R8794afc07a1e462b"/>
           <a:stretch xmlns:a="http://schemas.openxmlformats.org/drawingml/2006/main"/>
         </p:blipFill>
         <p:spPr>
@@ -7695,7 +7695,7 @@
           <p:cNvPr id="3" name="">
             <a:extLst xmlns:a="http://schemas.openxmlformats.org/drawingml/2006/main">
               <a:ext uri="{FF2B5EF4-FFF2-40B4-BE49-F238E27FC236}">
-                <a16:creationId xmlns:a16="http://schemas.microsoft.com/office/drawing/2014/main" id="{074FBBF3-0D73-4A4C-9B81-6120EC8E7FAB}"/>
+                <a16:creationId xmlns:a16="http://schemas.microsoft.com/office/drawing/2014/main" id="{4EDD620F-B792-42A8-9458-57BFB9A1ED17}"/>
               </a:ext>
             </a:extLst>
           </p:cNvPr>
@@ -7745,7 +7745,7 @@
           <p:cNvPr id="4" name="">
             <a:extLst xmlns:a="http://schemas.openxmlformats.org/drawingml/2006/main">
               <a:ext uri="{FF2B5EF4-FFF2-40B4-BE49-F238E27FC236}">
-                <a16:creationId xmlns:a16="http://schemas.microsoft.com/office/drawing/2014/main" id="{2564B4FC-2319-448B-9879-007C265B83E5}"/>
+                <a16:creationId xmlns:a16="http://schemas.microsoft.com/office/drawing/2014/main" id="{3F0012EE-23B6-4756-961F-B77E6074B8F2}"/>
               </a:ext>
             </a:extLst>
           </p:cNvPr>
@@ -7778,7 +7778,7 @@
           <p:cNvPr id="5" name="">
             <a:extLst xmlns:a="http://schemas.openxmlformats.org/drawingml/2006/main">
               <a:ext uri="{FF2B5EF4-FFF2-40B4-BE49-F238E27FC236}">
-                <a16:creationId xmlns:a16="http://schemas.microsoft.com/office/drawing/2014/main" id="{6970F37E-46E1-408B-99F0-D8462B224008}"/>
+                <a16:creationId xmlns:a16="http://schemas.microsoft.com/office/drawing/2014/main" id="{1A73F8A7-E5B7-4592-8DF4-4E128C8F6834}"/>
               </a:ext>
             </a:extLst>
           </p:cNvPr>
@@ -7809,7 +7809,7 @@
           <p:cNvPr id="6" name="">
             <a:extLst xmlns:a="http://schemas.openxmlformats.org/drawingml/2006/main">
               <a:ext uri="{FF2B5EF4-FFF2-40B4-BE49-F238E27FC236}">
-                <a16:creationId xmlns:a16="http://schemas.microsoft.com/office/drawing/2014/main" id="{6AC3FCF6-550D-4EB8-B586-4E77B85F17E1}"/>
+                <a16:creationId xmlns:a16="http://schemas.microsoft.com/office/drawing/2014/main" id="{355E3EFF-3A37-4ABA-90AB-C05EB2B783FD}"/>
               </a:ext>
             </a:extLst>
           </p:cNvPr>
@@ -7859,7 +7859,7 @@
           <p:cNvPr id="7" name="">
             <a:extLst xmlns:a="http://schemas.openxmlformats.org/drawingml/2006/main">
               <a:ext uri="{FF2B5EF4-FFF2-40B4-BE49-F238E27FC236}">
-                <a16:creationId xmlns:a16="http://schemas.microsoft.com/office/drawing/2014/main" id="{3BFAB9F2-5EAC-4117-BA30-8A50FE3269DB}"/>
+                <a16:creationId xmlns:a16="http://schemas.microsoft.com/office/drawing/2014/main" id="{AA96BC2D-5FB5-4A93-AF6D-3711CD1BDBCA}"/>
               </a:ext>
             </a:extLst>
           </p:cNvPr>
@@ -7909,7 +7909,7 @@
           <p:cNvPr id="8" name="">
             <a:extLst xmlns:a="http://schemas.openxmlformats.org/drawingml/2006/main">
               <a:ext uri="{FF2B5EF4-FFF2-40B4-BE49-F238E27FC236}">
-                <a16:creationId xmlns:a16="http://schemas.microsoft.com/office/drawing/2014/main" id="{949E4DE0-44A1-4083-A9B6-B34F69162BEA}"/>
+                <a16:creationId xmlns:a16="http://schemas.microsoft.com/office/drawing/2014/main" id="{5C612B60-EAD7-4551-8842-E432C1088AB2}"/>
               </a:ext>
             </a:extLst>
           </p:cNvPr>
@@ -7944,7 +7944,7 @@
           <p:cNvPr id="9" name="">
             <a:extLst xmlns:a="http://schemas.openxmlformats.org/drawingml/2006/main">
               <a:ext uri="{FF2B5EF4-FFF2-40B4-BE49-F238E27FC236}">
-                <a16:creationId xmlns:a16="http://schemas.microsoft.com/office/drawing/2014/main" id="{0CBF31BA-3AA1-4E5E-A423-69CF556352A8}"/>
+                <a16:creationId xmlns:a16="http://schemas.microsoft.com/office/drawing/2014/main" id="{25C1739B-AAB3-4F46-B0F6-47DE6CFD7B89}"/>
               </a:ext>
             </a:extLst>
           </p:cNvPr>
@@ -7994,7 +7994,7 @@
           <p:cNvPr id="10" name="">
             <a:extLst xmlns:a="http://schemas.openxmlformats.org/drawingml/2006/main">
               <a:ext uri="{FF2B5EF4-FFF2-40B4-BE49-F238E27FC236}">
-                <a16:creationId xmlns:a16="http://schemas.microsoft.com/office/drawing/2014/main" id="{09378161-F34D-4E49-B306-7AA46645C00B}"/>
+                <a16:creationId xmlns:a16="http://schemas.microsoft.com/office/drawing/2014/main" id="{8A8A48DA-98D5-46B6-A85B-BD3BF8ABC220}"/>
               </a:ext>
             </a:extLst>
           </p:cNvPr>
@@ -8044,7 +8044,7 @@
           <p:cNvPr id="11" name="">
             <a:extLst xmlns:a="http://schemas.openxmlformats.org/drawingml/2006/main">
               <a:ext uri="{FF2B5EF4-FFF2-40B4-BE49-F238E27FC236}">
-                <a16:creationId xmlns:a16="http://schemas.microsoft.com/office/drawing/2014/main" id="{CFF97530-357E-42B4-845E-C3B5287BA8F9}"/>
+                <a16:creationId xmlns:a16="http://schemas.microsoft.com/office/drawing/2014/main" id="{A76C5239-6E79-469D-B7AF-019E79F7F397}"/>
               </a:ext>
             </a:extLst>
           </p:cNvPr>
@@ -8094,7 +8094,7 @@
           <p:cNvPr id="12" name="">
             <a:extLst xmlns:a="http://schemas.openxmlformats.org/drawingml/2006/main">
               <a:ext uri="{FF2B5EF4-FFF2-40B4-BE49-F238E27FC236}">
-                <a16:creationId xmlns:a16="http://schemas.microsoft.com/office/drawing/2014/main" id="{4840DF49-AD89-43C8-9938-DDF243D27E35}"/>
+                <a16:creationId xmlns:a16="http://schemas.microsoft.com/office/drawing/2014/main" id="{A1024642-4E4D-416F-A149-7276ABDCB3A9}"/>
               </a:ext>
             </a:extLst>
           </p:cNvPr>
@@ -8125,7 +8125,7 @@
           <p:cNvPr id="13" name="">
             <a:extLst xmlns:a="http://schemas.openxmlformats.org/drawingml/2006/main">
               <a:ext uri="{FF2B5EF4-FFF2-40B4-BE49-F238E27FC236}">
-                <a16:creationId xmlns:a16="http://schemas.microsoft.com/office/drawing/2014/main" id="{F012933B-E821-4D7B-81E8-018620347C2B}"/>
+                <a16:creationId xmlns:a16="http://schemas.microsoft.com/office/drawing/2014/main" id="{51476031-D341-4CE7-A79F-CC66EC362A2D}"/>
               </a:ext>
             </a:extLst>
           </p:cNvPr>
@@ -8175,7 +8175,7 @@
           <p:cNvPr id="14" name="">
             <a:extLst xmlns:a="http://schemas.openxmlformats.org/drawingml/2006/main">
               <a:ext uri="{FF2B5EF4-FFF2-40B4-BE49-F238E27FC236}">
-                <a16:creationId xmlns:a16="http://schemas.microsoft.com/office/drawing/2014/main" id="{42AAF263-7518-47A7-B0F9-DEDFD584A38B}"/>
+                <a16:creationId xmlns:a16="http://schemas.microsoft.com/office/drawing/2014/main" id="{5F6B94C9-8758-4483-82B2-F6566C9AE3B5}"/>
               </a:ext>
             </a:extLst>
           </p:cNvPr>
@@ -8225,7 +8225,7 @@
           <p:cNvPr id="15" name="">
             <a:extLst xmlns:a="http://schemas.openxmlformats.org/drawingml/2006/main">
               <a:ext uri="{FF2B5EF4-FFF2-40B4-BE49-F238E27FC236}">
-                <a16:creationId xmlns:a16="http://schemas.microsoft.com/office/drawing/2014/main" id="{06B8833E-9A52-4B99-B554-C35D21B442DA}"/>
+                <a16:creationId xmlns:a16="http://schemas.microsoft.com/office/drawing/2014/main" id="{5CDEF054-0844-4F51-81FF-AA07A53F2021}"/>
               </a:ext>
             </a:extLst>
           </p:cNvPr>
@@ -8275,7 +8275,7 @@
           <p:cNvPr id="16" name="">
             <a:extLst xmlns:a="http://schemas.openxmlformats.org/drawingml/2006/main">
               <a:ext uri="{FF2B5EF4-FFF2-40B4-BE49-F238E27FC236}">
-                <a16:creationId xmlns:a16="http://schemas.microsoft.com/office/drawing/2014/main" id="{7707536A-012C-4BB5-8BF4-722985FA8F12}"/>
+                <a16:creationId xmlns:a16="http://schemas.microsoft.com/office/drawing/2014/main" id="{20ADEB70-F931-4BFE-A4A3-04FC00658058}"/>
               </a:ext>
             </a:extLst>
           </p:cNvPr>
@@ -8325,7 +8325,7 @@
           <p:cNvPr id="17" name="">
             <a:extLst xmlns:a="http://schemas.openxmlformats.org/drawingml/2006/main">
               <a:ext uri="{FF2B5EF4-FFF2-40B4-BE49-F238E27FC236}">
-                <a16:creationId xmlns:a16="http://schemas.microsoft.com/office/drawing/2014/main" id="{B4FFA2CC-9D59-4A28-A7AF-AF6D40EBC6C5}"/>
+                <a16:creationId xmlns:a16="http://schemas.microsoft.com/office/drawing/2014/main" id="{4B08092C-19AC-4B38-B7AA-A6DE6CB9609D}"/>
               </a:ext>
             </a:extLst>
           </p:cNvPr>
@@ -8360,7 +8360,7 @@
           <p:cNvPr id="18" name="">
             <a:extLst xmlns:a="http://schemas.openxmlformats.org/drawingml/2006/main">
               <a:ext uri="{FF2B5EF4-FFF2-40B4-BE49-F238E27FC236}">
-                <a16:creationId xmlns:a16="http://schemas.microsoft.com/office/drawing/2014/main" id="{27A66984-0401-4DA1-8033-D0A386F2D720}"/>
+                <a16:creationId xmlns:a16="http://schemas.microsoft.com/office/drawing/2014/main" id="{4C736049-50F5-41D3-AEA9-A7D4FF327394}"/>
               </a:ext>
             </a:extLst>
           </p:cNvPr>
@@ -8410,7 +8410,7 @@
           <p:cNvPr id="19" name="">
             <a:extLst xmlns:a="http://schemas.openxmlformats.org/drawingml/2006/main">
               <a:ext uri="{FF2B5EF4-FFF2-40B4-BE49-F238E27FC236}">
-                <a16:creationId xmlns:a16="http://schemas.microsoft.com/office/drawing/2014/main" id="{AD1E1489-E24B-47E4-AA26-257AC7591F85}"/>
+                <a16:creationId xmlns:a16="http://schemas.microsoft.com/office/drawing/2014/main" id="{506A5F10-5C32-4D39-BAAD-1569780FAB50}"/>
               </a:ext>
             </a:extLst>
           </p:cNvPr>
@@ -8460,7 +8460,7 @@
           <p:cNvPr id="20" name="">
             <a:extLst xmlns:a="http://schemas.openxmlformats.org/drawingml/2006/main">
               <a:ext uri="{FF2B5EF4-FFF2-40B4-BE49-F238E27FC236}">
-                <a16:creationId xmlns:a16="http://schemas.microsoft.com/office/drawing/2014/main" id="{80F0013C-C7B7-4353-AA3B-3724BF426C3E}"/>
+                <a16:creationId xmlns:a16="http://schemas.microsoft.com/office/drawing/2014/main" id="{7BFCC068-BAD1-4CE3-9285-159E7E8F58F6}"/>
               </a:ext>
             </a:extLst>
           </p:cNvPr>
@@ -8510,7 +8510,7 @@
           <p:cNvPr id="21" name="">
             <a:extLst xmlns:a="http://schemas.openxmlformats.org/drawingml/2006/main">
               <a:ext uri="{FF2B5EF4-FFF2-40B4-BE49-F238E27FC236}">
-                <a16:creationId xmlns:a16="http://schemas.microsoft.com/office/drawing/2014/main" id="{06BB671B-5BCC-4FC9-8B39-45D95464A4FC}"/>
+                <a16:creationId xmlns:a16="http://schemas.microsoft.com/office/drawing/2014/main" id="{4D07F9D0-BD28-4010-A727-30CCD47DB6C1}"/>
               </a:ext>
             </a:extLst>
           </p:cNvPr>
@@ -8541,7 +8541,7 @@
           <p:cNvPr id="22" name="">
             <a:extLst xmlns:a="http://schemas.openxmlformats.org/drawingml/2006/main">
               <a:ext uri="{FF2B5EF4-FFF2-40B4-BE49-F238E27FC236}">
-                <a16:creationId xmlns:a16="http://schemas.microsoft.com/office/drawing/2014/main" id="{61CABCB2-DB86-47EF-AD14-28DA22D1BD73}"/>
+                <a16:creationId xmlns:a16="http://schemas.microsoft.com/office/drawing/2014/main" id="{4FEA612D-FC22-4437-B512-6737027E6185}"/>
               </a:ext>
             </a:extLst>
           </p:cNvPr>
@@ -8591,7 +8591,7 @@
           <p:cNvPr id="23" name="">
             <a:extLst xmlns:a="http://schemas.openxmlformats.org/drawingml/2006/main">
               <a:ext uri="{FF2B5EF4-FFF2-40B4-BE49-F238E27FC236}">
-                <a16:creationId xmlns:a16="http://schemas.microsoft.com/office/drawing/2014/main" id="{A8B6288F-90FC-42BD-9988-F33092C8105D}"/>
+                <a16:creationId xmlns:a16="http://schemas.microsoft.com/office/drawing/2014/main" id="{49502C39-DAAD-4ADD-9CE9-882FEE11A6DB}"/>
               </a:ext>
             </a:extLst>
           </p:cNvPr>
@@ -8641,7 +8641,7 @@
           <p:cNvPr id="24" name="">
             <a:extLst xmlns:a="http://schemas.openxmlformats.org/drawingml/2006/main">
               <a:ext uri="{FF2B5EF4-FFF2-40B4-BE49-F238E27FC236}">
-                <a16:creationId xmlns:a16="http://schemas.microsoft.com/office/drawing/2014/main" id="{14FA4F1D-E11A-475C-9697-73EC049800B6}"/>
+                <a16:creationId xmlns:a16="http://schemas.microsoft.com/office/drawing/2014/main" id="{97540792-BE0A-459F-906E-937F18FE222E}"/>
               </a:ext>
             </a:extLst>
           </p:cNvPr>
@@ -8691,7 +8691,7 @@
           <p:cNvPr id="25" name="">
             <a:extLst xmlns:a="http://schemas.openxmlformats.org/drawingml/2006/main">
               <a:ext uri="{FF2B5EF4-FFF2-40B4-BE49-F238E27FC236}">
-                <a16:creationId xmlns:a16="http://schemas.microsoft.com/office/drawing/2014/main" id="{47968AC9-93DD-4E25-8623-A239EF2C731E}"/>
+                <a16:creationId xmlns:a16="http://schemas.microsoft.com/office/drawing/2014/main" id="{7C65F979-A9AD-43D8-A8F4-368A2D423CC7}"/>
               </a:ext>
             </a:extLst>
           </p:cNvPr>
@@ -8741,7 +8741,7 @@
           <p:cNvPr id="26" name="">
             <a:extLst xmlns:a="http://schemas.openxmlformats.org/drawingml/2006/main">
               <a:ext uri="{FF2B5EF4-FFF2-40B4-BE49-F238E27FC236}">
-                <a16:creationId xmlns:a16="http://schemas.microsoft.com/office/drawing/2014/main" id="{7B13CBAB-36F2-434A-A99B-70F583FBA7DC}"/>
+                <a16:creationId xmlns:a16="http://schemas.microsoft.com/office/drawing/2014/main" id="{66964192-894C-4BC9-8EE8-6FE91AE92AC7}"/>
               </a:ext>
             </a:extLst>
           </p:cNvPr>
@@ -8776,7 +8776,7 @@
           <p:cNvPr id="27" name="">
             <a:extLst xmlns:a="http://schemas.openxmlformats.org/drawingml/2006/main">
               <a:ext uri="{FF2B5EF4-FFF2-40B4-BE49-F238E27FC236}">
-                <a16:creationId xmlns:a16="http://schemas.microsoft.com/office/drawing/2014/main" id="{C9D101E8-19E2-48A5-8EF8-73B11735EE7B}"/>
+                <a16:creationId xmlns:a16="http://schemas.microsoft.com/office/drawing/2014/main" id="{80D34DE6-6779-4AE2-8081-84A2110FF94E}"/>
               </a:ext>
             </a:extLst>
           </p:cNvPr>
@@ -8826,7 +8826,7 @@
           <p:cNvPr id="28" name="">
             <a:extLst xmlns:a="http://schemas.openxmlformats.org/drawingml/2006/main">
               <a:ext uri="{FF2B5EF4-FFF2-40B4-BE49-F238E27FC236}">
-                <a16:creationId xmlns:a16="http://schemas.microsoft.com/office/drawing/2014/main" id="{BB46E4CB-6707-4654-9344-939BE81C8880}"/>
+                <a16:creationId xmlns:a16="http://schemas.microsoft.com/office/drawing/2014/main" id="{FD8DDA33-9254-4B0F-8563-4C109954A6A5}"/>
               </a:ext>
             </a:extLst>
           </p:cNvPr>
@@ -8876,7 +8876,7 @@
           <p:cNvPr id="29" name="">
             <a:extLst xmlns:a="http://schemas.openxmlformats.org/drawingml/2006/main">
               <a:ext uri="{FF2B5EF4-FFF2-40B4-BE49-F238E27FC236}">
-                <a16:creationId xmlns:a16="http://schemas.microsoft.com/office/drawing/2014/main" id="{4428D944-5E03-4DA4-AA68-A23A530B6BC8}"/>
+                <a16:creationId xmlns:a16="http://schemas.microsoft.com/office/drawing/2014/main" id="{24CA8A33-941C-4D68-8282-4CA7C86A4A1D}"/>
               </a:ext>
             </a:extLst>
           </p:cNvPr>
@@ -8926,7 +8926,7 @@
           <p:cNvPr id="30" name="">
             <a:extLst xmlns:a="http://schemas.openxmlformats.org/drawingml/2006/main">
               <a:ext uri="{FF2B5EF4-FFF2-40B4-BE49-F238E27FC236}">
-                <a16:creationId xmlns:a16="http://schemas.microsoft.com/office/drawing/2014/main" id="{8E8AD9F8-A088-46E0-93BB-A82D8E8E7EDA}"/>
+                <a16:creationId xmlns:a16="http://schemas.microsoft.com/office/drawing/2014/main" id="{7DB16E5C-99C6-4135-84E4-76CE70A86849}"/>
               </a:ext>
             </a:extLst>
           </p:cNvPr>
@@ -8957,7 +8957,7 @@
           <p:cNvPr id="31" name="">
             <a:extLst xmlns:a="http://schemas.openxmlformats.org/drawingml/2006/main">
               <a:ext uri="{FF2B5EF4-FFF2-40B4-BE49-F238E27FC236}">
-                <a16:creationId xmlns:a16="http://schemas.microsoft.com/office/drawing/2014/main" id="{7BDFE9C5-55DA-42BC-BE3C-54D5EE0FA81D}"/>
+                <a16:creationId xmlns:a16="http://schemas.microsoft.com/office/drawing/2014/main" id="{68864FC0-2E32-4B9A-A37F-42798EAD37F8}"/>
               </a:ext>
             </a:extLst>
           </p:cNvPr>
@@ -9007,7 +9007,7 @@
           <p:cNvPr id="32" name="">
             <a:extLst xmlns:a="http://schemas.openxmlformats.org/drawingml/2006/main">
               <a:ext uri="{FF2B5EF4-FFF2-40B4-BE49-F238E27FC236}">
-                <a16:creationId xmlns:a16="http://schemas.microsoft.com/office/drawing/2014/main" id="{3481E88B-FD2F-4CCC-B281-7BC22BF16313}"/>
+                <a16:creationId xmlns:a16="http://schemas.microsoft.com/office/drawing/2014/main" id="{0B6E3E39-B9AD-4A03-881B-F5056AB0A01E}"/>
               </a:ext>
             </a:extLst>
           </p:cNvPr>
@@ -9057,7 +9057,7 @@
           <p:cNvPr id="33" name="">
             <a:extLst xmlns:a="http://schemas.openxmlformats.org/drawingml/2006/main">
               <a:ext uri="{FF2B5EF4-FFF2-40B4-BE49-F238E27FC236}">
-                <a16:creationId xmlns:a16="http://schemas.microsoft.com/office/drawing/2014/main" id="{41E22C46-30F8-40D8-B9DA-02204B394F4C}"/>
+                <a16:creationId xmlns:a16="http://schemas.microsoft.com/office/drawing/2014/main" id="{9562559F-CBC6-4E46-8530-6BD28170BFB8}"/>
               </a:ext>
             </a:extLst>
           </p:cNvPr>
@@ -9107,7 +9107,7 @@
           <p:cNvPr id="34" name="">
             <a:extLst xmlns:a="http://schemas.openxmlformats.org/drawingml/2006/main">
               <a:ext uri="{FF2B5EF4-FFF2-40B4-BE49-F238E27FC236}">
-                <a16:creationId xmlns:a16="http://schemas.microsoft.com/office/drawing/2014/main" id="{B1C43CF9-A53B-4B41-819C-190DA1964710}"/>
+                <a16:creationId xmlns:a16="http://schemas.microsoft.com/office/drawing/2014/main" id="{3EBB28A7-69D4-4181-8A49-A0AE287B704D}"/>
               </a:ext>
             </a:extLst>
           </p:cNvPr>
@@ -9157,7 +9157,7 @@
           <p:cNvPr id="35" name="">
             <a:extLst xmlns:a="http://schemas.openxmlformats.org/drawingml/2006/main">
               <a:ext uri="{FF2B5EF4-FFF2-40B4-BE49-F238E27FC236}">
-                <a16:creationId xmlns:a16="http://schemas.microsoft.com/office/drawing/2014/main" id="{A8805F73-7FB1-439A-9BAB-3D68FCF9A722}"/>
+                <a16:creationId xmlns:a16="http://schemas.microsoft.com/office/drawing/2014/main" id="{8F726D41-F50E-4109-AF03-398DB403AB54}"/>
               </a:ext>
             </a:extLst>
           </p:cNvPr>
@@ -9192,7 +9192,7 @@
           <p:cNvPr id="36" name="">
             <a:extLst xmlns:a="http://schemas.openxmlformats.org/drawingml/2006/main">
               <a:ext uri="{FF2B5EF4-FFF2-40B4-BE49-F238E27FC236}">
-                <a16:creationId xmlns:a16="http://schemas.microsoft.com/office/drawing/2014/main" id="{94E865F2-CC26-4A1E-AD14-F16753C8B1CC}"/>
+                <a16:creationId xmlns:a16="http://schemas.microsoft.com/office/drawing/2014/main" id="{FD236E02-33E6-4E4E-B476-3EF5AC0AE27A}"/>
               </a:ext>
             </a:extLst>
           </p:cNvPr>
@@ -9242,7 +9242,7 @@
           <p:cNvPr id="37" name="">
             <a:extLst xmlns:a="http://schemas.openxmlformats.org/drawingml/2006/main">
               <a:ext uri="{FF2B5EF4-FFF2-40B4-BE49-F238E27FC236}">
-                <a16:creationId xmlns:a16="http://schemas.microsoft.com/office/drawing/2014/main" id="{C216B952-7601-406E-8A6C-F35C051B3A21}"/>
+                <a16:creationId xmlns:a16="http://schemas.microsoft.com/office/drawing/2014/main" id="{2C369955-6464-4922-8345-9B0B31F890AC}"/>
               </a:ext>
             </a:extLst>
           </p:cNvPr>
@@ -9292,7 +9292,7 @@
           <p:cNvPr id="38" name="">
             <a:extLst xmlns:a="http://schemas.openxmlformats.org/drawingml/2006/main">
               <a:ext uri="{FF2B5EF4-FFF2-40B4-BE49-F238E27FC236}">
-                <a16:creationId xmlns:a16="http://schemas.microsoft.com/office/drawing/2014/main" id="{E37DEE80-4B3C-4029-9962-772E0A9E66D5}"/>
+                <a16:creationId xmlns:a16="http://schemas.microsoft.com/office/drawing/2014/main" id="{82D091D5-293B-4BAB-BE92-502E1B83D29F}"/>
               </a:ext>
             </a:extLst>
           </p:cNvPr>
@@ -9342,7 +9342,7 @@
           <p:cNvPr id="39" name="">
             <a:extLst xmlns:a="http://schemas.openxmlformats.org/drawingml/2006/main">
               <a:ext uri="{FF2B5EF4-FFF2-40B4-BE49-F238E27FC236}">
-                <a16:creationId xmlns:a16="http://schemas.microsoft.com/office/drawing/2014/main" id="{D63FFCB4-F20A-4E69-A818-892BAE1F5775}"/>
+                <a16:creationId xmlns:a16="http://schemas.microsoft.com/office/drawing/2014/main" id="{9ACF2FD7-8623-49F7-8B9C-A6B41A5ED7DC}"/>
               </a:ext>
             </a:extLst>
           </p:cNvPr>
@@ -9373,7 +9373,7 @@
           <p:cNvPr id="40" name="">
             <a:extLst xmlns:a="http://schemas.openxmlformats.org/drawingml/2006/main">
               <a:ext uri="{FF2B5EF4-FFF2-40B4-BE49-F238E27FC236}">
-                <a16:creationId xmlns:a16="http://schemas.microsoft.com/office/drawing/2014/main" id="{1FD6F8DD-DEE6-4C80-AAC1-30E63C513C3A}"/>
+                <a16:creationId xmlns:a16="http://schemas.microsoft.com/office/drawing/2014/main" id="{10C78134-AB79-4E06-823E-A1DC8DF41801}"/>
               </a:ext>
             </a:extLst>
           </p:cNvPr>
@@ -9423,7 +9423,7 @@
           <p:cNvPr id="41" name="">
             <a:extLst xmlns:a="http://schemas.openxmlformats.org/drawingml/2006/main">
               <a:ext uri="{FF2B5EF4-FFF2-40B4-BE49-F238E27FC236}">
-                <a16:creationId xmlns:a16="http://schemas.microsoft.com/office/drawing/2014/main" id="{042EB54D-8DF6-4419-A7EF-4765B9C306CA}"/>
+                <a16:creationId xmlns:a16="http://schemas.microsoft.com/office/drawing/2014/main" id="{DCB4B97A-B6DD-4409-BBFF-FA3FDADE8D5C}"/>
               </a:ext>
             </a:extLst>
           </p:cNvPr>
@@ -9473,7 +9473,7 @@
           <p:cNvPr id="42" name="">
             <a:extLst xmlns:a="http://schemas.openxmlformats.org/drawingml/2006/main">
               <a:ext uri="{FF2B5EF4-FFF2-40B4-BE49-F238E27FC236}">
-                <a16:creationId xmlns:a16="http://schemas.microsoft.com/office/drawing/2014/main" id="{95EC3BA2-2D68-4E63-AA6D-5FC02217E13F}"/>
+                <a16:creationId xmlns:a16="http://schemas.microsoft.com/office/drawing/2014/main" id="{C4E06CF8-EA5F-4E2C-B249-277AE276CFB0}"/>
               </a:ext>
             </a:extLst>
           </p:cNvPr>
@@ -9523,7 +9523,7 @@
           <p:cNvPr id="43" name="">
             <a:extLst xmlns:a="http://schemas.openxmlformats.org/drawingml/2006/main">
               <a:ext uri="{FF2B5EF4-FFF2-40B4-BE49-F238E27FC236}">
-                <a16:creationId xmlns:a16="http://schemas.microsoft.com/office/drawing/2014/main" id="{AD6FC530-8CD3-4082-B914-FB679858BC4E}"/>
+                <a16:creationId xmlns:a16="http://schemas.microsoft.com/office/drawing/2014/main" id="{7CD94D30-C2C9-417F-8B0F-9C203A6A2505}"/>
               </a:ext>
             </a:extLst>
           </p:cNvPr>
@@ -9571,7 +9571,7 @@
     </p:spTree>
     <p:extLst>
       <p:ext uri="{BB962C8B-B14F-4D97-AF65-F5344CB8AC3E}">
-        <p14:creationId xmlns:p14="http://schemas.microsoft.com/office/powerpoint/2010/main" val="1092589643"/>
+        <p14:creationId xmlns:p14="http://schemas.microsoft.com/office/powerpoint/2010/main" val="1527712661"/>
       </p:ext>
     </p:extLst>
   </p:cSld>
@@ -9602,7 +9602,7 @@
           <p:cNvPr id="1" name="">
             <a:extLst xmlns:a="http://schemas.openxmlformats.org/drawingml/2006/main">
               <a:ext uri="{FF2B5EF4-FFF2-40B4-BE49-F238E27FC236}">
-                <a16:creationId xmlns:a16="http://schemas.microsoft.com/office/drawing/2014/main" id="{A3173D83-03F8-4E10-8010-8654851F2A14}"/>
+                <a16:creationId xmlns:a16="http://schemas.microsoft.com/office/drawing/2014/main" id="{F158EDEE-33DF-4960-8A9A-AF262CE8C473}"/>
               </a:ext>
             </a:extLst>
           </p:cNvPr>
@@ -9637,7 +9637,7 @@
           <p:nvPr/>
         </p:nvPicPr>
         <p:blipFill>
-          <a:blip xmlns:r="http://schemas.openxmlformats.org/officeDocument/2006/relationships" xmlns:a="http://schemas.openxmlformats.org/drawingml/2006/main" r:embed="R9d08e60b60c542c3"/>
+          <a:blip xmlns:r="http://schemas.openxmlformats.org/officeDocument/2006/relationships" xmlns:a="http://schemas.openxmlformats.org/drawingml/2006/main" r:embed="R1fb063dffe544efe"/>
           <a:stretch xmlns:a="http://schemas.openxmlformats.org/drawingml/2006/main"/>
         </p:blipFill>
         <p:spPr>
@@ -9655,7 +9655,7 @@
           <p:cNvPr id="3" name="">
             <a:extLst xmlns:a="http://schemas.openxmlformats.org/drawingml/2006/main">
               <a:ext uri="{FF2B5EF4-FFF2-40B4-BE49-F238E27FC236}">
-                <a16:creationId xmlns:a16="http://schemas.microsoft.com/office/drawing/2014/main" id="{AE3F0AA2-7969-49C7-BC9C-1624770B4191}"/>
+                <a16:creationId xmlns:a16="http://schemas.microsoft.com/office/drawing/2014/main" id="{A531894E-D097-4677-ABB7-AB1CC9D5AF00}"/>
               </a:ext>
             </a:extLst>
           </p:cNvPr>
@@ -9705,7 +9705,7 @@
           <p:cNvPr id="4" name="">
             <a:extLst xmlns:a="http://schemas.openxmlformats.org/drawingml/2006/main">
               <a:ext uri="{FF2B5EF4-FFF2-40B4-BE49-F238E27FC236}">
-                <a16:creationId xmlns:a16="http://schemas.microsoft.com/office/drawing/2014/main" id="{9AFE5A83-08E2-4075-80C7-D0DE0651AAEC}"/>
+                <a16:creationId xmlns:a16="http://schemas.microsoft.com/office/drawing/2014/main" id="{8445769A-0F1E-4CAF-9B97-EA4A83175661}"/>
               </a:ext>
             </a:extLst>
           </p:cNvPr>
@@ -9738,7 +9738,7 @@
           <p:cNvPr id="5" name="">
             <a:extLst xmlns:a="http://schemas.openxmlformats.org/drawingml/2006/main">
               <a:ext uri="{FF2B5EF4-FFF2-40B4-BE49-F238E27FC236}">
-                <a16:creationId xmlns:a16="http://schemas.microsoft.com/office/drawing/2014/main" id="{B02DF000-5D33-429D-B768-559112CA8180}"/>
+                <a16:creationId xmlns:a16="http://schemas.microsoft.com/office/drawing/2014/main" id="{624159C6-4578-4FAF-811E-E7A9AD1A27D4}"/>
               </a:ext>
             </a:extLst>
           </p:cNvPr>
@@ -9769,7 +9769,7 @@
           <p:cNvPr id="6" name="">
             <a:extLst xmlns:a="http://schemas.openxmlformats.org/drawingml/2006/main">
               <a:ext uri="{FF2B5EF4-FFF2-40B4-BE49-F238E27FC236}">
-                <a16:creationId xmlns:a16="http://schemas.microsoft.com/office/drawing/2014/main" id="{69FC5D91-7743-40C3-8EA2-4D7B32400E94}"/>
+                <a16:creationId xmlns:a16="http://schemas.microsoft.com/office/drawing/2014/main" id="{E4386275-CCD5-4340-B376-8A218655E939}"/>
               </a:ext>
             </a:extLst>
           </p:cNvPr>
@@ -9819,7 +9819,7 @@
           <p:cNvPr id="7" name="">
             <a:extLst xmlns:a="http://schemas.openxmlformats.org/drawingml/2006/main">
               <a:ext uri="{FF2B5EF4-FFF2-40B4-BE49-F238E27FC236}">
-                <a16:creationId xmlns:a16="http://schemas.microsoft.com/office/drawing/2014/main" id="{C1193BDE-7FA8-4BE1-A366-3990B7E701B0}"/>
+                <a16:creationId xmlns:a16="http://schemas.microsoft.com/office/drawing/2014/main" id="{61727547-6C30-44A0-A812-1F27B184F5C3}"/>
               </a:ext>
             </a:extLst>
           </p:cNvPr>
@@ -9869,7 +9869,7 @@
           <p:cNvPr id="8" name="">
             <a:extLst xmlns:a="http://schemas.openxmlformats.org/drawingml/2006/main">
               <a:ext uri="{FF2B5EF4-FFF2-40B4-BE49-F238E27FC236}">
-                <a16:creationId xmlns:a16="http://schemas.microsoft.com/office/drawing/2014/main" id="{305BC97B-C697-409D-BBED-D479642B7654}"/>
+                <a16:creationId xmlns:a16="http://schemas.microsoft.com/office/drawing/2014/main" id="{007E52AC-FDA3-4409-835B-D9D000C9EC48}"/>
               </a:ext>
             </a:extLst>
           </p:cNvPr>
@@ -9904,7 +9904,7 @@
           <p:cNvPr id="9" name="">
             <a:extLst xmlns:a="http://schemas.openxmlformats.org/drawingml/2006/main">
               <a:ext uri="{FF2B5EF4-FFF2-40B4-BE49-F238E27FC236}">
-                <a16:creationId xmlns:a16="http://schemas.microsoft.com/office/drawing/2014/main" id="{11F9D21D-2C00-4631-B86E-7EB06495EDB9}"/>
+                <a16:creationId xmlns:a16="http://schemas.microsoft.com/office/drawing/2014/main" id="{5BBB95B9-A680-4BFC-B31D-AFBC79DAFB2F}"/>
               </a:ext>
             </a:extLst>
           </p:cNvPr>
@@ -9954,7 +9954,7 @@
           <p:cNvPr id="10" name="">
             <a:extLst xmlns:a="http://schemas.openxmlformats.org/drawingml/2006/main">
               <a:ext uri="{FF2B5EF4-FFF2-40B4-BE49-F238E27FC236}">
-                <a16:creationId xmlns:a16="http://schemas.microsoft.com/office/drawing/2014/main" id="{6DA57478-1D77-4B43-BF97-080C2E2346A9}"/>
+                <a16:creationId xmlns:a16="http://schemas.microsoft.com/office/drawing/2014/main" id="{B3913A86-A040-4EB7-9D21-A213531DD568}"/>
               </a:ext>
             </a:extLst>
           </p:cNvPr>
@@ -10004,7 +10004,7 @@
           <p:cNvPr id="11" name="">
             <a:extLst xmlns:a="http://schemas.openxmlformats.org/drawingml/2006/main">
               <a:ext uri="{FF2B5EF4-FFF2-40B4-BE49-F238E27FC236}">
-                <a16:creationId xmlns:a16="http://schemas.microsoft.com/office/drawing/2014/main" id="{54A89920-5305-43E1-93E4-E262E83E5C73}"/>
+                <a16:creationId xmlns:a16="http://schemas.microsoft.com/office/drawing/2014/main" id="{6A064AC9-F8A2-45E6-BE48-B65DBEFAEF33}"/>
               </a:ext>
             </a:extLst>
           </p:cNvPr>
@@ -10054,7 +10054,7 @@
           <p:cNvPr id="12" name="">
             <a:extLst xmlns:a="http://schemas.openxmlformats.org/drawingml/2006/main">
               <a:ext uri="{FF2B5EF4-FFF2-40B4-BE49-F238E27FC236}">
-                <a16:creationId xmlns:a16="http://schemas.microsoft.com/office/drawing/2014/main" id="{3D92AD69-ACAC-47F3-81EF-4A791CE7C880}"/>
+                <a16:creationId xmlns:a16="http://schemas.microsoft.com/office/drawing/2014/main" id="{F8CD5D2B-5A85-464D-B3B5-3823C75D25B4}"/>
               </a:ext>
             </a:extLst>
           </p:cNvPr>
@@ -10085,7 +10085,7 @@
           <p:cNvPr id="13" name="">
             <a:extLst xmlns:a="http://schemas.openxmlformats.org/drawingml/2006/main">
               <a:ext uri="{FF2B5EF4-FFF2-40B4-BE49-F238E27FC236}">
-                <a16:creationId xmlns:a16="http://schemas.microsoft.com/office/drawing/2014/main" id="{5D23A4EE-8854-4EC0-A4A8-E5D2D751883A}"/>
+                <a16:creationId xmlns:a16="http://schemas.microsoft.com/office/drawing/2014/main" id="{FD13FD07-5D7D-47D1-9657-73205DC0C6D4}"/>
               </a:ext>
             </a:extLst>
           </p:cNvPr>
@@ -10135,7 +10135,7 @@
           <p:cNvPr id="14" name="">
             <a:extLst xmlns:a="http://schemas.openxmlformats.org/drawingml/2006/main">
               <a:ext uri="{FF2B5EF4-FFF2-40B4-BE49-F238E27FC236}">
-                <a16:creationId xmlns:a16="http://schemas.microsoft.com/office/drawing/2014/main" id="{156C5E8F-A7B1-4D4B-8537-2D8599FD8384}"/>
+                <a16:creationId xmlns:a16="http://schemas.microsoft.com/office/drawing/2014/main" id="{9983882B-15D5-45CD-932B-5B3E312EDF58}"/>
               </a:ext>
             </a:extLst>
           </p:cNvPr>
@@ -10185,7 +10185,7 @@
           <p:cNvPr id="15" name="">
             <a:extLst xmlns:a="http://schemas.openxmlformats.org/drawingml/2006/main">
               <a:ext uri="{FF2B5EF4-FFF2-40B4-BE49-F238E27FC236}">
-                <a16:creationId xmlns:a16="http://schemas.microsoft.com/office/drawing/2014/main" id="{CE4572B3-859C-4B89-BB8A-FD76D7F58925}"/>
+                <a16:creationId xmlns:a16="http://schemas.microsoft.com/office/drawing/2014/main" id="{71D3A65A-07DF-433D-82FC-78BD7399C4E8}"/>
               </a:ext>
             </a:extLst>
           </p:cNvPr>
@@ -10235,7 +10235,7 @@
           <p:cNvPr id="16" name="">
             <a:extLst xmlns:a="http://schemas.openxmlformats.org/drawingml/2006/main">
               <a:ext uri="{FF2B5EF4-FFF2-40B4-BE49-F238E27FC236}">
-                <a16:creationId xmlns:a16="http://schemas.microsoft.com/office/drawing/2014/main" id="{F8C48050-86FB-4CD1-9114-BE616CCBE427}"/>
+                <a16:creationId xmlns:a16="http://schemas.microsoft.com/office/drawing/2014/main" id="{BA25BBE2-477B-42C3-989A-142CFD0CC397}"/>
               </a:ext>
             </a:extLst>
           </p:cNvPr>
@@ -10285,7 +10285,7 @@
           <p:cNvPr id="17" name="">
             <a:extLst xmlns:a="http://schemas.openxmlformats.org/drawingml/2006/main">
               <a:ext uri="{FF2B5EF4-FFF2-40B4-BE49-F238E27FC236}">
-                <a16:creationId xmlns:a16="http://schemas.microsoft.com/office/drawing/2014/main" id="{BEE5C7ED-BB59-4FB4-A314-5827695F3F18}"/>
+                <a16:creationId xmlns:a16="http://schemas.microsoft.com/office/drawing/2014/main" id="{D68A0209-6953-4505-95E5-8711166102CB}"/>
               </a:ext>
             </a:extLst>
           </p:cNvPr>
@@ -10320,7 +10320,7 @@
           <p:cNvPr id="18" name="">
             <a:extLst xmlns:a="http://schemas.openxmlformats.org/drawingml/2006/main">
               <a:ext uri="{FF2B5EF4-FFF2-40B4-BE49-F238E27FC236}">
-                <a16:creationId xmlns:a16="http://schemas.microsoft.com/office/drawing/2014/main" id="{F88F9388-71D0-47ED-87CD-EE50B95524B1}"/>
+                <a16:creationId xmlns:a16="http://schemas.microsoft.com/office/drawing/2014/main" id="{B9931A07-DBC0-48BA-85C5-4DF21204C044}"/>
               </a:ext>
             </a:extLst>
           </p:cNvPr>
@@ -10370,7 +10370,7 @@
           <p:cNvPr id="19" name="">
             <a:extLst xmlns:a="http://schemas.openxmlformats.org/drawingml/2006/main">
               <a:ext uri="{FF2B5EF4-FFF2-40B4-BE49-F238E27FC236}">
-                <a16:creationId xmlns:a16="http://schemas.microsoft.com/office/drawing/2014/main" id="{3302BBAD-26F2-4D06-A3E1-5144C90A882E}"/>
+                <a16:creationId xmlns:a16="http://schemas.microsoft.com/office/drawing/2014/main" id="{DC8D9F78-BAA2-47D8-96D8-A6687CA60047}"/>
               </a:ext>
             </a:extLst>
           </p:cNvPr>
@@ -10420,7 +10420,7 @@
           <p:cNvPr id="20" name="">
             <a:extLst xmlns:a="http://schemas.openxmlformats.org/drawingml/2006/main">
               <a:ext uri="{FF2B5EF4-FFF2-40B4-BE49-F238E27FC236}">
-                <a16:creationId xmlns:a16="http://schemas.microsoft.com/office/drawing/2014/main" id="{3D0CB97B-CBB3-455E-9172-0961C363B9D4}"/>
+                <a16:creationId xmlns:a16="http://schemas.microsoft.com/office/drawing/2014/main" id="{E9C0040E-3442-44E3-98B5-659C4655CC92}"/>
               </a:ext>
             </a:extLst>
           </p:cNvPr>
@@ -10470,7 +10470,7 @@
           <p:cNvPr id="21" name="">
             <a:extLst xmlns:a="http://schemas.openxmlformats.org/drawingml/2006/main">
               <a:ext uri="{FF2B5EF4-FFF2-40B4-BE49-F238E27FC236}">
-                <a16:creationId xmlns:a16="http://schemas.microsoft.com/office/drawing/2014/main" id="{109470DA-BD4E-4C33-858F-E4CE567F357C}"/>
+                <a16:creationId xmlns:a16="http://schemas.microsoft.com/office/drawing/2014/main" id="{621CF59C-E8FF-44F2-95E6-C0BC0190B988}"/>
               </a:ext>
             </a:extLst>
           </p:cNvPr>
@@ -10501,7 +10501,7 @@
           <p:cNvPr id="22" name="">
             <a:extLst xmlns:a="http://schemas.openxmlformats.org/drawingml/2006/main">
               <a:ext uri="{FF2B5EF4-FFF2-40B4-BE49-F238E27FC236}">
-                <a16:creationId xmlns:a16="http://schemas.microsoft.com/office/drawing/2014/main" id="{1D492A12-6E9F-4491-B8C2-02BDF06A142C}"/>
+                <a16:creationId xmlns:a16="http://schemas.microsoft.com/office/drawing/2014/main" id="{8108150A-4BB3-406D-BF77-00AF2A8974E9}"/>
               </a:ext>
             </a:extLst>
           </p:cNvPr>
@@ -10551,7 +10551,7 @@
           <p:cNvPr id="23" name="">
             <a:extLst xmlns:a="http://schemas.openxmlformats.org/drawingml/2006/main">
               <a:ext uri="{FF2B5EF4-FFF2-40B4-BE49-F238E27FC236}">
-                <a16:creationId xmlns:a16="http://schemas.microsoft.com/office/drawing/2014/main" id="{14429D8D-2AC1-4D07-802F-5645EA866653}"/>
+                <a16:creationId xmlns:a16="http://schemas.microsoft.com/office/drawing/2014/main" id="{9605B397-971C-4480-BACC-CA86A9BE1D53}"/>
               </a:ext>
             </a:extLst>
           </p:cNvPr>
@@ -10601,7 +10601,7 @@
           <p:cNvPr id="24" name="">
             <a:extLst xmlns:a="http://schemas.openxmlformats.org/drawingml/2006/main">
               <a:ext uri="{FF2B5EF4-FFF2-40B4-BE49-F238E27FC236}">
-                <a16:creationId xmlns:a16="http://schemas.microsoft.com/office/drawing/2014/main" id="{721C3C21-681B-4062-BA0E-8B2FFD83362C}"/>
+                <a16:creationId xmlns:a16="http://schemas.microsoft.com/office/drawing/2014/main" id="{0ED227A8-094C-491F-841D-4011568AD5DD}"/>
               </a:ext>
             </a:extLst>
           </p:cNvPr>
@@ -10651,7 +10651,7 @@
           <p:cNvPr id="25" name="">
             <a:extLst xmlns:a="http://schemas.openxmlformats.org/drawingml/2006/main">
               <a:ext uri="{FF2B5EF4-FFF2-40B4-BE49-F238E27FC236}">
-                <a16:creationId xmlns:a16="http://schemas.microsoft.com/office/drawing/2014/main" id="{50089A15-96F3-4CEF-92F3-9CB4E4DB70C9}"/>
+                <a16:creationId xmlns:a16="http://schemas.microsoft.com/office/drawing/2014/main" id="{62A23119-67C1-435F-AAEB-FF84FE0697B0}"/>
               </a:ext>
             </a:extLst>
           </p:cNvPr>
@@ -10701,7 +10701,7 @@
           <p:cNvPr id="26" name="">
             <a:extLst xmlns:a="http://schemas.openxmlformats.org/drawingml/2006/main">
               <a:ext uri="{FF2B5EF4-FFF2-40B4-BE49-F238E27FC236}">
-                <a16:creationId xmlns:a16="http://schemas.microsoft.com/office/drawing/2014/main" id="{392ACD9C-1B72-4DDF-99AB-ED92E62DC38E}"/>
+                <a16:creationId xmlns:a16="http://schemas.microsoft.com/office/drawing/2014/main" id="{EB9D1B36-CB28-4405-8B64-5247C48385C8}"/>
               </a:ext>
             </a:extLst>
           </p:cNvPr>
@@ -10736,7 +10736,7 @@
           <p:cNvPr id="27" name="">
             <a:extLst xmlns:a="http://schemas.openxmlformats.org/drawingml/2006/main">
               <a:ext uri="{FF2B5EF4-FFF2-40B4-BE49-F238E27FC236}">
-                <a16:creationId xmlns:a16="http://schemas.microsoft.com/office/drawing/2014/main" id="{E4BA7DF6-A44E-4D6B-9F03-65B72E9A7BB9}"/>
+                <a16:creationId xmlns:a16="http://schemas.microsoft.com/office/drawing/2014/main" id="{E1A975D4-403F-4186-A24C-0F841BD0538E}"/>
               </a:ext>
             </a:extLst>
           </p:cNvPr>
@@ -10786,7 +10786,7 @@
           <p:cNvPr id="28" name="">
             <a:extLst xmlns:a="http://schemas.openxmlformats.org/drawingml/2006/main">
               <a:ext uri="{FF2B5EF4-FFF2-40B4-BE49-F238E27FC236}">
-                <a16:creationId xmlns:a16="http://schemas.microsoft.com/office/drawing/2014/main" id="{FD93AF1E-D694-41AA-92E8-E90B1E284A7B}"/>
+                <a16:creationId xmlns:a16="http://schemas.microsoft.com/office/drawing/2014/main" id="{7994EE17-227E-4B8A-90C7-EE4543CAFA40}"/>
               </a:ext>
             </a:extLst>
           </p:cNvPr>
@@ -10836,7 +10836,7 @@
           <p:cNvPr id="29" name="">
             <a:extLst xmlns:a="http://schemas.openxmlformats.org/drawingml/2006/main">
               <a:ext uri="{FF2B5EF4-FFF2-40B4-BE49-F238E27FC236}">
-                <a16:creationId xmlns:a16="http://schemas.microsoft.com/office/drawing/2014/main" id="{59400B16-96C6-46E5-989A-BBEACE387088}"/>
+                <a16:creationId xmlns:a16="http://schemas.microsoft.com/office/drawing/2014/main" id="{10761C19-8A3D-40CF-A7E7-249F6C1277F1}"/>
               </a:ext>
             </a:extLst>
           </p:cNvPr>
@@ -10886,7 +10886,7 @@
           <p:cNvPr id="30" name="">
             <a:extLst xmlns:a="http://schemas.openxmlformats.org/drawingml/2006/main">
               <a:ext uri="{FF2B5EF4-FFF2-40B4-BE49-F238E27FC236}">
-                <a16:creationId xmlns:a16="http://schemas.microsoft.com/office/drawing/2014/main" id="{6102E351-F33A-4857-A1BF-9CC218E6F567}"/>
+                <a16:creationId xmlns:a16="http://schemas.microsoft.com/office/drawing/2014/main" id="{71463D86-08E7-4584-A229-2071F60B71D0}"/>
               </a:ext>
             </a:extLst>
           </p:cNvPr>
@@ -10917,7 +10917,7 @@
           <p:cNvPr id="31" name="">
             <a:extLst xmlns:a="http://schemas.openxmlformats.org/drawingml/2006/main">
               <a:ext uri="{FF2B5EF4-FFF2-40B4-BE49-F238E27FC236}">
-                <a16:creationId xmlns:a16="http://schemas.microsoft.com/office/drawing/2014/main" id="{8998CF72-8395-4726-B2FE-D9FAAA260554}"/>
+                <a16:creationId xmlns:a16="http://schemas.microsoft.com/office/drawing/2014/main" id="{84E7A3BF-10EC-418B-9E5F-C7279066D406}"/>
               </a:ext>
             </a:extLst>
           </p:cNvPr>
@@ -10967,7 +10967,7 @@
           <p:cNvPr id="32" name="">
             <a:extLst xmlns:a="http://schemas.openxmlformats.org/drawingml/2006/main">
               <a:ext uri="{FF2B5EF4-FFF2-40B4-BE49-F238E27FC236}">
-                <a16:creationId xmlns:a16="http://schemas.microsoft.com/office/drawing/2014/main" id="{21D5E29E-D798-4044-A1C3-1CA1B844781B}"/>
+                <a16:creationId xmlns:a16="http://schemas.microsoft.com/office/drawing/2014/main" id="{76402263-ACA3-4172-B10E-4D336EF054DE}"/>
               </a:ext>
             </a:extLst>
           </p:cNvPr>
@@ -11017,7 +11017,7 @@
           <p:cNvPr id="33" name="">
             <a:extLst xmlns:a="http://schemas.openxmlformats.org/drawingml/2006/main">
               <a:ext uri="{FF2B5EF4-FFF2-40B4-BE49-F238E27FC236}">
-                <a16:creationId xmlns:a16="http://schemas.microsoft.com/office/drawing/2014/main" id="{C75BA0A3-C31F-4C96-8F8C-3F015F807029}"/>
+                <a16:creationId xmlns:a16="http://schemas.microsoft.com/office/drawing/2014/main" id="{3268F91B-1D5C-4242-ACBD-3381C25D2039}"/>
               </a:ext>
             </a:extLst>
           </p:cNvPr>
@@ -11067,7 +11067,7 @@
           <p:cNvPr id="34" name="">
             <a:extLst xmlns:a="http://schemas.openxmlformats.org/drawingml/2006/main">
               <a:ext uri="{FF2B5EF4-FFF2-40B4-BE49-F238E27FC236}">
-                <a16:creationId xmlns:a16="http://schemas.microsoft.com/office/drawing/2014/main" id="{6CB2515E-6C98-4AF3-9D97-C7C935337E02}"/>
+                <a16:creationId xmlns:a16="http://schemas.microsoft.com/office/drawing/2014/main" id="{D8C2793B-92EE-4F3C-9DCC-E85751996B75}"/>
               </a:ext>
             </a:extLst>
           </p:cNvPr>
@@ -11117,7 +11117,7 @@
           <p:cNvPr id="35" name="">
             <a:extLst xmlns:a="http://schemas.openxmlformats.org/drawingml/2006/main">
               <a:ext uri="{FF2B5EF4-FFF2-40B4-BE49-F238E27FC236}">
-                <a16:creationId xmlns:a16="http://schemas.microsoft.com/office/drawing/2014/main" id="{D921A9D7-61B8-43C6-87DA-1A8F32D56E16}"/>
+                <a16:creationId xmlns:a16="http://schemas.microsoft.com/office/drawing/2014/main" id="{D1F7B264-A392-4EFE-997C-305097094052}"/>
               </a:ext>
             </a:extLst>
           </p:cNvPr>
@@ -11152,7 +11152,7 @@
           <p:cNvPr id="36" name="">
             <a:extLst xmlns:a="http://schemas.openxmlformats.org/drawingml/2006/main">
               <a:ext uri="{FF2B5EF4-FFF2-40B4-BE49-F238E27FC236}">
-                <a16:creationId xmlns:a16="http://schemas.microsoft.com/office/drawing/2014/main" id="{2E0D4418-A90B-4C02-8803-C1CA0A5F592E}"/>
+                <a16:creationId xmlns:a16="http://schemas.microsoft.com/office/drawing/2014/main" id="{2460D3FF-0352-4A39-B4C6-9F09C886AB82}"/>
               </a:ext>
             </a:extLst>
           </p:cNvPr>
@@ -11202,7 +11202,7 @@
           <p:cNvPr id="37" name="">
             <a:extLst xmlns:a="http://schemas.openxmlformats.org/drawingml/2006/main">
               <a:ext uri="{FF2B5EF4-FFF2-40B4-BE49-F238E27FC236}">
-                <a16:creationId xmlns:a16="http://schemas.microsoft.com/office/drawing/2014/main" id="{C93C24F0-FEAD-461F-A721-3548B0343DDB}"/>
+                <a16:creationId xmlns:a16="http://schemas.microsoft.com/office/drawing/2014/main" id="{6D196C40-BA6C-4BBB-8871-F45F1311D36F}"/>
               </a:ext>
             </a:extLst>
           </p:cNvPr>
@@ -11252,7 +11252,7 @@
           <p:cNvPr id="38" name="">
             <a:extLst xmlns:a="http://schemas.openxmlformats.org/drawingml/2006/main">
               <a:ext uri="{FF2B5EF4-FFF2-40B4-BE49-F238E27FC236}">
-                <a16:creationId xmlns:a16="http://schemas.microsoft.com/office/drawing/2014/main" id="{ABA831C2-E2F4-413E-985D-59C42B12152F}"/>
+                <a16:creationId xmlns:a16="http://schemas.microsoft.com/office/drawing/2014/main" id="{B943227D-718A-430E-BE49-BE565E13DB64}"/>
               </a:ext>
             </a:extLst>
           </p:cNvPr>
@@ -11302,7 +11302,7 @@
           <p:cNvPr id="39" name="">
             <a:extLst xmlns:a="http://schemas.openxmlformats.org/drawingml/2006/main">
               <a:ext uri="{FF2B5EF4-FFF2-40B4-BE49-F238E27FC236}">
-                <a16:creationId xmlns:a16="http://schemas.microsoft.com/office/drawing/2014/main" id="{042FD63B-86E6-4749-9C02-48C9AB583D25}"/>
+                <a16:creationId xmlns:a16="http://schemas.microsoft.com/office/drawing/2014/main" id="{8638745A-7BAD-468B-B8FC-9A6D969C8C0A}"/>
               </a:ext>
             </a:extLst>
           </p:cNvPr>
@@ -11333,7 +11333,7 @@
           <p:cNvPr id="40" name="">
             <a:extLst xmlns:a="http://schemas.openxmlformats.org/drawingml/2006/main">
               <a:ext uri="{FF2B5EF4-FFF2-40B4-BE49-F238E27FC236}">
-                <a16:creationId xmlns:a16="http://schemas.microsoft.com/office/drawing/2014/main" id="{1B91843E-89EF-4705-9579-FCC9762C8595}"/>
+                <a16:creationId xmlns:a16="http://schemas.microsoft.com/office/drawing/2014/main" id="{027E5316-50DA-4F90-A028-7F3052D45FEF}"/>
               </a:ext>
             </a:extLst>
           </p:cNvPr>
@@ -11383,7 +11383,7 @@
           <p:cNvPr id="41" name="">
             <a:extLst xmlns:a="http://schemas.openxmlformats.org/drawingml/2006/main">
               <a:ext uri="{FF2B5EF4-FFF2-40B4-BE49-F238E27FC236}">
-                <a16:creationId xmlns:a16="http://schemas.microsoft.com/office/drawing/2014/main" id="{71087939-8213-4151-9F57-862B49AA1F71}"/>
+                <a16:creationId xmlns:a16="http://schemas.microsoft.com/office/drawing/2014/main" id="{B8D2CA89-AB37-42D1-B7FC-6CBAC59F1163}"/>
               </a:ext>
             </a:extLst>
           </p:cNvPr>
@@ -11433,7 +11433,7 @@
           <p:cNvPr id="42" name="">
             <a:extLst xmlns:a="http://schemas.openxmlformats.org/drawingml/2006/main">
               <a:ext uri="{FF2B5EF4-FFF2-40B4-BE49-F238E27FC236}">
-                <a16:creationId xmlns:a16="http://schemas.microsoft.com/office/drawing/2014/main" id="{01754668-1AA1-4F71-B0B1-DD5CBBBB5DD4}"/>
+                <a16:creationId xmlns:a16="http://schemas.microsoft.com/office/drawing/2014/main" id="{CB0D2BB0-F9DE-49B9-BF66-0B9819CA85F0}"/>
               </a:ext>
             </a:extLst>
           </p:cNvPr>
@@ -11483,7 +11483,7 @@
           <p:cNvPr id="43" name="">
             <a:extLst xmlns:a="http://schemas.openxmlformats.org/drawingml/2006/main">
               <a:ext uri="{FF2B5EF4-FFF2-40B4-BE49-F238E27FC236}">
-                <a16:creationId xmlns:a16="http://schemas.microsoft.com/office/drawing/2014/main" id="{674861B6-2C3A-47D4-8B19-70262D5B0C50}"/>
+                <a16:creationId xmlns:a16="http://schemas.microsoft.com/office/drawing/2014/main" id="{E1D963AC-B7CF-49E7-B2D6-E841006F1133}"/>
               </a:ext>
             </a:extLst>
           </p:cNvPr>
@@ -11531,7 +11531,7 @@
     </p:spTree>
     <p:extLst>
       <p:ext uri="{BB962C8B-B14F-4D97-AF65-F5344CB8AC3E}">
-        <p14:creationId xmlns:p14="http://schemas.microsoft.com/office/powerpoint/2010/main" val="1849648486"/>
+        <p14:creationId xmlns:p14="http://schemas.microsoft.com/office/powerpoint/2010/main" val="618958453"/>
       </p:ext>
     </p:extLst>
   </p:cSld>
@@ -11562,7 +11562,7 @@
           <p:cNvPr id="1" name="">
             <a:extLst xmlns:a="http://schemas.openxmlformats.org/drawingml/2006/main">
               <a:ext uri="{FF2B5EF4-FFF2-40B4-BE49-F238E27FC236}">
-                <a16:creationId xmlns:a16="http://schemas.microsoft.com/office/drawing/2014/main" id="{B30E5952-5003-48BC-B214-87C68C0FF4E6}"/>
+                <a16:creationId xmlns:a16="http://schemas.microsoft.com/office/drawing/2014/main" id="{ADFE0A59-620A-498C-8AC5-829F5B914D69}"/>
               </a:ext>
             </a:extLst>
           </p:cNvPr>
@@ -11597,7 +11597,7 @@
           <p:nvPr/>
         </p:nvPicPr>
         <p:blipFill>
-          <a:blip xmlns:r="http://schemas.openxmlformats.org/officeDocument/2006/relationships" xmlns:a="http://schemas.openxmlformats.org/drawingml/2006/main" r:embed="R174d3b86651e4bd5"/>
+          <a:blip xmlns:r="http://schemas.openxmlformats.org/officeDocument/2006/relationships" xmlns:a="http://schemas.openxmlformats.org/drawingml/2006/main" r:embed="Rec915db3c6304ae8"/>
           <a:stretch xmlns:a="http://schemas.openxmlformats.org/drawingml/2006/main"/>
         </p:blipFill>
         <p:spPr>
@@ -11615,7 +11615,7 @@
           <p:cNvPr id="3" name="">
             <a:extLst xmlns:a="http://schemas.openxmlformats.org/drawingml/2006/main">
               <a:ext uri="{FF2B5EF4-FFF2-40B4-BE49-F238E27FC236}">
-                <a16:creationId xmlns:a16="http://schemas.microsoft.com/office/drawing/2014/main" id="{8A3284F9-382E-4067-9E47-D7D3E2102B79}"/>
+                <a16:creationId xmlns:a16="http://schemas.microsoft.com/office/drawing/2014/main" id="{A86FA2AA-05EC-4504-B278-F0FFC91DBCF1}"/>
               </a:ext>
             </a:extLst>
           </p:cNvPr>
@@ -11665,7 +11665,7 @@
           <p:cNvPr id="4" name="">
             <a:extLst xmlns:a="http://schemas.openxmlformats.org/drawingml/2006/main">
               <a:ext uri="{FF2B5EF4-FFF2-40B4-BE49-F238E27FC236}">
-                <a16:creationId xmlns:a16="http://schemas.microsoft.com/office/drawing/2014/main" id="{EB784C58-6C14-4F99-89A5-D6595521D19A}"/>
+                <a16:creationId xmlns:a16="http://schemas.microsoft.com/office/drawing/2014/main" id="{500A54B5-A420-482B-8D73-47342441270B}"/>
               </a:ext>
             </a:extLst>
           </p:cNvPr>
@@ -11698,7 +11698,7 @@
           <p:cNvPr id="5" name="">
             <a:extLst xmlns:a="http://schemas.openxmlformats.org/drawingml/2006/main">
               <a:ext uri="{FF2B5EF4-FFF2-40B4-BE49-F238E27FC236}">
-                <a16:creationId xmlns:a16="http://schemas.microsoft.com/office/drawing/2014/main" id="{6453DDD5-8599-43AB-B857-B416F0649B7A}"/>
+                <a16:creationId xmlns:a16="http://schemas.microsoft.com/office/drawing/2014/main" id="{AF22537D-5993-46CF-B7A6-5FD741B2CB69}"/>
               </a:ext>
             </a:extLst>
           </p:cNvPr>
@@ -11729,7 +11729,7 @@
           <p:cNvPr id="6" name="">
             <a:extLst xmlns:a="http://schemas.openxmlformats.org/drawingml/2006/main">
               <a:ext uri="{FF2B5EF4-FFF2-40B4-BE49-F238E27FC236}">
-                <a16:creationId xmlns:a16="http://schemas.microsoft.com/office/drawing/2014/main" id="{29002768-E40E-46E9-A306-4683FBBA08BB}"/>
+                <a16:creationId xmlns:a16="http://schemas.microsoft.com/office/drawing/2014/main" id="{1B0A17D0-C8AD-40E2-B225-7970B46C3D1F}"/>
               </a:ext>
             </a:extLst>
           </p:cNvPr>
@@ -11779,7 +11779,7 @@
           <p:cNvPr id="7" name="">
             <a:extLst xmlns:a="http://schemas.openxmlformats.org/drawingml/2006/main">
               <a:ext uri="{FF2B5EF4-FFF2-40B4-BE49-F238E27FC236}">
-                <a16:creationId xmlns:a16="http://schemas.microsoft.com/office/drawing/2014/main" id="{9D4B1E84-DD5B-4764-BD16-A26085F00E39}"/>
+                <a16:creationId xmlns:a16="http://schemas.microsoft.com/office/drawing/2014/main" id="{B70C0A49-A9E6-4208-A03B-49EC6D5AB3DA}"/>
               </a:ext>
             </a:extLst>
           </p:cNvPr>
@@ -11829,7 +11829,7 @@
           <p:cNvPr id="8" name="">
             <a:extLst xmlns:a="http://schemas.openxmlformats.org/drawingml/2006/main">
               <a:ext uri="{FF2B5EF4-FFF2-40B4-BE49-F238E27FC236}">
-                <a16:creationId xmlns:a16="http://schemas.microsoft.com/office/drawing/2014/main" id="{91A4B69C-07E3-439F-BA21-F0386EB6A82D}"/>
+                <a16:creationId xmlns:a16="http://schemas.microsoft.com/office/drawing/2014/main" id="{F8E45944-B7D0-42D1-A41A-5A808D7DA584}"/>
               </a:ext>
             </a:extLst>
           </p:cNvPr>
@@ -11864,7 +11864,7 @@
           <p:cNvPr id="9" name="">
             <a:extLst xmlns:a="http://schemas.openxmlformats.org/drawingml/2006/main">
               <a:ext uri="{FF2B5EF4-FFF2-40B4-BE49-F238E27FC236}">
-                <a16:creationId xmlns:a16="http://schemas.microsoft.com/office/drawing/2014/main" id="{61A35BF6-938E-4181-9E80-760BEE89C21B}"/>
+                <a16:creationId xmlns:a16="http://schemas.microsoft.com/office/drawing/2014/main" id="{369F3FDC-AC9E-4F83-AF76-EC57CDFDA1D6}"/>
               </a:ext>
             </a:extLst>
           </p:cNvPr>
@@ -11897,7 +11897,7 @@
           <p:cNvPr id="10" name="">
             <a:extLst xmlns:a="http://schemas.openxmlformats.org/drawingml/2006/main">
               <a:ext uri="{FF2B5EF4-FFF2-40B4-BE49-F238E27FC236}">
-                <a16:creationId xmlns:a16="http://schemas.microsoft.com/office/drawing/2014/main" id="{A2774FE4-9EAF-4BC6-8E52-B4D8E8B26632}"/>
+                <a16:creationId xmlns:a16="http://schemas.microsoft.com/office/drawing/2014/main" id="{0760422B-D344-4E74-91A9-6AED2A4D52FF}"/>
               </a:ext>
             </a:extLst>
           </p:cNvPr>
@@ -11947,7 +11947,7 @@
           <p:cNvPr id="11" name="">
             <a:extLst xmlns:a="http://schemas.openxmlformats.org/drawingml/2006/main">
               <a:ext uri="{FF2B5EF4-FFF2-40B4-BE49-F238E27FC236}">
-                <a16:creationId xmlns:a16="http://schemas.microsoft.com/office/drawing/2014/main" id="{7E585CCC-984D-4CF4-82C5-237E8FD9F464}"/>
+                <a16:creationId xmlns:a16="http://schemas.microsoft.com/office/drawing/2014/main" id="{B8D5447B-A461-455D-93DB-0760D34E0756}"/>
               </a:ext>
             </a:extLst>
           </p:cNvPr>
@@ -11997,7 +11997,7 @@
           <p:cNvPr id="12" name="">
             <a:extLst xmlns:a="http://schemas.openxmlformats.org/drawingml/2006/main">
               <a:ext uri="{FF2B5EF4-FFF2-40B4-BE49-F238E27FC236}">
-                <a16:creationId xmlns:a16="http://schemas.microsoft.com/office/drawing/2014/main" id="{08C7CE2A-9D45-4A96-AC7B-0C96EABA5739}"/>
+                <a16:creationId xmlns:a16="http://schemas.microsoft.com/office/drawing/2014/main" id="{CEDECA97-5DCB-4E5F-BC36-DD322F39AC17}"/>
               </a:ext>
             </a:extLst>
           </p:cNvPr>
@@ -12047,7 +12047,7 @@
           <p:cNvPr id="13" name="">
             <a:extLst xmlns:a="http://schemas.openxmlformats.org/drawingml/2006/main">
               <a:ext uri="{FF2B5EF4-FFF2-40B4-BE49-F238E27FC236}">
-                <a16:creationId xmlns:a16="http://schemas.microsoft.com/office/drawing/2014/main" id="{AAFC4DAA-2895-44FA-861C-0FAA780CA65A}"/>
+                <a16:creationId xmlns:a16="http://schemas.microsoft.com/office/drawing/2014/main" id="{ACCF3451-41CF-460E-978D-DE735F806CC9}"/>
               </a:ext>
             </a:extLst>
           </p:cNvPr>
@@ -12078,7 +12078,7 @@
           <p:cNvPr id="14" name="">
             <a:extLst xmlns:a="http://schemas.openxmlformats.org/drawingml/2006/main">
               <a:ext uri="{FF2B5EF4-FFF2-40B4-BE49-F238E27FC236}">
-                <a16:creationId xmlns:a16="http://schemas.microsoft.com/office/drawing/2014/main" id="{9D162B27-AF9E-4257-A7FF-94401DD4A49E}"/>
+                <a16:creationId xmlns:a16="http://schemas.microsoft.com/office/drawing/2014/main" id="{0C0A4FA4-1CC8-4699-BBA1-CC3E2130538B}"/>
               </a:ext>
             </a:extLst>
           </p:cNvPr>
@@ -12128,7 +12128,7 @@
           <p:cNvPr id="15" name="">
             <a:extLst xmlns:a="http://schemas.openxmlformats.org/drawingml/2006/main">
               <a:ext uri="{FF2B5EF4-FFF2-40B4-BE49-F238E27FC236}">
-                <a16:creationId xmlns:a16="http://schemas.microsoft.com/office/drawing/2014/main" id="{FAEF1566-4D64-4259-8631-B1EDA1D247B9}"/>
+                <a16:creationId xmlns:a16="http://schemas.microsoft.com/office/drawing/2014/main" id="{F9F9A308-719D-4239-BC65-31F6206F5CDD}"/>
               </a:ext>
             </a:extLst>
           </p:cNvPr>
@@ -12178,7 +12178,7 @@
           <p:cNvPr id="16" name="">
             <a:extLst xmlns:a="http://schemas.openxmlformats.org/drawingml/2006/main">
               <a:ext uri="{FF2B5EF4-FFF2-40B4-BE49-F238E27FC236}">
-                <a16:creationId xmlns:a16="http://schemas.microsoft.com/office/drawing/2014/main" id="{5BA11A85-4D30-4BE2-9359-7873CFC5CDAE}"/>
+                <a16:creationId xmlns:a16="http://schemas.microsoft.com/office/drawing/2014/main" id="{A67AC6C7-9295-40CC-8D06-524883441074}"/>
               </a:ext>
             </a:extLst>
           </p:cNvPr>
@@ -12213,7 +12213,7 @@
           <p:cNvPr id="17" name="">
             <a:extLst xmlns:a="http://schemas.openxmlformats.org/drawingml/2006/main">
               <a:ext uri="{FF2B5EF4-FFF2-40B4-BE49-F238E27FC236}">
-                <a16:creationId xmlns:a16="http://schemas.microsoft.com/office/drawing/2014/main" id="{48FDC769-5FDC-4A3B-BF82-87C601CF29EF}"/>
+                <a16:creationId xmlns:a16="http://schemas.microsoft.com/office/drawing/2014/main" id="{F06F27E9-6A6D-4E78-B3FB-6437FC2ABDD4}"/>
               </a:ext>
             </a:extLst>
           </p:cNvPr>
@@ -12246,7 +12246,7 @@
           <p:cNvPr id="18" name="">
             <a:extLst xmlns:a="http://schemas.openxmlformats.org/drawingml/2006/main">
               <a:ext uri="{FF2B5EF4-FFF2-40B4-BE49-F238E27FC236}">
-                <a16:creationId xmlns:a16="http://schemas.microsoft.com/office/drawing/2014/main" id="{844240EB-F642-4CD0-A86E-21B3A0810A5E}"/>
+                <a16:creationId xmlns:a16="http://schemas.microsoft.com/office/drawing/2014/main" id="{1C1D8BA4-0375-43E0-9F03-B62E8DCD4D36}"/>
               </a:ext>
             </a:extLst>
           </p:cNvPr>
@@ -12296,7 +12296,7 @@
           <p:cNvPr id="19" name="">
             <a:extLst xmlns:a="http://schemas.openxmlformats.org/drawingml/2006/main">
               <a:ext uri="{FF2B5EF4-FFF2-40B4-BE49-F238E27FC236}">
-                <a16:creationId xmlns:a16="http://schemas.microsoft.com/office/drawing/2014/main" id="{A605DBBF-A6FB-4EF1-90B1-12BE859187D8}"/>
+                <a16:creationId xmlns:a16="http://schemas.microsoft.com/office/drawing/2014/main" id="{F41FC2F7-01D3-40D1-91F0-3F5906118D31}"/>
               </a:ext>
             </a:extLst>
           </p:cNvPr>
@@ -12346,7 +12346,7 @@
           <p:cNvPr id="20" name="">
             <a:extLst xmlns:a="http://schemas.openxmlformats.org/drawingml/2006/main">
               <a:ext uri="{FF2B5EF4-FFF2-40B4-BE49-F238E27FC236}">
-                <a16:creationId xmlns:a16="http://schemas.microsoft.com/office/drawing/2014/main" id="{3FBF1492-08BB-4A29-8C9B-CCC987990AEA}"/>
+                <a16:creationId xmlns:a16="http://schemas.microsoft.com/office/drawing/2014/main" id="{51384C9D-ABB4-4972-BB57-53C47F607B53}"/>
               </a:ext>
             </a:extLst>
           </p:cNvPr>
@@ -12396,7 +12396,7 @@
           <p:cNvPr id="21" name="">
             <a:extLst xmlns:a="http://schemas.openxmlformats.org/drawingml/2006/main">
               <a:ext uri="{FF2B5EF4-FFF2-40B4-BE49-F238E27FC236}">
-                <a16:creationId xmlns:a16="http://schemas.microsoft.com/office/drawing/2014/main" id="{899E959A-AD55-4D9A-AB0B-F792522864A5}"/>
+                <a16:creationId xmlns:a16="http://schemas.microsoft.com/office/drawing/2014/main" id="{D3617115-0DB6-40E2-9CDD-0ED77B176599}"/>
               </a:ext>
             </a:extLst>
           </p:cNvPr>
@@ -12427,7 +12427,7 @@
           <p:cNvPr id="22" name="">
             <a:extLst xmlns:a="http://schemas.openxmlformats.org/drawingml/2006/main">
               <a:ext uri="{FF2B5EF4-FFF2-40B4-BE49-F238E27FC236}">
-                <a16:creationId xmlns:a16="http://schemas.microsoft.com/office/drawing/2014/main" id="{CE659E4C-5619-4B60-8AE9-21EAC8785AC2}"/>
+                <a16:creationId xmlns:a16="http://schemas.microsoft.com/office/drawing/2014/main" id="{7B4C34D7-F8CE-4C8E-9BFB-0DF0E1B25386}"/>
               </a:ext>
             </a:extLst>
           </p:cNvPr>
@@ -12477,7 +12477,7 @@
           <p:cNvPr id="23" name="">
             <a:extLst xmlns:a="http://schemas.openxmlformats.org/drawingml/2006/main">
               <a:ext uri="{FF2B5EF4-FFF2-40B4-BE49-F238E27FC236}">
-                <a16:creationId xmlns:a16="http://schemas.microsoft.com/office/drawing/2014/main" id="{93C73CBA-A40C-4A17-9414-7C238535A853}"/>
+                <a16:creationId xmlns:a16="http://schemas.microsoft.com/office/drawing/2014/main" id="{8A0D51E5-BD97-4F50-8CD3-81E2BBFA858A}"/>
               </a:ext>
             </a:extLst>
           </p:cNvPr>
@@ -12527,7 +12527,7 @@
           <p:cNvPr id="24" name="">
             <a:extLst xmlns:a="http://schemas.openxmlformats.org/drawingml/2006/main">
               <a:ext uri="{FF2B5EF4-FFF2-40B4-BE49-F238E27FC236}">
-                <a16:creationId xmlns:a16="http://schemas.microsoft.com/office/drawing/2014/main" id="{DD57E13E-0FAC-4779-B10D-93934DC597FB}"/>
+                <a16:creationId xmlns:a16="http://schemas.microsoft.com/office/drawing/2014/main" id="{921F100A-C647-4303-B596-88CC86CF077E}"/>
               </a:ext>
             </a:extLst>
           </p:cNvPr>
@@ -12562,7 +12562,7 @@
           <p:cNvPr id="25" name="">
             <a:extLst xmlns:a="http://schemas.openxmlformats.org/drawingml/2006/main">
               <a:ext uri="{FF2B5EF4-FFF2-40B4-BE49-F238E27FC236}">
-                <a16:creationId xmlns:a16="http://schemas.microsoft.com/office/drawing/2014/main" id="{3EF939B9-7C84-474C-B0A4-D955E91AF8BD}"/>
+                <a16:creationId xmlns:a16="http://schemas.microsoft.com/office/drawing/2014/main" id="{7C5E13E9-8D43-4824-ADFC-AEFC82C488B5}"/>
               </a:ext>
             </a:extLst>
           </p:cNvPr>
@@ -12595,7 +12595,7 @@
           <p:cNvPr id="26" name="">
             <a:extLst xmlns:a="http://schemas.openxmlformats.org/drawingml/2006/main">
               <a:ext uri="{FF2B5EF4-FFF2-40B4-BE49-F238E27FC236}">
-                <a16:creationId xmlns:a16="http://schemas.microsoft.com/office/drawing/2014/main" id="{990B2CE9-0B64-495A-B4EE-78360EAB5E39}"/>
+                <a16:creationId xmlns:a16="http://schemas.microsoft.com/office/drawing/2014/main" id="{DB6CED5E-BC2E-4400-8162-77903A2BF71E}"/>
               </a:ext>
             </a:extLst>
           </p:cNvPr>
@@ -12645,7 +12645,7 @@
           <p:cNvPr id="27" name="">
             <a:extLst xmlns:a="http://schemas.openxmlformats.org/drawingml/2006/main">
               <a:ext uri="{FF2B5EF4-FFF2-40B4-BE49-F238E27FC236}">
-                <a16:creationId xmlns:a16="http://schemas.microsoft.com/office/drawing/2014/main" id="{0F884ABE-0288-4CCD-9F48-D743C956A22E}"/>
+                <a16:creationId xmlns:a16="http://schemas.microsoft.com/office/drawing/2014/main" id="{B5AD892F-1F2D-4D93-B3AC-4F7864920220}"/>
               </a:ext>
             </a:extLst>
           </p:cNvPr>
@@ -12695,7 +12695,7 @@
           <p:cNvPr id="28" name="">
             <a:extLst xmlns:a="http://schemas.openxmlformats.org/drawingml/2006/main">
               <a:ext uri="{FF2B5EF4-FFF2-40B4-BE49-F238E27FC236}">
-                <a16:creationId xmlns:a16="http://schemas.microsoft.com/office/drawing/2014/main" id="{CBB68942-413D-4517-8484-081686B0F88A}"/>
+                <a16:creationId xmlns:a16="http://schemas.microsoft.com/office/drawing/2014/main" id="{5A23F543-A21D-4428-B00A-A1B68CF185EC}"/>
               </a:ext>
             </a:extLst>
           </p:cNvPr>
@@ -12745,7 +12745,7 @@
           <p:cNvPr id="29" name="">
             <a:extLst xmlns:a="http://schemas.openxmlformats.org/drawingml/2006/main">
               <a:ext uri="{FF2B5EF4-FFF2-40B4-BE49-F238E27FC236}">
-                <a16:creationId xmlns:a16="http://schemas.microsoft.com/office/drawing/2014/main" id="{AB1082BD-3C95-4BC4-BCD2-EBDBB64CBD62}"/>
+                <a16:creationId xmlns:a16="http://schemas.microsoft.com/office/drawing/2014/main" id="{C7D950FC-2296-47BD-8DD6-356B797D5C6E}"/>
               </a:ext>
             </a:extLst>
           </p:cNvPr>
@@ -12776,7 +12776,7 @@
           <p:cNvPr id="30" name="">
             <a:extLst xmlns:a="http://schemas.openxmlformats.org/drawingml/2006/main">
               <a:ext uri="{FF2B5EF4-FFF2-40B4-BE49-F238E27FC236}">
-                <a16:creationId xmlns:a16="http://schemas.microsoft.com/office/drawing/2014/main" id="{46548D08-469C-4E74-BD9B-15E5D2CB4E6B}"/>
+                <a16:creationId xmlns:a16="http://schemas.microsoft.com/office/drawing/2014/main" id="{44D2C740-311E-4DFA-9108-E0D75EFF7B6F}"/>
               </a:ext>
             </a:extLst>
           </p:cNvPr>
@@ -12826,7 +12826,7 @@
           <p:cNvPr id="31" name="">
             <a:extLst xmlns:a="http://schemas.openxmlformats.org/drawingml/2006/main">
               <a:ext uri="{FF2B5EF4-FFF2-40B4-BE49-F238E27FC236}">
-                <a16:creationId xmlns:a16="http://schemas.microsoft.com/office/drawing/2014/main" id="{D9C237A6-7D78-4551-B173-EC406077ED96}"/>
+                <a16:creationId xmlns:a16="http://schemas.microsoft.com/office/drawing/2014/main" id="{F45E53B2-87D0-46C4-AA77-9CF5F88F053D}"/>
               </a:ext>
             </a:extLst>
           </p:cNvPr>
@@ -12874,7 +12874,7 @@
     </p:spTree>
     <p:extLst>
       <p:ext uri="{BB962C8B-B14F-4D97-AF65-F5344CB8AC3E}">
-        <p14:creationId xmlns:p14="http://schemas.microsoft.com/office/powerpoint/2010/main" val="1295805741"/>
+        <p14:creationId xmlns:p14="http://schemas.microsoft.com/office/powerpoint/2010/main" val="1117913236"/>
       </p:ext>
     </p:extLst>
   </p:cSld>
@@ -12905,7 +12905,7 @@
           <p:cNvPr id="1" name="">
             <a:extLst xmlns:a="http://schemas.openxmlformats.org/drawingml/2006/main">
               <a:ext uri="{FF2B5EF4-FFF2-40B4-BE49-F238E27FC236}">
-                <a16:creationId xmlns:a16="http://schemas.microsoft.com/office/drawing/2014/main" id="{FB311ED7-91E4-44AF-B414-194F76B51FE3}"/>
+                <a16:creationId xmlns:a16="http://schemas.microsoft.com/office/drawing/2014/main" id="{D5DDF52D-9447-4D79-AAC7-8C0AB655A771}"/>
               </a:ext>
             </a:extLst>
           </p:cNvPr>
@@ -12940,7 +12940,7 @@
           <p:nvPr/>
         </p:nvPicPr>
         <p:blipFill>
-          <a:blip xmlns:r="http://schemas.openxmlformats.org/officeDocument/2006/relationships" xmlns:a="http://schemas.openxmlformats.org/drawingml/2006/main" r:embed="R6b615db394d54316"/>
+          <a:blip xmlns:r="http://schemas.openxmlformats.org/officeDocument/2006/relationships" xmlns:a="http://schemas.openxmlformats.org/drawingml/2006/main" r:embed="Rafc1a8d0721a4d6f"/>
           <a:stretch xmlns:a="http://schemas.openxmlformats.org/drawingml/2006/main"/>
         </p:blipFill>
         <p:spPr>
@@ -12958,7 +12958,7 @@
           <p:cNvPr id="3" name="">
             <a:extLst xmlns:a="http://schemas.openxmlformats.org/drawingml/2006/main">
               <a:ext uri="{FF2B5EF4-FFF2-40B4-BE49-F238E27FC236}">
-                <a16:creationId xmlns:a16="http://schemas.microsoft.com/office/drawing/2014/main" id="{99D9B229-6FC3-49BD-92B2-72BFFEECD31A}"/>
+                <a16:creationId xmlns:a16="http://schemas.microsoft.com/office/drawing/2014/main" id="{FA0E0110-7DA8-4A0A-9ABE-26D147786A30}"/>
               </a:ext>
             </a:extLst>
           </p:cNvPr>
@@ -13008,7 +13008,7 @@
           <p:cNvPr id="4" name="">
             <a:extLst xmlns:a="http://schemas.openxmlformats.org/drawingml/2006/main">
               <a:ext uri="{FF2B5EF4-FFF2-40B4-BE49-F238E27FC236}">
-                <a16:creationId xmlns:a16="http://schemas.microsoft.com/office/drawing/2014/main" id="{C21DEE1C-7B7C-49D2-9850-EB8F7AE0F09D}"/>
+                <a16:creationId xmlns:a16="http://schemas.microsoft.com/office/drawing/2014/main" id="{BE01E9E7-2257-4456-9985-1D7EA88473C8}"/>
               </a:ext>
             </a:extLst>
           </p:cNvPr>
@@ -13041,7 +13041,7 @@
           <p:cNvPr id="5" name="">
             <a:extLst xmlns:a="http://schemas.openxmlformats.org/drawingml/2006/main">
               <a:ext uri="{FF2B5EF4-FFF2-40B4-BE49-F238E27FC236}">
-                <a16:creationId xmlns:a16="http://schemas.microsoft.com/office/drawing/2014/main" id="{5CD76CE4-410E-4FE1-BE19-2863FAB40B63}"/>
+                <a16:creationId xmlns:a16="http://schemas.microsoft.com/office/drawing/2014/main" id="{D80AB725-BDE3-4C7D-BD18-C75480F25F52}"/>
               </a:ext>
             </a:extLst>
           </p:cNvPr>
@@ -13072,7 +13072,7 @@
           <p:cNvPr id="6" name="">
             <a:extLst xmlns:a="http://schemas.openxmlformats.org/drawingml/2006/main">
               <a:ext uri="{FF2B5EF4-FFF2-40B4-BE49-F238E27FC236}">
-                <a16:creationId xmlns:a16="http://schemas.microsoft.com/office/drawing/2014/main" id="{1D5AB591-ED3E-455C-82D3-23CE1AEACD23}"/>
+                <a16:creationId xmlns:a16="http://schemas.microsoft.com/office/drawing/2014/main" id="{4D94C1A7-09DD-48A7-ABF1-FACA06BDF702}"/>
               </a:ext>
             </a:extLst>
           </p:cNvPr>
@@ -13122,7 +13122,7 @@
           <p:cNvPr id="7" name="">
             <a:extLst xmlns:a="http://schemas.openxmlformats.org/drawingml/2006/main">
               <a:ext uri="{FF2B5EF4-FFF2-40B4-BE49-F238E27FC236}">
-                <a16:creationId xmlns:a16="http://schemas.microsoft.com/office/drawing/2014/main" id="{F9751A3C-E0E6-4FF0-8673-57372B227FD9}"/>
+                <a16:creationId xmlns:a16="http://schemas.microsoft.com/office/drawing/2014/main" id="{9ADAA942-344B-458A-9A8B-DA1A7B95BCA9}"/>
               </a:ext>
             </a:extLst>
           </p:cNvPr>
@@ -13172,7 +13172,7 @@
           <p:cNvPr id="8" name="">
             <a:extLst xmlns:a="http://schemas.openxmlformats.org/drawingml/2006/main">
               <a:ext uri="{FF2B5EF4-FFF2-40B4-BE49-F238E27FC236}">
-                <a16:creationId xmlns:a16="http://schemas.microsoft.com/office/drawing/2014/main" id="{6A5C9749-A68E-433E-A54C-9CF55FC934DF}"/>
+                <a16:creationId xmlns:a16="http://schemas.microsoft.com/office/drawing/2014/main" id="{F461FA73-AA53-49EF-BD1A-2270FC2AC8BC}"/>
               </a:ext>
             </a:extLst>
           </p:cNvPr>
@@ -13222,7 +13222,7 @@
           <p:cNvPr id="9" name="">
             <a:extLst xmlns:a="http://schemas.openxmlformats.org/drawingml/2006/main">
               <a:ext uri="{FF2B5EF4-FFF2-40B4-BE49-F238E27FC236}">
-                <a16:creationId xmlns:a16="http://schemas.microsoft.com/office/drawing/2014/main" id="{A67F892B-68C6-494E-9349-A1D248EF0AC8}"/>
+                <a16:creationId xmlns:a16="http://schemas.microsoft.com/office/drawing/2014/main" id="{2FA0F3C2-9707-4572-B7D5-7669EACECAE2}"/>
               </a:ext>
             </a:extLst>
           </p:cNvPr>
@@ -13272,7 +13272,7 @@
           <p:cNvPr id="10" name="">
             <a:extLst xmlns:a="http://schemas.openxmlformats.org/drawingml/2006/main">
               <a:ext uri="{FF2B5EF4-FFF2-40B4-BE49-F238E27FC236}">
-                <a16:creationId xmlns:a16="http://schemas.microsoft.com/office/drawing/2014/main" id="{ED92ABE1-C6A3-4FC8-8CC8-734C532CC6C4}"/>
+                <a16:creationId xmlns:a16="http://schemas.microsoft.com/office/drawing/2014/main" id="{3A2A8DF4-845F-4CB7-AD1D-88070BBDE5D6}"/>
               </a:ext>
             </a:extLst>
           </p:cNvPr>
@@ -13303,7 +13303,7 @@
           <p:cNvPr id="11" name="">
             <a:extLst xmlns:a="http://schemas.openxmlformats.org/drawingml/2006/main">
               <a:ext uri="{FF2B5EF4-FFF2-40B4-BE49-F238E27FC236}">
-                <a16:creationId xmlns:a16="http://schemas.microsoft.com/office/drawing/2014/main" id="{B06D550B-3466-455A-9362-58A4A6C86F9B}"/>
+                <a16:creationId xmlns:a16="http://schemas.microsoft.com/office/drawing/2014/main" id="{44FFBD31-AA91-4EB0-8674-A6F141288675}"/>
               </a:ext>
             </a:extLst>
           </p:cNvPr>
@@ -13353,7 +13353,7 @@
           <p:cNvPr id="12" name="">
             <a:extLst xmlns:a="http://schemas.openxmlformats.org/drawingml/2006/main">
               <a:ext uri="{FF2B5EF4-FFF2-40B4-BE49-F238E27FC236}">
-                <a16:creationId xmlns:a16="http://schemas.microsoft.com/office/drawing/2014/main" id="{E21E3E6D-6612-41B3-AD7A-234D6FA864AE}"/>
+                <a16:creationId xmlns:a16="http://schemas.microsoft.com/office/drawing/2014/main" id="{14904983-06FA-43C1-BC5F-8CD31DD26868}"/>
               </a:ext>
             </a:extLst>
           </p:cNvPr>
@@ -13403,7 +13403,7 @@
           <p:cNvPr id="13" name="">
             <a:extLst xmlns:a="http://schemas.openxmlformats.org/drawingml/2006/main">
               <a:ext uri="{FF2B5EF4-FFF2-40B4-BE49-F238E27FC236}">
-                <a16:creationId xmlns:a16="http://schemas.microsoft.com/office/drawing/2014/main" id="{71EB3EDA-CEEC-40F8-9CE0-6B4E867F64B5}"/>
+                <a16:creationId xmlns:a16="http://schemas.microsoft.com/office/drawing/2014/main" id="{0CB777F1-F1E4-47A3-A123-646FDF5604E8}"/>
               </a:ext>
             </a:extLst>
           </p:cNvPr>
@@ -13434,7 +13434,7 @@
           <p:cNvPr id="14" name="">
             <a:extLst xmlns:a="http://schemas.openxmlformats.org/drawingml/2006/main">
               <a:ext uri="{FF2B5EF4-FFF2-40B4-BE49-F238E27FC236}">
-                <a16:creationId xmlns:a16="http://schemas.microsoft.com/office/drawing/2014/main" id="{96AB4149-2D21-4CDE-AF01-50A264583CDB}"/>
+                <a16:creationId xmlns:a16="http://schemas.microsoft.com/office/drawing/2014/main" id="{96977DFA-8ECC-4B48-BFA1-10FC72B8A363}"/>
               </a:ext>
             </a:extLst>
           </p:cNvPr>
@@ -13484,7 +13484,7 @@
           <p:cNvPr id="15" name="">
             <a:extLst xmlns:a="http://schemas.openxmlformats.org/drawingml/2006/main">
               <a:ext uri="{FF2B5EF4-FFF2-40B4-BE49-F238E27FC236}">
-                <a16:creationId xmlns:a16="http://schemas.microsoft.com/office/drawing/2014/main" id="{0233F9E0-876D-4EAD-9385-04A8909BE8C2}"/>
+                <a16:creationId xmlns:a16="http://schemas.microsoft.com/office/drawing/2014/main" id="{CEC6E1BE-E16A-4A43-8BCA-802757E2B167}"/>
               </a:ext>
             </a:extLst>
           </p:cNvPr>
@@ -13534,7 +13534,7 @@
           <p:cNvPr id="16" name="">
             <a:extLst xmlns:a="http://schemas.openxmlformats.org/drawingml/2006/main">
               <a:ext uri="{FF2B5EF4-FFF2-40B4-BE49-F238E27FC236}">
-                <a16:creationId xmlns:a16="http://schemas.microsoft.com/office/drawing/2014/main" id="{2994D882-C6A2-475B-A8B5-14D8ED587EDD}"/>
+                <a16:creationId xmlns:a16="http://schemas.microsoft.com/office/drawing/2014/main" id="{88A74F98-95B3-4B1B-AE20-2907C2F26040}"/>
               </a:ext>
             </a:extLst>
           </p:cNvPr>
@@ -13565,7 +13565,7 @@
           <p:cNvPr id="17" name="">
             <a:extLst xmlns:a="http://schemas.openxmlformats.org/drawingml/2006/main">
               <a:ext uri="{FF2B5EF4-FFF2-40B4-BE49-F238E27FC236}">
-                <a16:creationId xmlns:a16="http://schemas.microsoft.com/office/drawing/2014/main" id="{54E6219C-6F6C-41AE-8B91-E153CAA75BC5}"/>
+                <a16:creationId xmlns:a16="http://schemas.microsoft.com/office/drawing/2014/main" id="{874BC017-4A46-426D-92C6-9A9081A8738E}"/>
               </a:ext>
             </a:extLst>
           </p:cNvPr>
@@ -13615,7 +13615,7 @@
           <p:cNvPr id="18" name="">
             <a:extLst xmlns:a="http://schemas.openxmlformats.org/drawingml/2006/main">
               <a:ext uri="{FF2B5EF4-FFF2-40B4-BE49-F238E27FC236}">
-                <a16:creationId xmlns:a16="http://schemas.microsoft.com/office/drawing/2014/main" id="{5DFF6413-AC80-4D9F-9EFA-589ABB869816}"/>
+                <a16:creationId xmlns:a16="http://schemas.microsoft.com/office/drawing/2014/main" id="{487D6D43-3A1F-4294-9339-3B7C8A359A33}"/>
               </a:ext>
             </a:extLst>
           </p:cNvPr>
@@ -13665,7 +13665,7 @@
           <p:cNvPr id="19" name="">
             <a:extLst xmlns:a="http://schemas.openxmlformats.org/drawingml/2006/main">
               <a:ext uri="{FF2B5EF4-FFF2-40B4-BE49-F238E27FC236}">
-                <a16:creationId xmlns:a16="http://schemas.microsoft.com/office/drawing/2014/main" id="{BF33F9F5-36AA-4F59-9926-69B11E806392}"/>
+                <a16:creationId xmlns:a16="http://schemas.microsoft.com/office/drawing/2014/main" id="{2BD83C5D-DCE1-4B0D-A21F-2794C060D6F9}"/>
               </a:ext>
             </a:extLst>
           </p:cNvPr>
@@ -13700,7 +13700,7 @@
           <p:cNvPr id="20" name="">
             <a:extLst xmlns:a="http://schemas.openxmlformats.org/drawingml/2006/main">
               <a:ext uri="{FF2B5EF4-FFF2-40B4-BE49-F238E27FC236}">
-                <a16:creationId xmlns:a16="http://schemas.microsoft.com/office/drawing/2014/main" id="{8826B28E-9F46-4581-8FAE-1293C3A52AAC}"/>
+                <a16:creationId xmlns:a16="http://schemas.microsoft.com/office/drawing/2014/main" id="{427D3ED1-BFCF-4CC9-A8CC-847BDEEE377E}"/>
               </a:ext>
             </a:extLst>
           </p:cNvPr>
@@ -13750,7 +13750,7 @@
           <p:cNvPr id="21" name="">
             <a:extLst xmlns:a="http://schemas.openxmlformats.org/drawingml/2006/main">
               <a:ext uri="{FF2B5EF4-FFF2-40B4-BE49-F238E27FC236}">
-                <a16:creationId xmlns:a16="http://schemas.microsoft.com/office/drawing/2014/main" id="{0399DA6A-C3DE-4384-A8F7-07B49F975BD8}"/>
+                <a16:creationId xmlns:a16="http://schemas.microsoft.com/office/drawing/2014/main" id="{D54307F2-92EA-49E3-B80D-B9C06EDDB5A3}"/>
               </a:ext>
             </a:extLst>
           </p:cNvPr>
@@ -13804,7 +13804,7 @@
           <p:nvPr/>
         </p:nvPicPr>
         <p:blipFill>
-          <a:blip xmlns:r="http://schemas.openxmlformats.org/officeDocument/2006/relationships" xmlns:a="http://schemas.openxmlformats.org/drawingml/2006/main" r:embed="R3f9c73364f024654"/>
+          <a:blip xmlns:r="http://schemas.openxmlformats.org/officeDocument/2006/relationships" xmlns:a="http://schemas.openxmlformats.org/drawingml/2006/main" r:embed="Rb5a4d14eed2e41f4"/>
           <a:stretch xmlns:a="http://schemas.openxmlformats.org/drawingml/2006/main"/>
         </p:blipFill>
         <p:spPr>
@@ -13822,7 +13822,7 @@
           <p:cNvPr id="23" name="">
             <a:extLst xmlns:a="http://schemas.openxmlformats.org/drawingml/2006/main">
               <a:ext uri="{FF2B5EF4-FFF2-40B4-BE49-F238E27FC236}">
-                <a16:creationId xmlns:a16="http://schemas.microsoft.com/office/drawing/2014/main" id="{D0698D56-F58D-41A1-9F79-0DEECB951B8B}"/>
+                <a16:creationId xmlns:a16="http://schemas.microsoft.com/office/drawing/2014/main" id="{52EC2445-D874-4204-AAB6-4FD287C67FF9}"/>
               </a:ext>
             </a:extLst>
           </p:cNvPr>
@@ -13872,7 +13872,7 @@
           <p:cNvPr id="24" name="">
             <a:extLst xmlns:a="http://schemas.openxmlformats.org/drawingml/2006/main">
               <a:ext uri="{FF2B5EF4-FFF2-40B4-BE49-F238E27FC236}">
-                <a16:creationId xmlns:a16="http://schemas.microsoft.com/office/drawing/2014/main" id="{2F339F28-F9B7-4898-9330-8D1C493F3BCA}"/>
+                <a16:creationId xmlns:a16="http://schemas.microsoft.com/office/drawing/2014/main" id="{8075D739-21B4-47A8-8D3B-8D4637D5FDB8}"/>
               </a:ext>
             </a:extLst>
           </p:cNvPr>
@@ -13922,7 +13922,7 @@
           <p:cNvPr id="25" name="">
             <a:extLst xmlns:a="http://schemas.openxmlformats.org/drawingml/2006/main">
               <a:ext uri="{FF2B5EF4-FFF2-40B4-BE49-F238E27FC236}">
-                <a16:creationId xmlns:a16="http://schemas.microsoft.com/office/drawing/2014/main" id="{42C9DD09-00D5-4719-9413-E079E8A840CB}"/>
+                <a16:creationId xmlns:a16="http://schemas.microsoft.com/office/drawing/2014/main" id="{39627B9A-B1FB-4BB8-A82F-5F0017284892}"/>
               </a:ext>
             </a:extLst>
           </p:cNvPr>
@@ -13970,7 +13970,7 @@
     </p:spTree>
     <p:extLst>
       <p:ext uri="{BB962C8B-B14F-4D97-AF65-F5344CB8AC3E}">
-        <p14:creationId xmlns:p14="http://schemas.microsoft.com/office/powerpoint/2010/main" val="1724789130"/>
+        <p14:creationId xmlns:p14="http://schemas.microsoft.com/office/powerpoint/2010/main" val="1581370479"/>
       </p:ext>
     </p:extLst>
   </p:cSld>

</xml_diff>